<commit_message>
Finalize camera-ready consistency fixes
</commit_message>
<xml_diff>
--- a/paper/figures/DPES_Figure1_v2_editable.pptx
+++ b/paper/figures/DPES_Figure1_v2_editable.pptx
@@ -2138,7 +2138,7 @@
               <a:buNone/>
             </a:pPr>
             <a:r>
-              <a:rPr lang="en-US" sz="760" i="1" dirty="0">
+              <a:rPr lang="en-US" sz="740" i="1" dirty="0">
                 <a:solidFill>
                   <a:srgbClr val="1A1F2B"/>
                 </a:solidFill>
@@ -2155,7 +2155,7 @@
               <a:buNone/>
             </a:pPr>
             <a:r>
-              <a:rPr lang="en-US" sz="760" baseline="-40000" dirty="0">
+              <a:rPr lang="en-US" sz="740" baseline="-40000" dirty="0">
                 <a:solidFill>
                   <a:srgbClr val="1A1F2B"/>
                 </a:solidFill>
@@ -2172,7 +2172,7 @@
               <a:buNone/>
             </a:pPr>
             <a:r>
-              <a:rPr lang="en-US" sz="760" dirty="0">
+              <a:rPr lang="en-US" sz="740" dirty="0">
                 <a:solidFill>
                   <a:srgbClr val="1A1F2B"/>
                 </a:solidFill>
@@ -2189,7 +2189,7 @@
               <a:buNone/>
             </a:pPr>
             <a:r>
-              <a:rPr lang="en-US" sz="760" i="1" dirty="0">
+              <a:rPr lang="en-US" sz="740" i="1" dirty="0">
                 <a:solidFill>
                   <a:srgbClr val="1A1F2B"/>
                 </a:solidFill>
@@ -2206,7 +2206,7 @@
               <a:buNone/>
             </a:pPr>
             <a:r>
-              <a:rPr lang="en-US" sz="760" dirty="0">
+              <a:rPr lang="en-US" sz="740" dirty="0">
                 <a:solidFill>
                   <a:srgbClr val="1A1F2B"/>
                 </a:solidFill>
@@ -2214,16 +2214,16 @@
                 <a:ea typeface="Times New Roman" pitchFamily="34" charset="-122"/>
                 <a:cs typeface="Times New Roman" pitchFamily="34" charset="-120"/>
               </a:rPr>
-              <a:t>) = mean</a:t>
-            </a:r>
-            <a:pPr algn="ctr" indent="0" marL="0">
-              <a:lnSpc>
-                <a:spcPct val="100000"/>
-              </a:lnSpc>
-              <a:buNone/>
-            </a:pPr>
-            <a:r>
-              <a:rPr lang="en-US" sz="760" baseline="-40000" dirty="0">
+              <a:t>) = </a:t>
+            </a:r>
+            <a:pPr algn="ctr" indent="0" marL="0">
+              <a:lnSpc>
+                <a:spcPct val="100000"/>
+              </a:lnSpc>
+              <a:buNone/>
+            </a:pPr>
+            <a:r>
+              <a:rPr lang="en-US" sz="740" i="1" dirty="0">
                 <a:solidFill>
                   <a:srgbClr val="1A1F2B"/>
                 </a:solidFill>
@@ -2231,16 +2231,16 @@
                 <a:ea typeface="Times New Roman" pitchFamily="34" charset="-122"/>
                 <a:cs typeface="Times New Roman" pitchFamily="34" charset="-120"/>
               </a:rPr>
-              <a:t>i∈B</a:t>
-            </a:r>
-            <a:pPr algn="ctr" indent="0" marL="0">
-              <a:lnSpc>
-                <a:spcPct val="100000"/>
-              </a:lnSpc>
-              <a:buNone/>
-            </a:pPr>
-            <a:r>
-              <a:rPr lang="en-US" sz="760" dirty="0">
+              <a:t>b</a:t>
+            </a:r>
+            <a:pPr algn="ctr" indent="0" marL="0">
+              <a:lnSpc>
+                <a:spcPct val="100000"/>
+              </a:lnSpc>
+              <a:buNone/>
+            </a:pPr>
+            <a:r>
+              <a:rPr lang="en-US" sz="740" baseline="30000" dirty="0">
                 <a:solidFill>
                   <a:srgbClr val="1A1F2B"/>
                 </a:solidFill>
@@ -2248,16 +2248,16 @@
                 <a:ea typeface="Times New Roman" pitchFamily="34" charset="-122"/>
                 <a:cs typeface="Times New Roman" pitchFamily="34" charset="-120"/>
               </a:rPr>
-              <a:t> clip(</a:t>
-            </a:r>
-            <a:pPr algn="ctr" indent="0" marL="0">
-              <a:lnSpc>
-                <a:spcPct val="100000"/>
-              </a:lnSpc>
-              <a:buNone/>
-            </a:pPr>
-            <a:r>
-              <a:rPr lang="en-US" sz="760" i="1" dirty="0">
+              <a:t>−1</a:t>
+            </a:r>
+            <a:pPr algn="ctr" indent="0" marL="0">
+              <a:lnSpc>
+                <a:spcPct val="100000"/>
+              </a:lnSpc>
+              <a:buNone/>
+            </a:pPr>
+            <a:r>
+              <a:rPr lang="en-US" sz="740" dirty="0">
                 <a:solidFill>
                   <a:srgbClr val="1A1F2B"/>
                 </a:solidFill>
@@ -2265,16 +2265,16 @@
                 <a:ea typeface="Times New Roman" pitchFamily="34" charset="-122"/>
                 <a:cs typeface="Times New Roman" pitchFamily="34" charset="-120"/>
               </a:rPr>
-              <a:t>u</a:t>
-            </a:r>
-            <a:pPr algn="ctr" indent="0" marL="0">
-              <a:lnSpc>
-                <a:spcPct val="100000"/>
-              </a:lnSpc>
-              <a:buNone/>
-            </a:pPr>
-            <a:r>
-              <a:rPr lang="en-US" sz="760" baseline="-40000" dirty="0">
+              <a:t> Σ</a:t>
+            </a:r>
+            <a:pPr algn="ctr" indent="0" marL="0">
+              <a:lnSpc>
+                <a:spcPct val="100000"/>
+              </a:lnSpc>
+              <a:buNone/>
+            </a:pPr>
+            <a:r>
+              <a:rPr lang="en-US" sz="740" baseline="-40000" dirty="0">
                 <a:solidFill>
                   <a:srgbClr val="1A1F2B"/>
                 </a:solidFill>
@@ -2282,16 +2282,16 @@
                 <a:ea typeface="Times New Roman" pitchFamily="34" charset="-122"/>
                 <a:cs typeface="Times New Roman" pitchFamily="34" charset="-120"/>
               </a:rPr>
-              <a:t>i</a:t>
-            </a:r>
-            <a:pPr algn="ctr" indent="0" marL="0">
-              <a:lnSpc>
-                <a:spcPct val="100000"/>
-              </a:lnSpc>
-              <a:buNone/>
-            </a:pPr>
-            <a:r>
-              <a:rPr lang="en-US" sz="760" dirty="0">
+              <a:t>i∈B</a:t>
+            </a:r>
+            <a:pPr algn="ctr" indent="0" marL="0">
+              <a:lnSpc>
+                <a:spcPct val="100000"/>
+              </a:lnSpc>
+              <a:buNone/>
+            </a:pPr>
+            <a:r>
+              <a:rPr lang="en-US" sz="740" dirty="0">
                 <a:solidFill>
                   <a:srgbClr val="1A1F2B"/>
                 </a:solidFill>
@@ -2299,9 +2299,60 @@
                 <a:ea typeface="Times New Roman" pitchFamily="34" charset="-122"/>
                 <a:cs typeface="Times New Roman" pitchFamily="34" charset="-120"/>
               </a:rPr>
+              <a:t> clip(</a:t>
+            </a:r>
+            <a:pPr algn="ctr" indent="0" marL="0">
+              <a:lnSpc>
+                <a:spcPct val="100000"/>
+              </a:lnSpc>
+              <a:buNone/>
+            </a:pPr>
+            <a:r>
+              <a:rPr lang="en-US" sz="740" i="1" dirty="0">
+                <a:solidFill>
+                  <a:srgbClr val="1A1F2B"/>
+                </a:solidFill>
+                <a:latin typeface="Times New Roman" pitchFamily="34" charset="0"/>
+                <a:ea typeface="Times New Roman" pitchFamily="34" charset="-122"/>
+                <a:cs typeface="Times New Roman" pitchFamily="34" charset="-120"/>
+              </a:rPr>
+              <a:t>u</a:t>
+            </a:r>
+            <a:pPr algn="ctr" indent="0" marL="0">
+              <a:lnSpc>
+                <a:spcPct val="100000"/>
+              </a:lnSpc>
+              <a:buNone/>
+            </a:pPr>
+            <a:r>
+              <a:rPr lang="en-US" sz="740" baseline="-40000" dirty="0">
+                <a:solidFill>
+                  <a:srgbClr val="1A1F2B"/>
+                </a:solidFill>
+                <a:latin typeface="Times New Roman" pitchFamily="34" charset="0"/>
+                <a:ea typeface="Times New Roman" pitchFamily="34" charset="-122"/>
+                <a:cs typeface="Times New Roman" pitchFamily="34" charset="-120"/>
+              </a:rPr>
+              <a:t>i</a:t>
+            </a:r>
+            <a:pPr algn="ctr" indent="0" marL="0">
+              <a:lnSpc>
+                <a:spcPct val="100000"/>
+              </a:lnSpc>
+              <a:buNone/>
+            </a:pPr>
+            <a:r>
+              <a:rPr lang="en-US" sz="740" dirty="0">
+                <a:solidFill>
+                  <a:srgbClr val="1A1F2B"/>
+                </a:solidFill>
+                <a:latin typeface="Times New Roman" pitchFamily="34" charset="0"/>
+                <a:ea typeface="Times New Roman" pitchFamily="34" charset="-122"/>
+                <a:cs typeface="Times New Roman" pitchFamily="34" charset="-120"/>
+              </a:rPr>
               <a:t>)</a:t>
             </a:r>
-            <a:endParaRPr lang="en-US" sz="760" dirty="0"/>
+            <a:endParaRPr lang="en-US" sz="740" dirty="0"/>
           </a:p>
         </p:txBody>
       </p:sp>
@@ -2333,7 +2384,7 @@
               <a:buNone/>
             </a:pPr>
             <a:r>
-              <a:rPr lang="en-US" sz="760" dirty="0">
+              <a:rPr lang="en-US" sz="740" dirty="0">
                 <a:solidFill>
                   <a:srgbClr val="1A1F2B"/>
                 </a:solidFill>
@@ -2350,7 +2401,7 @@
               <a:buNone/>
             </a:pPr>
             <a:r>
-              <a:rPr lang="en-US" sz="760" i="1" dirty="0">
+              <a:rPr lang="en-US" sz="740" i="1" dirty="0">
                 <a:solidFill>
                   <a:srgbClr val="1A1F2B"/>
                 </a:solidFill>
@@ -2367,7 +2418,7 @@
               <a:buNone/>
             </a:pPr>
             <a:r>
-              <a:rPr lang="en-US" sz="760" baseline="-40000" dirty="0">
+              <a:rPr lang="en-US" sz="740" baseline="-40000" dirty="0">
                 <a:solidFill>
                   <a:srgbClr val="1A1F2B"/>
                 </a:solidFill>
@@ -2384,7 +2435,7 @@
               <a:buNone/>
             </a:pPr>
             <a:r>
-              <a:rPr lang="en-US" sz="760" dirty="0">
+              <a:rPr lang="en-US" sz="740" dirty="0">
                 <a:solidFill>
                   <a:srgbClr val="1A1F2B"/>
                 </a:solidFill>
@@ -2401,7 +2452,7 @@
               <a:buNone/>
             </a:pPr>
             <a:r>
-              <a:rPr lang="en-US" sz="760" dirty="0">
+              <a:rPr lang="en-US" sz="740" dirty="0">
                 <a:solidFill>
                   <a:srgbClr val="1A1F2B"/>
                 </a:solidFill>
@@ -2418,7 +2469,7 @@
               <a:buNone/>
             </a:pPr>
             <a:r>
-              <a:rPr lang="en-US" sz="760" dirty="0">
+              <a:rPr lang="en-US" sz="740" dirty="0">
                 <a:solidFill>
                   <a:srgbClr val="1A1F2B"/>
                 </a:solidFill>
@@ -2435,7 +2486,7 @@
               <a:buNone/>
             </a:pPr>
             <a:r>
-              <a:rPr lang="en-US" sz="760" i="1" dirty="0">
+              <a:rPr lang="en-US" sz="740" i="1" dirty="0">
                 <a:solidFill>
                   <a:srgbClr val="1A1F2B"/>
                 </a:solidFill>
@@ -2452,7 +2503,7 @@
               <a:buNone/>
             </a:pPr>
             <a:r>
-              <a:rPr lang="en-US" sz="760" dirty="0">
+              <a:rPr lang="en-US" sz="740" baseline="-40000" dirty="0">
                 <a:solidFill>
                   <a:srgbClr val="1A1F2B"/>
                 </a:solidFill>
@@ -2460,16 +2511,16 @@
                 <a:ea typeface="Times New Roman" pitchFamily="34" charset="-122"/>
                 <a:cs typeface="Times New Roman" pitchFamily="34" charset="-120"/>
               </a:rPr>
-              <a:t>/</a:t>
-            </a:r>
-            <a:pPr algn="ctr" indent="0" marL="0">
-              <a:lnSpc>
-                <a:spcPct val="100000"/>
-              </a:lnSpc>
-              <a:buNone/>
-            </a:pPr>
-            <a:r>
-              <a:rPr lang="en-US" sz="760" i="1" dirty="0">
+              <a:t>clip</a:t>
+            </a:r>
+            <a:pPr algn="ctr" indent="0" marL="0">
+              <a:lnSpc>
+                <a:spcPct val="100000"/>
+              </a:lnSpc>
+              <a:buNone/>
+            </a:pPr>
+            <a:r>
+              <a:rPr lang="en-US" sz="740" dirty="0">
                 <a:solidFill>
                   <a:srgbClr val="1A1F2B"/>
                 </a:solidFill>
@@ -2477,16 +2528,16 @@
                 <a:ea typeface="Times New Roman" pitchFamily="34" charset="-122"/>
                 <a:cs typeface="Times New Roman" pitchFamily="34" charset="-120"/>
               </a:rPr>
-              <a:t>b</a:t>
-            </a:r>
-            <a:pPr algn="ctr" indent="0" marL="0">
-              <a:lnSpc>
-                <a:spcPct val="100000"/>
-              </a:lnSpc>
-              <a:buNone/>
-            </a:pPr>
-            <a:r>
-              <a:rPr lang="en-US" sz="760" dirty="0">
+              <a:t>/</a:t>
+            </a:r>
+            <a:pPr algn="ctr" indent="0" marL="0">
+              <a:lnSpc>
+                <a:spcPct val="100000"/>
+              </a:lnSpc>
+              <a:buNone/>
+            </a:pPr>
+            <a:r>
+              <a:rPr lang="en-US" sz="740" i="1" dirty="0">
                 <a:solidFill>
                   <a:srgbClr val="1A1F2B"/>
                 </a:solidFill>
@@ -2494,9 +2545,26 @@
                 <a:ea typeface="Times New Roman" pitchFamily="34" charset="-122"/>
                 <a:cs typeface="Times New Roman" pitchFamily="34" charset="-120"/>
               </a:rPr>
+              <a:t>b</a:t>
+            </a:r>
+            <a:pPr algn="ctr" indent="0" marL="0">
+              <a:lnSpc>
+                <a:spcPct val="100000"/>
+              </a:lnSpc>
+              <a:buNone/>
+            </a:pPr>
+            <a:r>
+              <a:rPr lang="en-US" sz="740" dirty="0">
+                <a:solidFill>
+                  <a:srgbClr val="1A1F2B"/>
+                </a:solidFill>
+                <a:latin typeface="Times New Roman" pitchFamily="34" charset="0"/>
+                <a:ea typeface="Times New Roman" pitchFamily="34" charset="-122"/>
+                <a:cs typeface="Times New Roman" pitchFamily="34" charset="-120"/>
+              </a:rPr>
               <a:t>)²)</a:t>
             </a:r>
-            <a:endParaRPr lang="en-US" sz="760" dirty="0"/>
+            <a:endParaRPr lang="en-US" sz="740" dirty="0"/>
           </a:p>
         </p:txBody>
       </p:sp>

</xml_diff>

<commit_message>
Clarify fixed-population privacy accounting
</commit_message>
<xml_diff>
--- a/paper/figures/DPES_Figure1_v2_editable.pptx
+++ b/paper/figures/DPES_Figure1_v2_editable.pptx
@@ -1085,7 +1085,7 @@
                 <a:ea typeface="Arial" pitchFamily="34" charset="-122"/>
                 <a:cs typeface="Arial" pitchFamily="34" charset="-120"/>
               </a:rPr>
-              <a:t>Top-K survivors  </a:t>
+              <a:t>Top-M parents  </a:t>
             </a:r>
             <a:pPr algn="ctr" indent="0" marL="0">
               <a:lnSpc>
@@ -1102,7 +1102,7 @@
                 <a:ea typeface="Arial" pitchFamily="34" charset="-122"/>
                 <a:cs typeface="Arial" pitchFamily="34" charset="-120"/>
               </a:rPr>
-              <a:t>P</a:t>
+              <a:t>S</a:t>
             </a:r>
             <a:pPr algn="ctr" indent="0" marL="0">
               <a:lnSpc>
@@ -1650,16 +1650,16 @@
                 <a:ea typeface="Times New Roman" pitchFamily="34" charset="-122"/>
                 <a:cs typeface="Times New Roman" pitchFamily="34" charset="-120"/>
               </a:rPr>
-              <a:t>p</a:t>
-            </a:r>
-            <a:pPr algn="ctr" indent="0" marL="0">
-              <a:lnSpc>
-                <a:spcPct val="100000"/>
-              </a:lnSpc>
-              <a:buNone/>
-            </a:pPr>
-            <a:r>
-              <a:rPr lang="en-US" sz="760" dirty="0">
+              <a:t>P</a:t>
+            </a:r>
+            <a:pPr algn="ctr" indent="0" marL="0">
+              <a:lnSpc>
+                <a:spcPct val="100000"/>
+              </a:lnSpc>
+              <a:buNone/>
+            </a:pPr>
+            <a:r>
+              <a:rPr lang="en-US" sz="760" baseline="-40000" dirty="0">
                 <a:solidFill>
                   <a:srgbClr val="1A1F2B"/>
                 </a:solidFill>
@@ -1667,16 +1667,16 @@
                 <a:ea typeface="Times New Roman" pitchFamily="34" charset="-122"/>
                 <a:cs typeface="Times New Roman" pitchFamily="34" charset="-120"/>
               </a:rPr>
-              <a:t>′  ∼  Mutate(</a:t>
-            </a:r>
-            <a:pPr algn="ctr" indent="0" marL="0">
-              <a:lnSpc>
-                <a:spcPct val="100000"/>
-              </a:lnSpc>
-              <a:buNone/>
-            </a:pPr>
-            <a:r>
-              <a:rPr lang="en-US" sz="760" i="1" dirty="0">
+              <a:t>t</a:t>
+            </a:r>
+            <a:pPr algn="ctr" indent="0" marL="0">
+              <a:lnSpc>
+                <a:spcPct val="100000"/>
+              </a:lnSpc>
+              <a:buNone/>
+            </a:pPr>
+            <a:r>
+              <a:rPr lang="en-US" sz="760" dirty="0">
                 <a:solidFill>
                   <a:srgbClr val="1A1F2B"/>
                 </a:solidFill>
@@ -1684,16 +1684,16 @@
                 <a:ea typeface="Times New Roman" pitchFamily="34" charset="-122"/>
                 <a:cs typeface="Times New Roman" pitchFamily="34" charset="-120"/>
               </a:rPr>
-              <a:t>p</a:t>
-            </a:r>
-            <a:pPr algn="ctr" indent="0" marL="0">
-              <a:lnSpc>
-                <a:spcPct val="100000"/>
-              </a:lnSpc>
-              <a:buNone/>
-            </a:pPr>
-            <a:r>
-              <a:rPr lang="en-US" sz="760" dirty="0">
+              <a:t>  ←  Mutate-To-K(</a:t>
+            </a:r>
+            <a:pPr algn="ctr" indent="0" marL="0">
+              <a:lnSpc>
+                <a:spcPct val="100000"/>
+              </a:lnSpc>
+              <a:buNone/>
+            </a:pPr>
+            <a:r>
+              <a:rPr lang="en-US" sz="760" i="1" dirty="0">
                 <a:solidFill>
                   <a:srgbClr val="1A1F2B"/>
                 </a:solidFill>
@@ -1701,16 +1701,16 @@
                 <a:ea typeface="Times New Roman" pitchFamily="34" charset="-122"/>
                 <a:cs typeface="Times New Roman" pitchFamily="34" charset="-120"/>
               </a:rPr>
-              <a:t>),   </a:t>
-            </a:r>
-            <a:pPr algn="ctr" indent="0" marL="0">
-              <a:lnSpc>
-                <a:spcPct val="100000"/>
-              </a:lnSpc>
-              <a:buNone/>
-            </a:pPr>
-            <a:r>
-              <a:rPr lang="en-US" sz="760" i="1" dirty="0">
+              <a:t>S</a:t>
+            </a:r>
+            <a:pPr algn="ctr" indent="0" marL="0">
+              <a:lnSpc>
+                <a:spcPct val="100000"/>
+              </a:lnSpc>
+              <a:buNone/>
+            </a:pPr>
+            <a:r>
+              <a:rPr lang="en-US" sz="760" baseline="-40000" dirty="0">
                 <a:solidFill>
                   <a:srgbClr val="1A1F2B"/>
                 </a:solidFill>
@@ -1718,7 +1718,7 @@
                 <a:ea typeface="Times New Roman" pitchFamily="34" charset="-122"/>
                 <a:cs typeface="Times New Roman" pitchFamily="34" charset="-120"/>
               </a:rPr>
-              <a:t>p</a:t>
+              <a:t>t−1</a:t>
             </a:r>
             <a:pPr algn="ctr" indent="0" marL="0">
               <a:lnSpc>
@@ -1735,7 +1735,7 @@
                 <a:ea typeface="Times New Roman" pitchFamily="34" charset="-122"/>
                 <a:cs typeface="Times New Roman" pitchFamily="34" charset="-120"/>
               </a:rPr>
-              <a:t> ∈ </a:t>
+              <a:t>),   |</a:t>
             </a:r>
             <a:pPr algn="ctr" indent="0" marL="0">
               <a:lnSpc>
@@ -1769,7 +1769,41 @@
                 <a:ea typeface="Times New Roman" pitchFamily="34" charset="-122"/>
                 <a:cs typeface="Times New Roman" pitchFamily="34" charset="-120"/>
               </a:rPr>
-              <a:t>t−1</a:t>
+              <a:t>t</a:t>
+            </a:r>
+            <a:pPr algn="ctr" indent="0" marL="0">
+              <a:lnSpc>
+                <a:spcPct val="100000"/>
+              </a:lnSpc>
+              <a:buNone/>
+            </a:pPr>
+            <a:r>
+              <a:rPr lang="en-US" sz="760" dirty="0">
+                <a:solidFill>
+                  <a:srgbClr val="1A1F2B"/>
+                </a:solidFill>
+                <a:latin typeface="Times New Roman" pitchFamily="34" charset="0"/>
+                <a:ea typeface="Times New Roman" pitchFamily="34" charset="-122"/>
+                <a:cs typeface="Times New Roman" pitchFamily="34" charset="-120"/>
+              </a:rPr>
+              <a:t>| = </a:t>
+            </a:r>
+            <a:pPr algn="ctr" indent="0" marL="0">
+              <a:lnSpc>
+                <a:spcPct val="100000"/>
+              </a:lnSpc>
+              <a:buNone/>
+            </a:pPr>
+            <a:r>
+              <a:rPr lang="en-US" sz="760" i="1" dirty="0">
+                <a:solidFill>
+                  <a:srgbClr val="1A1F2B"/>
+                </a:solidFill>
+                <a:latin typeface="Times New Roman" pitchFamily="34" charset="0"/>
+                <a:ea typeface="Times New Roman" pitchFamily="34" charset="-122"/>
+                <a:cs typeface="Times New Roman" pitchFamily="34" charset="-120"/>
+              </a:rPr>
+              <a:t>K</a:t>
             </a:r>
             <a:endParaRPr lang="en-US" sz="760" dirty="0"/>
           </a:p>
@@ -1811,7 +1845,7 @@
                 <a:ea typeface="Arial" pitchFamily="34" charset="-122"/>
                 <a:cs typeface="Arial" pitchFamily="34" charset="-120"/>
               </a:rPr>
-              <a:t>Uses only parent prompts and public randomness; never reads the private set </a:t>
+              <a:t>Builds a fixed K-candidate population from selected parents; never reads the private set </a:t>
             </a:r>
             <a:pPr algn="l" indent="0" marL="0">
               <a:lnSpc>
@@ -2959,7 +2993,7 @@
                 <a:ea typeface="Times New Roman" pitchFamily="34" charset="-122"/>
                 <a:cs typeface="Times New Roman" pitchFamily="34" charset="-120"/>
               </a:rPr>
-              <a:t>Top-K(private scores)</a:t>
+              <a:t>Top-M(privatized scores)</a:t>
             </a:r>
             <a:endParaRPr lang="en-US" sz="720" dirty="0"/>
           </a:p>
@@ -3001,7 +3035,7 @@
                 <a:ea typeface="Arial" pitchFamily="34" charset="-122"/>
                 <a:cs typeface="Arial" pitchFamily="34" charset="-120"/>
               </a:rPr>
-              <a:t>Top-K uses only released scores; both options are post-processing.</a:t>
+              <a:t>Top-M uses only released scores; both options are post-processing.</a:t>
             </a:r>
             <a:endParaRPr lang="en-US" sz="660" dirty="0"/>
           </a:p>
@@ -3546,7 +3580,7 @@
                 <a:ea typeface="Arial" pitchFamily="34" charset="-122"/>
                 <a:cs typeface="Arial" pitchFamily="34" charset="-120"/>
               </a:rPr>
-              <a:t>private scores</a:t>
+              <a:t>privatized scores</a:t>
             </a:r>
             <a:endParaRPr lang="en-US" sz="680" dirty="0"/>
           </a:p>
@@ -4323,7 +4357,7 @@
                           <a:ea typeface="Arial" pitchFamily="34" charset="-122"/>
                           <a:cs typeface="Arial" pitchFamily="34" charset="-120"/>
                         </a:rPr>
-                        <a:t>Top-K on privatized scores; alternatives persist</a:t>
+                        <a:t>Top-M on privatized scores; alternatives persist</a:t>
                       </a:r>
                       <a:endParaRPr lang="en-US" sz="1200" dirty="0"/>
                     </a:p>

</xml_diff>

<commit_message>
State worst-case score release count
</commit_message>
<xml_diff>
--- a/paper/figures/DPES_Figure1_v2_editable.pptx
+++ b/paper/figures/DPES_Figure1_v2_editable.pptx
@@ -2728,6 +2728,23 @@
               <a:buNone/>
             </a:pPr>
             <a:r>
+              <a:rPr lang="en-US" sz="640" b="1" dirty="0">
+                <a:solidFill>
+                  <a:srgbClr val="FFFFFF"/>
+                </a:solidFill>
+                <a:latin typeface="Arial" pitchFamily="34" charset="0"/>
+                <a:ea typeface="Arial" pitchFamily="34" charset="-122"/>
+                <a:cs typeface="Arial" pitchFamily="34" charset="-120"/>
+              </a:rPr>
+              <a:t>≤ </a:t>
+            </a:r>
+            <a:pPr algn="ctr" indent="0" marL="0">
+              <a:lnSpc>
+                <a:spcPct val="100000"/>
+              </a:lnSpc>
+              <a:buNone/>
+            </a:pPr>
+            <a:r>
               <a:rPr lang="en-US" sz="640" b="1" i="1" dirty="0">
                 <a:solidFill>
                   <a:srgbClr val="FFFFFF"/>
@@ -3666,7 +3683,7 @@
                 <a:ea typeface="Arial" pitchFamily="34" charset="-122"/>
                 <a:cs typeface="Arial" pitchFamily="34" charset="-120"/>
               </a:rPr>
-              <a:t>  only the </a:t>
+              <a:t>  at most </a:t>
             </a:r>
             <a:pPr algn="ctr" indent="0" marL="0">
               <a:lnSpc>

</xml_diff>

<commit_message>
Increase camera-ready figure legibility
</commit_message>
<xml_diff>
--- a/paper/figures/DPES_Figure1_v2_editable.pptx
+++ b/paper/figures/DPES_Figure1_v2_editable.pptx
@@ -1,17 +1,17 @@
 
 <file path=ppt/presentation.xml><?xml version="1.0" encoding="utf-8"?>
-<p:presentation xmlns:a="http://schemas.openxmlformats.org/drawingml/2006/main" xmlns:r="http://schemas.openxmlformats.org/officeDocument/2006/relationships" xmlns:p="http://schemas.openxmlformats.org/presentationml/2006/main" saveSubsetFonts="1" autoCompressPictures="0">
+<p:presentation xmlns:a="http://schemas.openxmlformats.org/drawingml/2006/main" xmlns:r="http://schemas.openxmlformats.org/officeDocument/2006/relationships" xmlns:p="http://schemas.openxmlformats.org/presentationml/2006/main" autoCompressPictures="0">
   <p:sldMasterIdLst>
     <p:sldMasterId id="2147483648" r:id="rId1"/>
   </p:sldMasterIdLst>
+  <p:notesMasterIdLst>
+    <p:notesMasterId r:id="rId4"/>
+  </p:notesMasterIdLst>
   <p:sldIdLst>
-    <p:sldId id="256" r:id="rId2"/>
+    <p:sldId id="256" r:id="rId3"/>
   </p:sldIdLst>
-  <p:notesMasterIdLst>
-    <p:notesMasterId r:id="rId3"/>
-  </p:notesMasterIdLst>
-  <p:sldSz cx="5760720" cy="4453128"/>
-  <p:notesSz cx="4453128" cy="5760720"/>
+  <p:sldSz cx="5760720" cy="4452620"/>
+  <p:notesSz cx="4452620" cy="5760720"/>
   <p:defaultTextStyle>
     <a:lvl1pPr marL="0" algn="l" defTabSz="914400" rtl="0" eaLnBrk="1" latinLnBrk="0" hangingPunct="1">
       <a:defRPr sz="1800" kern="1200">
@@ -189,7 +189,6 @@
           <a:p>
             <a:fld id="{5282F153-3F37-0F45-9E97-73ACFA13230C}" type="datetimeFigureOut">
               <a:rPr lang="en-US"/>
-              <a:t>7/23/19</a:t>
             </a:fld>
             <a:endParaRPr lang="en-US"/>
           </a:p>
@@ -256,6 +255,7 @@
               <a:rPr lang="en-US"/>
               <a:t>Click to edit Master text styles</a:t>
             </a:r>
+            <a:endParaRPr lang="en-US"/>
           </a:p>
           <a:p>
             <a:pPr lvl="1"/>
@@ -263,6 +263,7 @@
               <a:rPr lang="en-US"/>
               <a:t>Second level</a:t>
             </a:r>
+            <a:endParaRPr lang="en-US"/>
           </a:p>
           <a:p>
             <a:pPr lvl="2"/>
@@ -270,6 +271,7 @@
               <a:rPr lang="en-US"/>
               <a:t>Third level</a:t>
             </a:r>
+            <a:endParaRPr lang="en-US"/>
           </a:p>
           <a:p>
             <a:pPr lvl="3"/>
@@ -277,6 +279,7 @@
               <a:rPr lang="en-US"/>
               <a:t>Fourth level</a:t>
             </a:r>
+            <a:endParaRPr lang="en-US"/>
           </a:p>
           <a:p>
             <a:pPr lvl="4"/>
@@ -284,6 +287,7 @@
               <a:rPr lang="en-US"/>
               <a:t>Fifth level</a:t>
             </a:r>
+            <a:endParaRPr lang="en-US"/>
           </a:p>
         </p:txBody>
       </p:sp>
@@ -347,18 +351,12 @@
           <a:p>
             <a:fld id="{CE5E9CC1-C706-0F49-92D6-E571CC5EEA8F}" type="slidenum">
               <a:rPr lang="en-US"/>
-              <a:t>‹#›</a:t>
             </a:fld>
             <a:endParaRPr lang="en-US"/>
           </a:p>
         </p:txBody>
       </p:sp>
     </p:spTree>
-    <p:extLst>
-      <p:ext uri="{BB962C8B-B14F-4D97-AF65-F5344CB8AC3E}">
-        <p14:creationId xmlns:p14="http://schemas.microsoft.com/office/powerpoint/2010/main" val="1024086991"/>
-      </p:ext>
-    </p:extLst>
   </p:cSld>
   <p:clrMap bg1="lt1" tx1="dk1" bg2="lt2" tx2="dk2" accent1="accent1" accent2="accent2" accent3="accent3" accent4="accent4" accent5="accent5" accent6="accent6" hlink="hlink" folHlink="folHlink"/>
   <p:notesStyle>
@@ -500,10 +498,6 @@
           <a:bodyPr/>
           <a:lstStyle/>
           <a:p>
-            <a:r>
-              <a:rPr lang="en-US" dirty="0"/>
-              <a:t/>
-            </a:r>
             <a:endParaRPr lang="en-US" dirty="0"/>
           </a:p>
         </p:txBody>
@@ -525,18 +519,12 @@
           <a:p>
             <a:fld id="{F7021451-1387-4CA6-816F-3879F97B5CBC}" type="slidenum">
               <a:rPr lang="en-US"/>
-              <a:t>1</a:t>
             </a:fld>
             <a:endParaRPr lang="en-US"/>
           </a:p>
         </p:txBody>
       </p:sp>
     </p:spTree>
-    <p:extLst>
-      <p:ext uri="{BB962C8B-B14F-4D97-AF65-F5344CB8AC3E}">
-        <p14:creationId xmlns:p14="http://schemas.microsoft.com/office/powerpoint/2010/main" val="1024086991"/>
-      </p:ext>
-    </p:extLst>
   </p:cSld>
   <p:clrMapOvr>
     <a:masterClrMapping/>
@@ -577,6 +565,11 @@
 <file path=ppt/slideMasters/slideMaster1.xml><?xml version="1.0" encoding="utf-8"?>
 <p:sldMaster xmlns:a="http://schemas.openxmlformats.org/drawingml/2006/main" xmlns:r="http://schemas.openxmlformats.org/officeDocument/2006/relationships" xmlns:p="http://schemas.openxmlformats.org/presentationml/2006/main">
   <p:cSld>
+    <p:bg>
+      <p:bgRef idx="1001">
+        <a:schemeClr val="bg1"/>
+      </p:bgRef>
+    </p:bg>
     <p:spTree>
       <p:nvGrpSpPr>
         <p:cNvPr id="1" name=""/>
@@ -620,7 +613,7 @@
         <a:spcBef>
           <a:spcPct val="20000"/>
         </a:spcBef>
-        <a:buFont typeface="Arial" pitchFamily="34" charset="0"/>
+        <a:buFont typeface="Arial" panose="020B0604020202090204" pitchFamily="34" charset="0"/>
         <a:buChar char="•"/>
         <a:defRPr sz="3200" kern="1200">
           <a:solidFill>
@@ -635,7 +628,7 @@
         <a:spcBef>
           <a:spcPct val="20000"/>
         </a:spcBef>
-        <a:buFont typeface="Arial" pitchFamily="34" charset="0"/>
+        <a:buFont typeface="Arial" panose="020B0604020202090204" pitchFamily="34" charset="0"/>
         <a:buChar char="–"/>
         <a:defRPr sz="2800" kern="1200">
           <a:solidFill>
@@ -650,7 +643,7 @@
         <a:spcBef>
           <a:spcPct val="20000"/>
         </a:spcBef>
-        <a:buFont typeface="Arial" pitchFamily="34" charset="0"/>
+        <a:buFont typeface="Arial" panose="020B0604020202090204" pitchFamily="34" charset="0"/>
         <a:buChar char="•"/>
         <a:defRPr sz="2400" kern="1200">
           <a:solidFill>
@@ -665,7 +658,7 @@
         <a:spcBef>
           <a:spcPct val="20000"/>
         </a:spcBef>
-        <a:buFont typeface="Arial" pitchFamily="34" charset="0"/>
+        <a:buFont typeface="Arial" panose="020B0604020202090204" pitchFamily="34" charset="0"/>
         <a:buChar char="–"/>
         <a:defRPr sz="2000" kern="1200">
           <a:solidFill>
@@ -680,7 +673,7 @@
         <a:spcBef>
           <a:spcPct val="20000"/>
         </a:spcBef>
-        <a:buFont typeface="Arial" pitchFamily="34" charset="0"/>
+        <a:buFont typeface="Arial" panose="020B0604020202090204" pitchFamily="34" charset="0"/>
         <a:buChar char="»"/>
         <a:defRPr sz="2000" kern="1200">
           <a:solidFill>
@@ -695,7 +688,7 @@
         <a:spcBef>
           <a:spcPct val="20000"/>
         </a:spcBef>
-        <a:buFont typeface="Arial" pitchFamily="34" charset="0"/>
+        <a:buFont typeface="Arial" panose="020B0604020202090204" pitchFamily="34" charset="0"/>
         <a:buChar char="•"/>
         <a:defRPr sz="2000" kern="1200">
           <a:solidFill>
@@ -710,7 +703,7 @@
         <a:spcBef>
           <a:spcPct val="20000"/>
         </a:spcBef>
-        <a:buFont typeface="Arial" pitchFamily="34" charset="0"/>
+        <a:buFont typeface="Arial" panose="020B0604020202090204" pitchFamily="34" charset="0"/>
         <a:buChar char="•"/>
         <a:defRPr sz="2000" kern="1200">
           <a:solidFill>
@@ -725,7 +718,7 @@
         <a:spcBef>
           <a:spcPct val="20000"/>
         </a:spcBef>
-        <a:buFont typeface="Arial" pitchFamily="34" charset="0"/>
+        <a:buFont typeface="Arial" panose="020B0604020202090204" pitchFamily="34" charset="0"/>
         <a:buChar char="•"/>
         <a:defRPr sz="2000" kern="1200">
           <a:solidFill>
@@ -740,7 +733,7 @@
         <a:spcBef>
           <a:spcPct val="20000"/>
         </a:spcBef>
-        <a:buFont typeface="Arial" pitchFamily="34" charset="0"/>
+        <a:buFont typeface="Arial" panose="020B0604020202090204" pitchFamily="34" charset="0"/>
         <a:buChar char="•"/>
         <a:defRPr sz="2000" kern="1200">
           <a:solidFill>
@@ -853,12 +846,13 @@
 
 <file path=ppt/slides/slide1.xml><?xml version="1.0" encoding="utf-8"?>
 <p:sld xmlns:a="http://schemas.openxmlformats.org/drawingml/2006/main" xmlns:r="http://schemas.openxmlformats.org/officeDocument/2006/relationships" xmlns:p="http://schemas.openxmlformats.org/presentationml/2006/main">
-  <p:cSld name="Slide 1">
+  <p:cSld>
     <p:bg>
       <p:bgPr>
         <a:solidFill>
           <a:srgbClr val="FFFFFF"/>
         </a:solidFill>
+        <a:effectLst/>
       </p:bgPr>
     </p:bg>
     <p:spTree>
@@ -890,13 +884,12 @@
             <a:avLst/>
           </a:prstGeom>
           <a:noFill/>
-          <a:ln/>
         </p:spPr>
         <p:txBody>
           <a:bodyPr wrap="square" lIns="0" tIns="0" rIns="0" bIns="0" rtlCol="0" anchor="t"/>
           <a:lstStyle/>
           <a:p>
-            <a:pPr algn="l" indent="0" marL="0">
+            <a:pPr marL="0" indent="0" algn="l">
               <a:lnSpc>
                 <a:spcPct val="100000"/>
               </a:lnSpc>
@@ -907,43 +900,31 @@
                 <a:solidFill>
                   <a:srgbClr val="1A1F2B"/>
                 </a:solidFill>
-                <a:latin typeface="Arial" pitchFamily="34" charset="0"/>
-                <a:ea typeface="Arial" pitchFamily="34" charset="-122"/>
-                <a:cs typeface="Arial" pitchFamily="34" charset="-120"/>
+                <a:latin typeface="Arial" panose="020B0604020202090204" pitchFamily="34" charset="0"/>
+                <a:ea typeface="Arial" panose="020B0604020202090204" pitchFamily="34" charset="-122"/>
+                <a:cs typeface="Arial" panose="020B0604020202090204" pitchFamily="34" charset="-120"/>
               </a:rPr>
               <a:t>(a)   One </a:t>
             </a:r>
-            <a:pPr algn="l" indent="0" marL="0">
-              <a:lnSpc>
-                <a:spcPct val="100000"/>
-              </a:lnSpc>
-              <a:buNone/>
-            </a:pPr>
             <a:r>
               <a:rPr lang="en-US" sz="900" b="1" dirty="0">
                 <a:solidFill>
                   <a:srgbClr val="1A1F2B"/>
                 </a:solidFill>
-                <a:latin typeface="Arial" pitchFamily="34" charset="0"/>
-                <a:ea typeface="Arial" pitchFamily="34" charset="-122"/>
-                <a:cs typeface="Arial" pitchFamily="34" charset="-120"/>
+                <a:latin typeface="Arial" panose="020B0604020202090204" pitchFamily="34" charset="0"/>
+                <a:ea typeface="Arial" panose="020B0604020202090204" pitchFamily="34" charset="-122"/>
+                <a:cs typeface="Arial" panose="020B0604020202090204" pitchFamily="34" charset="-120"/>
               </a:rPr>
               <a:t>DP-ES</a:t>
             </a:r>
-            <a:pPr algn="l" indent="0" marL="0">
-              <a:lnSpc>
-                <a:spcPct val="100000"/>
-              </a:lnSpc>
-              <a:buNone/>
-            </a:pPr>
             <a:r>
               <a:rPr lang="en-US" sz="900" b="1" dirty="0">
                 <a:solidFill>
                   <a:srgbClr val="1A1F2B"/>
                 </a:solidFill>
-                <a:latin typeface="Arial" pitchFamily="34" charset="0"/>
-                <a:ea typeface="Arial" pitchFamily="34" charset="-122"/>
-                <a:cs typeface="Arial" pitchFamily="34" charset="-120"/>
+                <a:latin typeface="Arial" panose="020B0604020202090204" pitchFamily="34" charset="0"/>
+                <a:ea typeface="Arial" panose="020B0604020202090204" pitchFamily="34" charset="-122"/>
+                <a:cs typeface="Arial" panose="020B0604020202090204" pitchFamily="34" charset="-120"/>
               </a:rPr>
               <a:t> iteration: privacy-free exploration, private scoring</a:t>
             </a:r>
@@ -1057,20 +1038,19 @@
         </p:nvSpPr>
         <p:spPr>
           <a:xfrm>
-            <a:off x="1691640" y="315468"/>
+            <a:off x="1691640" y="307848"/>
             <a:ext cx="2377440" cy="118872"/>
           </a:xfrm>
           <a:prstGeom prst="rect">
             <a:avLst/>
           </a:prstGeom>
           <a:noFill/>
-          <a:ln/>
         </p:spPr>
         <p:txBody>
           <a:bodyPr wrap="square" lIns="0" tIns="0" rIns="0" bIns="0" rtlCol="0" anchor="t"/>
           <a:lstStyle/>
           <a:p>
-            <a:pPr algn="ctr" indent="0" marL="0">
+            <a:pPr marL="0" indent="0" algn="ctr">
               <a:lnSpc>
                 <a:spcPct val="100000"/>
               </a:lnSpc>
@@ -1081,94 +1061,86 @@
                 <a:solidFill>
                   <a:srgbClr val="1F3D7A"/>
                 </a:solidFill>
-                <a:latin typeface="Arial" pitchFamily="34" charset="0"/>
-                <a:ea typeface="Arial" pitchFamily="34" charset="-122"/>
-                <a:cs typeface="Arial" pitchFamily="34" charset="-120"/>
+                <a:latin typeface="Arial" panose="020B0604020202090204" pitchFamily="34" charset="0"/>
+                <a:ea typeface="Arial" panose="020B0604020202090204" pitchFamily="34" charset="-122"/>
+                <a:cs typeface="Arial" panose="020B0604020202090204" pitchFamily="34" charset="-120"/>
               </a:rPr>
               <a:t>Top-M parents  </a:t>
             </a:r>
-            <a:pPr algn="ctr" indent="0" marL="0">
-              <a:lnSpc>
-                <a:spcPct val="100000"/>
-              </a:lnSpc>
-              <a:buNone/>
-            </a:pPr>
             <a:r>
               <a:rPr lang="en-US" sz="680" b="1" i="1" dirty="0">
                 <a:solidFill>
                   <a:srgbClr val="1F3D7A"/>
                 </a:solidFill>
-                <a:latin typeface="Arial" pitchFamily="34" charset="0"/>
-                <a:ea typeface="Arial" pitchFamily="34" charset="-122"/>
-                <a:cs typeface="Arial" pitchFamily="34" charset="-120"/>
+                <a:latin typeface="Arial" panose="020B0604020202090204" pitchFamily="34" charset="0"/>
+                <a:ea typeface="Arial" panose="020B0604020202090204" pitchFamily="34" charset="-122"/>
+                <a:cs typeface="Arial" panose="020B0604020202090204" pitchFamily="34" charset="-120"/>
               </a:rPr>
               <a:t>S</a:t>
             </a:r>
-            <a:pPr algn="ctr" indent="0" marL="0">
-              <a:lnSpc>
-                <a:spcPct val="100000"/>
-              </a:lnSpc>
-              <a:buNone/>
-            </a:pPr>
             <a:r>
               <a:rPr lang="en-US" sz="680" b="1" baseline="-40000" dirty="0">
                 <a:solidFill>
                   <a:srgbClr val="1F3D7A"/>
                 </a:solidFill>
-                <a:latin typeface="Arial" pitchFamily="34" charset="0"/>
-                <a:ea typeface="Arial" pitchFamily="34" charset="-122"/>
-                <a:cs typeface="Arial" pitchFamily="34" charset="-120"/>
+                <a:latin typeface="Arial" panose="020B0604020202090204" pitchFamily="34" charset="0"/>
+                <a:ea typeface="Arial" panose="020B0604020202090204" pitchFamily="34" charset="-122"/>
+                <a:cs typeface="Arial" panose="020B0604020202090204" pitchFamily="34" charset="-120"/>
               </a:rPr>
               <a:t>t</a:t>
             </a:r>
-            <a:pPr algn="ctr" indent="0" marL="0">
-              <a:lnSpc>
-                <a:spcPct val="100000"/>
-              </a:lnSpc>
-              <a:buNone/>
-            </a:pPr>
             <a:r>
               <a:rPr lang="en-US" sz="680" b="1" dirty="0">
                 <a:solidFill>
                   <a:srgbClr val="1F3D7A"/>
                 </a:solidFill>
-                <a:latin typeface="Arial" pitchFamily="34" charset="0"/>
-                <a:ea typeface="Arial" pitchFamily="34" charset="-122"/>
-                <a:cs typeface="Arial" pitchFamily="34" charset="-120"/>
-              </a:rPr>
-              <a:t>  →  next iteration  (× </a:t>
-            </a:r>
-            <a:pPr algn="ctr" indent="0" marL="0">
-              <a:lnSpc>
-                <a:spcPct val="100000"/>
-              </a:lnSpc>
-              <a:buNone/>
-            </a:pPr>
+                <a:latin typeface="Arial" panose="020B0604020202090204" pitchFamily="34" charset="0"/>
+                <a:ea typeface="Arial" panose="020B0604020202090204" pitchFamily="34" charset="-122"/>
+                <a:cs typeface="Arial" panose="020B0604020202090204" pitchFamily="34" charset="-120"/>
+              </a:rPr>
+              <a:t>  </a:t>
+            </a:r>
+            <a:r>
+              <a:rPr lang="en-US" sz="800" b="1" dirty="0">
+                <a:solidFill>
+                  <a:srgbClr val="1F3D7A"/>
+                </a:solidFill>
+                <a:latin typeface="Arial" panose="020B0604020202090204" pitchFamily="34" charset="0"/>
+                <a:ea typeface="Arial" panose="020B0604020202090204" pitchFamily="34" charset="-122"/>
+                <a:cs typeface="Arial" panose="020B0604020202090204" pitchFamily="34" charset="0"/>
+              </a:rPr>
+              <a:t>→</a:t>
+            </a:r>
+            <a:r>
+              <a:rPr lang="en-US" sz="680" b="1" dirty="0">
+                <a:solidFill>
+                  <a:srgbClr val="1F3D7A"/>
+                </a:solidFill>
+                <a:latin typeface="Arial" panose="020B0604020202090204" pitchFamily="34" charset="0"/>
+                <a:ea typeface="Arial" panose="020B0604020202090204" pitchFamily="34" charset="-122"/>
+                <a:cs typeface="Arial" panose="020B0604020202090204" pitchFamily="34" charset="-120"/>
+              </a:rPr>
+              <a:t>  next iteration  (× </a:t>
+            </a:r>
             <a:r>
               <a:rPr lang="en-US" sz="680" b="1" i="1" dirty="0">
                 <a:solidFill>
                   <a:srgbClr val="1F3D7A"/>
                 </a:solidFill>
-                <a:latin typeface="Arial" pitchFamily="34" charset="0"/>
-                <a:ea typeface="Arial" pitchFamily="34" charset="-122"/>
-                <a:cs typeface="Arial" pitchFamily="34" charset="-120"/>
-              </a:rPr>
-              <a:t>T</a:t>
-            </a:r>
-            <a:pPr algn="ctr" indent="0" marL="0">
-              <a:lnSpc>
-                <a:spcPct val="100000"/>
-              </a:lnSpc>
-              <a:buNone/>
-            </a:pPr>
+                <a:latin typeface="Arial" panose="020B0604020202090204" pitchFamily="34" charset="0"/>
+                <a:ea typeface="Arial" panose="020B0604020202090204" pitchFamily="34" charset="-122"/>
+                <a:cs typeface="Arial" panose="020B0604020202090204" pitchFamily="34" charset="-120"/>
+              </a:rPr>
+              <a:t>T </a:t>
+            </a:r>
             <a:r>
               <a:rPr lang="en-US" sz="680" b="1" dirty="0">
                 <a:solidFill>
                   <a:srgbClr val="1F3D7A"/>
                 </a:solidFill>
-                <a:latin typeface="Arial" pitchFamily="34" charset="0"/>
-                <a:ea typeface="Arial" pitchFamily="34" charset="-122"/>
-                <a:cs typeface="Arial" pitchFamily="34" charset="-120"/>
+                <a:latin typeface="Arial" panose="020B0604020202090204" pitchFamily="34" charset="0"/>
+                <a:ea typeface="Arial" panose="020B0604020202090204" pitchFamily="34" charset="-122"/>
+                <a:cs typeface="Arial" panose="020B0604020202090204" pitchFamily="34" charset="-120"/>
               </a:rPr>
               <a:t>)</a:t>
             </a:r>
@@ -1218,26 +1190,25 @@
             <a:avLst/>
           </a:prstGeom>
           <a:noFill/>
-          <a:ln/>
         </p:spPr>
         <p:txBody>
           <a:bodyPr wrap="square" lIns="0" tIns="0" rIns="0" bIns="0" rtlCol="0" anchor="t"/>
           <a:lstStyle/>
           <a:p>
-            <a:pPr algn="ctr" indent="0" marL="0">
+            <a:pPr marL="0" indent="0" algn="ctr">
               <a:lnSpc>
                 <a:spcPct val="100000"/>
               </a:lnSpc>
               <a:buNone/>
             </a:pPr>
             <a:r>
-              <a:rPr lang="en-US" sz="760" b="1" spc="35" kern="0" dirty="0">
+              <a:rPr lang="en-US" sz="760" b="1" kern="0" spc="35" dirty="0">
                 <a:solidFill>
                   <a:srgbClr val="0E7C7B"/>
                 </a:solidFill>
-                <a:latin typeface="Arial" pitchFamily="34" charset="0"/>
-                <a:ea typeface="Arial" pitchFamily="34" charset="-122"/>
-                <a:cs typeface="Arial" pitchFamily="34" charset="-120"/>
+                <a:latin typeface="Arial" panose="020B0604020202090204" pitchFamily="34" charset="0"/>
+                <a:ea typeface="Arial" panose="020B0604020202090204" pitchFamily="34" charset="-122"/>
+                <a:cs typeface="Arial" panose="020B0604020202090204" pitchFamily="34" charset="-120"/>
               </a:rPr>
               <a:t>PRIVACY-FREE</a:t>
             </a:r>
@@ -1287,26 +1258,25 @@
             <a:avLst/>
           </a:prstGeom>
           <a:noFill/>
-          <a:ln/>
         </p:spPr>
         <p:txBody>
           <a:bodyPr wrap="square" lIns="0" tIns="0" rIns="0" bIns="0" rtlCol="0" anchor="t"/>
           <a:lstStyle/>
           <a:p>
-            <a:pPr algn="ctr" indent="0" marL="0">
+            <a:pPr marL="0" indent="0" algn="ctr">
               <a:lnSpc>
                 <a:spcPct val="100000"/>
               </a:lnSpc>
               <a:buNone/>
             </a:pPr>
             <a:r>
-              <a:rPr lang="en-US" sz="760" b="1" spc="35" kern="0" dirty="0">
+              <a:rPr lang="en-US" sz="760" b="1" kern="0" spc="35" dirty="0">
                 <a:solidFill>
                   <a:srgbClr val="1F3D7A"/>
                 </a:solidFill>
-                <a:latin typeface="Arial" pitchFamily="34" charset="0"/>
-                <a:ea typeface="Arial" pitchFamily="34" charset="-122"/>
-                <a:cs typeface="Arial" pitchFamily="34" charset="-120"/>
+                <a:latin typeface="Arial" panose="020B0604020202090204" pitchFamily="34" charset="0"/>
+                <a:ea typeface="Arial" panose="020B0604020202090204" pitchFamily="34" charset="-122"/>
+                <a:cs typeface="Arial" panose="020B0604020202090204" pitchFamily="34" charset="-120"/>
               </a:rPr>
               <a:t>PRIVATE-DATA ACCESS</a:t>
             </a:r>
@@ -1356,26 +1326,25 @@
             <a:avLst/>
           </a:prstGeom>
           <a:noFill/>
-          <a:ln/>
         </p:spPr>
         <p:txBody>
           <a:bodyPr wrap="square" lIns="0" tIns="0" rIns="0" bIns="0" rtlCol="0" anchor="t"/>
           <a:lstStyle/>
           <a:p>
-            <a:pPr algn="ctr" indent="0" marL="0">
+            <a:pPr marL="0" indent="0" algn="ctr">
               <a:lnSpc>
                 <a:spcPct val="100000"/>
               </a:lnSpc>
               <a:buNone/>
             </a:pPr>
             <a:r>
-              <a:rPr lang="en-US" sz="760" b="1" spc="35" kern="0" dirty="0">
+              <a:rPr lang="en-US" sz="760" b="1" kern="0" spc="35" dirty="0">
                 <a:solidFill>
                   <a:srgbClr val="2E7D32"/>
                 </a:solidFill>
-                <a:latin typeface="Arial" pitchFamily="34" charset="0"/>
-                <a:ea typeface="Arial" pitchFamily="34" charset="-122"/>
-                <a:cs typeface="Arial" pitchFamily="34" charset="-120"/>
+                <a:latin typeface="Arial" panose="020B0604020202090204" pitchFamily="34" charset="0"/>
+                <a:ea typeface="Arial" panose="020B0604020202090204" pitchFamily="34" charset="-122"/>
+                <a:cs typeface="Arial" panose="020B0604020202090204" pitchFamily="34" charset="-120"/>
               </a:rPr>
               <a:t>POST-PROCESSING</a:t>
             </a:r>
@@ -1427,7 +1396,6 @@
           <a:solidFill>
             <a:srgbClr val="0E7C7B"/>
           </a:solidFill>
-          <a:ln/>
         </p:spPr>
       </p:sp>
       <p:sp>
@@ -1567,13 +1535,12 @@
             <a:avLst/>
           </a:prstGeom>
           <a:noFill/>
-          <a:ln/>
         </p:spPr>
         <p:txBody>
           <a:bodyPr wrap="square" lIns="0" tIns="0" rIns="0" bIns="0" rtlCol="0" anchor="ctr"/>
           <a:lstStyle/>
           <a:p>
-            <a:pPr algn="ctr" indent="0" marL="0">
+            <a:pPr marL="0" indent="0" algn="ctr">
               <a:lnSpc>
                 <a:spcPct val="104000"/>
               </a:lnSpc>
@@ -1584,16 +1551,16 @@
                 <a:solidFill>
                   <a:srgbClr val="0E7C7B"/>
                 </a:solidFill>
-                <a:latin typeface="Arial" pitchFamily="34" charset="0"/>
-                <a:ea typeface="Arial" pitchFamily="34" charset="-122"/>
-                <a:cs typeface="Arial" pitchFamily="34" charset="-120"/>
+                <a:latin typeface="Arial" panose="020B0604020202090204" pitchFamily="34" charset="0"/>
+                <a:ea typeface="Arial" panose="020B0604020202090204" pitchFamily="34" charset="-122"/>
+                <a:cs typeface="Arial" panose="020B0604020202090204" pitchFamily="34" charset="-120"/>
               </a:rPr>
               <a:t>Phase 1</a:t>
             </a:r>
             <a:endParaRPr lang="en-US" sz="780" dirty="0"/>
           </a:p>
           <a:p>
-            <a:pPr algn="ctr" indent="0" marL="0">
+            <a:pPr marL="0" indent="0" algn="ctr">
               <a:lnSpc>
                 <a:spcPct val="104000"/>
               </a:lnSpc>
@@ -1604,9 +1571,9 @@
                 <a:solidFill>
                   <a:srgbClr val="0E7C7B"/>
                 </a:solidFill>
-                <a:latin typeface="Arial" pitchFamily="34" charset="0"/>
-                <a:ea typeface="Arial" pitchFamily="34" charset="-122"/>
-                <a:cs typeface="Arial" pitchFamily="34" charset="-120"/>
+                <a:latin typeface="Arial" panose="020B0604020202090204" pitchFamily="34" charset="0"/>
+                <a:ea typeface="Arial" panose="020B0604020202090204" pitchFamily="34" charset="-122"/>
+                <a:cs typeface="Arial" panose="020B0604020202090204" pitchFamily="34" charset="-120"/>
               </a:rPr>
               <a:t>LLM mutation</a:t>
             </a:r>
@@ -1622,326 +1589,297 @@
         </p:nvSpPr>
         <p:spPr>
           <a:xfrm>
-            <a:off x="256032" y="1353312"/>
-            <a:ext cx="1493520" cy="118872"/>
+            <a:off x="210312" y="1273302"/>
+            <a:ext cx="1581912" cy="118872"/>
           </a:xfrm>
           <a:prstGeom prst="rect">
             <a:avLst/>
           </a:prstGeom>
           <a:noFill/>
-          <a:ln/>
         </p:spPr>
         <p:txBody>
           <a:bodyPr wrap="square" lIns="0" tIns="0" rIns="0" bIns="0" rtlCol="0" anchor="t"/>
           <a:lstStyle/>
           <a:p>
-            <a:pPr algn="ctr" indent="0" marL="0">
+            <a:pPr marL="0" indent="0" algn="ctr">
               <a:lnSpc>
                 <a:spcPct val="100000"/>
               </a:lnSpc>
               <a:buNone/>
             </a:pPr>
             <a:r>
-              <a:rPr lang="en-US" sz="760" i="1" dirty="0">
+              <a:rPr lang="en-US" sz="800" i="1" dirty="0">
                 <a:solidFill>
                   <a:srgbClr val="1A1F2B"/>
                 </a:solidFill>
-                <a:latin typeface="Times New Roman" pitchFamily="34" charset="0"/>
-                <a:ea typeface="Times New Roman" pitchFamily="34" charset="-122"/>
-                <a:cs typeface="Times New Roman" pitchFamily="34" charset="-120"/>
+                <a:latin typeface="Times New Roman Regular" panose="02020503050405090304" charset="0"/>
+                <a:ea typeface="Times New Roman" panose="02020503050405090304" pitchFamily="34" charset="-122"/>
+                <a:cs typeface="Times New Roman Regular" panose="02020503050405090304" charset="0"/>
               </a:rPr>
               <a:t>P</a:t>
             </a:r>
-            <a:pPr algn="ctr" indent="0" marL="0">
+            <a:r>
+              <a:rPr lang="en-US" sz="800" baseline="-40000" dirty="0">
+                <a:solidFill>
+                  <a:srgbClr val="1A1F2B"/>
+                </a:solidFill>
+                <a:latin typeface="Times New Roman Regular" panose="02020503050405090304" charset="0"/>
+                <a:ea typeface="Times New Roman" panose="02020503050405090304" pitchFamily="34" charset="-122"/>
+                <a:cs typeface="Times New Roman Regular" panose="02020503050405090304" charset="0"/>
+              </a:rPr>
+              <a:t>t</a:t>
+            </a:r>
+            <a:r>
+              <a:rPr lang="en-US" sz="800" dirty="0">
+                <a:solidFill>
+                  <a:srgbClr val="1A1F2B"/>
+                </a:solidFill>
+                <a:latin typeface="Times New Roman Regular" panose="02020503050405090304" charset="0"/>
+                <a:ea typeface="Times New Roman" panose="02020503050405090304" pitchFamily="34" charset="-122"/>
+                <a:cs typeface="Times New Roman Regular" panose="02020503050405090304" charset="0"/>
+              </a:rPr>
+              <a:t>  ←  Mutate-To-K(</a:t>
+            </a:r>
+            <a:r>
+              <a:rPr lang="en-US" sz="800" i="1" dirty="0">
+                <a:solidFill>
+                  <a:srgbClr val="1A1F2B"/>
+                </a:solidFill>
+                <a:latin typeface="Times New Roman Regular" panose="02020503050405090304" charset="0"/>
+                <a:ea typeface="Times New Roman" panose="02020503050405090304" pitchFamily="34" charset="-122"/>
+                <a:cs typeface="Times New Roman Regular" panose="02020503050405090304" charset="0"/>
+              </a:rPr>
+              <a:t>S</a:t>
+            </a:r>
+            <a:r>
+              <a:rPr lang="en-US" sz="800" baseline="-40000" dirty="0">
+                <a:solidFill>
+                  <a:srgbClr val="1A1F2B"/>
+                </a:solidFill>
+                <a:latin typeface="Times New Roman Regular" panose="02020503050405090304" charset="0"/>
+                <a:ea typeface="Times New Roman" panose="02020503050405090304" pitchFamily="34" charset="-122"/>
+                <a:cs typeface="Times New Roman Regular" panose="02020503050405090304" charset="0"/>
+              </a:rPr>
+              <a:t>t−1</a:t>
+            </a:r>
+            <a:r>
+              <a:rPr lang="en-US" sz="800" dirty="0">
+                <a:solidFill>
+                  <a:srgbClr val="1A1F2B"/>
+                </a:solidFill>
+                <a:latin typeface="Times New Roman Regular" panose="02020503050405090304" charset="0"/>
+                <a:ea typeface="Times New Roman" panose="02020503050405090304" pitchFamily="34" charset="-122"/>
+                <a:cs typeface="Times New Roman Regular" panose="02020503050405090304" charset="0"/>
+              </a:rPr>
+              <a:t>), </a:t>
+            </a:r>
+            <a:endParaRPr lang="en-US" sz="800" dirty="0">
+              <a:solidFill>
+                <a:srgbClr val="1A1F2B"/>
+              </a:solidFill>
+              <a:latin typeface="Times New Roman Regular" panose="02020503050405090304" charset="0"/>
+              <a:ea typeface="Times New Roman" panose="02020503050405090304" pitchFamily="34" charset="-122"/>
+              <a:cs typeface="Times New Roman Regular" panose="02020503050405090304" charset="0"/>
+            </a:endParaRPr>
+          </a:p>
+          <a:p>
+            <a:pPr marL="0" indent="0" algn="ctr">
               <a:lnSpc>
                 <a:spcPct val="100000"/>
               </a:lnSpc>
               <a:buNone/>
             </a:pPr>
             <a:r>
-              <a:rPr lang="en-US" sz="760" baseline="-40000" dirty="0">
+              <a:rPr lang="en-US" sz="800" dirty="0">
                 <a:solidFill>
                   <a:srgbClr val="1A1F2B"/>
                 </a:solidFill>
-                <a:latin typeface="Times New Roman" pitchFamily="34" charset="0"/>
-                <a:ea typeface="Times New Roman" pitchFamily="34" charset="-122"/>
-                <a:cs typeface="Times New Roman" pitchFamily="34" charset="-120"/>
+                <a:latin typeface="Times New Roman Regular" panose="02020503050405090304" charset="0"/>
+                <a:ea typeface="Times New Roman" panose="02020503050405090304" pitchFamily="34" charset="-122"/>
+                <a:cs typeface="Times New Roman Regular" panose="02020503050405090304" charset="0"/>
+              </a:rPr>
+              <a:t>  |</a:t>
+            </a:r>
+            <a:r>
+              <a:rPr lang="en-US" sz="800" i="1" dirty="0">
+                <a:solidFill>
+                  <a:srgbClr val="1A1F2B"/>
+                </a:solidFill>
+                <a:latin typeface="Times New Roman Regular" panose="02020503050405090304" charset="0"/>
+                <a:ea typeface="Times New Roman" panose="02020503050405090304" pitchFamily="34" charset="-122"/>
+                <a:cs typeface="Times New Roman Regular" panose="02020503050405090304" charset="0"/>
+              </a:rPr>
+              <a:t>P</a:t>
+            </a:r>
+            <a:r>
+              <a:rPr lang="en-US" sz="800" baseline="-40000" dirty="0">
+                <a:solidFill>
+                  <a:srgbClr val="1A1F2B"/>
+                </a:solidFill>
+                <a:latin typeface="Times New Roman Regular" panose="02020503050405090304" charset="0"/>
+                <a:ea typeface="Times New Roman" panose="02020503050405090304" pitchFamily="34" charset="-122"/>
+                <a:cs typeface="Times New Roman Regular" panose="02020503050405090304" charset="0"/>
               </a:rPr>
               <a:t>t</a:t>
             </a:r>
-            <a:pPr algn="ctr" indent="0" marL="0">
+            <a:r>
+              <a:rPr lang="en-US" sz="800" dirty="0">
+                <a:solidFill>
+                  <a:srgbClr val="1A1F2B"/>
+                </a:solidFill>
+                <a:latin typeface="Times New Roman Regular" panose="02020503050405090304" charset="0"/>
+                <a:ea typeface="Times New Roman" panose="02020503050405090304" pitchFamily="34" charset="-122"/>
+                <a:cs typeface="Times New Roman Regular" panose="02020503050405090304" charset="0"/>
+              </a:rPr>
+              <a:t>| = </a:t>
+            </a:r>
+            <a:r>
+              <a:rPr lang="en-US" sz="800" i="1" dirty="0">
+                <a:solidFill>
+                  <a:srgbClr val="1A1F2B"/>
+                </a:solidFill>
+                <a:latin typeface="Times New Roman Regular" panose="02020503050405090304" charset="0"/>
+                <a:ea typeface="Times New Roman" panose="02020503050405090304" pitchFamily="34" charset="-122"/>
+                <a:cs typeface="Times New Roman Regular" panose="02020503050405090304" charset="0"/>
+              </a:rPr>
+              <a:t>K</a:t>
+            </a:r>
+            <a:endParaRPr lang="en-US" sz="800" i="1" dirty="0">
+              <a:solidFill>
+                <a:srgbClr val="1A1F2B"/>
+              </a:solidFill>
+              <a:latin typeface="Times New Roman Regular" panose="02020503050405090304" charset="0"/>
+              <a:ea typeface="Times New Roman" panose="02020503050405090304" pitchFamily="34" charset="-122"/>
+              <a:cs typeface="Times New Roman Regular" panose="02020503050405090304" charset="0"/>
+            </a:endParaRPr>
+          </a:p>
+        </p:txBody>
+      </p:sp>
+      <p:sp>
+        <p:nvSpPr>
+          <p:cNvPr id="22" name="a.p1.body"/>
+          <p:cNvSpPr txBox="1"/>
+          <p:nvPr/>
+        </p:nvSpPr>
+        <p:spPr>
+          <a:xfrm>
+            <a:off x="283464" y="1554480"/>
+            <a:ext cx="1438656" cy="329184"/>
+          </a:xfrm>
+          <a:prstGeom prst="rect">
+            <a:avLst/>
+          </a:prstGeom>
+          <a:noFill/>
+        </p:spPr>
+        <p:txBody>
+          <a:bodyPr wrap="square" lIns="0" tIns="0" rIns="0" bIns="0" rtlCol="0" anchor="t"/>
+          <a:lstStyle/>
+          <a:p>
+            <a:pPr marL="0" indent="0" algn="l">
+              <a:lnSpc>
+                <a:spcPct val="96000"/>
+              </a:lnSpc>
+              <a:buNone/>
+            </a:pPr>
+            <a:r>
+              <a:rPr lang="en-US" sz="700" dirty="0">
+                <a:solidFill>
+                  <a:srgbClr val="333B48"/>
+                </a:solidFill>
+                <a:latin typeface="Times New Roman Regular" panose="02020503050405090304" charset="0"/>
+                <a:ea typeface="Arial" panose="020B0604020202090204" pitchFamily="34" charset="-122"/>
+                <a:cs typeface="Times New Roman Regular" panose="02020503050405090304" charset="0"/>
+              </a:rPr>
+              <a:t>Builds a fixed K-candidate population from selected parents; never reads the private set </a:t>
+            </a:r>
+            <a:r>
+              <a:rPr lang="en-US" sz="700" dirty="0">
+                <a:solidFill>
+                  <a:srgbClr val="333B48"/>
+                </a:solidFill>
+                <a:latin typeface="Times New Roman Regular" panose="02020503050405090304" charset="0"/>
+                <a:ea typeface="Cambria Math" pitchFamily="34" charset="-122"/>
+                <a:cs typeface="Times New Roman Regular" panose="02020503050405090304" charset="0"/>
+              </a:rPr>
+              <a:t>𝒟</a:t>
+            </a:r>
+            <a:r>
+              <a:rPr lang="en-US" sz="700" dirty="0">
+                <a:solidFill>
+                  <a:srgbClr val="333B48"/>
+                </a:solidFill>
+                <a:latin typeface="Times New Roman Regular" panose="02020503050405090304" charset="0"/>
+                <a:ea typeface="Arial" panose="020B0604020202090204" pitchFamily="34" charset="-122"/>
+                <a:cs typeface="Times New Roman Regular" panose="02020503050405090304" charset="0"/>
+              </a:rPr>
+              <a:t>.</a:t>
+            </a:r>
+            <a:endParaRPr lang="en-US" sz="700" dirty="0">
+              <a:solidFill>
+                <a:srgbClr val="333B48"/>
+              </a:solidFill>
+              <a:latin typeface="Times New Roman Regular" panose="02020503050405090304" charset="0"/>
+              <a:ea typeface="Arial" panose="020B0604020202090204" pitchFamily="34" charset="-122"/>
+              <a:cs typeface="Times New Roman Regular" panose="02020503050405090304" charset="0"/>
+            </a:endParaRPr>
+          </a:p>
+        </p:txBody>
+      </p:sp>
+      <p:sp>
+        <p:nvSpPr>
+          <p:cNvPr id="23" name="a.p1.costPill"/>
+          <p:cNvSpPr/>
+          <p:nvPr/>
+        </p:nvSpPr>
+        <p:spPr>
+          <a:xfrm>
+            <a:off x="374904" y="1929384"/>
+            <a:ext cx="1255776" cy="182880"/>
+          </a:xfrm>
+          <a:prstGeom prst="roundRect">
+            <a:avLst>
+              <a:gd name="adj" fmla="val 25000"/>
+            </a:avLst>
+          </a:prstGeom>
+          <a:solidFill>
+            <a:srgbClr val="0E7C7B"/>
+          </a:solidFill>
+        </p:spPr>
+      </p:sp>
+      <p:sp>
+        <p:nvSpPr>
+          <p:cNvPr id="24" name="a.p1.costLabel"/>
+          <p:cNvSpPr txBox="1"/>
+          <p:nvPr/>
+        </p:nvSpPr>
+        <p:spPr>
+          <a:xfrm>
+            <a:off x="374904" y="1958645"/>
+            <a:ext cx="1255776" cy="137160"/>
+          </a:xfrm>
+          <a:prstGeom prst="rect">
+            <a:avLst/>
+          </a:prstGeom>
+          <a:noFill/>
+        </p:spPr>
+        <p:txBody>
+          <a:bodyPr wrap="square" lIns="0" tIns="0" rIns="0" bIns="0" rtlCol="0" anchor="t"/>
+          <a:lstStyle/>
+          <a:p>
+            <a:pPr marL="0" indent="0" algn="ctr">
               <a:lnSpc>
                 <a:spcPct val="100000"/>
               </a:lnSpc>
               <a:buNone/>
             </a:pPr>
             <a:r>
-              <a:rPr lang="en-US" sz="760" dirty="0">
-                <a:solidFill>
-                  <a:srgbClr val="1A1F2B"/>
-                </a:solidFill>
-                <a:latin typeface="Times New Roman" pitchFamily="34" charset="0"/>
-                <a:ea typeface="Times New Roman" pitchFamily="34" charset="-122"/>
-                <a:cs typeface="Times New Roman" pitchFamily="34" charset="-120"/>
-              </a:rPr>
-              <a:t>  ←  Mutate-To-K(</a:t>
-            </a:r>
-            <a:pPr algn="ctr" indent="0" marL="0">
-              <a:lnSpc>
-                <a:spcPct val="100000"/>
-              </a:lnSpc>
-              <a:buNone/>
-            </a:pPr>
-            <a:r>
-              <a:rPr lang="en-US" sz="760" i="1" dirty="0">
-                <a:solidFill>
-                  <a:srgbClr val="1A1F2B"/>
-                </a:solidFill>
-                <a:latin typeface="Times New Roman" pitchFamily="34" charset="0"/>
-                <a:ea typeface="Times New Roman" pitchFamily="34" charset="-122"/>
-                <a:cs typeface="Times New Roman" pitchFamily="34" charset="-120"/>
-              </a:rPr>
-              <a:t>S</a:t>
-            </a:r>
-            <a:pPr algn="ctr" indent="0" marL="0">
-              <a:lnSpc>
-                <a:spcPct val="100000"/>
-              </a:lnSpc>
-              <a:buNone/>
-            </a:pPr>
-            <a:r>
-              <a:rPr lang="en-US" sz="760" baseline="-40000" dirty="0">
-                <a:solidFill>
-                  <a:srgbClr val="1A1F2B"/>
-                </a:solidFill>
-                <a:latin typeface="Times New Roman" pitchFamily="34" charset="0"/>
-                <a:ea typeface="Times New Roman" pitchFamily="34" charset="-122"/>
-                <a:cs typeface="Times New Roman" pitchFamily="34" charset="-120"/>
-              </a:rPr>
-              <a:t>t−1</a:t>
-            </a:r>
-            <a:pPr algn="ctr" indent="0" marL="0">
-              <a:lnSpc>
-                <a:spcPct val="100000"/>
-              </a:lnSpc>
-              <a:buNone/>
-            </a:pPr>
-            <a:r>
-              <a:rPr lang="en-US" sz="760" dirty="0">
-                <a:solidFill>
-                  <a:srgbClr val="1A1F2B"/>
-                </a:solidFill>
-                <a:latin typeface="Times New Roman" pitchFamily="34" charset="0"/>
-                <a:ea typeface="Times New Roman" pitchFamily="34" charset="-122"/>
-                <a:cs typeface="Times New Roman" pitchFamily="34" charset="-120"/>
-              </a:rPr>
-              <a:t>),   |</a:t>
-            </a:r>
-            <a:pPr algn="ctr" indent="0" marL="0">
-              <a:lnSpc>
-                <a:spcPct val="100000"/>
-              </a:lnSpc>
-              <a:buNone/>
-            </a:pPr>
-            <a:r>
-              <a:rPr lang="en-US" sz="760" i="1" dirty="0">
-                <a:solidFill>
-                  <a:srgbClr val="1A1F2B"/>
-                </a:solidFill>
-                <a:latin typeface="Times New Roman" pitchFamily="34" charset="0"/>
-                <a:ea typeface="Times New Roman" pitchFamily="34" charset="-122"/>
-                <a:cs typeface="Times New Roman" pitchFamily="34" charset="-120"/>
-              </a:rPr>
-              <a:t>P</a:t>
-            </a:r>
-            <a:pPr algn="ctr" indent="0" marL="0">
-              <a:lnSpc>
-                <a:spcPct val="100000"/>
-              </a:lnSpc>
-              <a:buNone/>
-            </a:pPr>
-            <a:r>
-              <a:rPr lang="en-US" sz="760" baseline="-40000" dirty="0">
-                <a:solidFill>
-                  <a:srgbClr val="1A1F2B"/>
-                </a:solidFill>
-                <a:latin typeface="Times New Roman" pitchFamily="34" charset="0"/>
-                <a:ea typeface="Times New Roman" pitchFamily="34" charset="-122"/>
-                <a:cs typeface="Times New Roman" pitchFamily="34" charset="-120"/>
-              </a:rPr>
-              <a:t>t</a:t>
-            </a:r>
-            <a:pPr algn="ctr" indent="0" marL="0">
-              <a:lnSpc>
-                <a:spcPct val="100000"/>
-              </a:lnSpc>
-              <a:buNone/>
-            </a:pPr>
-            <a:r>
-              <a:rPr lang="en-US" sz="760" dirty="0">
-                <a:solidFill>
-                  <a:srgbClr val="1A1F2B"/>
-                </a:solidFill>
-                <a:latin typeface="Times New Roman" pitchFamily="34" charset="0"/>
-                <a:ea typeface="Times New Roman" pitchFamily="34" charset="-122"/>
-                <a:cs typeface="Times New Roman" pitchFamily="34" charset="-120"/>
-              </a:rPr>
-              <a:t>| = </a:t>
-            </a:r>
-            <a:pPr algn="ctr" indent="0" marL="0">
-              <a:lnSpc>
-                <a:spcPct val="100000"/>
-              </a:lnSpc>
-              <a:buNone/>
-            </a:pPr>
-            <a:r>
-              <a:rPr lang="en-US" sz="760" i="1" dirty="0">
-                <a:solidFill>
-                  <a:srgbClr val="1A1F2B"/>
-                </a:solidFill>
-                <a:latin typeface="Times New Roman" pitchFamily="34" charset="0"/>
-                <a:ea typeface="Times New Roman" pitchFamily="34" charset="-122"/>
-                <a:cs typeface="Times New Roman" pitchFamily="34" charset="-120"/>
-              </a:rPr>
-              <a:t>K</a:t>
-            </a:r>
-            <a:endParaRPr lang="en-US" sz="760" dirty="0"/>
-          </a:p>
-        </p:txBody>
-      </p:sp>
-      <p:sp>
-        <p:nvSpPr>
-          <p:cNvPr id="22" name="a.p1.body"/>
-          <p:cNvSpPr txBox="1"/>
-          <p:nvPr/>
-        </p:nvSpPr>
-        <p:spPr>
-          <a:xfrm>
-            <a:off x="283464" y="1554480"/>
-            <a:ext cx="1438656" cy="329184"/>
-          </a:xfrm>
-          <a:prstGeom prst="rect">
-            <a:avLst/>
-          </a:prstGeom>
-          <a:noFill/>
-          <a:ln/>
-        </p:spPr>
-        <p:txBody>
-          <a:bodyPr wrap="square" lIns="0" tIns="0" rIns="0" bIns="0" rtlCol="0" anchor="t"/>
-          <a:lstStyle/>
-          <a:p>
-            <a:pPr algn="l" indent="0" marL="0">
-              <a:lnSpc>
-                <a:spcPct val="96000"/>
-              </a:lnSpc>
-              <a:buNone/>
-            </a:pPr>
-            <a:r>
-              <a:rPr lang="en-US" sz="660" dirty="0">
-                <a:solidFill>
-                  <a:srgbClr val="333B48"/>
-                </a:solidFill>
-                <a:latin typeface="Arial" pitchFamily="34" charset="0"/>
-                <a:ea typeface="Arial" pitchFamily="34" charset="-122"/>
-                <a:cs typeface="Arial" pitchFamily="34" charset="-120"/>
-              </a:rPr>
-              <a:t>Builds a fixed K-candidate population from selected parents; never reads the private set </a:t>
-            </a:r>
-            <a:pPr algn="l" indent="0" marL="0">
-              <a:lnSpc>
-                <a:spcPct val="96000"/>
-              </a:lnSpc>
-              <a:buNone/>
-            </a:pPr>
-            <a:r>
-              <a:rPr lang="en-US" sz="660" dirty="0">
-                <a:solidFill>
-                  <a:srgbClr val="333B48"/>
-                </a:solidFill>
-                <a:latin typeface="Cambria Math" pitchFamily="34" charset="0"/>
-                <a:ea typeface="Cambria Math" pitchFamily="34" charset="-122"/>
-                <a:cs typeface="Cambria Math" pitchFamily="34" charset="-120"/>
-              </a:rPr>
-              <a:t>𝒟</a:t>
-            </a:r>
-            <a:pPr algn="l" indent="0" marL="0">
-              <a:lnSpc>
-                <a:spcPct val="96000"/>
-              </a:lnSpc>
-              <a:buNone/>
-            </a:pPr>
-            <a:r>
-              <a:rPr lang="en-US" sz="660" dirty="0">
-                <a:solidFill>
-                  <a:srgbClr val="333B48"/>
-                </a:solidFill>
-                <a:latin typeface="Arial" pitchFamily="34" charset="0"/>
-                <a:ea typeface="Arial" pitchFamily="34" charset="-122"/>
-                <a:cs typeface="Arial" pitchFamily="34" charset="-120"/>
-              </a:rPr>
-              <a:t>.</a:t>
-            </a:r>
-            <a:endParaRPr lang="en-US" sz="660" dirty="0"/>
-          </a:p>
-        </p:txBody>
-      </p:sp>
-      <p:sp>
-        <p:nvSpPr>
-          <p:cNvPr id="23" name="a.p1.costPill"/>
-          <p:cNvSpPr/>
-          <p:nvPr/>
-        </p:nvSpPr>
-        <p:spPr>
-          <a:xfrm>
-            <a:off x="374904" y="1929384"/>
-            <a:ext cx="1255776" cy="182880"/>
-          </a:xfrm>
-          <a:prstGeom prst="roundRect">
-            <a:avLst>
-              <a:gd name="adj" fmla="val 25000"/>
-            </a:avLst>
-          </a:prstGeom>
-          <a:solidFill>
-            <a:srgbClr val="0E7C7B"/>
-          </a:solidFill>
-          <a:ln/>
-        </p:spPr>
-      </p:sp>
-      <p:sp>
-        <p:nvSpPr>
-          <p:cNvPr id="24" name="a.p1.costLabel"/>
-          <p:cNvSpPr txBox="1"/>
-          <p:nvPr/>
-        </p:nvSpPr>
-        <p:spPr>
-          <a:xfrm>
-            <a:off x="374904" y="1958645"/>
-            <a:ext cx="1255776" cy="137160"/>
-          </a:xfrm>
-          <a:prstGeom prst="rect">
-            <a:avLst/>
-          </a:prstGeom>
-          <a:noFill/>
-          <a:ln/>
-        </p:spPr>
-        <p:txBody>
-          <a:bodyPr wrap="square" lIns="0" tIns="0" rIns="0" bIns="0" rtlCol="0" anchor="t"/>
-          <a:lstStyle/>
-          <a:p>
-            <a:pPr algn="ctr" indent="0" marL="0">
-              <a:lnSpc>
-                <a:spcPct val="100000"/>
-              </a:lnSpc>
-              <a:buNone/>
-            </a:pPr>
-            <a:r>
               <a:rPr lang="en-US" sz="640" b="1" dirty="0">
                 <a:solidFill>
                   <a:srgbClr val="FFFFFF"/>
                 </a:solidFill>
-                <a:latin typeface="Arial" pitchFamily="34" charset="0"/>
-                <a:ea typeface="Arial" pitchFamily="34" charset="-122"/>
-                <a:cs typeface="Arial" pitchFamily="34" charset="-120"/>
+                <a:latin typeface="Arial" panose="020B0604020202090204" pitchFamily="34" charset="0"/>
+                <a:ea typeface="Arial" panose="020B0604020202090204" pitchFamily="34" charset="-122"/>
+                <a:cs typeface="Arial" panose="020B0604020202090204" pitchFamily="34" charset="-120"/>
               </a:rPr>
               <a:t>0 additional privacy loss</a:t>
             </a:r>
@@ -1993,7 +1931,6 @@
           <a:solidFill>
             <a:srgbClr val="1F3D7A"/>
           </a:solidFill>
-          <a:ln/>
         </p:spPr>
       </p:sp>
       <p:sp>
@@ -2079,7 +2016,6 @@
           <a:solidFill>
             <a:srgbClr val="FFFFFF"/>
           </a:solidFill>
-          <a:ln/>
         </p:spPr>
       </p:sp>
       <p:sp>
@@ -2097,13 +2033,12 @@
             <a:avLst/>
           </a:prstGeom>
           <a:noFill/>
-          <a:ln/>
         </p:spPr>
         <p:txBody>
           <a:bodyPr wrap="square" lIns="0" tIns="0" rIns="0" bIns="0" rtlCol="0" anchor="ctr"/>
           <a:lstStyle/>
           <a:p>
-            <a:pPr algn="ctr" indent="0" marL="0">
+            <a:pPr marL="0" indent="0" algn="ctr">
               <a:lnSpc>
                 <a:spcPct val="104000"/>
               </a:lnSpc>
@@ -2114,16 +2049,16 @@
                 <a:solidFill>
                   <a:srgbClr val="1F3D7A"/>
                 </a:solidFill>
-                <a:latin typeface="Arial" pitchFamily="34" charset="0"/>
-                <a:ea typeface="Arial" pitchFamily="34" charset="-122"/>
-                <a:cs typeface="Arial" pitchFamily="34" charset="-120"/>
+                <a:latin typeface="Arial" panose="020B0604020202090204" pitchFamily="34" charset="0"/>
+                <a:ea typeface="Arial" panose="020B0604020202090204" pitchFamily="34" charset="-122"/>
+                <a:cs typeface="Arial" panose="020B0604020202090204" pitchFamily="34" charset="-120"/>
               </a:rPr>
               <a:t>Phase 2</a:t>
             </a:r>
             <a:endParaRPr lang="en-US" sz="780" dirty="0"/>
           </a:p>
           <a:p>
-            <a:pPr algn="ctr" indent="0" marL="0">
+            <a:pPr marL="0" indent="0" algn="ctr">
               <a:lnSpc>
                 <a:spcPct val="104000"/>
               </a:lnSpc>
@@ -2134,9 +2069,9 @@
                 <a:solidFill>
                   <a:srgbClr val="1F3D7A"/>
                 </a:solidFill>
-                <a:latin typeface="Arial" pitchFamily="34" charset="0"/>
-                <a:ea typeface="Arial" pitchFamily="34" charset="-122"/>
-                <a:cs typeface="Arial" pitchFamily="34" charset="-120"/>
+                <a:latin typeface="Arial" panose="020B0604020202090204" pitchFamily="34" charset="0"/>
+                <a:ea typeface="Arial" panose="020B0604020202090204" pitchFamily="34" charset="-122"/>
+                <a:cs typeface="Arial" panose="020B0604020202090204" pitchFamily="34" charset="-120"/>
               </a:rPr>
               <a:t>DP scoring</a:t>
             </a:r>
@@ -2152,623 +2087,479 @@
         </p:nvSpPr>
         <p:spPr>
           <a:xfrm>
-            <a:off x="2133600" y="1293876"/>
+            <a:off x="2133600" y="1286256"/>
             <a:ext cx="1493520" cy="118872"/>
           </a:xfrm>
           <a:prstGeom prst="rect">
             <a:avLst/>
           </a:prstGeom>
           <a:noFill/>
-          <a:ln/>
         </p:spPr>
         <p:txBody>
           <a:bodyPr wrap="square" lIns="0" tIns="0" rIns="0" bIns="0" rtlCol="0" anchor="t"/>
           <a:lstStyle/>
           <a:p>
-            <a:pPr algn="ctr" indent="0" marL="0">
+            <a:pPr marL="0" indent="0" algn="ctr">
               <a:lnSpc>
                 <a:spcPct val="100000"/>
               </a:lnSpc>
               <a:buNone/>
             </a:pPr>
             <a:r>
-              <a:rPr lang="en-US" sz="740" i="1" dirty="0">
+              <a:rPr lang="en-US" sz="800" i="1" dirty="0">
                 <a:solidFill>
                   <a:srgbClr val="1A1F2B"/>
                 </a:solidFill>
-                <a:latin typeface="Times New Roman" pitchFamily="34" charset="0"/>
-                <a:ea typeface="Times New Roman" pitchFamily="34" charset="-122"/>
-                <a:cs typeface="Times New Roman" pitchFamily="34" charset="-120"/>
+                <a:latin typeface="Times New Roman Regular" panose="02020503050405090304" charset="0"/>
+                <a:ea typeface="Times New Roman" panose="02020503050405090304" pitchFamily="34" charset="-122"/>
+                <a:cs typeface="Times New Roman Regular" panose="02020503050405090304" charset="0"/>
               </a:rPr>
               <a:t>s</a:t>
             </a:r>
-            <a:pPr algn="ctr" indent="0" marL="0">
+            <a:r>
+              <a:rPr lang="en-US" sz="800" baseline="-40000" dirty="0">
+                <a:solidFill>
+                  <a:srgbClr val="1A1F2B"/>
+                </a:solidFill>
+                <a:latin typeface="Times New Roman Regular" panose="02020503050405090304" charset="0"/>
+                <a:ea typeface="Times New Roman" panose="02020503050405090304" pitchFamily="34" charset="-122"/>
+                <a:cs typeface="Times New Roman Regular" panose="02020503050405090304" charset="0"/>
+              </a:rPr>
+              <a:t>p</a:t>
+            </a:r>
+            <a:r>
+              <a:rPr lang="en-US" sz="800" dirty="0">
+                <a:solidFill>
+                  <a:srgbClr val="1A1F2B"/>
+                </a:solidFill>
+                <a:latin typeface="Times New Roman Regular" panose="02020503050405090304" charset="0"/>
+                <a:ea typeface="Times New Roman" panose="02020503050405090304" pitchFamily="34" charset="-122"/>
+                <a:cs typeface="Times New Roman Regular" panose="02020503050405090304" charset="0"/>
+              </a:rPr>
+              <a:t>(</a:t>
+            </a:r>
+            <a:r>
+              <a:rPr lang="en-US" sz="800" i="1" dirty="0">
+                <a:solidFill>
+                  <a:srgbClr val="1A1F2B"/>
+                </a:solidFill>
+                <a:latin typeface="Times New Roman Regular" panose="02020503050405090304" charset="0"/>
+                <a:ea typeface="Times New Roman" panose="02020503050405090304" pitchFamily="34" charset="-122"/>
+                <a:cs typeface="Times New Roman Regular" panose="02020503050405090304" charset="0"/>
+              </a:rPr>
+              <a:t>B </a:t>
+            </a:r>
+            <a:r>
+              <a:rPr lang="en-US" sz="800" dirty="0">
+                <a:solidFill>
+                  <a:srgbClr val="1A1F2B"/>
+                </a:solidFill>
+                <a:latin typeface="Times New Roman Regular" panose="02020503050405090304" charset="0"/>
+                <a:ea typeface="Times New Roman" panose="02020503050405090304" pitchFamily="34" charset="-122"/>
+                <a:cs typeface="Times New Roman Regular" panose="02020503050405090304" charset="0"/>
+              </a:rPr>
+              <a:t>) = </a:t>
+            </a:r>
+            <a:r>
+              <a:rPr lang="en-US" sz="800" i="1" dirty="0">
+                <a:solidFill>
+                  <a:srgbClr val="1A1F2B"/>
+                </a:solidFill>
+                <a:latin typeface="Times New Roman Regular" panose="02020503050405090304" charset="0"/>
+                <a:ea typeface="Times New Roman" panose="02020503050405090304" pitchFamily="34" charset="-122"/>
+                <a:cs typeface="Times New Roman Regular" panose="02020503050405090304" charset="0"/>
+              </a:rPr>
+              <a:t>b</a:t>
+            </a:r>
+            <a:r>
+              <a:rPr lang="en-US" sz="800" baseline="30000" dirty="0">
+                <a:solidFill>
+                  <a:srgbClr val="1A1F2B"/>
+                </a:solidFill>
+                <a:latin typeface="Times New Roman Regular" panose="02020503050405090304" charset="0"/>
+                <a:ea typeface="Times New Roman" panose="02020503050405090304" pitchFamily="34" charset="-122"/>
+                <a:cs typeface="Times New Roman Regular" panose="02020503050405090304" charset="0"/>
+              </a:rPr>
+              <a:t>−1</a:t>
+            </a:r>
+            <a:r>
+              <a:rPr lang="en-US" sz="800" dirty="0">
+                <a:solidFill>
+                  <a:srgbClr val="1A1F2B"/>
+                </a:solidFill>
+                <a:latin typeface="Times New Roman Regular" panose="02020503050405090304" charset="0"/>
+                <a:ea typeface="Times New Roman" panose="02020503050405090304" pitchFamily="34" charset="-122"/>
+                <a:cs typeface="Times New Roman Regular" panose="02020503050405090304" charset="0"/>
+              </a:rPr>
+              <a:t> Σ</a:t>
+            </a:r>
+            <a:r>
+              <a:rPr lang="en-US" sz="800" baseline="-40000" dirty="0">
+                <a:solidFill>
+                  <a:srgbClr val="1A1F2B"/>
+                </a:solidFill>
+                <a:latin typeface="Times New Roman Regular" panose="02020503050405090304" charset="0"/>
+                <a:ea typeface="Times New Roman" panose="02020503050405090304" pitchFamily="34" charset="-122"/>
+                <a:cs typeface="Times New Roman Regular" panose="02020503050405090304" charset="0"/>
+              </a:rPr>
+              <a:t>i∈B</a:t>
+            </a:r>
+            <a:r>
+              <a:rPr lang="en-US" sz="800" dirty="0">
+                <a:solidFill>
+                  <a:srgbClr val="1A1F2B"/>
+                </a:solidFill>
+                <a:latin typeface="Times New Roman Regular" panose="02020503050405090304" charset="0"/>
+                <a:ea typeface="Times New Roman" panose="02020503050405090304" pitchFamily="34" charset="-122"/>
+                <a:cs typeface="Times New Roman Regular" panose="02020503050405090304" charset="0"/>
+              </a:rPr>
+              <a:t> clip(</a:t>
+            </a:r>
+            <a:r>
+              <a:rPr lang="en-US" sz="800" i="1" dirty="0">
+                <a:solidFill>
+                  <a:srgbClr val="1A1F2B"/>
+                </a:solidFill>
+                <a:latin typeface="Times New Roman Regular" panose="02020503050405090304" charset="0"/>
+                <a:ea typeface="Times New Roman" panose="02020503050405090304" pitchFamily="34" charset="-122"/>
+                <a:cs typeface="Times New Roman Regular" panose="02020503050405090304" charset="0"/>
+              </a:rPr>
+              <a:t>u</a:t>
+            </a:r>
+            <a:r>
+              <a:rPr lang="en-US" sz="800" baseline="-40000" dirty="0">
+                <a:solidFill>
+                  <a:srgbClr val="1A1F2B"/>
+                </a:solidFill>
+                <a:latin typeface="Times New Roman Regular" panose="02020503050405090304" charset="0"/>
+                <a:ea typeface="Times New Roman" panose="02020503050405090304" pitchFamily="34" charset="-122"/>
+                <a:cs typeface="Times New Roman Regular" panose="02020503050405090304" charset="0"/>
+              </a:rPr>
+              <a:t>i</a:t>
+            </a:r>
+            <a:r>
+              <a:rPr lang="en-US" sz="800" dirty="0">
+                <a:solidFill>
+                  <a:srgbClr val="1A1F2B"/>
+                </a:solidFill>
+                <a:latin typeface="Times New Roman Regular" panose="02020503050405090304" charset="0"/>
+                <a:ea typeface="Times New Roman" panose="02020503050405090304" pitchFamily="34" charset="-122"/>
+                <a:cs typeface="Times New Roman Regular" panose="02020503050405090304" charset="0"/>
+              </a:rPr>
+              <a:t>)</a:t>
+            </a:r>
+            <a:endParaRPr lang="en-US" sz="800" dirty="0">
+              <a:latin typeface="Times New Roman Regular" panose="02020503050405090304" charset="0"/>
+              <a:cs typeface="Times New Roman Regular" panose="02020503050405090304" charset="0"/>
+            </a:endParaRPr>
+          </a:p>
+        </p:txBody>
+      </p:sp>
+      <p:sp>
+        <p:nvSpPr>
+          <p:cNvPr id="32" name="a.p2.formula2"/>
+          <p:cNvSpPr txBox="1"/>
+          <p:nvPr/>
+        </p:nvSpPr>
+        <p:spPr>
+          <a:xfrm>
+            <a:off x="2133600" y="1454658"/>
+            <a:ext cx="1493520" cy="118872"/>
+          </a:xfrm>
+          <a:prstGeom prst="rect">
+            <a:avLst/>
+          </a:prstGeom>
+          <a:noFill/>
+        </p:spPr>
+        <p:txBody>
+          <a:bodyPr wrap="square" lIns="0" tIns="0" rIns="0" bIns="0" rtlCol="0" anchor="t"/>
+          <a:lstStyle/>
+          <a:p>
+            <a:pPr marL="0" indent="0" algn="ctr">
               <a:lnSpc>
                 <a:spcPct val="100000"/>
               </a:lnSpc>
               <a:buNone/>
             </a:pPr>
             <a:r>
-              <a:rPr lang="en-US" sz="740" baseline="-40000" dirty="0">
+              <a:rPr lang="en-US" sz="800" dirty="0">
                 <a:solidFill>
                   <a:srgbClr val="1A1F2B"/>
                 </a:solidFill>
-                <a:latin typeface="Times New Roman" pitchFamily="34" charset="0"/>
-                <a:ea typeface="Times New Roman" pitchFamily="34" charset="-122"/>
-                <a:cs typeface="Times New Roman" pitchFamily="34" charset="-120"/>
+                <a:latin typeface="Times New Roman Regular" panose="02020503050405090304" charset="0"/>
+                <a:ea typeface="Times New Roman" panose="02020503050405090304" pitchFamily="34" charset="-122"/>
+                <a:cs typeface="Times New Roman Regular" panose="02020503050405090304" charset="0"/>
+              </a:rPr>
+              <a:t>release  </a:t>
+            </a:r>
+            <a:r>
+              <a:rPr lang="en-US" sz="800" i="1" dirty="0">
+                <a:solidFill>
+                  <a:srgbClr val="1A1F2B"/>
+                </a:solidFill>
+                <a:latin typeface="Times New Roman Regular" panose="02020503050405090304" charset="0"/>
+                <a:ea typeface="Times New Roman" panose="02020503050405090304" pitchFamily="34" charset="-122"/>
+                <a:cs typeface="Times New Roman Regular" panose="02020503050405090304" charset="0"/>
+              </a:rPr>
+              <a:t>s</a:t>
+            </a:r>
+            <a:r>
+              <a:rPr lang="en-US" sz="800" baseline="-40000" dirty="0">
+                <a:solidFill>
+                  <a:srgbClr val="1A1F2B"/>
+                </a:solidFill>
+                <a:latin typeface="Times New Roman Regular" panose="02020503050405090304" charset="0"/>
+                <a:ea typeface="Times New Roman" panose="02020503050405090304" pitchFamily="34" charset="-122"/>
+                <a:cs typeface="Times New Roman Regular" panose="02020503050405090304" charset="0"/>
               </a:rPr>
               <a:t>p</a:t>
             </a:r>
-            <a:pPr algn="ctr" indent="0" marL="0">
+            <a:r>
+              <a:rPr lang="en-US" sz="800" dirty="0">
+                <a:solidFill>
+                  <a:srgbClr val="1A1F2B"/>
+                </a:solidFill>
+                <a:latin typeface="Times New Roman Regular" panose="02020503050405090304" charset="0"/>
+                <a:ea typeface="Times New Roman" panose="02020503050405090304" pitchFamily="34" charset="-122"/>
+                <a:cs typeface="Times New Roman Regular" panose="02020503050405090304" charset="0"/>
+              </a:rPr>
+              <a:t> + </a:t>
+            </a:r>
+            <a:r>
+              <a:rPr lang="en-US" sz="800" dirty="0">
+                <a:solidFill>
+                  <a:srgbClr val="1A1F2B"/>
+                </a:solidFill>
+                <a:latin typeface="Times New Roman Regular" panose="02020503050405090304" charset="0"/>
+                <a:ea typeface="Cambria Math" pitchFamily="34" charset="-122"/>
+                <a:cs typeface="Times New Roman Regular" panose="02020503050405090304" charset="0"/>
+              </a:rPr>
+              <a:t>𝒩</a:t>
+            </a:r>
+            <a:r>
+              <a:rPr lang="en-US" sz="800" dirty="0">
+                <a:solidFill>
+                  <a:srgbClr val="1A1F2B"/>
+                </a:solidFill>
+                <a:latin typeface="Times New Roman Regular" panose="02020503050405090304" charset="0"/>
+                <a:ea typeface="Times New Roman" panose="02020503050405090304" pitchFamily="34" charset="-122"/>
+                <a:cs typeface="Times New Roman Regular" panose="02020503050405090304" charset="0"/>
+              </a:rPr>
+              <a:t>(0, (</a:t>
+            </a:r>
+            <a:r>
+              <a:rPr lang="en-US" sz="800" i="1" dirty="0">
+                <a:solidFill>
+                  <a:srgbClr val="1A1F2B"/>
+                </a:solidFill>
+                <a:latin typeface="Times New Roman Regular" panose="02020503050405090304" charset="0"/>
+                <a:ea typeface="Times New Roman" panose="02020503050405090304" pitchFamily="34" charset="-122"/>
+                <a:cs typeface="Times New Roman Regular" panose="02020503050405090304" charset="0"/>
+              </a:rPr>
+              <a:t>z C</a:t>
+            </a:r>
+            <a:r>
+              <a:rPr lang="en-US" sz="800" baseline="-40000" dirty="0">
+                <a:solidFill>
+                  <a:srgbClr val="1A1F2B"/>
+                </a:solidFill>
+                <a:latin typeface="Times New Roman Regular" panose="02020503050405090304" charset="0"/>
+                <a:ea typeface="Times New Roman" panose="02020503050405090304" pitchFamily="34" charset="-122"/>
+                <a:cs typeface="Times New Roman Regular" panose="02020503050405090304" charset="0"/>
+              </a:rPr>
+              <a:t>clip</a:t>
+            </a:r>
+            <a:r>
+              <a:rPr lang="en-US" sz="800" dirty="0">
+                <a:solidFill>
+                  <a:srgbClr val="1A1F2B"/>
+                </a:solidFill>
+                <a:latin typeface="Times New Roman Regular" panose="02020503050405090304" charset="0"/>
+                <a:ea typeface="Times New Roman" panose="02020503050405090304" pitchFamily="34" charset="-122"/>
+                <a:cs typeface="Times New Roman Regular" panose="02020503050405090304" charset="0"/>
+              </a:rPr>
+              <a:t>/</a:t>
+            </a:r>
+            <a:r>
+              <a:rPr lang="en-US" sz="800" i="1" dirty="0">
+                <a:solidFill>
+                  <a:srgbClr val="1A1F2B"/>
+                </a:solidFill>
+                <a:latin typeface="Times New Roman Regular" panose="02020503050405090304" charset="0"/>
+                <a:ea typeface="Times New Roman" panose="02020503050405090304" pitchFamily="34" charset="-122"/>
+                <a:cs typeface="Times New Roman Regular" panose="02020503050405090304" charset="0"/>
+              </a:rPr>
+              <a:t>b</a:t>
+            </a:r>
+            <a:r>
+              <a:rPr lang="en-US" sz="800" dirty="0">
+                <a:solidFill>
+                  <a:srgbClr val="1A1F2B"/>
+                </a:solidFill>
+                <a:latin typeface="Times New Roman Regular" panose="02020503050405090304" charset="0"/>
+                <a:ea typeface="Times New Roman" panose="02020503050405090304" pitchFamily="34" charset="-122"/>
+                <a:cs typeface="Times New Roman Regular" panose="02020503050405090304" charset="0"/>
+              </a:rPr>
+              <a:t>)²)</a:t>
+            </a:r>
+            <a:endParaRPr lang="en-US" sz="800" dirty="0">
+              <a:solidFill>
+                <a:srgbClr val="1A1F2B"/>
+              </a:solidFill>
+              <a:latin typeface="Times New Roman Regular" panose="02020503050405090304" charset="0"/>
+              <a:ea typeface="Times New Roman" panose="02020503050405090304" pitchFamily="34" charset="-122"/>
+              <a:cs typeface="Times New Roman Regular" panose="02020503050405090304" charset="0"/>
+            </a:endParaRPr>
+          </a:p>
+        </p:txBody>
+      </p:sp>
+      <p:sp>
+        <p:nvSpPr>
+          <p:cNvPr id="33" name="a.p2.body"/>
+          <p:cNvSpPr txBox="1"/>
+          <p:nvPr/>
+        </p:nvSpPr>
+        <p:spPr>
+          <a:xfrm>
+            <a:off x="2252345" y="1609344"/>
+            <a:ext cx="1367790" cy="301752"/>
+          </a:xfrm>
+          <a:prstGeom prst="rect">
+            <a:avLst/>
+          </a:prstGeom>
+          <a:noFill/>
+        </p:spPr>
+        <p:txBody>
+          <a:bodyPr wrap="square" lIns="0" tIns="0" rIns="0" bIns="0" rtlCol="0" anchor="t"/>
+          <a:lstStyle/>
+          <a:p>
+            <a:pPr marL="0" indent="0" algn="l">
+              <a:lnSpc>
+                <a:spcPct val="96000"/>
+              </a:lnSpc>
+              <a:buNone/>
+            </a:pPr>
+            <a:r>
+              <a:rPr lang="en-US" sz="700" dirty="0">
+                <a:solidFill>
+                  <a:srgbClr val="333B48"/>
+                </a:solidFill>
+                <a:latin typeface="Times New Roman Regular" panose="02020503050405090304" charset="0"/>
+                <a:ea typeface="Arial" panose="020B0604020202090204" pitchFamily="34" charset="-122"/>
+                <a:cs typeface="Times New Roman Regular" panose="02020503050405090304" charset="0"/>
+              </a:rPr>
+              <a:t>Each candidate releases one clipped, sampled-Gaussian score from </a:t>
+            </a:r>
+            <a:r>
+              <a:rPr lang="en-US" sz="700" dirty="0">
+                <a:solidFill>
+                  <a:srgbClr val="333B48"/>
+                </a:solidFill>
+                <a:latin typeface="Times New Roman Regular" panose="02020503050405090304" charset="0"/>
+                <a:ea typeface="Cambria Math" pitchFamily="34" charset="-122"/>
+                <a:cs typeface="Times New Roman Regular" panose="02020503050405090304" charset="0"/>
+              </a:rPr>
+              <a:t>𝒟</a:t>
+            </a:r>
+            <a:r>
+              <a:rPr lang="en-US" sz="700" dirty="0">
+                <a:solidFill>
+                  <a:srgbClr val="333B48"/>
+                </a:solidFill>
+                <a:latin typeface="Times New Roman Regular" panose="02020503050405090304" charset="0"/>
+                <a:ea typeface="Arial" panose="020B0604020202090204" pitchFamily="34" charset="-122"/>
+                <a:cs typeface="Times New Roman Regular" panose="02020503050405090304" charset="0"/>
+              </a:rPr>
+              <a:t>.</a:t>
+            </a:r>
+            <a:endParaRPr lang="en-US" sz="700" dirty="0">
+              <a:solidFill>
+                <a:srgbClr val="333B48"/>
+              </a:solidFill>
+              <a:latin typeface="Times New Roman Regular" panose="02020503050405090304" charset="0"/>
+              <a:ea typeface="Arial" panose="020B0604020202090204" pitchFamily="34" charset="-122"/>
+              <a:cs typeface="Times New Roman Regular" panose="02020503050405090304" charset="0"/>
+            </a:endParaRPr>
+          </a:p>
+        </p:txBody>
+      </p:sp>
+      <p:sp>
+        <p:nvSpPr>
+          <p:cNvPr id="34" name="a.p2.costPill"/>
+          <p:cNvSpPr/>
+          <p:nvPr/>
+        </p:nvSpPr>
+        <p:spPr>
+          <a:xfrm>
+            <a:off x="2252472" y="1929384"/>
+            <a:ext cx="1255776" cy="182880"/>
+          </a:xfrm>
+          <a:prstGeom prst="roundRect">
+            <a:avLst>
+              <a:gd name="adj" fmla="val 25000"/>
+            </a:avLst>
+          </a:prstGeom>
+          <a:solidFill>
+            <a:srgbClr val="1F3D7A"/>
+          </a:solidFill>
+        </p:spPr>
+      </p:sp>
+      <p:sp>
+        <p:nvSpPr>
+          <p:cNvPr id="35" name="a.p2.costLabel"/>
+          <p:cNvSpPr txBox="1"/>
+          <p:nvPr/>
+        </p:nvSpPr>
+        <p:spPr>
+          <a:xfrm>
+            <a:off x="2252472" y="1958645"/>
+            <a:ext cx="1255776" cy="137160"/>
+          </a:xfrm>
+          <a:prstGeom prst="rect">
+            <a:avLst/>
+          </a:prstGeom>
+          <a:noFill/>
+        </p:spPr>
+        <p:txBody>
+          <a:bodyPr wrap="square" lIns="0" tIns="0" rIns="0" bIns="0" rtlCol="0" anchor="t"/>
+          <a:lstStyle/>
+          <a:p>
+            <a:pPr marL="0" indent="0" algn="ctr">
               <a:lnSpc>
                 <a:spcPct val="100000"/>
               </a:lnSpc>
               <a:buNone/>
             </a:pPr>
             <a:r>
-              <a:rPr lang="en-US" sz="740" dirty="0">
-                <a:solidFill>
-                  <a:srgbClr val="1A1F2B"/>
-                </a:solidFill>
-                <a:latin typeface="Times New Roman" pitchFamily="34" charset="0"/>
-                <a:ea typeface="Times New Roman" pitchFamily="34" charset="-122"/>
-                <a:cs typeface="Times New Roman" pitchFamily="34" charset="-120"/>
-              </a:rPr>
-              <a:t>(</a:t>
-            </a:r>
-            <a:pPr algn="ctr" indent="0" marL="0">
-              <a:lnSpc>
-                <a:spcPct val="100000"/>
-              </a:lnSpc>
-              <a:buNone/>
-            </a:pPr>
-            <a:r>
-              <a:rPr lang="en-US" sz="740" i="1" dirty="0">
-                <a:solidFill>
-                  <a:srgbClr val="1A1F2B"/>
-                </a:solidFill>
-                <a:latin typeface="Times New Roman" pitchFamily="34" charset="0"/>
-                <a:ea typeface="Times New Roman" pitchFamily="34" charset="-122"/>
-                <a:cs typeface="Times New Roman" pitchFamily="34" charset="-120"/>
-              </a:rPr>
-              <a:t>B</a:t>
-            </a:r>
-            <a:pPr algn="ctr" indent="0" marL="0">
-              <a:lnSpc>
-                <a:spcPct val="100000"/>
-              </a:lnSpc>
-              <a:buNone/>
-            </a:pPr>
-            <a:r>
-              <a:rPr lang="en-US" sz="740" dirty="0">
-                <a:solidFill>
-                  <a:srgbClr val="1A1F2B"/>
-                </a:solidFill>
-                <a:latin typeface="Times New Roman" pitchFamily="34" charset="0"/>
-                <a:ea typeface="Times New Roman" pitchFamily="34" charset="-122"/>
-                <a:cs typeface="Times New Roman" pitchFamily="34" charset="-120"/>
-              </a:rPr>
-              <a:t>) = </a:t>
-            </a:r>
-            <a:pPr algn="ctr" indent="0" marL="0">
-              <a:lnSpc>
-                <a:spcPct val="100000"/>
-              </a:lnSpc>
-              <a:buNone/>
-            </a:pPr>
-            <a:r>
-              <a:rPr lang="en-US" sz="740" i="1" dirty="0">
-                <a:solidFill>
-                  <a:srgbClr val="1A1F2B"/>
-                </a:solidFill>
-                <a:latin typeface="Times New Roman" pitchFamily="34" charset="0"/>
-                <a:ea typeface="Times New Roman" pitchFamily="34" charset="-122"/>
-                <a:cs typeface="Times New Roman" pitchFamily="34" charset="-120"/>
-              </a:rPr>
-              <a:t>b</a:t>
-            </a:r>
-            <a:pPr algn="ctr" indent="0" marL="0">
-              <a:lnSpc>
-                <a:spcPct val="100000"/>
-              </a:lnSpc>
-              <a:buNone/>
-            </a:pPr>
-            <a:r>
-              <a:rPr lang="en-US" sz="740" baseline="30000" dirty="0">
-                <a:solidFill>
-                  <a:srgbClr val="1A1F2B"/>
-                </a:solidFill>
-                <a:latin typeface="Times New Roman" pitchFamily="34" charset="0"/>
-                <a:ea typeface="Times New Roman" pitchFamily="34" charset="-122"/>
-                <a:cs typeface="Times New Roman" pitchFamily="34" charset="-120"/>
-              </a:rPr>
-              <a:t>−1</a:t>
-            </a:r>
-            <a:pPr algn="ctr" indent="0" marL="0">
-              <a:lnSpc>
-                <a:spcPct val="100000"/>
-              </a:lnSpc>
-              <a:buNone/>
-            </a:pPr>
-            <a:r>
-              <a:rPr lang="en-US" sz="740" dirty="0">
-                <a:solidFill>
-                  <a:srgbClr val="1A1F2B"/>
-                </a:solidFill>
-                <a:latin typeface="Times New Roman" pitchFamily="34" charset="0"/>
-                <a:ea typeface="Times New Roman" pitchFamily="34" charset="-122"/>
-                <a:cs typeface="Times New Roman" pitchFamily="34" charset="-120"/>
-              </a:rPr>
-              <a:t> Σ</a:t>
-            </a:r>
-            <a:pPr algn="ctr" indent="0" marL="0">
-              <a:lnSpc>
-                <a:spcPct val="100000"/>
-              </a:lnSpc>
-              <a:buNone/>
-            </a:pPr>
-            <a:r>
-              <a:rPr lang="en-US" sz="740" baseline="-40000" dirty="0">
-                <a:solidFill>
-                  <a:srgbClr val="1A1F2B"/>
-                </a:solidFill>
-                <a:latin typeface="Times New Roman" pitchFamily="34" charset="0"/>
-                <a:ea typeface="Times New Roman" pitchFamily="34" charset="-122"/>
-                <a:cs typeface="Times New Roman" pitchFamily="34" charset="-120"/>
-              </a:rPr>
-              <a:t>i∈B</a:t>
-            </a:r>
-            <a:pPr algn="ctr" indent="0" marL="0">
-              <a:lnSpc>
-                <a:spcPct val="100000"/>
-              </a:lnSpc>
-              <a:buNone/>
-            </a:pPr>
-            <a:r>
-              <a:rPr lang="en-US" sz="740" dirty="0">
-                <a:solidFill>
-                  <a:srgbClr val="1A1F2B"/>
-                </a:solidFill>
-                <a:latin typeface="Times New Roman" pitchFamily="34" charset="0"/>
-                <a:ea typeface="Times New Roman" pitchFamily="34" charset="-122"/>
-                <a:cs typeface="Times New Roman" pitchFamily="34" charset="-120"/>
-              </a:rPr>
-              <a:t> clip(</a:t>
-            </a:r>
-            <a:pPr algn="ctr" indent="0" marL="0">
-              <a:lnSpc>
-                <a:spcPct val="100000"/>
-              </a:lnSpc>
-              <a:buNone/>
-            </a:pPr>
-            <a:r>
-              <a:rPr lang="en-US" sz="740" i="1" dirty="0">
-                <a:solidFill>
-                  <a:srgbClr val="1A1F2B"/>
-                </a:solidFill>
-                <a:latin typeface="Times New Roman" pitchFamily="34" charset="0"/>
-                <a:ea typeface="Times New Roman" pitchFamily="34" charset="-122"/>
-                <a:cs typeface="Times New Roman" pitchFamily="34" charset="-120"/>
-              </a:rPr>
-              <a:t>u</a:t>
-            </a:r>
-            <a:pPr algn="ctr" indent="0" marL="0">
-              <a:lnSpc>
-                <a:spcPct val="100000"/>
-              </a:lnSpc>
-              <a:buNone/>
-            </a:pPr>
-            <a:r>
-              <a:rPr lang="en-US" sz="740" baseline="-40000" dirty="0">
-                <a:solidFill>
-                  <a:srgbClr val="1A1F2B"/>
-                </a:solidFill>
-                <a:latin typeface="Times New Roman" pitchFamily="34" charset="0"/>
-                <a:ea typeface="Times New Roman" pitchFamily="34" charset="-122"/>
-                <a:cs typeface="Times New Roman" pitchFamily="34" charset="-120"/>
-              </a:rPr>
-              <a:t>i</a:t>
-            </a:r>
-            <a:pPr algn="ctr" indent="0" marL="0">
-              <a:lnSpc>
-                <a:spcPct val="100000"/>
-              </a:lnSpc>
-              <a:buNone/>
-            </a:pPr>
-            <a:r>
-              <a:rPr lang="en-US" sz="740" dirty="0">
-                <a:solidFill>
-                  <a:srgbClr val="1A1F2B"/>
-                </a:solidFill>
-                <a:latin typeface="Times New Roman" pitchFamily="34" charset="0"/>
-                <a:ea typeface="Times New Roman" pitchFamily="34" charset="-122"/>
-                <a:cs typeface="Times New Roman" pitchFamily="34" charset="-120"/>
-              </a:rPr>
-              <a:t>)</a:t>
-            </a:r>
-            <a:endParaRPr lang="en-US" sz="740" dirty="0"/>
-          </a:p>
-        </p:txBody>
-      </p:sp>
-      <p:sp>
-        <p:nvSpPr>
-          <p:cNvPr id="32" name="a.p2.formula2"/>
-          <p:cNvSpPr txBox="1"/>
-          <p:nvPr/>
-        </p:nvSpPr>
-        <p:spPr>
-          <a:xfrm>
-            <a:off x="2133600" y="1412748"/>
-            <a:ext cx="1493520" cy="118872"/>
-          </a:xfrm>
-          <a:prstGeom prst="rect">
-            <a:avLst/>
-          </a:prstGeom>
-          <a:noFill/>
-          <a:ln/>
-        </p:spPr>
-        <p:txBody>
-          <a:bodyPr wrap="square" lIns="0" tIns="0" rIns="0" bIns="0" rtlCol="0" anchor="t"/>
-          <a:lstStyle/>
-          <a:p>
-            <a:pPr algn="ctr" indent="0" marL="0">
-              <a:lnSpc>
-                <a:spcPct val="100000"/>
-              </a:lnSpc>
-              <a:buNone/>
-            </a:pPr>
-            <a:r>
-              <a:rPr lang="en-US" sz="740" dirty="0">
-                <a:solidFill>
-                  <a:srgbClr val="1A1F2B"/>
-                </a:solidFill>
-                <a:latin typeface="Times New Roman" pitchFamily="34" charset="0"/>
-                <a:ea typeface="Times New Roman" pitchFamily="34" charset="-122"/>
-                <a:cs typeface="Times New Roman" pitchFamily="34" charset="-120"/>
-              </a:rPr>
-              <a:t>release  </a:t>
-            </a:r>
-            <a:pPr algn="ctr" indent="0" marL="0">
-              <a:lnSpc>
-                <a:spcPct val="100000"/>
-              </a:lnSpc>
-              <a:buNone/>
-            </a:pPr>
-            <a:r>
-              <a:rPr lang="en-US" sz="740" i="1" dirty="0">
-                <a:solidFill>
-                  <a:srgbClr val="1A1F2B"/>
-                </a:solidFill>
-                <a:latin typeface="Times New Roman" pitchFamily="34" charset="0"/>
-                <a:ea typeface="Times New Roman" pitchFamily="34" charset="-122"/>
-                <a:cs typeface="Times New Roman" pitchFamily="34" charset="-120"/>
-              </a:rPr>
-              <a:t>s</a:t>
-            </a:r>
-            <a:pPr algn="ctr" indent="0" marL="0">
-              <a:lnSpc>
-                <a:spcPct val="100000"/>
-              </a:lnSpc>
-              <a:buNone/>
-            </a:pPr>
-            <a:r>
-              <a:rPr lang="en-US" sz="740" baseline="-40000" dirty="0">
-                <a:solidFill>
-                  <a:srgbClr val="1A1F2B"/>
-                </a:solidFill>
-                <a:latin typeface="Times New Roman" pitchFamily="34" charset="0"/>
-                <a:ea typeface="Times New Roman" pitchFamily="34" charset="-122"/>
-                <a:cs typeface="Times New Roman" pitchFamily="34" charset="-120"/>
-              </a:rPr>
-              <a:t>p</a:t>
-            </a:r>
-            <a:pPr algn="ctr" indent="0" marL="0">
-              <a:lnSpc>
-                <a:spcPct val="100000"/>
-              </a:lnSpc>
-              <a:buNone/>
-            </a:pPr>
-            <a:r>
-              <a:rPr lang="en-US" sz="740" dirty="0">
-                <a:solidFill>
-                  <a:srgbClr val="1A1F2B"/>
-                </a:solidFill>
-                <a:latin typeface="Times New Roman" pitchFamily="34" charset="0"/>
-                <a:ea typeface="Times New Roman" pitchFamily="34" charset="-122"/>
-                <a:cs typeface="Times New Roman" pitchFamily="34" charset="-120"/>
-              </a:rPr>
-              <a:t> + </a:t>
-            </a:r>
-            <a:pPr algn="ctr" indent="0" marL="0">
-              <a:lnSpc>
-                <a:spcPct val="100000"/>
-              </a:lnSpc>
-              <a:buNone/>
-            </a:pPr>
-            <a:r>
-              <a:rPr lang="en-US" sz="740" dirty="0">
-                <a:solidFill>
-                  <a:srgbClr val="1A1F2B"/>
-                </a:solidFill>
-                <a:latin typeface="Cambria Math" pitchFamily="34" charset="0"/>
-                <a:ea typeface="Cambria Math" pitchFamily="34" charset="-122"/>
-                <a:cs typeface="Cambria Math" pitchFamily="34" charset="-120"/>
-              </a:rPr>
-              <a:t>𝒩</a:t>
-            </a:r>
-            <a:pPr algn="ctr" indent="0" marL="0">
-              <a:lnSpc>
-                <a:spcPct val="100000"/>
-              </a:lnSpc>
-              <a:buNone/>
-            </a:pPr>
-            <a:r>
-              <a:rPr lang="en-US" sz="740" dirty="0">
-                <a:solidFill>
-                  <a:srgbClr val="1A1F2B"/>
-                </a:solidFill>
-                <a:latin typeface="Times New Roman" pitchFamily="34" charset="0"/>
-                <a:ea typeface="Times New Roman" pitchFamily="34" charset="-122"/>
-                <a:cs typeface="Times New Roman" pitchFamily="34" charset="-120"/>
-              </a:rPr>
-              <a:t>(0, (</a:t>
-            </a:r>
-            <a:pPr algn="ctr" indent="0" marL="0">
-              <a:lnSpc>
-                <a:spcPct val="100000"/>
-              </a:lnSpc>
-              <a:buNone/>
-            </a:pPr>
-            <a:r>
-              <a:rPr lang="en-US" sz="740" i="1" dirty="0">
-                <a:solidFill>
-                  <a:srgbClr val="1A1F2B"/>
-                </a:solidFill>
-                <a:latin typeface="Times New Roman" pitchFamily="34" charset="0"/>
-                <a:ea typeface="Times New Roman" pitchFamily="34" charset="-122"/>
-                <a:cs typeface="Times New Roman" pitchFamily="34" charset="-120"/>
-              </a:rPr>
-              <a:t>zC</a:t>
-            </a:r>
-            <a:pPr algn="ctr" indent="0" marL="0">
-              <a:lnSpc>
-                <a:spcPct val="100000"/>
-              </a:lnSpc>
-              <a:buNone/>
-            </a:pPr>
-            <a:r>
-              <a:rPr lang="en-US" sz="740" baseline="-40000" dirty="0">
-                <a:solidFill>
-                  <a:srgbClr val="1A1F2B"/>
-                </a:solidFill>
-                <a:latin typeface="Times New Roman" pitchFamily="34" charset="0"/>
-                <a:ea typeface="Times New Roman" pitchFamily="34" charset="-122"/>
-                <a:cs typeface="Times New Roman" pitchFamily="34" charset="-120"/>
-              </a:rPr>
-              <a:t>clip</a:t>
-            </a:r>
-            <a:pPr algn="ctr" indent="0" marL="0">
-              <a:lnSpc>
-                <a:spcPct val="100000"/>
-              </a:lnSpc>
-              <a:buNone/>
-            </a:pPr>
-            <a:r>
-              <a:rPr lang="en-US" sz="740" dirty="0">
-                <a:solidFill>
-                  <a:srgbClr val="1A1F2B"/>
-                </a:solidFill>
-                <a:latin typeface="Times New Roman" pitchFamily="34" charset="0"/>
-                <a:ea typeface="Times New Roman" pitchFamily="34" charset="-122"/>
-                <a:cs typeface="Times New Roman" pitchFamily="34" charset="-120"/>
-              </a:rPr>
-              <a:t>/</a:t>
-            </a:r>
-            <a:pPr algn="ctr" indent="0" marL="0">
-              <a:lnSpc>
-                <a:spcPct val="100000"/>
-              </a:lnSpc>
-              <a:buNone/>
-            </a:pPr>
-            <a:r>
-              <a:rPr lang="en-US" sz="740" i="1" dirty="0">
-                <a:solidFill>
-                  <a:srgbClr val="1A1F2B"/>
-                </a:solidFill>
-                <a:latin typeface="Times New Roman" pitchFamily="34" charset="0"/>
-                <a:ea typeface="Times New Roman" pitchFamily="34" charset="-122"/>
-                <a:cs typeface="Times New Roman" pitchFamily="34" charset="-120"/>
-              </a:rPr>
-              <a:t>b</a:t>
-            </a:r>
-            <a:pPr algn="ctr" indent="0" marL="0">
-              <a:lnSpc>
-                <a:spcPct val="100000"/>
-              </a:lnSpc>
-              <a:buNone/>
-            </a:pPr>
-            <a:r>
-              <a:rPr lang="en-US" sz="740" dirty="0">
-                <a:solidFill>
-                  <a:srgbClr val="1A1F2B"/>
-                </a:solidFill>
-                <a:latin typeface="Times New Roman" pitchFamily="34" charset="0"/>
-                <a:ea typeface="Times New Roman" pitchFamily="34" charset="-122"/>
-                <a:cs typeface="Times New Roman" pitchFamily="34" charset="-120"/>
-              </a:rPr>
-              <a:t>)²)</a:t>
-            </a:r>
-            <a:endParaRPr lang="en-US" sz="740" dirty="0"/>
-          </a:p>
-        </p:txBody>
-      </p:sp>
-      <p:sp>
-        <p:nvSpPr>
-          <p:cNvPr id="33" name="a.p2.body"/>
-          <p:cNvSpPr txBox="1"/>
-          <p:nvPr/>
-        </p:nvSpPr>
-        <p:spPr>
-          <a:xfrm>
-            <a:off x="2161032" y="1554480"/>
-            <a:ext cx="1438656" cy="329184"/>
-          </a:xfrm>
-          <a:prstGeom prst="rect">
-            <a:avLst/>
-          </a:prstGeom>
-          <a:noFill/>
-          <a:ln/>
-        </p:spPr>
-        <p:txBody>
-          <a:bodyPr wrap="square" lIns="0" tIns="0" rIns="0" bIns="0" rtlCol="0" anchor="t"/>
-          <a:lstStyle/>
-          <a:p>
-            <a:pPr algn="l" indent="0" marL="0">
-              <a:lnSpc>
-                <a:spcPct val="96000"/>
-              </a:lnSpc>
-              <a:buNone/>
-            </a:pPr>
-            <a:r>
-              <a:rPr lang="en-US" sz="660" dirty="0">
-                <a:solidFill>
-                  <a:srgbClr val="333B48"/>
-                </a:solidFill>
-                <a:latin typeface="Arial" pitchFamily="34" charset="0"/>
-                <a:ea typeface="Arial" pitchFamily="34" charset="-122"/>
-                <a:cs typeface="Arial" pitchFamily="34" charset="-120"/>
-              </a:rPr>
-              <a:t>Each candidate releases one clipped, sampled-Gaussian score from </a:t>
-            </a:r>
-            <a:pPr algn="l" indent="0" marL="0">
-              <a:lnSpc>
-                <a:spcPct val="96000"/>
-              </a:lnSpc>
-              <a:buNone/>
-            </a:pPr>
-            <a:r>
-              <a:rPr lang="en-US" sz="660" dirty="0">
-                <a:solidFill>
-                  <a:srgbClr val="333B48"/>
-                </a:solidFill>
-                <a:latin typeface="Cambria Math" pitchFamily="34" charset="0"/>
-                <a:ea typeface="Cambria Math" pitchFamily="34" charset="-122"/>
-                <a:cs typeface="Cambria Math" pitchFamily="34" charset="-120"/>
-              </a:rPr>
-              <a:t>𝒟</a:t>
-            </a:r>
-            <a:pPr algn="l" indent="0" marL="0">
-              <a:lnSpc>
-                <a:spcPct val="96000"/>
-              </a:lnSpc>
-              <a:buNone/>
-            </a:pPr>
-            <a:r>
-              <a:rPr lang="en-US" sz="660" dirty="0">
-                <a:solidFill>
-                  <a:srgbClr val="333B48"/>
-                </a:solidFill>
-                <a:latin typeface="Arial" pitchFamily="34" charset="0"/>
-                <a:ea typeface="Arial" pitchFamily="34" charset="-122"/>
-                <a:cs typeface="Arial" pitchFamily="34" charset="-120"/>
-              </a:rPr>
-              <a:t>.</a:t>
-            </a:r>
-            <a:endParaRPr lang="en-US" sz="660" dirty="0"/>
-          </a:p>
-        </p:txBody>
-      </p:sp>
-      <p:sp>
-        <p:nvSpPr>
-          <p:cNvPr id="34" name="a.p2.costPill"/>
-          <p:cNvSpPr/>
-          <p:nvPr/>
-        </p:nvSpPr>
-        <p:spPr>
-          <a:xfrm>
-            <a:off x="2252472" y="1929384"/>
-            <a:ext cx="1255776" cy="182880"/>
-          </a:xfrm>
-          <a:prstGeom prst="roundRect">
-            <a:avLst>
-              <a:gd name="adj" fmla="val 25000"/>
-            </a:avLst>
-          </a:prstGeom>
-          <a:solidFill>
-            <a:srgbClr val="1F3D7A"/>
-          </a:solidFill>
-          <a:ln/>
-        </p:spPr>
-      </p:sp>
-      <p:sp>
-        <p:nvSpPr>
-          <p:cNvPr id="35" name="a.p2.costLabel"/>
-          <p:cNvSpPr txBox="1"/>
-          <p:nvPr/>
-        </p:nvSpPr>
-        <p:spPr>
-          <a:xfrm>
-            <a:off x="2252472" y="1958645"/>
-            <a:ext cx="1255776" cy="137160"/>
-          </a:xfrm>
-          <a:prstGeom prst="rect">
-            <a:avLst/>
-          </a:prstGeom>
-          <a:noFill/>
-          <a:ln/>
-        </p:spPr>
-        <p:txBody>
-          <a:bodyPr wrap="square" lIns="0" tIns="0" rIns="0" bIns="0" rtlCol="0" anchor="t"/>
-          <a:lstStyle/>
-          <a:p>
-            <a:pPr algn="ctr" indent="0" marL="0">
-              <a:lnSpc>
-                <a:spcPct val="100000"/>
-              </a:lnSpc>
-              <a:buNone/>
-            </a:pPr>
-            <a:r>
               <a:rPr lang="en-US" sz="640" b="1" dirty="0">
                 <a:solidFill>
                   <a:srgbClr val="FFFFFF"/>
                 </a:solidFill>
-                <a:latin typeface="Arial" pitchFamily="34" charset="0"/>
-                <a:ea typeface="Arial" pitchFamily="34" charset="-122"/>
-                <a:cs typeface="Arial" pitchFamily="34" charset="-120"/>
+                <a:latin typeface="Arial" panose="020B0604020202090204" pitchFamily="34" charset="0"/>
+                <a:ea typeface="Arial" panose="020B0604020202090204" pitchFamily="34" charset="-122"/>
+                <a:cs typeface="Arial" panose="020B0604020202090204" pitchFamily="34" charset="-120"/>
               </a:rPr>
               <a:t>≤ </a:t>
             </a:r>
-            <a:pPr algn="ctr" indent="0" marL="0">
-              <a:lnSpc>
-                <a:spcPct val="100000"/>
-              </a:lnSpc>
-              <a:buNone/>
-            </a:pPr>
             <a:r>
               <a:rPr lang="en-US" sz="640" b="1" i="1" dirty="0">
                 <a:solidFill>
                   <a:srgbClr val="FFFFFF"/>
                 </a:solidFill>
-                <a:latin typeface="Arial" pitchFamily="34" charset="0"/>
-                <a:ea typeface="Arial" pitchFamily="34" charset="-122"/>
-                <a:cs typeface="Arial" pitchFamily="34" charset="-120"/>
+                <a:latin typeface="Arial" panose="020B0604020202090204" pitchFamily="34" charset="0"/>
+                <a:ea typeface="Arial" panose="020B0604020202090204" pitchFamily="34" charset="-122"/>
+                <a:cs typeface="Arial" panose="020B0604020202090204" pitchFamily="34" charset="-120"/>
               </a:rPr>
               <a:t>TK</a:t>
             </a:r>
-            <a:pPr algn="ctr" indent="0" marL="0">
-              <a:lnSpc>
-                <a:spcPct val="100000"/>
-              </a:lnSpc>
-              <a:buNone/>
-            </a:pPr>
             <a:r>
               <a:rPr lang="en-US" sz="640" b="1" dirty="0">
                 <a:solidFill>
                   <a:srgbClr val="FFFFFF"/>
                 </a:solidFill>
-                <a:latin typeface="Arial" pitchFamily="34" charset="0"/>
-                <a:ea typeface="Arial" pitchFamily="34" charset="-122"/>
-                <a:cs typeface="Arial" pitchFamily="34" charset="-120"/>
+                <a:latin typeface="Arial" panose="020B0604020202090204" pitchFamily="34" charset="0"/>
+                <a:ea typeface="Arial" panose="020B0604020202090204" pitchFamily="34" charset="-122"/>
+                <a:cs typeface="Arial" panose="020B0604020202090204" pitchFamily="34" charset="-120"/>
               </a:rPr>
               <a:t> score releases total</a:t>
             </a:r>
@@ -2820,7 +2611,6 @@
           <a:solidFill>
             <a:srgbClr val="2E7D32"/>
           </a:solidFill>
-          <a:ln/>
         </p:spPr>
       </p:sp>
       <p:sp>
@@ -2867,7 +2657,6 @@
           <a:solidFill>
             <a:srgbClr val="FFFFFF"/>
           </a:solidFill>
-          <a:ln/>
         </p:spPr>
       </p:sp>
       <p:sp>
@@ -2885,13 +2674,12 @@
             <a:avLst/>
           </a:prstGeom>
           <a:noFill/>
-          <a:ln/>
         </p:spPr>
         <p:txBody>
           <a:bodyPr wrap="square" lIns="0" tIns="0" rIns="0" bIns="0" rtlCol="0" anchor="ctr"/>
           <a:lstStyle/>
           <a:p>
-            <a:pPr algn="ctr" indent="0" marL="0">
+            <a:pPr marL="0" indent="0" algn="ctr">
               <a:lnSpc>
                 <a:spcPct val="104000"/>
               </a:lnSpc>
@@ -2902,16 +2690,16 @@
                 <a:solidFill>
                   <a:srgbClr val="2E7D32"/>
                 </a:solidFill>
-                <a:latin typeface="Arial" pitchFamily="34" charset="0"/>
-                <a:ea typeface="Arial" pitchFamily="34" charset="-122"/>
-                <a:cs typeface="Arial" pitchFamily="34" charset="-120"/>
+                <a:latin typeface="Arial" panose="020B0604020202090204" pitchFamily="34" charset="0"/>
+                <a:ea typeface="Arial" panose="020B0604020202090204" pitchFamily="34" charset="-122"/>
+                <a:cs typeface="Arial" panose="020B0604020202090204" pitchFamily="34" charset="-120"/>
               </a:rPr>
               <a:t>Phase 3</a:t>
             </a:r>
             <a:endParaRPr lang="en-US" sz="780" dirty="0"/>
           </a:p>
           <a:p>
-            <a:pPr algn="ctr" indent="0" marL="0">
+            <a:pPr marL="0" indent="0" algn="ctr">
               <a:lnSpc>
                 <a:spcPct val="104000"/>
               </a:lnSpc>
@@ -2922,9 +2710,9 @@
                 <a:solidFill>
                   <a:srgbClr val="2E7D32"/>
                 </a:solidFill>
-                <a:latin typeface="Arial" pitchFamily="34" charset="0"/>
-                <a:ea typeface="Arial" pitchFamily="34" charset="-122"/>
-                <a:cs typeface="Arial" pitchFamily="34" charset="-120"/>
+                <a:latin typeface="Arial" panose="020B0604020202090204" pitchFamily="34" charset="0"/>
+                <a:ea typeface="Arial" panose="020B0604020202090204" pitchFamily="34" charset="-122"/>
+                <a:cs typeface="Arial" panose="020B0604020202090204" pitchFamily="34" charset="-120"/>
               </a:rPr>
               <a:t>Post-process &amp; select</a:t>
             </a:r>
@@ -2940,37 +2728,43 @@
         </p:nvSpPr>
         <p:spPr>
           <a:xfrm>
-            <a:off x="4011168" y="1293876"/>
-            <a:ext cx="1493520" cy="118872"/>
+            <a:off x="3950208" y="1261872"/>
+            <a:ext cx="1618488" cy="118872"/>
           </a:xfrm>
           <a:prstGeom prst="rect">
             <a:avLst/>
           </a:prstGeom>
           <a:noFill/>
-          <a:ln/>
         </p:spPr>
         <p:txBody>
           <a:bodyPr wrap="square" lIns="0" tIns="0" rIns="0" bIns="0" rtlCol="0" anchor="t"/>
           <a:lstStyle/>
           <a:p>
-            <a:pPr algn="ctr" indent="0" marL="0">
+            <a:pPr marL="0" indent="0" algn="ctr">
               <a:lnSpc>
                 <a:spcPct val="100000"/>
               </a:lnSpc>
               <a:buNone/>
             </a:pPr>
             <a:r>
-              <a:rPr lang="en-US" sz="720" dirty="0">
+              <a:rPr lang="en-US" sz="800" dirty="0">
                 <a:solidFill>
                   <a:srgbClr val="1A1F2B"/>
                 </a:solidFill>
-                <a:latin typeface="Times New Roman" pitchFamily="34" charset="0"/>
-                <a:ea typeface="Times New Roman" pitchFamily="34" charset="-122"/>
-                <a:cs typeface="Times New Roman" pitchFamily="34" charset="-120"/>
+                <a:latin typeface="Times New Roman Regular" panose="02020503050405090304" charset="0"/>
+                <a:ea typeface="Times New Roman" panose="02020503050405090304" pitchFamily="34" charset="-122"/>
+                <a:cs typeface="Times New Roman Regular" panose="02020503050405090304" charset="0"/>
               </a:rPr>
               <a:t>Gumbel-smoothed or deterministic</a:t>
             </a:r>
-            <a:endParaRPr lang="en-US" sz="720" dirty="0"/>
+            <a:endParaRPr lang="en-US" sz="800" dirty="0">
+              <a:solidFill>
+                <a:srgbClr val="1A1F2B"/>
+              </a:solidFill>
+              <a:latin typeface="Times New Roman Regular" panose="02020503050405090304" charset="0"/>
+              <a:ea typeface="Times New Roman" panose="02020503050405090304" pitchFamily="34" charset="-122"/>
+              <a:cs typeface="Times New Roman Regular" panose="02020503050405090304" charset="0"/>
+            </a:endParaRPr>
           </a:p>
         </p:txBody>
       </p:sp>
@@ -2982,37 +2776,43 @@
         </p:nvSpPr>
         <p:spPr>
           <a:xfrm>
-            <a:off x="4011168" y="1412748"/>
-            <a:ext cx="1493520" cy="118872"/>
+            <a:off x="3950208" y="1472184"/>
+            <a:ext cx="1618488" cy="118872"/>
           </a:xfrm>
           <a:prstGeom prst="rect">
             <a:avLst/>
           </a:prstGeom>
           <a:noFill/>
-          <a:ln/>
         </p:spPr>
         <p:txBody>
           <a:bodyPr wrap="square" lIns="0" tIns="0" rIns="0" bIns="0" rtlCol="0" anchor="t"/>
           <a:lstStyle/>
           <a:p>
-            <a:pPr algn="ctr" indent="0" marL="0">
+            <a:pPr marL="0" indent="0" algn="ctr">
               <a:lnSpc>
                 <a:spcPct val="100000"/>
               </a:lnSpc>
               <a:buNone/>
             </a:pPr>
             <a:r>
-              <a:rPr lang="en-US" sz="720" dirty="0">
+              <a:rPr lang="en-US" sz="800" dirty="0">
                 <a:solidFill>
                   <a:srgbClr val="1A1F2B"/>
                 </a:solidFill>
-                <a:latin typeface="Times New Roman" pitchFamily="34" charset="0"/>
-                <a:ea typeface="Times New Roman" pitchFamily="34" charset="-122"/>
-                <a:cs typeface="Times New Roman" pitchFamily="34" charset="-120"/>
+                <a:latin typeface="Times New Roman Regular" panose="02020503050405090304" charset="0"/>
+                <a:ea typeface="Times New Roman" panose="02020503050405090304" pitchFamily="34" charset="-122"/>
+                <a:cs typeface="Times New Roman Regular" panose="02020503050405090304" charset="0"/>
               </a:rPr>
               <a:t>Top-M(privatized scores)</a:t>
             </a:r>
-            <a:endParaRPr lang="en-US" sz="720" dirty="0"/>
+            <a:endParaRPr lang="en-US" sz="800" dirty="0">
+              <a:solidFill>
+                <a:srgbClr val="1A1F2B"/>
+              </a:solidFill>
+              <a:latin typeface="Times New Roman Regular" panose="02020503050405090304" charset="0"/>
+              <a:ea typeface="Times New Roman" panose="02020503050405090304" pitchFamily="34" charset="-122"/>
+              <a:cs typeface="Times New Roman Regular" panose="02020503050405090304" charset="0"/>
+            </a:endParaRPr>
           </a:p>
         </p:txBody>
       </p:sp>
@@ -3024,37 +2824,43 @@
         </p:nvSpPr>
         <p:spPr>
           <a:xfrm>
-            <a:off x="4038600" y="1554480"/>
+            <a:off x="4109720" y="1659890"/>
             <a:ext cx="1438656" cy="329184"/>
           </a:xfrm>
           <a:prstGeom prst="rect">
             <a:avLst/>
           </a:prstGeom>
           <a:noFill/>
-          <a:ln/>
         </p:spPr>
         <p:txBody>
           <a:bodyPr wrap="square" lIns="0" tIns="0" rIns="0" bIns="0" rtlCol="0" anchor="t"/>
           <a:lstStyle/>
           <a:p>
-            <a:pPr algn="l" indent="0" marL="0">
+            <a:pPr marL="0" indent="0" algn="l">
               <a:lnSpc>
                 <a:spcPct val="96000"/>
               </a:lnSpc>
               <a:buNone/>
             </a:pPr>
             <a:r>
-              <a:rPr lang="en-US" sz="660" dirty="0">
+              <a:rPr lang="en-US" sz="700" dirty="0">
                 <a:solidFill>
                   <a:srgbClr val="333B48"/>
                 </a:solidFill>
-                <a:latin typeface="Arial" pitchFamily="34" charset="0"/>
-                <a:ea typeface="Arial" pitchFamily="34" charset="-122"/>
-                <a:cs typeface="Arial" pitchFamily="34" charset="-120"/>
+                <a:latin typeface="Times New Roman Regular" panose="02020503050405090304" charset="0"/>
+                <a:ea typeface="Arial" panose="020B0604020202090204" pitchFamily="34" charset="-122"/>
+                <a:cs typeface="Times New Roman Regular" panose="02020503050405090304" charset="0"/>
               </a:rPr>
               <a:t>Top-M uses only released scores; both options are post-processing.</a:t>
             </a:r>
-            <a:endParaRPr lang="en-US" sz="660" dirty="0"/>
+            <a:endParaRPr lang="en-US" sz="700" dirty="0">
+              <a:solidFill>
+                <a:srgbClr val="333B48"/>
+              </a:solidFill>
+              <a:latin typeface="Times New Roman Regular" panose="02020503050405090304" charset="0"/>
+              <a:ea typeface="Arial" panose="020B0604020202090204" pitchFamily="34" charset="-122"/>
+              <a:cs typeface="Times New Roman Regular" panose="02020503050405090304" charset="0"/>
+            </a:endParaRPr>
           </a:p>
         </p:txBody>
       </p:sp>
@@ -3077,7 +2883,6 @@
           <a:solidFill>
             <a:srgbClr val="2E7D32"/>
           </a:solidFill>
-          <a:ln/>
         </p:spPr>
       </p:sp>
       <p:sp>
@@ -3095,13 +2900,12 @@
             <a:avLst/>
           </a:prstGeom>
           <a:noFill/>
-          <a:ln/>
         </p:spPr>
         <p:txBody>
           <a:bodyPr wrap="square" lIns="0" tIns="0" rIns="0" bIns="0" rtlCol="0" anchor="t"/>
           <a:lstStyle/>
           <a:p>
-            <a:pPr algn="ctr" indent="0" marL="0">
+            <a:pPr marL="0" indent="0" algn="ctr">
               <a:lnSpc>
                 <a:spcPct val="100000"/>
               </a:lnSpc>
@@ -3112,9 +2916,9 @@
                 <a:solidFill>
                   <a:srgbClr val="FFFFFF"/>
                 </a:solidFill>
-                <a:latin typeface="Arial" pitchFamily="34" charset="0"/>
-                <a:ea typeface="Arial" pitchFamily="34" charset="-122"/>
-                <a:cs typeface="Arial" pitchFamily="34" charset="-120"/>
+                <a:latin typeface="Arial" panose="020B0604020202090204" pitchFamily="34" charset="0"/>
+                <a:ea typeface="Arial" panose="020B0604020202090204" pitchFamily="34" charset="-122"/>
+                <a:cs typeface="Arial" panose="020B0604020202090204" pitchFamily="34" charset="-120"/>
               </a:rPr>
               <a:t>0 additional privacy loss</a:t>
             </a:r>
@@ -3233,67 +3037,66 @@
             <a:avLst/>
           </a:prstGeom>
           <a:noFill/>
-          <a:ln/>
         </p:spPr>
         <p:txBody>
           <a:bodyPr wrap="square" lIns="0" tIns="0" rIns="0" bIns="0" rtlCol="0" anchor="ctr"/>
           <a:lstStyle/>
           <a:p>
-            <a:pPr algn="l" indent="0" marL="0">
+            <a:pPr marL="0" indent="0" algn="l">
               <a:lnSpc>
                 <a:spcPct val="102000"/>
               </a:lnSpc>
               <a:buNone/>
             </a:pPr>
             <a:r>
-              <a:rPr lang="en-US" sz="680" b="1" dirty="0">
+              <a:rPr lang="en-US" sz="800" b="1" dirty="0">
                 <a:solidFill>
                   <a:srgbClr val="0E7C7B"/>
                 </a:solidFill>
-                <a:latin typeface="Arial" pitchFamily="34" charset="0"/>
-                <a:ea typeface="Arial" pitchFamily="34" charset="-122"/>
-                <a:cs typeface="Arial" pitchFamily="34" charset="-120"/>
+                <a:latin typeface="Times New Roman Regular" panose="02020503050405090304" charset="0"/>
+                <a:ea typeface="Arial" panose="020B0604020202090204" pitchFamily="34" charset="-122"/>
+                <a:cs typeface="Times New Roman Regular" panose="02020503050405090304" charset="0"/>
               </a:rPr>
               <a:t>Mutation never</a:t>
             </a:r>
-            <a:endParaRPr lang="en-US" sz="680" dirty="0"/>
+            <a:endParaRPr lang="en-US" sz="800" dirty="0">
+              <a:latin typeface="Times New Roman Regular" panose="02020503050405090304" charset="0"/>
+              <a:cs typeface="Times New Roman Regular" panose="02020503050405090304" charset="0"/>
+            </a:endParaRPr>
           </a:p>
           <a:p>
-            <a:pPr algn="l" indent="0" marL="0">
+            <a:pPr marL="0" indent="0" algn="l">
               <a:lnSpc>
                 <a:spcPct val="102000"/>
               </a:lnSpc>
               <a:buNone/>
             </a:pPr>
             <a:r>
-              <a:rPr lang="en-US" sz="680" b="1" dirty="0">
+              <a:rPr lang="en-US" sz="800" b="1" dirty="0">
                 <a:solidFill>
                   <a:srgbClr val="0E7C7B"/>
                 </a:solidFill>
-                <a:latin typeface="Arial" pitchFamily="34" charset="0"/>
-                <a:ea typeface="Arial" pitchFamily="34" charset="-122"/>
-                <a:cs typeface="Arial" pitchFamily="34" charset="-120"/>
+                <a:latin typeface="Times New Roman Regular" panose="02020503050405090304" charset="0"/>
+                <a:ea typeface="Arial" panose="020B0604020202090204" pitchFamily="34" charset="-122"/>
+                <a:cs typeface="Times New Roman Regular" panose="02020503050405090304" charset="0"/>
               </a:rPr>
               <a:t>reads </a:t>
             </a:r>
-            <a:pPr algn="l" indent="0" marL="0">
-              <a:lnSpc>
-                <a:spcPct val="102000"/>
-              </a:lnSpc>
-              <a:buNone/>
-            </a:pPr>
-            <a:r>
-              <a:rPr lang="en-US" sz="680" b="1" dirty="0">
+            <a:r>
+              <a:rPr lang="en-US" sz="800" b="1" dirty="0">
                 <a:solidFill>
                   <a:srgbClr val="0E7C7B"/>
                 </a:solidFill>
-                <a:latin typeface="Cambria Math" pitchFamily="34" charset="0"/>
+                <a:latin typeface="Times New Roman Regular" panose="02020503050405090304" charset="0"/>
                 <a:ea typeface="Cambria Math" pitchFamily="34" charset="-122"/>
-                <a:cs typeface="Cambria Math" pitchFamily="34" charset="-120"/>
+                <a:cs typeface="Times New Roman Regular" panose="02020503050405090304" charset="0"/>
               </a:rPr>
               <a:t>𝒟</a:t>
             </a:r>
-            <a:endParaRPr lang="en-US" sz="680" dirty="0"/>
+            <a:endParaRPr lang="en-US" sz="800" dirty="0">
+              <a:latin typeface="Times New Roman Regular" panose="02020503050405090304" charset="0"/>
+              <a:cs typeface="Times New Roman Regular" panose="02020503050405090304" charset="0"/>
+            </a:endParaRPr>
           </a:p>
         </p:txBody>
       </p:sp>
@@ -3337,135 +3140,110 @@
             <a:avLst/>
           </a:prstGeom>
           <a:noFill/>
-          <a:ln/>
         </p:spPr>
         <p:txBody>
           <a:bodyPr wrap="square" lIns="0" tIns="0" rIns="0" bIns="0" rtlCol="0" anchor="ctr"/>
           <a:lstStyle/>
           <a:p>
-            <a:pPr algn="l" indent="0" marL="0">
+            <a:pPr marL="0" indent="0" algn="l">
               <a:lnSpc>
                 <a:spcPct val="102000"/>
               </a:lnSpc>
               <a:buNone/>
             </a:pPr>
             <a:r>
-              <a:rPr lang="en-US" sz="680" dirty="0">
+              <a:rPr lang="en-US" sz="800" dirty="0">
                 <a:solidFill>
                   <a:srgbClr val="1F3D7A"/>
                 </a:solidFill>
-                <a:latin typeface="Cambria Math" pitchFamily="34" charset="0"/>
+                <a:latin typeface="Times New Roman Regular" panose="02020503050405090304" charset="0"/>
                 <a:ea typeface="Cambria Math" pitchFamily="34" charset="-122"/>
-                <a:cs typeface="Cambria Math" pitchFamily="34" charset="-120"/>
+                <a:cs typeface="Times New Roman Regular" panose="02020503050405090304" charset="0"/>
               </a:rPr>
               <a:t>𝒟</a:t>
             </a:r>
-            <a:pPr algn="l" indent="0" marL="0">
+            <a:r>
+              <a:rPr lang="en-US" sz="800" dirty="0">
+                <a:solidFill>
+                  <a:srgbClr val="1F3D7A"/>
+                </a:solidFill>
+                <a:latin typeface="Times New Roman Regular" panose="02020503050405090304" charset="0"/>
+                <a:ea typeface="Arial" panose="020B0604020202090204" pitchFamily="34" charset="-122"/>
+                <a:cs typeface="Times New Roman Regular" panose="02020503050405090304" charset="0"/>
+              </a:rPr>
+              <a:t>: </a:t>
+            </a:r>
+            <a:r>
+              <a:rPr lang="en-US" sz="800" b="1" dirty="0">
+                <a:solidFill>
+                  <a:srgbClr val="1F3D7A"/>
+                </a:solidFill>
+                <a:latin typeface="Times New Roman Regular" panose="02020503050405090304" charset="0"/>
+                <a:ea typeface="Arial" panose="020B0604020202090204" pitchFamily="34" charset="-122"/>
+                <a:cs typeface="Times New Roman Regular" panose="02020503050405090304" charset="0"/>
+              </a:rPr>
+              <a:t>private</a:t>
+            </a:r>
+            <a:r>
+              <a:rPr lang="en-US" sz="800" dirty="0">
+                <a:solidFill>
+                  <a:srgbClr val="1F3D7A"/>
+                </a:solidFill>
+                <a:latin typeface="Times New Roman Regular" panose="02020503050405090304" charset="0"/>
+                <a:ea typeface="Arial" panose="020B0604020202090204" pitchFamily="34" charset="-122"/>
+                <a:cs typeface="Times New Roman Regular" panose="02020503050405090304" charset="0"/>
+              </a:rPr>
+              <a:t> optimization</a:t>
+            </a:r>
+            <a:endParaRPr lang="en-US" sz="800" dirty="0">
+              <a:latin typeface="Times New Roman Regular" panose="02020503050405090304" charset="0"/>
+              <a:cs typeface="Times New Roman Regular" panose="02020503050405090304" charset="0"/>
+            </a:endParaRPr>
+          </a:p>
+          <a:p>
+            <a:pPr marL="0" indent="0" algn="l">
               <a:lnSpc>
                 <a:spcPct val="102000"/>
               </a:lnSpc>
               <a:buNone/>
             </a:pPr>
             <a:r>
-              <a:rPr lang="en-US" sz="680" dirty="0">
+              <a:rPr lang="en-US" sz="800" dirty="0">
                 <a:solidFill>
                   <a:srgbClr val="1F3D7A"/>
                 </a:solidFill>
-                <a:latin typeface="Arial" pitchFamily="34" charset="0"/>
-                <a:ea typeface="Arial" pitchFamily="34" charset="-122"/>
-                <a:cs typeface="Arial" pitchFamily="34" charset="-120"/>
-              </a:rPr>
-              <a:t>: </a:t>
-            </a:r>
-            <a:pPr algn="l" indent="0" marL="0">
-              <a:lnSpc>
-                <a:spcPct val="102000"/>
-              </a:lnSpc>
-              <a:buNone/>
-            </a:pPr>
-            <a:r>
-              <a:rPr lang="en-US" sz="680" b="1" dirty="0">
+                <a:latin typeface="Times New Roman Regular" panose="02020503050405090304" charset="0"/>
+                <a:ea typeface="Arial" panose="020B0604020202090204" pitchFamily="34" charset="-122"/>
+                <a:cs typeface="Times New Roman Regular" panose="02020503050405090304" charset="0"/>
+              </a:rPr>
+              <a:t>set (</a:t>
+            </a:r>
+            <a:r>
+              <a:rPr lang="en-US" sz="800" i="1" dirty="0">
                 <a:solidFill>
                   <a:srgbClr val="1F3D7A"/>
                 </a:solidFill>
-                <a:latin typeface="Arial" pitchFamily="34" charset="0"/>
-                <a:ea typeface="Arial" pitchFamily="34" charset="-122"/>
-                <a:cs typeface="Arial" pitchFamily="34" charset="-120"/>
-              </a:rPr>
-              <a:t>private</a:t>
-            </a:r>
-            <a:pPr algn="l" indent="0" marL="0">
-              <a:lnSpc>
-                <a:spcPct val="102000"/>
-              </a:lnSpc>
-              <a:buNone/>
-            </a:pPr>
-            <a:r>
-              <a:rPr lang="en-US" sz="680" dirty="0">
+                <a:latin typeface="Times New Roman Regular" panose="02020503050405090304" charset="0"/>
+                <a:ea typeface="Arial" panose="020B0604020202090204" pitchFamily="34" charset="-122"/>
+                <a:cs typeface="Times New Roman Regular" panose="02020503050405090304" charset="0"/>
+              </a:rPr>
+              <a:t>n</a:t>
+            </a:r>
+            <a:r>
+              <a:rPr lang="en-US" sz="800" dirty="0">
                 <a:solidFill>
                   <a:srgbClr val="1F3D7A"/>
                 </a:solidFill>
-                <a:latin typeface="Arial" pitchFamily="34" charset="0"/>
-                <a:ea typeface="Arial" pitchFamily="34" charset="-122"/>
-                <a:cs typeface="Arial" pitchFamily="34" charset="-120"/>
-              </a:rPr>
-              <a:t> optimization</a:t>
-            </a:r>
-            <a:endParaRPr lang="en-US" sz="680" dirty="0"/>
-          </a:p>
-          <a:p>
-            <a:pPr algn="l" indent="0" marL="0">
-              <a:lnSpc>
-                <a:spcPct val="102000"/>
-              </a:lnSpc>
-              <a:buNone/>
-            </a:pPr>
-            <a:r>
-              <a:rPr lang="en-US" sz="680" dirty="0">
-                <a:solidFill>
-                  <a:srgbClr val="1F3D7A"/>
-                </a:solidFill>
-                <a:latin typeface="Arial" pitchFamily="34" charset="0"/>
-                <a:ea typeface="Arial" pitchFamily="34" charset="-122"/>
-                <a:cs typeface="Arial" pitchFamily="34" charset="-120"/>
-              </a:rPr>
-              <a:t>set (</a:t>
-            </a:r>
-            <a:pPr algn="l" indent="0" marL="0">
-              <a:lnSpc>
-                <a:spcPct val="102000"/>
-              </a:lnSpc>
-              <a:buNone/>
-            </a:pPr>
-            <a:r>
-              <a:rPr lang="en-US" sz="680" i="1" dirty="0">
-                <a:solidFill>
-                  <a:srgbClr val="1F3D7A"/>
-                </a:solidFill>
-                <a:latin typeface="Arial" pitchFamily="34" charset="0"/>
-                <a:ea typeface="Arial" pitchFamily="34" charset="-122"/>
-                <a:cs typeface="Arial" pitchFamily="34" charset="-120"/>
-              </a:rPr>
-              <a:t>n</a:t>
-            </a:r>
-            <a:pPr algn="l" indent="0" marL="0">
-              <a:lnSpc>
-                <a:spcPct val="102000"/>
-              </a:lnSpc>
-              <a:buNone/>
-            </a:pPr>
-            <a:r>
-              <a:rPr lang="en-US" sz="680" dirty="0">
-                <a:solidFill>
-                  <a:srgbClr val="1F3D7A"/>
-                </a:solidFill>
-                <a:latin typeface="Arial" pitchFamily="34" charset="0"/>
-                <a:ea typeface="Arial" pitchFamily="34" charset="-122"/>
-                <a:cs typeface="Arial" pitchFamily="34" charset="-120"/>
+                <a:latin typeface="Times New Roman Regular" panose="02020503050405090304" charset="0"/>
+                <a:ea typeface="Arial" panose="020B0604020202090204" pitchFamily="34" charset="-122"/>
+                <a:cs typeface="Times New Roman Regular" panose="02020503050405090304" charset="0"/>
               </a:rPr>
               <a:t> records)</a:t>
             </a:r>
-            <a:endParaRPr lang="en-US" sz="680" dirty="0"/>
+            <a:endParaRPr lang="en-US" sz="800" dirty="0">
+              <a:latin typeface="Times New Roman Regular" panose="02020503050405090304" charset="0"/>
+              <a:cs typeface="Times New Roman Regular" panose="02020503050405090304" charset="0"/>
+            </a:endParaRPr>
           </a:p>
         </p:txBody>
       </p:sp>
@@ -3556,50 +3334,55 @@
             <a:avLst/>
           </a:prstGeom>
           <a:noFill/>
-          <a:ln/>
         </p:spPr>
         <p:txBody>
           <a:bodyPr wrap="square" lIns="0" tIns="0" rIns="0" bIns="0" rtlCol="0" anchor="ctr"/>
           <a:lstStyle/>
           <a:p>
-            <a:pPr algn="l" indent="0" marL="0">
+            <a:pPr marL="0" indent="0" algn="l">
               <a:lnSpc>
                 <a:spcPct val="102000"/>
               </a:lnSpc>
               <a:buNone/>
             </a:pPr>
             <a:r>
-              <a:rPr lang="en-US" sz="680" b="1" dirty="0">
+              <a:rPr lang="en-US" sz="800" b="1" dirty="0">
                 <a:solidFill>
                   <a:srgbClr val="2E7D32"/>
                 </a:solidFill>
-                <a:latin typeface="Arial" pitchFamily="34" charset="0"/>
-                <a:ea typeface="Arial" pitchFamily="34" charset="-122"/>
-                <a:cs typeface="Arial" pitchFamily="34" charset="-120"/>
+                <a:latin typeface="Times New Roman Regular" panose="02020503050405090304" charset="0"/>
+                <a:ea typeface="Arial" panose="020B0604020202090204" pitchFamily="34" charset="-122"/>
+                <a:cs typeface="Times New Roman Regular" panose="02020503050405090304" charset="0"/>
               </a:rPr>
               <a:t>Selection reads only</a:t>
             </a:r>
-            <a:endParaRPr lang="en-US" sz="680" dirty="0"/>
+            <a:endParaRPr lang="en-US" sz="800" dirty="0">
+              <a:latin typeface="Times New Roman Regular" panose="02020503050405090304" charset="0"/>
+              <a:cs typeface="Times New Roman Regular" panose="02020503050405090304" charset="0"/>
+            </a:endParaRPr>
           </a:p>
           <a:p>
-            <a:pPr algn="l" indent="0" marL="0">
+            <a:pPr marL="0" indent="0" algn="l">
               <a:lnSpc>
                 <a:spcPct val="102000"/>
               </a:lnSpc>
               <a:buNone/>
             </a:pPr>
             <a:r>
-              <a:rPr lang="en-US" sz="680" b="1" dirty="0">
+              <a:rPr lang="en-US" sz="800" b="1" dirty="0">
                 <a:solidFill>
                   <a:srgbClr val="2E7D32"/>
                 </a:solidFill>
-                <a:latin typeface="Arial" pitchFamily="34" charset="0"/>
-                <a:ea typeface="Arial" pitchFamily="34" charset="-122"/>
-                <a:cs typeface="Arial" pitchFamily="34" charset="-120"/>
+                <a:latin typeface="Times New Roman Regular" panose="02020503050405090304" charset="0"/>
+                <a:ea typeface="Arial" panose="020B0604020202090204" pitchFamily="34" charset="-122"/>
+                <a:cs typeface="Times New Roman Regular" panose="02020503050405090304" charset="0"/>
               </a:rPr>
               <a:t>privatized scores</a:t>
             </a:r>
-            <a:endParaRPr lang="en-US" sz="680" dirty="0"/>
+            <a:endParaRPr lang="en-US" sz="800" dirty="0">
+              <a:latin typeface="Times New Roman Regular" panose="02020503050405090304" charset="0"/>
+              <a:cs typeface="Times New Roman Regular" panose="02020503050405090304" charset="0"/>
+            </a:endParaRPr>
           </a:p>
         </p:txBody>
       </p:sp>
@@ -3645,229 +3428,176 @@
             <a:avLst/>
           </a:prstGeom>
           <a:noFill/>
-          <a:ln/>
         </p:spPr>
         <p:txBody>
           <a:bodyPr wrap="square" lIns="0" tIns="0" rIns="0" bIns="0" rtlCol="0" anchor="t"/>
           <a:lstStyle/>
           <a:p>
-            <a:pPr algn="ctr" indent="0" marL="0">
+            <a:pPr marL="0" indent="0" algn="ctr">
               <a:lnSpc>
                 <a:spcPct val="100000"/>
               </a:lnSpc>
               <a:buNone/>
             </a:pPr>
             <a:r>
-              <a:rPr lang="en-US" sz="720" b="1" dirty="0">
+              <a:rPr lang="en-US" sz="800" b="1" dirty="0">
                 <a:solidFill>
                   <a:srgbClr val="1F3D7A"/>
                 </a:solidFill>
-                <a:latin typeface="Arial" pitchFamily="34" charset="0"/>
-                <a:ea typeface="Arial" pitchFamily="34" charset="-122"/>
-                <a:cs typeface="Arial" pitchFamily="34" charset="-120"/>
-              </a:rPr>
-              <a:t>Privacy accounting:</a:t>
-            </a:r>
-            <a:pPr algn="ctr" indent="0" marL="0">
+                <a:latin typeface="Times New Roman" panose="02020503050405090304" pitchFamily="34" charset="0"/>
+                <a:ea typeface="Arial" panose="020B0604020202090204" pitchFamily="34" charset="-122"/>
+                <a:cs typeface="Times New Roman" panose="02020503050405090304" pitchFamily="34" charset="0"/>
+              </a:rPr>
+              <a:t>Privacy accounting: </a:t>
+            </a:r>
+            <a:r>
+              <a:rPr lang="en-US" sz="800" dirty="0">
+                <a:solidFill>
+                  <a:srgbClr val="1F3D7A"/>
+                </a:solidFill>
+                <a:latin typeface="Times New Roman" panose="02020503050405090304" pitchFamily="34" charset="0"/>
+                <a:ea typeface="Arial" panose="020B0604020202090204" pitchFamily="34" charset="-122"/>
+                <a:cs typeface="Times New Roman" panose="02020503050405090304" pitchFamily="34" charset="0"/>
+              </a:rPr>
+              <a:t> at most TK sampled-Gaussian score releases compose in one</a:t>
+            </a:r>
+            <a:endParaRPr lang="en-US" sz="800" dirty="0">
+              <a:solidFill>
+                <a:srgbClr val="1F3D7A"/>
+              </a:solidFill>
+              <a:latin typeface="Times New Roman" panose="02020503050405090304" pitchFamily="34" charset="0"/>
+              <a:ea typeface="Arial" panose="020B0604020202090204" pitchFamily="34" charset="-122"/>
+              <a:cs typeface="Times New Roman" panose="02020503050405090304" pitchFamily="34" charset="0"/>
+            </a:endParaRPr>
+          </a:p>
+        </p:txBody>
+      </p:sp>
+      <p:sp>
+        <p:nvSpPr>
+          <p:cNvPr id="58" name="a.acct.line2"/>
+          <p:cNvSpPr txBox="1"/>
+          <p:nvPr/>
+        </p:nvSpPr>
+        <p:spPr>
+          <a:xfrm>
+            <a:off x="521208" y="2948940"/>
+            <a:ext cx="4718304" cy="128016"/>
+          </a:xfrm>
+          <a:prstGeom prst="rect">
+            <a:avLst/>
+          </a:prstGeom>
+          <a:noFill/>
+        </p:spPr>
+        <p:txBody>
+          <a:bodyPr wrap="square" lIns="0" tIns="0" rIns="0" bIns="0" rtlCol="0" anchor="t"/>
+          <a:lstStyle/>
+          <a:p>
+            <a:pPr marL="0" indent="0" algn="ctr">
               <a:lnSpc>
                 <a:spcPct val="100000"/>
               </a:lnSpc>
               <a:buNone/>
             </a:pPr>
             <a:r>
-              <a:rPr lang="en-US" sz="720" dirty="0">
+              <a:rPr lang="en-US" sz="800" dirty="0">
                 <a:solidFill>
                   <a:srgbClr val="1F3D7A"/>
                 </a:solidFill>
-                <a:latin typeface="Arial" pitchFamily="34" charset="0"/>
-                <a:ea typeface="Arial" pitchFamily="34" charset="-122"/>
-                <a:cs typeface="Arial" pitchFamily="34" charset="-120"/>
-              </a:rPr>
-              <a:t>  at most </a:t>
-            </a:r>
-            <a:pPr algn="ctr" indent="0" marL="0">
+                <a:latin typeface="Times New Roman" panose="02020503050405090304" pitchFamily="34" charset="0"/>
+                <a:ea typeface="Arial" panose="020B0604020202090204" pitchFamily="34" charset="-122"/>
+                <a:cs typeface="Times New Roman" panose="02020503050405090304" pitchFamily="34" charset="0"/>
+              </a:rPr>
+              <a:t>RDP accountant  ⟹  overall (ε, δ)-DP.   Mutation and selection add no privacy loss.</a:t>
+            </a:r>
+            <a:endParaRPr lang="en-US" sz="800" dirty="0">
+              <a:solidFill>
+                <a:srgbClr val="1F3D7A"/>
+              </a:solidFill>
+              <a:latin typeface="Times New Roman" panose="02020503050405090304" pitchFamily="34" charset="0"/>
+              <a:ea typeface="Arial" panose="020B0604020202090204" pitchFamily="34" charset="-122"/>
+              <a:cs typeface="Times New Roman" panose="02020503050405090304" pitchFamily="34" charset="0"/>
+            </a:endParaRPr>
+          </a:p>
+        </p:txBody>
+      </p:sp>
+      <p:sp>
+        <p:nvSpPr>
+          <p:cNvPr id="59" name="b.title"/>
+          <p:cNvSpPr txBox="1"/>
+          <p:nvPr/>
+        </p:nvSpPr>
+        <p:spPr>
+          <a:xfrm>
+            <a:off x="109728" y="3246120"/>
+            <a:ext cx="5541264" cy="155448"/>
+          </a:xfrm>
+          <a:prstGeom prst="rect">
+            <a:avLst/>
+          </a:prstGeom>
+          <a:noFill/>
+        </p:spPr>
+        <p:txBody>
+          <a:bodyPr wrap="square" lIns="0" tIns="0" rIns="0" bIns="0" rtlCol="0" anchor="t"/>
+          <a:lstStyle/>
+          <a:p>
+            <a:pPr marL="0" indent="0" algn="l">
               <a:lnSpc>
                 <a:spcPct val="100000"/>
               </a:lnSpc>
               <a:buNone/>
             </a:pPr>
             <a:r>
-              <a:rPr lang="en-US" sz="720" i="1" dirty="0">
-                <a:solidFill>
-                  <a:srgbClr val="1F3D7A"/>
-                </a:solidFill>
-                <a:latin typeface="Arial" pitchFamily="34" charset="0"/>
-                <a:ea typeface="Arial" pitchFamily="34" charset="-122"/>
-                <a:cs typeface="Arial" pitchFamily="34" charset="-120"/>
-              </a:rPr>
-              <a:t>TK</a:t>
-            </a:r>
-            <a:pPr algn="ctr" indent="0" marL="0">
-              <a:lnSpc>
-                <a:spcPct val="100000"/>
-              </a:lnSpc>
-              <a:buNone/>
-            </a:pPr>
-            <a:r>
-              <a:rPr lang="en-US" sz="720" dirty="0">
-                <a:solidFill>
-                  <a:srgbClr val="1F3D7A"/>
-                </a:solidFill>
-                <a:latin typeface="Arial" pitchFamily="34" charset="0"/>
-                <a:ea typeface="Arial" pitchFamily="34" charset="-122"/>
-                <a:cs typeface="Arial" pitchFamily="34" charset="-120"/>
-              </a:rPr>
-              <a:t> sampled-Gaussian score releases compose in one</a:t>
-            </a:r>
-            <a:endParaRPr lang="en-US" sz="720" dirty="0"/>
-          </a:p>
-        </p:txBody>
-      </p:sp>
-      <p:sp>
-        <p:nvSpPr>
-          <p:cNvPr id="58" name="a.acct.line2"/>
-          <p:cNvSpPr txBox="1"/>
-          <p:nvPr/>
-        </p:nvSpPr>
-        <p:spPr>
-          <a:xfrm>
-            <a:off x="521208" y="2948940"/>
-            <a:ext cx="4718304" cy="128016"/>
-          </a:xfrm>
-          <a:prstGeom prst="rect">
-            <a:avLst/>
-          </a:prstGeom>
-          <a:noFill/>
-          <a:ln/>
-        </p:spPr>
-        <p:txBody>
-          <a:bodyPr wrap="square" lIns="0" tIns="0" rIns="0" bIns="0" rtlCol="0" anchor="t"/>
-          <a:lstStyle/>
-          <a:p>
-            <a:pPr algn="ctr" indent="0" marL="0">
-              <a:lnSpc>
-                <a:spcPct val="100000"/>
-              </a:lnSpc>
-              <a:buNone/>
-            </a:pPr>
-            <a:r>
-              <a:rPr lang="en-US" sz="720" dirty="0">
-                <a:solidFill>
-                  <a:srgbClr val="1F3D7A"/>
-                </a:solidFill>
-                <a:latin typeface="Arial" pitchFamily="34" charset="0"/>
-                <a:ea typeface="Arial" pitchFamily="34" charset="-122"/>
-                <a:cs typeface="Arial" pitchFamily="34" charset="-120"/>
-              </a:rPr>
-              <a:t>RDP accountant  ⟹  overall (ε, δ)-DP.   Mutation and selection add no privacy loss.</a:t>
-            </a:r>
-            <a:endParaRPr lang="en-US" sz="720" dirty="0"/>
-          </a:p>
-        </p:txBody>
-      </p:sp>
-      <p:sp>
-        <p:nvSpPr>
-          <p:cNvPr id="59" name="b.title"/>
-          <p:cNvSpPr txBox="1"/>
-          <p:nvPr/>
-        </p:nvSpPr>
-        <p:spPr>
-          <a:xfrm>
-            <a:off x="109728" y="3246120"/>
-            <a:ext cx="5541264" cy="155448"/>
-          </a:xfrm>
-          <a:prstGeom prst="rect">
-            <a:avLst/>
-          </a:prstGeom>
-          <a:noFill/>
-          <a:ln/>
-        </p:spPr>
-        <p:txBody>
-          <a:bodyPr wrap="square" lIns="0" tIns="0" rIns="0" bIns="0" rtlCol="0" anchor="t"/>
-          <a:lstStyle/>
-          <a:p>
-            <a:pPr algn="l" indent="0" marL="0">
-              <a:lnSpc>
-                <a:spcPct val="100000"/>
-              </a:lnSpc>
-              <a:buNone/>
-            </a:pPr>
-            <a:r>
               <a:rPr lang="en-US" sz="900" b="1" dirty="0">
                 <a:solidFill>
                   <a:srgbClr val="1A1F2B"/>
                 </a:solidFill>
-                <a:latin typeface="Arial" pitchFamily="34" charset="0"/>
-                <a:ea typeface="Arial" pitchFamily="34" charset="-122"/>
-                <a:cs typeface="Arial" pitchFamily="34" charset="-120"/>
+                <a:latin typeface="Arial" panose="020B0604020202090204" pitchFamily="34" charset="0"/>
+                <a:ea typeface="Arial" panose="020B0604020202090204" pitchFamily="34" charset="-122"/>
+                <a:cs typeface="Arial" panose="020B0604020202090204" pitchFamily="34" charset="-120"/>
               </a:rPr>
               <a:t>(b)   </a:t>
             </a:r>
-            <a:pPr algn="l" indent="0" marL="0">
-              <a:lnSpc>
-                <a:spcPct val="100000"/>
-              </a:lnSpc>
-              <a:buNone/>
-            </a:pPr>
             <a:r>
               <a:rPr lang="en-US" sz="900" b="1" dirty="0">
                 <a:solidFill>
                   <a:srgbClr val="0E7C7B"/>
                 </a:solidFill>
-                <a:latin typeface="Arial" pitchFamily="34" charset="0"/>
-                <a:ea typeface="Arial" pitchFamily="34" charset="-122"/>
-                <a:cs typeface="Arial" pitchFamily="34" charset="-120"/>
+                <a:latin typeface="Arial" panose="020B0604020202090204" pitchFamily="34" charset="0"/>
+                <a:ea typeface="Arial" panose="020B0604020202090204" pitchFamily="34" charset="-122"/>
+                <a:cs typeface="Arial" panose="020B0604020202090204" pitchFamily="34" charset="-120"/>
               </a:rPr>
               <a:t>DP-ES</a:t>
             </a:r>
-            <a:pPr algn="l" indent="0" marL="0">
-              <a:lnSpc>
-                <a:spcPct val="100000"/>
-              </a:lnSpc>
-              <a:buNone/>
-            </a:pPr>
             <a:r>
               <a:rPr lang="en-US" sz="900" b="1" dirty="0">
                 <a:solidFill>
                   <a:srgbClr val="1A1F2B"/>
                 </a:solidFill>
-                <a:latin typeface="Arial" pitchFamily="34" charset="0"/>
-                <a:ea typeface="Arial" pitchFamily="34" charset="-122"/>
-                <a:cs typeface="Arial" pitchFamily="34" charset="-120"/>
+                <a:latin typeface="Arial" panose="020B0604020202090204" pitchFamily="34" charset="0"/>
+                <a:ea typeface="Arial" panose="020B0604020202090204" pitchFamily="34" charset="-122"/>
+                <a:cs typeface="Arial" panose="020B0604020202090204" pitchFamily="34" charset="-120"/>
               </a:rPr>
               <a:t> vs. </a:t>
             </a:r>
-            <a:pPr algn="l" indent="0" marL="0">
-              <a:lnSpc>
-                <a:spcPct val="100000"/>
-              </a:lnSpc>
-              <a:buNone/>
-            </a:pPr>
             <a:r>
               <a:rPr lang="en-US" sz="900" b="1" dirty="0">
                 <a:solidFill>
                   <a:srgbClr val="B23124"/>
                 </a:solidFill>
-                <a:latin typeface="Arial" pitchFamily="34" charset="0"/>
-                <a:ea typeface="Arial" pitchFamily="34" charset="-122"/>
-                <a:cs typeface="Arial" pitchFamily="34" charset="-120"/>
+                <a:latin typeface="Arial" panose="020B0604020202090204" pitchFamily="34" charset="0"/>
+                <a:ea typeface="Arial" panose="020B0604020202090204" pitchFamily="34" charset="-122"/>
+                <a:cs typeface="Arial" panose="020B0604020202090204" pitchFamily="34" charset="-120"/>
               </a:rPr>
               <a:t>DP-OPT</a:t>
             </a:r>
-            <a:pPr algn="l" indent="0" marL="0">
-              <a:lnSpc>
-                <a:spcPct val="100000"/>
-              </a:lnSpc>
-              <a:buNone/>
-            </a:pPr>
             <a:r>
               <a:rPr lang="en-US" sz="900" b="1" dirty="0">
                 <a:solidFill>
                   <a:srgbClr val="1A1F2B"/>
                 </a:solidFill>
-                <a:latin typeface="Arial" pitchFamily="34" charset="0"/>
-                <a:ea typeface="Arial" pitchFamily="34" charset="-122"/>
-                <a:cs typeface="Arial" pitchFamily="34" charset="-120"/>
+                <a:latin typeface="Arial" panose="020B0604020202090204" pitchFamily="34" charset="0"/>
+                <a:ea typeface="Arial" panose="020B0604020202090204" pitchFamily="34" charset="-122"/>
+                <a:cs typeface="Arial" panose="020B0604020202090204" pitchFamily="34" charset="-120"/>
               </a:rPr>
               <a:t>: mechanism and observed stability</a:t>
             </a:r>
@@ -3877,17 +3607,11 @@
       </p:sp>
       <p:graphicFrame>
         <p:nvGraphicFramePr>
-          <p:cNvPr id="2" name="b.table"/>
+          <p:cNvPr id="60" name="b.table"/>
           <p:cNvGraphicFramePr>
             <a:graphicFrameLocks noGrp="1"/>
           </p:cNvGraphicFramePr>
-          <p:nvPr>
-            <p:extLst>
-              <p:ext uri="{D42A27DB-BD31-4B8C-83A1-F6EECF244321}">
-                <p14:modId xmlns:p14="http://schemas.microsoft.com/office/powerpoint/2010/main" val="1579011935"/>
-              </p:ext>
-            </p:extLst>
-          </p:nvPr>
+          <p:nvPr/>
         </p:nvGraphicFramePr>
         <p:xfrm>
           <a:off x="109728" y="3474720"/>
@@ -3908,7 +3632,7 @@
                     <a:bodyPr/>
                     <a:lstStyle/>
                     <a:p>
-                      <a:pPr algn="ctr" indent="0" marL="0">
+                      <a:pPr marL="0" indent="0" algn="ctr">
                         <a:buNone/>
                       </a:pPr>
                       <a:r>
@@ -3916,9 +3640,9 @@
                           <a:solidFill>
                             <a:srgbClr val="1A1F2B"/>
                           </a:solidFill>
-                          <a:latin typeface="Arial" pitchFamily="34" charset="0"/>
-                          <a:ea typeface="Arial" pitchFamily="34" charset="-122"/>
-                          <a:cs typeface="Arial" pitchFamily="34" charset="-120"/>
+                          <a:latin typeface="Arial" panose="020B0604020202090204" pitchFamily="34" charset="0"/>
+                          <a:ea typeface="Arial" panose="020B0604020202090204" pitchFamily="34" charset="-122"/>
+                          <a:cs typeface="Arial" panose="020B0604020202090204" pitchFamily="34" charset="-120"/>
                         </a:rPr>
                         <a:t>Aspect</a:t>
                       </a:r>
@@ -3957,7 +3681,7 @@
                     <a:bodyPr/>
                     <a:lstStyle/>
                     <a:p>
-                      <a:pPr algn="ctr" indent="0" marL="0">
+                      <a:pPr marL="0" indent="0" algn="ctr">
                         <a:buNone/>
                       </a:pPr>
                       <a:r>
@@ -3965,9 +3689,9 @@
                           <a:solidFill>
                             <a:srgbClr val="0E7C7B"/>
                           </a:solidFill>
-                          <a:latin typeface="Arial" pitchFamily="34" charset="0"/>
-                          <a:ea typeface="Arial" pitchFamily="34" charset="-122"/>
-                          <a:cs typeface="Arial" pitchFamily="34" charset="-120"/>
+                          <a:latin typeface="Arial" panose="020B0604020202090204" pitchFamily="34" charset="0"/>
+                          <a:ea typeface="Arial" panose="020B0604020202090204" pitchFamily="34" charset="-122"/>
+                          <a:cs typeface="Arial" panose="020B0604020202090204" pitchFamily="34" charset="-120"/>
                         </a:rPr>
                         <a:t>DP-ES (ours)</a:t>
                       </a:r>
@@ -4006,7 +3730,7 @@
                     <a:bodyPr/>
                     <a:lstStyle/>
                     <a:p>
-                      <a:pPr algn="ctr" indent="0" marL="0">
+                      <a:pPr marL="0" indent="0" algn="ctr">
                         <a:buNone/>
                       </a:pPr>
                       <a:r>
@@ -4014,9 +3738,9 @@
                           <a:solidFill>
                             <a:srgbClr val="B23124"/>
                           </a:solidFill>
-                          <a:latin typeface="Arial" pitchFamily="34" charset="0"/>
-                          <a:ea typeface="Arial" pitchFamily="34" charset="-122"/>
-                          <a:cs typeface="Arial" pitchFamily="34" charset="-120"/>
+                          <a:latin typeface="Arial" panose="020B0604020202090204" pitchFamily="34" charset="0"/>
+                          <a:ea typeface="Arial" panose="020B0604020202090204" pitchFamily="34" charset="-122"/>
+                          <a:cs typeface="Arial" panose="020B0604020202090204" pitchFamily="34" charset="-120"/>
                         </a:rPr>
                         <a:t>DP-OPT</a:t>
                       </a:r>
@@ -4057,7 +3781,7 @@
                     <a:bodyPr/>
                     <a:lstStyle/>
                     <a:p>
-                      <a:pPr algn="ctr" indent="0" marL="0">
+                      <a:pPr marL="0" indent="0" algn="ctr">
                         <a:buNone/>
                       </a:pPr>
                       <a:r>
@@ -4065,9 +3789,9 @@
                           <a:solidFill>
                             <a:srgbClr val="1A1F2B"/>
                           </a:solidFill>
-                          <a:latin typeface="Arial" pitchFamily="34" charset="0"/>
-                          <a:ea typeface="Arial" pitchFamily="34" charset="-122"/>
-                          <a:cs typeface="Arial" pitchFamily="34" charset="-120"/>
+                          <a:latin typeface="Arial" panose="020B0604020202090204" pitchFamily="34" charset="0"/>
+                          <a:ea typeface="Arial" panose="020B0604020202090204" pitchFamily="34" charset="-122"/>
+                          <a:cs typeface="Arial" panose="020B0604020202090204" pitchFamily="34" charset="-120"/>
                         </a:rPr>
                         <a:t>Search unit</a:t>
                       </a:r>
@@ -4100,21 +3824,28 @@
                     <a:bodyPr/>
                     <a:lstStyle/>
                     <a:p>
-                      <a:pPr algn="ctr" indent="0" marL="0">
+                      <a:pPr marL="0" indent="0" algn="ctr">
                         <a:buNone/>
                       </a:pPr>
                       <a:r>
-                        <a:rPr lang="en-US" sz="680" dirty="0">
+                        <a:rPr lang="en-US" sz="700" dirty="0">
                           <a:solidFill>
                             <a:srgbClr val="1A1F2B"/>
                           </a:solidFill>
-                          <a:latin typeface="Arial" pitchFamily="34" charset="0"/>
-                          <a:ea typeface="Arial" pitchFamily="34" charset="-122"/>
-                          <a:cs typeface="Arial" pitchFamily="34" charset="-120"/>
+                          <a:latin typeface="Times New Roman" panose="02020503050405090304" pitchFamily="34" charset="0"/>
+                          <a:ea typeface="Arial" panose="020B0604020202090204" pitchFamily="34" charset="-122"/>
+                          <a:cs typeface="Times New Roman" panose="02020503050405090304" pitchFamily="34" charset="0"/>
                         </a:rPr>
                         <a:t>Population of complete prompts</a:t>
                       </a:r>
-                      <a:endParaRPr lang="en-US" sz="1200" dirty="0"/>
+                      <a:endParaRPr lang="en-US" sz="700" dirty="0">
+                        <a:solidFill>
+                          <a:srgbClr val="1A1F2B"/>
+                        </a:solidFill>
+                        <a:latin typeface="Times New Roman" panose="02020503050405090304" pitchFamily="34" charset="0"/>
+                        <a:ea typeface="Arial" panose="020B0604020202090204" pitchFamily="34" charset="-122"/>
+                        <a:cs typeface="Times New Roman" panose="02020503050405090304" pitchFamily="34" charset="0"/>
+                      </a:endParaRPr>
                     </a:p>
                   </a:txBody>
                   <a:tcPr marL="38100" marR="38100" marT="12700" marB="12700" anchor="ctr">
@@ -4143,21 +3874,31 @@
                     <a:bodyPr/>
                     <a:lstStyle/>
                     <a:p>
-                      <a:pPr algn="ctr" indent="0" marL="0">
+                      <a:pPr marL="0" algn="ctr">
+                        <a:buClrTx/>
+                        <a:buSzTx/>
+                        <a:buFontTx/>
                         <a:buNone/>
                       </a:pPr>
                       <a:r>
-                        <a:rPr lang="en-US" sz="680" dirty="0">
+                        <a:rPr lang="en-US" sz="700" dirty="0">
                           <a:solidFill>
                             <a:srgbClr val="1A1F2B"/>
                           </a:solidFill>
-                          <a:latin typeface="Arial" pitchFamily="34" charset="0"/>
-                          <a:ea typeface="Arial" pitchFamily="34" charset="-122"/>
-                          <a:cs typeface="Arial" pitchFamily="34" charset="-120"/>
+                          <a:latin typeface="Times New Roman" panose="02020503050405090304" pitchFamily="34" charset="0"/>
+                          <a:ea typeface="Arial" panose="020B0604020202090204" pitchFamily="34" charset="-122"/>
+                          <a:cs typeface="Times New Roman" panose="02020503050405090304" pitchFamily="34" charset="0"/>
                         </a:rPr>
                         <a:t>Greedy token-by-token construction</a:t>
                       </a:r>
-                      <a:endParaRPr lang="en-US" sz="1200" dirty="0"/>
+                      <a:endParaRPr lang="en-US" sz="700" dirty="0">
+                        <a:solidFill>
+                          <a:srgbClr val="1A1F2B"/>
+                        </a:solidFill>
+                        <a:latin typeface="Times New Roman" panose="02020503050405090304" pitchFamily="34" charset="0"/>
+                        <a:ea typeface="Arial" panose="020B0604020202090204" pitchFamily="34" charset="-122"/>
+                        <a:cs typeface="Times New Roman" panose="02020503050405090304" pitchFamily="34" charset="0"/>
+                      </a:endParaRPr>
                     </a:p>
                   </a:txBody>
                   <a:tcPr marL="38100" marR="38100" marT="12700" marB="12700" anchor="ctr">
@@ -4188,7 +3929,7 @@
                     <a:bodyPr/>
                     <a:lstStyle/>
                     <a:p>
-                      <a:pPr algn="ctr" indent="0" marL="0">
+                      <a:pPr marL="0" indent="0" algn="ctr">
                         <a:buNone/>
                       </a:pPr>
                       <a:r>
@@ -4196,9 +3937,9 @@
                           <a:solidFill>
                             <a:srgbClr val="1A1F2B"/>
                           </a:solidFill>
-                          <a:latin typeface="Arial" pitchFamily="34" charset="0"/>
-                          <a:ea typeface="Arial" pitchFamily="34" charset="-122"/>
-                          <a:cs typeface="Arial" pitchFamily="34" charset="-120"/>
+                          <a:latin typeface="Arial" panose="020B0604020202090204" pitchFamily="34" charset="0"/>
+                          <a:ea typeface="Arial" panose="020B0604020202090204" pitchFamily="34" charset="-122"/>
+                          <a:cs typeface="Arial" panose="020B0604020202090204" pitchFamily="34" charset="-120"/>
                         </a:rPr>
                         <a:t>Private-data access</a:t>
                       </a:r>
@@ -4231,21 +3972,31 @@
                     <a:bodyPr/>
                     <a:lstStyle/>
                     <a:p>
-                      <a:pPr algn="ctr" indent="0" marL="0">
+                      <a:pPr marL="0" algn="ctr">
+                        <a:buClrTx/>
+                        <a:buSzTx/>
+                        <a:buFontTx/>
                         <a:buNone/>
                       </a:pPr>
                       <a:r>
-                        <a:rPr lang="en-US" sz="680" dirty="0">
+                        <a:rPr lang="en-US" sz="700" dirty="0">
                           <a:solidFill>
                             <a:srgbClr val="1A1F2B"/>
                           </a:solidFill>
-                          <a:latin typeface="Arial" pitchFamily="34" charset="0"/>
-                          <a:ea typeface="Arial" pitchFamily="34" charset="-122"/>
-                          <a:cs typeface="Arial" pitchFamily="34" charset="-120"/>
+                          <a:latin typeface="Times New Roman" panose="02020503050405090304" pitchFamily="34" charset="0"/>
+                          <a:ea typeface="Arial" panose="020B0604020202090204" pitchFamily="34" charset="-122"/>
+                          <a:cs typeface="Times New Roman" panose="02020503050405090304" pitchFamily="34" charset="0"/>
                         </a:rPr>
                         <a:t>Sampled utility scoring only</a:t>
                       </a:r>
-                      <a:endParaRPr lang="en-US" sz="1200" dirty="0"/>
+                      <a:endParaRPr lang="en-US" sz="700" dirty="0">
+                        <a:solidFill>
+                          <a:srgbClr val="1A1F2B"/>
+                        </a:solidFill>
+                        <a:latin typeface="Times New Roman" panose="02020503050405090304" pitchFamily="34" charset="0"/>
+                        <a:ea typeface="Arial" panose="020B0604020202090204" pitchFamily="34" charset="-122"/>
+                        <a:cs typeface="Times New Roman" panose="02020503050405090304" pitchFamily="34" charset="0"/>
+                      </a:endParaRPr>
                     </a:p>
                   </a:txBody>
                   <a:tcPr marL="38100" marR="38100" marT="12700" marB="12700" anchor="ctr">
@@ -4274,21 +4025,31 @@
                     <a:bodyPr/>
                     <a:lstStyle/>
                     <a:p>
-                      <a:pPr algn="ctr" indent="0" marL="0">
+                      <a:pPr marL="0" algn="ctr">
+                        <a:buClrTx/>
+                        <a:buSzTx/>
+                        <a:buFontTx/>
                         <a:buNone/>
                       </a:pPr>
                       <a:r>
-                        <a:rPr lang="en-US" sz="680" dirty="0">
+                        <a:rPr lang="en-US" sz="700" dirty="0">
                           <a:solidFill>
                             <a:srgbClr val="1A1F2B"/>
                           </a:solidFill>
-                          <a:latin typeface="Arial" pitchFamily="34" charset="0"/>
-                          <a:ea typeface="Arial" pitchFamily="34" charset="-122"/>
-                          <a:cs typeface="Arial" pitchFamily="34" charset="-120"/>
+                          <a:latin typeface="Times New Roman" panose="02020503050405090304" pitchFamily="34" charset="0"/>
+                          <a:ea typeface="Arial" panose="020B0604020202090204" pitchFamily="34" charset="-122"/>
+                          <a:cs typeface="Times New Roman" panose="02020503050405090304" pitchFamily="34" charset="0"/>
                         </a:rPr>
                         <a:t>Private histogram queries during construction</a:t>
                       </a:r>
-                      <a:endParaRPr lang="en-US" sz="1200" dirty="0"/>
+                      <a:endParaRPr lang="en-US" sz="700" dirty="0">
+                        <a:solidFill>
+                          <a:srgbClr val="1A1F2B"/>
+                        </a:solidFill>
+                        <a:latin typeface="Times New Roman" panose="02020503050405090304" pitchFamily="34" charset="0"/>
+                        <a:ea typeface="Arial" panose="020B0604020202090204" pitchFamily="34" charset="-122"/>
+                        <a:cs typeface="Times New Roman" panose="02020503050405090304" pitchFamily="34" charset="0"/>
+                      </a:endParaRPr>
                     </a:p>
                   </a:txBody>
                   <a:tcPr marL="38100" marR="38100" marT="12700" marB="12700" anchor="ctr">
@@ -4319,7 +4080,7 @@
                     <a:bodyPr/>
                     <a:lstStyle/>
                     <a:p>
-                      <a:pPr algn="ctr" indent="0" marL="0">
+                      <a:pPr marL="0" indent="0" algn="ctr">
                         <a:buNone/>
                       </a:pPr>
                       <a:r>
@@ -4327,9 +4088,9 @@
                           <a:solidFill>
                             <a:srgbClr val="1A1F2B"/>
                           </a:solidFill>
-                          <a:latin typeface="Arial" pitchFamily="34" charset="0"/>
-                          <a:ea typeface="Arial" pitchFamily="34" charset="-122"/>
-                          <a:cs typeface="Arial" pitchFamily="34" charset="-120"/>
+                          <a:latin typeface="Arial" panose="020B0604020202090204" pitchFamily="34" charset="0"/>
+                          <a:ea typeface="Arial" panose="020B0604020202090204" pitchFamily="34" charset="-122"/>
+                          <a:cs typeface="Arial" panose="020B0604020202090204" pitchFamily="34" charset="-120"/>
                         </a:rPr>
                         <a:t>Selection / recovery</a:t>
                       </a:r>
@@ -4362,21 +4123,31 @@
                     <a:bodyPr/>
                     <a:lstStyle/>
                     <a:p>
-                      <a:pPr algn="ctr" indent="0" marL="0">
+                      <a:pPr marL="0" algn="ctr">
+                        <a:buClrTx/>
+                        <a:buSzTx/>
+                        <a:buFontTx/>
                         <a:buNone/>
                       </a:pPr>
                       <a:r>
-                        <a:rPr lang="en-US" sz="680" dirty="0">
+                        <a:rPr lang="en-US" sz="700" dirty="0">
                           <a:solidFill>
                             <a:srgbClr val="1A1F2B"/>
                           </a:solidFill>
-                          <a:latin typeface="Arial" pitchFamily="34" charset="0"/>
-                          <a:ea typeface="Arial" pitchFamily="34" charset="-122"/>
-                          <a:cs typeface="Arial" pitchFamily="34" charset="-120"/>
+                          <a:latin typeface="Times New Roman" panose="02020503050405090304" pitchFamily="34" charset="0"/>
+                          <a:ea typeface="Arial" panose="020B0604020202090204" pitchFamily="34" charset="-122"/>
+                          <a:cs typeface="Times New Roman" panose="02020503050405090304" pitchFamily="34" charset="0"/>
                         </a:rPr>
                         <a:t>Top-M on privatized scores; alternatives persist</a:t>
                       </a:r>
-                      <a:endParaRPr lang="en-US" sz="1200" dirty="0"/>
+                      <a:endParaRPr lang="en-US" sz="700" dirty="0">
+                        <a:solidFill>
+                          <a:srgbClr val="1A1F2B"/>
+                        </a:solidFill>
+                        <a:latin typeface="Times New Roman" panose="02020503050405090304" pitchFamily="34" charset="0"/>
+                        <a:ea typeface="Arial" panose="020B0604020202090204" pitchFamily="34" charset="-122"/>
+                        <a:cs typeface="Times New Roman" panose="02020503050405090304" pitchFamily="34" charset="0"/>
+                      </a:endParaRPr>
                     </a:p>
                   </a:txBody>
                   <a:tcPr marL="38100" marR="38100" marT="12700" marB="12700" anchor="ctr">
@@ -4405,21 +4176,31 @@
                     <a:bodyPr/>
                     <a:lstStyle/>
                     <a:p>
-                      <a:pPr algn="ctr" indent="0" marL="0">
+                      <a:pPr marL="0" algn="ctr">
+                        <a:buClrTx/>
+                        <a:buSzTx/>
+                        <a:buFontTx/>
                         <a:buNone/>
                       </a:pPr>
                       <a:r>
-                        <a:rPr lang="en-US" sz="680" dirty="0">
+                        <a:rPr lang="en-US" sz="700" dirty="0">
                           <a:solidFill>
                             <a:srgbClr val="1A1F2B"/>
                           </a:solidFill>
-                          <a:latin typeface="Arial" pitchFamily="34" charset="0"/>
-                          <a:ea typeface="Arial" pitchFamily="34" charset="-122"/>
-                          <a:cs typeface="Arial" pitchFamily="34" charset="-120"/>
+                          <a:latin typeface="Times New Roman" panose="02020503050405090304" pitchFamily="34" charset="0"/>
+                          <a:ea typeface="Arial" panose="020B0604020202090204" pitchFamily="34" charset="-122"/>
+                          <a:cs typeface="Times New Roman" panose="02020503050405090304" pitchFamily="34" charset="0"/>
                         </a:rPr>
                         <a:t>Private token releases; no token-level backtracking</a:t>
                       </a:r>
-                      <a:endParaRPr lang="en-US" sz="1200" dirty="0"/>
+                      <a:endParaRPr lang="en-US" sz="700" dirty="0">
+                        <a:solidFill>
+                          <a:srgbClr val="1A1F2B"/>
+                        </a:solidFill>
+                        <a:latin typeface="Times New Roman" panose="02020503050405090304" pitchFamily="34" charset="0"/>
+                        <a:ea typeface="Arial" panose="020B0604020202090204" pitchFamily="34" charset="-122"/>
+                        <a:cs typeface="Times New Roman" panose="02020503050405090304" pitchFamily="34" charset="0"/>
+                      </a:endParaRPr>
                     </a:p>
                   </a:txBody>
                   <a:tcPr marL="38100" marR="38100" marT="12700" marB="12700" anchor="ctr">
@@ -4450,7 +4231,7 @@
                     <a:bodyPr/>
                     <a:lstStyle/>
                     <a:p>
-                      <a:pPr algn="ctr" indent="0" marL="0">
+                      <a:pPr marL="0" indent="0" algn="ctr">
                         <a:buNone/>
                       </a:pPr>
                       <a:r>
@@ -4458,9 +4239,9 @@
                           <a:solidFill>
                             <a:srgbClr val="1A1F2B"/>
                           </a:solidFill>
-                          <a:latin typeface="Arial" pitchFamily="34" charset="0"/>
-                          <a:ea typeface="Arial" pitchFamily="34" charset="-122"/>
-                          <a:cs typeface="Arial" pitchFamily="34" charset="-120"/>
+                          <a:latin typeface="Arial" panose="020B0604020202090204" pitchFamily="34" charset="0"/>
+                          <a:ea typeface="Arial" panose="020B0604020202090204" pitchFamily="34" charset="-122"/>
+                          <a:cs typeface="Arial" panose="020B0604020202090204" pitchFamily="34" charset="-120"/>
                         </a:rPr>
                         <a:t>GSM8K (30 runs)</a:t>
                       </a:r>
@@ -4493,7 +4274,7 @@
                     <a:bodyPr/>
                     <a:lstStyle/>
                     <a:p>
-                      <a:pPr algn="ctr" indent="0" marL="0">
+                      <a:pPr marL="0" indent="0" algn="ctr">
                         <a:buNone/>
                       </a:pPr>
                       <a:r>
@@ -4501,9 +4282,9 @@
                           <a:solidFill>
                             <a:srgbClr val="0E7C7B"/>
                           </a:solidFill>
-                          <a:latin typeface="Arial" pitchFamily="34" charset="0"/>
-                          <a:ea typeface="Arial" pitchFamily="34" charset="-122"/>
-                          <a:cs typeface="Arial" pitchFamily="34" charset="-120"/>
+                          <a:latin typeface="Arial" panose="020B0604020202090204" pitchFamily="34" charset="0"/>
+                          <a:ea typeface="Arial" panose="020B0604020202090204" pitchFamily="34" charset="-122"/>
+                          <a:cs typeface="Arial" panose="020B0604020202090204" pitchFamily="34" charset="-120"/>
                         </a:rPr>
                         <a:t>88.1 ± 3.2%</a:t>
                       </a:r>
@@ -4539,7 +4320,7 @@
                     <a:bodyPr/>
                     <a:lstStyle/>
                     <a:p>
-                      <a:pPr algn="ctr" indent="0" marL="0">
+                      <a:pPr marL="0" indent="0" algn="ctr">
                         <a:buNone/>
                       </a:pPr>
                       <a:r>
@@ -4547,9 +4328,9 @@
                           <a:solidFill>
                             <a:srgbClr val="B23124"/>
                           </a:solidFill>
-                          <a:latin typeface="Arial" pitchFamily="34" charset="0"/>
-                          <a:ea typeface="Arial" pitchFamily="34" charset="-122"/>
-                          <a:cs typeface="Arial" pitchFamily="34" charset="-120"/>
+                          <a:latin typeface="Arial" panose="020B0604020202090204" pitchFamily="34" charset="0"/>
+                          <a:ea typeface="Arial" panose="020B0604020202090204" pitchFamily="34" charset="-122"/>
+                          <a:cs typeface="Arial" panose="020B0604020202090204" pitchFamily="34" charset="-120"/>
                         </a:rPr>
                         <a:t>49.5 ± 28.5%</a:t>
                       </a:r>
@@ -4636,7 +4417,7 @@
     </a:clrScheme>
     <a:fontScheme name="Office">
       <a:majorFont>
-        <a:latin typeface="Calibri Light" panose="020F0302020204030204"/>
+        <a:latin typeface="Calibri Light"/>
         <a:ea typeface=""/>
         <a:cs typeface=""/>
         <a:font script="Jpan" typeface="游ゴシック Light"/>
@@ -4669,26 +4450,9 @@
         <a:font script="Viet" typeface="Times New Roman"/>
         <a:font script="Uigh" typeface="Microsoft Uighur"/>
         <a:font script="Geor" typeface="Sylfaen"/>
-        <a:font script="Armn" typeface="Arial"/>
-        <a:font script="Bugi" typeface="Leelawadee UI"/>
-        <a:font script="Bopo" typeface="Microsoft JhengHei"/>
-        <a:font script="Java" typeface="Javanese Text"/>
-        <a:font script="Lisu" typeface="Segoe UI"/>
-        <a:font script="Mymr" typeface="Myanmar Text"/>
-        <a:font script="Nkoo" typeface="Ebrima"/>
-        <a:font script="Olck" typeface="Nirmala UI"/>
-        <a:font script="Osma" typeface="Ebrima"/>
-        <a:font script="Phag" typeface="Phagspa"/>
-        <a:font script="Syrn" typeface="Estrangelo Edessa"/>
-        <a:font script="Syrj" typeface="Estrangelo Edessa"/>
-        <a:font script="Syre" typeface="Estrangelo Edessa"/>
-        <a:font script="Sora" typeface="Nirmala UI"/>
-        <a:font script="Tale" typeface="Microsoft Tai Le"/>
-        <a:font script="Talu" typeface="Microsoft New Tai Lue"/>
-        <a:font script="Tfng" typeface="Ebrima"/>
       </a:majorFont>
       <a:minorFont>
-        <a:latin typeface="Calibri" panose="020F0502020204030204"/>
+        <a:latin typeface="Calibri"/>
         <a:ea typeface=""/>
         <a:cs typeface=""/>
         <a:font script="Jpan" typeface="游ゴシック"/>
@@ -4721,23 +4485,6 @@
         <a:font script="Viet" typeface="Arial"/>
         <a:font script="Uigh" typeface="Microsoft Uighur"/>
         <a:font script="Geor" typeface="Sylfaen"/>
-        <a:font script="Armn" typeface="Arial"/>
-        <a:font script="Bugi" typeface="Leelawadee UI"/>
-        <a:font script="Bopo" typeface="Microsoft JhengHei"/>
-        <a:font script="Java" typeface="Javanese Text"/>
-        <a:font script="Lisu" typeface="Segoe UI"/>
-        <a:font script="Mymr" typeface="Myanmar Text"/>
-        <a:font script="Nkoo" typeface="Ebrima"/>
-        <a:font script="Olck" typeface="Nirmala UI"/>
-        <a:font script="Osma" typeface="Ebrima"/>
-        <a:font script="Phag" typeface="Phagspa"/>
-        <a:font script="Syrn" typeface="Estrangelo Edessa"/>
-        <a:font script="Syrj" typeface="Estrangelo Edessa"/>
-        <a:font script="Syre" typeface="Estrangelo Edessa"/>
-        <a:font script="Sora" typeface="Nirmala UI"/>
-        <a:font script="Tale" typeface="Microsoft Tai Le"/>
-        <a:font script="Talu" typeface="Microsoft New Tai Lue"/>
-        <a:font script="Tfng" typeface="Ebrima"/>
       </a:minorFont>
     </a:fontScheme>
     <a:fmtScheme name="Office">
@@ -4878,8 +4625,265 @@
       </a:bgFillStyleLst>
     </a:fmtScheme>
   </a:themeElements>
-  <a:objectDefaults/>
-  <a:extraClrSchemeLst/>
+  <a:extLst>
+    <a:ext uri="{05A4C25C-085E-4340-85A3-A5531E510DB2}">
+      <thm15:themeFamily xmlns:thm15="http://schemas.microsoft.com/office/thememl/2012/main" name="Office Theme" id="{62F939B6-93AF-4DB8-9C6B-D6C7DFDC589F}" vid="{4A3C46E8-61CC-4603-A589-7422A47A8E4A}"/>
+    </a:ext>
+  </a:extLst>
+</a:theme>
+</file>
+
+<file path=ppt/theme/theme2.xml><?xml version="1.0" encoding="utf-8"?>
+<a:theme xmlns:a="http://schemas.openxmlformats.org/drawingml/2006/main" name="Office Theme">
+  <a:themeElements>
+    <a:clrScheme name="Office">
+      <a:dk1>
+        <a:sysClr val="windowText" lastClr="000000"/>
+      </a:dk1>
+      <a:lt1>
+        <a:sysClr val="window" lastClr="FFFFFF"/>
+      </a:lt1>
+      <a:dk2>
+        <a:srgbClr val="44546A"/>
+      </a:dk2>
+      <a:lt2>
+        <a:srgbClr val="E7E6E6"/>
+      </a:lt2>
+      <a:accent1>
+        <a:srgbClr val="4472C4"/>
+      </a:accent1>
+      <a:accent2>
+        <a:srgbClr val="ED7D31"/>
+      </a:accent2>
+      <a:accent3>
+        <a:srgbClr val="A5A5A5"/>
+      </a:accent3>
+      <a:accent4>
+        <a:srgbClr val="FFC000"/>
+      </a:accent4>
+      <a:accent5>
+        <a:srgbClr val="5B9BD5"/>
+      </a:accent5>
+      <a:accent6>
+        <a:srgbClr val="70AD47"/>
+      </a:accent6>
+      <a:hlink>
+        <a:srgbClr val="0563C1"/>
+      </a:hlink>
+      <a:folHlink>
+        <a:srgbClr val="954F72"/>
+      </a:folHlink>
+    </a:clrScheme>
+    <a:fontScheme name="Office">
+      <a:majorFont>
+        <a:latin typeface="Calibri Light"/>
+        <a:ea typeface=""/>
+        <a:cs typeface=""/>
+        <a:font script="Jpan" typeface="游ゴシック Light"/>
+        <a:font script="Hang" typeface="맑은 고딕"/>
+        <a:font script="Hans" typeface="等线 Light"/>
+        <a:font script="Hant" typeface="新細明體"/>
+        <a:font script="Arab" typeface="Times New Roman"/>
+        <a:font script="Hebr" typeface="Times New Roman"/>
+        <a:font script="Thai" typeface="Angsana New"/>
+        <a:font script="Ethi" typeface="Nyala"/>
+        <a:font script="Beng" typeface="Vrinda"/>
+        <a:font script="Gujr" typeface="Shruti"/>
+        <a:font script="Khmr" typeface="MoolBoran"/>
+        <a:font script="Knda" typeface="Tunga"/>
+        <a:font script="Guru" typeface="Raavi"/>
+        <a:font script="Cans" typeface="Euphemia"/>
+        <a:font script="Cher" typeface="Plantagenet Cherokee"/>
+        <a:font script="Yiii" typeface="Microsoft Yi Baiti"/>
+        <a:font script="Tibt" typeface="Microsoft Himalaya"/>
+        <a:font script="Thaa" typeface="MV Boli"/>
+        <a:font script="Deva" typeface="Mangal"/>
+        <a:font script="Telu" typeface="Gautami"/>
+        <a:font script="Taml" typeface="Latha"/>
+        <a:font script="Syrc" typeface="Estrangelo Edessa"/>
+        <a:font script="Orya" typeface="Kalinga"/>
+        <a:font script="Mlym" typeface="Kartika"/>
+        <a:font script="Laoo" typeface="DokChampa"/>
+        <a:font script="Sinh" typeface="Iskoola Pota"/>
+        <a:font script="Mong" typeface="Mongolian Baiti"/>
+        <a:font script="Viet" typeface="Times New Roman"/>
+        <a:font script="Uigh" typeface="Microsoft Uighur"/>
+        <a:font script="Geor" typeface="Sylfaen"/>
+      </a:majorFont>
+      <a:minorFont>
+        <a:latin typeface="Calibri"/>
+        <a:ea typeface=""/>
+        <a:cs typeface=""/>
+        <a:font script="Jpan" typeface="游ゴシック"/>
+        <a:font script="Hang" typeface="맑은 고딕"/>
+        <a:font script="Hans" typeface="等线"/>
+        <a:font script="Hant" typeface="新細明體"/>
+        <a:font script="Arab" typeface="Arial"/>
+        <a:font script="Hebr" typeface="Arial"/>
+        <a:font script="Thai" typeface="Cordia New"/>
+        <a:font script="Ethi" typeface="Nyala"/>
+        <a:font script="Beng" typeface="Vrinda"/>
+        <a:font script="Gujr" typeface="Shruti"/>
+        <a:font script="Khmr" typeface="DaunPenh"/>
+        <a:font script="Knda" typeface="Tunga"/>
+        <a:font script="Guru" typeface="Raavi"/>
+        <a:font script="Cans" typeface="Euphemia"/>
+        <a:font script="Cher" typeface="Plantagenet Cherokee"/>
+        <a:font script="Yiii" typeface="Microsoft Yi Baiti"/>
+        <a:font script="Tibt" typeface="Microsoft Himalaya"/>
+        <a:font script="Thaa" typeface="MV Boli"/>
+        <a:font script="Deva" typeface="Mangal"/>
+        <a:font script="Telu" typeface="Gautami"/>
+        <a:font script="Taml" typeface="Latha"/>
+        <a:font script="Syrc" typeface="Estrangelo Edessa"/>
+        <a:font script="Orya" typeface="Kalinga"/>
+        <a:font script="Mlym" typeface="Kartika"/>
+        <a:font script="Laoo" typeface="DokChampa"/>
+        <a:font script="Sinh" typeface="Iskoola Pota"/>
+        <a:font script="Mong" typeface="Mongolian Baiti"/>
+        <a:font script="Viet" typeface="Arial"/>
+        <a:font script="Uigh" typeface="Microsoft Uighur"/>
+        <a:font script="Geor" typeface="Sylfaen"/>
+      </a:minorFont>
+    </a:fontScheme>
+    <a:fmtScheme name="Office">
+      <a:fillStyleLst>
+        <a:solidFill>
+          <a:schemeClr val="phClr"/>
+        </a:solidFill>
+        <a:gradFill rotWithShape="1">
+          <a:gsLst>
+            <a:gs pos="0">
+              <a:schemeClr val="phClr">
+                <a:lumMod val="110000"/>
+                <a:satMod val="105000"/>
+                <a:tint val="67000"/>
+              </a:schemeClr>
+            </a:gs>
+            <a:gs pos="50000">
+              <a:schemeClr val="phClr">
+                <a:lumMod val="105000"/>
+                <a:satMod val="103000"/>
+                <a:tint val="73000"/>
+              </a:schemeClr>
+            </a:gs>
+            <a:gs pos="100000">
+              <a:schemeClr val="phClr">
+                <a:lumMod val="105000"/>
+                <a:satMod val="109000"/>
+                <a:tint val="81000"/>
+              </a:schemeClr>
+            </a:gs>
+          </a:gsLst>
+          <a:lin ang="5400000" scaled="0"/>
+        </a:gradFill>
+        <a:gradFill rotWithShape="1">
+          <a:gsLst>
+            <a:gs pos="0">
+              <a:schemeClr val="phClr">
+                <a:satMod val="103000"/>
+                <a:lumMod val="102000"/>
+                <a:tint val="94000"/>
+              </a:schemeClr>
+            </a:gs>
+            <a:gs pos="50000">
+              <a:schemeClr val="phClr">
+                <a:satMod val="110000"/>
+                <a:lumMod val="100000"/>
+                <a:shade val="100000"/>
+              </a:schemeClr>
+            </a:gs>
+            <a:gs pos="100000">
+              <a:schemeClr val="phClr">
+                <a:lumMod val="99000"/>
+                <a:satMod val="120000"/>
+                <a:shade val="78000"/>
+              </a:schemeClr>
+            </a:gs>
+          </a:gsLst>
+          <a:lin ang="5400000" scaled="0"/>
+        </a:gradFill>
+      </a:fillStyleLst>
+      <a:lnStyleLst>
+        <a:ln w="6350" cap="flat" cmpd="sng" algn="ctr">
+          <a:solidFill>
+            <a:schemeClr val="phClr"/>
+          </a:solidFill>
+          <a:prstDash val="solid"/>
+          <a:miter lim="800000"/>
+        </a:ln>
+        <a:ln w="12700" cap="flat" cmpd="sng" algn="ctr">
+          <a:solidFill>
+            <a:schemeClr val="phClr"/>
+          </a:solidFill>
+          <a:prstDash val="solid"/>
+          <a:miter lim="800000"/>
+        </a:ln>
+        <a:ln w="19050" cap="flat" cmpd="sng" algn="ctr">
+          <a:solidFill>
+            <a:schemeClr val="phClr"/>
+          </a:solidFill>
+          <a:prstDash val="solid"/>
+          <a:miter lim="800000"/>
+        </a:ln>
+      </a:lnStyleLst>
+      <a:effectStyleLst>
+        <a:effectStyle>
+          <a:effectLst/>
+        </a:effectStyle>
+        <a:effectStyle>
+          <a:effectLst/>
+        </a:effectStyle>
+        <a:effectStyle>
+          <a:effectLst>
+            <a:outerShdw blurRad="57150" dist="19050" dir="5400000" algn="ctr" rotWithShape="0">
+              <a:srgbClr val="000000">
+                <a:alpha val="63000"/>
+              </a:srgbClr>
+            </a:outerShdw>
+          </a:effectLst>
+        </a:effectStyle>
+      </a:effectStyleLst>
+      <a:bgFillStyleLst>
+        <a:solidFill>
+          <a:schemeClr val="phClr"/>
+        </a:solidFill>
+        <a:solidFill>
+          <a:schemeClr val="phClr">
+            <a:tint val="95000"/>
+            <a:satMod val="170000"/>
+          </a:schemeClr>
+        </a:solidFill>
+        <a:gradFill rotWithShape="1">
+          <a:gsLst>
+            <a:gs pos="0">
+              <a:schemeClr val="phClr">
+                <a:tint val="93000"/>
+                <a:satMod val="150000"/>
+                <a:shade val="98000"/>
+                <a:lumMod val="102000"/>
+              </a:schemeClr>
+            </a:gs>
+            <a:gs pos="50000">
+              <a:schemeClr val="phClr">
+                <a:tint val="98000"/>
+                <a:satMod val="130000"/>
+                <a:shade val="90000"/>
+                <a:lumMod val="103000"/>
+              </a:schemeClr>
+            </a:gs>
+            <a:gs pos="100000">
+              <a:schemeClr val="phClr">
+                <a:shade val="63000"/>
+                <a:satMod val="120000"/>
+              </a:schemeClr>
+            </a:gs>
+          </a:gsLst>
+          <a:lin ang="5400000" scaled="0"/>
+        </a:gradFill>
+      </a:bgFillStyleLst>
+    </a:fmtScheme>
+  </a:themeElements>
   <a:extLst>
     <a:ext uri="{05A4C25C-085E-4340-85A3-A5531E510DB2}">
       <thm15:themeFamily xmlns:thm15="http://schemas.microsoft.com/office/thememl/2012/main" name="Office Theme" id="{62F939B6-93AF-4DB8-9C6B-D6C7DFDC589F}" vid="{4A3C46E8-61CC-4603-A589-7422A47A8E4A}"/>

</xml_diff>

<commit_message>
Restore Figure 1 and enlarge diversity annotations
</commit_message>
<xml_diff>
--- a/paper/figures/DPES_Figure1_v2_editable.pptx
+++ b/paper/figures/DPES_Figure1_v2_editable.pptx
@@ -1,17 +1,17 @@
 
 <file path=ppt/presentation.xml><?xml version="1.0" encoding="utf-8"?>
-<p:presentation xmlns:a="http://schemas.openxmlformats.org/drawingml/2006/main" xmlns:r="http://schemas.openxmlformats.org/officeDocument/2006/relationships" xmlns:p="http://schemas.openxmlformats.org/presentationml/2006/main" autoCompressPictures="0">
+<p:presentation xmlns:a="http://schemas.openxmlformats.org/drawingml/2006/main" xmlns:r="http://schemas.openxmlformats.org/officeDocument/2006/relationships" xmlns:p="http://schemas.openxmlformats.org/presentationml/2006/main" saveSubsetFonts="1" autoCompressPictures="0">
   <p:sldMasterIdLst>
     <p:sldMasterId id="2147483648" r:id="rId1"/>
   </p:sldMasterIdLst>
+  <p:sldIdLst>
+    <p:sldId id="256" r:id="rId2"/>
+  </p:sldIdLst>
   <p:notesMasterIdLst>
-    <p:notesMasterId r:id="rId4"/>
+    <p:notesMasterId r:id="rId3"/>
   </p:notesMasterIdLst>
-  <p:sldIdLst>
-    <p:sldId id="256" r:id="rId3"/>
-  </p:sldIdLst>
-  <p:sldSz cx="5760720" cy="4452620"/>
-  <p:notesSz cx="4452620" cy="5760720"/>
+  <p:sldSz cx="5760720" cy="4453128"/>
+  <p:notesSz cx="4453128" cy="5760720"/>
   <p:defaultTextStyle>
     <a:lvl1pPr marL="0" algn="l" defTabSz="914400" rtl="0" eaLnBrk="1" latinLnBrk="0" hangingPunct="1">
       <a:defRPr sz="1800" kern="1200">
@@ -189,6 +189,7 @@
           <a:p>
             <a:fld id="{5282F153-3F37-0F45-9E97-73ACFA13230C}" type="datetimeFigureOut">
               <a:rPr lang="en-US"/>
+              <a:t>7/23/19</a:t>
             </a:fld>
             <a:endParaRPr lang="en-US"/>
           </a:p>
@@ -255,7 +256,6 @@
               <a:rPr lang="en-US"/>
               <a:t>Click to edit Master text styles</a:t>
             </a:r>
-            <a:endParaRPr lang="en-US"/>
           </a:p>
           <a:p>
             <a:pPr lvl="1"/>
@@ -263,7 +263,6 @@
               <a:rPr lang="en-US"/>
               <a:t>Second level</a:t>
             </a:r>
-            <a:endParaRPr lang="en-US"/>
           </a:p>
           <a:p>
             <a:pPr lvl="2"/>
@@ -271,7 +270,6 @@
               <a:rPr lang="en-US"/>
               <a:t>Third level</a:t>
             </a:r>
-            <a:endParaRPr lang="en-US"/>
           </a:p>
           <a:p>
             <a:pPr lvl="3"/>
@@ -279,7 +277,6 @@
               <a:rPr lang="en-US"/>
               <a:t>Fourth level</a:t>
             </a:r>
-            <a:endParaRPr lang="en-US"/>
           </a:p>
           <a:p>
             <a:pPr lvl="4"/>
@@ -287,7 +284,6 @@
               <a:rPr lang="en-US"/>
               <a:t>Fifth level</a:t>
             </a:r>
-            <a:endParaRPr lang="en-US"/>
           </a:p>
         </p:txBody>
       </p:sp>
@@ -351,12 +347,18 @@
           <a:p>
             <a:fld id="{CE5E9CC1-C706-0F49-92D6-E571CC5EEA8F}" type="slidenum">
               <a:rPr lang="en-US"/>
+              <a:t>‹#›</a:t>
             </a:fld>
             <a:endParaRPr lang="en-US"/>
           </a:p>
         </p:txBody>
       </p:sp>
     </p:spTree>
+    <p:extLst>
+      <p:ext uri="{BB962C8B-B14F-4D97-AF65-F5344CB8AC3E}">
+        <p14:creationId xmlns:p14="http://schemas.microsoft.com/office/powerpoint/2010/main" val="1024086991"/>
+      </p:ext>
+    </p:extLst>
   </p:cSld>
   <p:clrMap bg1="lt1" tx1="dk1" bg2="lt2" tx2="dk2" accent1="accent1" accent2="accent2" accent3="accent3" accent4="accent4" accent5="accent5" accent6="accent6" hlink="hlink" folHlink="folHlink"/>
   <p:notesStyle>
@@ -498,6 +500,10 @@
           <a:bodyPr/>
           <a:lstStyle/>
           <a:p>
+            <a:r>
+              <a:rPr lang="en-US" dirty="0"/>
+              <a:t/>
+            </a:r>
             <a:endParaRPr lang="en-US" dirty="0"/>
           </a:p>
         </p:txBody>
@@ -519,12 +525,18 @@
           <a:p>
             <a:fld id="{F7021451-1387-4CA6-816F-3879F97B5CBC}" type="slidenum">
               <a:rPr lang="en-US"/>
+              <a:t>1</a:t>
             </a:fld>
             <a:endParaRPr lang="en-US"/>
           </a:p>
         </p:txBody>
       </p:sp>
     </p:spTree>
+    <p:extLst>
+      <p:ext uri="{BB962C8B-B14F-4D97-AF65-F5344CB8AC3E}">
+        <p14:creationId xmlns:p14="http://schemas.microsoft.com/office/powerpoint/2010/main" val="1024086991"/>
+      </p:ext>
+    </p:extLst>
   </p:cSld>
   <p:clrMapOvr>
     <a:masterClrMapping/>
@@ -565,11 +577,6 @@
 <file path=ppt/slideMasters/slideMaster1.xml><?xml version="1.0" encoding="utf-8"?>
 <p:sldMaster xmlns:a="http://schemas.openxmlformats.org/drawingml/2006/main" xmlns:r="http://schemas.openxmlformats.org/officeDocument/2006/relationships" xmlns:p="http://schemas.openxmlformats.org/presentationml/2006/main">
   <p:cSld>
-    <p:bg>
-      <p:bgRef idx="1001">
-        <a:schemeClr val="bg1"/>
-      </p:bgRef>
-    </p:bg>
     <p:spTree>
       <p:nvGrpSpPr>
         <p:cNvPr id="1" name=""/>
@@ -613,7 +620,7 @@
         <a:spcBef>
           <a:spcPct val="20000"/>
         </a:spcBef>
-        <a:buFont typeface="Arial" panose="020B0604020202090204" pitchFamily="34" charset="0"/>
+        <a:buFont typeface="Arial" pitchFamily="34" charset="0"/>
         <a:buChar char="•"/>
         <a:defRPr sz="3200" kern="1200">
           <a:solidFill>
@@ -628,7 +635,7 @@
         <a:spcBef>
           <a:spcPct val="20000"/>
         </a:spcBef>
-        <a:buFont typeface="Arial" panose="020B0604020202090204" pitchFamily="34" charset="0"/>
+        <a:buFont typeface="Arial" pitchFamily="34" charset="0"/>
         <a:buChar char="–"/>
         <a:defRPr sz="2800" kern="1200">
           <a:solidFill>
@@ -643,7 +650,7 @@
         <a:spcBef>
           <a:spcPct val="20000"/>
         </a:spcBef>
-        <a:buFont typeface="Arial" panose="020B0604020202090204" pitchFamily="34" charset="0"/>
+        <a:buFont typeface="Arial" pitchFamily="34" charset="0"/>
         <a:buChar char="•"/>
         <a:defRPr sz="2400" kern="1200">
           <a:solidFill>
@@ -658,7 +665,7 @@
         <a:spcBef>
           <a:spcPct val="20000"/>
         </a:spcBef>
-        <a:buFont typeface="Arial" panose="020B0604020202090204" pitchFamily="34" charset="0"/>
+        <a:buFont typeface="Arial" pitchFamily="34" charset="0"/>
         <a:buChar char="–"/>
         <a:defRPr sz="2000" kern="1200">
           <a:solidFill>
@@ -673,7 +680,7 @@
         <a:spcBef>
           <a:spcPct val="20000"/>
         </a:spcBef>
-        <a:buFont typeface="Arial" panose="020B0604020202090204" pitchFamily="34" charset="0"/>
+        <a:buFont typeface="Arial" pitchFamily="34" charset="0"/>
         <a:buChar char="»"/>
         <a:defRPr sz="2000" kern="1200">
           <a:solidFill>
@@ -688,7 +695,7 @@
         <a:spcBef>
           <a:spcPct val="20000"/>
         </a:spcBef>
-        <a:buFont typeface="Arial" panose="020B0604020202090204" pitchFamily="34" charset="0"/>
+        <a:buFont typeface="Arial" pitchFamily="34" charset="0"/>
         <a:buChar char="•"/>
         <a:defRPr sz="2000" kern="1200">
           <a:solidFill>
@@ -703,7 +710,7 @@
         <a:spcBef>
           <a:spcPct val="20000"/>
         </a:spcBef>
-        <a:buFont typeface="Arial" panose="020B0604020202090204" pitchFamily="34" charset="0"/>
+        <a:buFont typeface="Arial" pitchFamily="34" charset="0"/>
         <a:buChar char="•"/>
         <a:defRPr sz="2000" kern="1200">
           <a:solidFill>
@@ -718,7 +725,7 @@
         <a:spcBef>
           <a:spcPct val="20000"/>
         </a:spcBef>
-        <a:buFont typeface="Arial" panose="020B0604020202090204" pitchFamily="34" charset="0"/>
+        <a:buFont typeface="Arial" pitchFamily="34" charset="0"/>
         <a:buChar char="•"/>
         <a:defRPr sz="2000" kern="1200">
           <a:solidFill>
@@ -733,7 +740,7 @@
         <a:spcBef>
           <a:spcPct val="20000"/>
         </a:spcBef>
-        <a:buFont typeface="Arial" panose="020B0604020202090204" pitchFamily="34" charset="0"/>
+        <a:buFont typeface="Arial" pitchFamily="34" charset="0"/>
         <a:buChar char="•"/>
         <a:defRPr sz="2000" kern="1200">
           <a:solidFill>
@@ -846,13 +853,12 @@
 
 <file path=ppt/slides/slide1.xml><?xml version="1.0" encoding="utf-8"?>
 <p:sld xmlns:a="http://schemas.openxmlformats.org/drawingml/2006/main" xmlns:r="http://schemas.openxmlformats.org/officeDocument/2006/relationships" xmlns:p="http://schemas.openxmlformats.org/presentationml/2006/main">
-  <p:cSld>
+  <p:cSld name="Slide 1">
     <p:bg>
       <p:bgPr>
         <a:solidFill>
           <a:srgbClr val="FFFFFF"/>
         </a:solidFill>
-        <a:effectLst/>
       </p:bgPr>
     </p:bg>
     <p:spTree>
@@ -884,12 +890,13 @@
             <a:avLst/>
           </a:prstGeom>
           <a:noFill/>
+          <a:ln/>
         </p:spPr>
         <p:txBody>
           <a:bodyPr wrap="square" lIns="0" tIns="0" rIns="0" bIns="0" rtlCol="0" anchor="t"/>
           <a:lstStyle/>
           <a:p>
-            <a:pPr marL="0" indent="0" algn="l">
+            <a:pPr algn="l" indent="0" marL="0">
               <a:lnSpc>
                 <a:spcPct val="100000"/>
               </a:lnSpc>
@@ -900,31 +907,43 @@
                 <a:solidFill>
                   <a:srgbClr val="1A1F2B"/>
                 </a:solidFill>
-                <a:latin typeface="Arial" panose="020B0604020202090204" pitchFamily="34" charset="0"/>
-                <a:ea typeface="Arial" panose="020B0604020202090204" pitchFamily="34" charset="-122"/>
-                <a:cs typeface="Arial" panose="020B0604020202090204" pitchFamily="34" charset="-120"/>
+                <a:latin typeface="Arial" pitchFamily="34" charset="0"/>
+                <a:ea typeface="Arial" pitchFamily="34" charset="-122"/>
+                <a:cs typeface="Arial" pitchFamily="34" charset="-120"/>
               </a:rPr>
               <a:t>(a)   One </a:t>
             </a:r>
+            <a:pPr algn="l" indent="0" marL="0">
+              <a:lnSpc>
+                <a:spcPct val="100000"/>
+              </a:lnSpc>
+              <a:buNone/>
+            </a:pPr>
             <a:r>
               <a:rPr lang="en-US" sz="900" b="1" dirty="0">
                 <a:solidFill>
                   <a:srgbClr val="1A1F2B"/>
                 </a:solidFill>
-                <a:latin typeface="Arial" panose="020B0604020202090204" pitchFamily="34" charset="0"/>
-                <a:ea typeface="Arial" panose="020B0604020202090204" pitchFamily="34" charset="-122"/>
-                <a:cs typeface="Arial" panose="020B0604020202090204" pitchFamily="34" charset="-120"/>
+                <a:latin typeface="Arial" pitchFamily="34" charset="0"/>
+                <a:ea typeface="Arial" pitchFamily="34" charset="-122"/>
+                <a:cs typeface="Arial" pitchFamily="34" charset="-120"/>
               </a:rPr>
               <a:t>DP-ES</a:t>
             </a:r>
+            <a:pPr algn="l" indent="0" marL="0">
+              <a:lnSpc>
+                <a:spcPct val="100000"/>
+              </a:lnSpc>
+              <a:buNone/>
+            </a:pPr>
             <a:r>
               <a:rPr lang="en-US" sz="900" b="1" dirty="0">
                 <a:solidFill>
                   <a:srgbClr val="1A1F2B"/>
                 </a:solidFill>
-                <a:latin typeface="Arial" panose="020B0604020202090204" pitchFamily="34" charset="0"/>
-                <a:ea typeface="Arial" panose="020B0604020202090204" pitchFamily="34" charset="-122"/>
-                <a:cs typeface="Arial" panose="020B0604020202090204" pitchFamily="34" charset="-120"/>
+                <a:latin typeface="Arial" pitchFamily="34" charset="0"/>
+                <a:ea typeface="Arial" pitchFamily="34" charset="-122"/>
+                <a:cs typeface="Arial" pitchFamily="34" charset="-120"/>
               </a:rPr>
               <a:t> iteration: privacy-free exploration, private scoring</a:t>
             </a:r>
@@ -1038,19 +1057,20 @@
         </p:nvSpPr>
         <p:spPr>
           <a:xfrm>
-            <a:off x="1691640" y="307848"/>
+            <a:off x="1691640" y="315468"/>
             <a:ext cx="2377440" cy="118872"/>
           </a:xfrm>
           <a:prstGeom prst="rect">
             <a:avLst/>
           </a:prstGeom>
           <a:noFill/>
+          <a:ln/>
         </p:spPr>
         <p:txBody>
           <a:bodyPr wrap="square" lIns="0" tIns="0" rIns="0" bIns="0" rtlCol="0" anchor="t"/>
           <a:lstStyle/>
           <a:p>
-            <a:pPr marL="0" indent="0" algn="ctr">
+            <a:pPr algn="ctr" indent="0" marL="0">
               <a:lnSpc>
                 <a:spcPct val="100000"/>
               </a:lnSpc>
@@ -1061,86 +1081,94 @@
                 <a:solidFill>
                   <a:srgbClr val="1F3D7A"/>
                 </a:solidFill>
-                <a:latin typeface="Arial" panose="020B0604020202090204" pitchFamily="34" charset="0"/>
-                <a:ea typeface="Arial" panose="020B0604020202090204" pitchFamily="34" charset="-122"/>
-                <a:cs typeface="Arial" panose="020B0604020202090204" pitchFamily="34" charset="-120"/>
+                <a:latin typeface="Arial" pitchFamily="34" charset="0"/>
+                <a:ea typeface="Arial" pitchFamily="34" charset="-122"/>
+                <a:cs typeface="Arial" pitchFamily="34" charset="-120"/>
               </a:rPr>
               <a:t>Top-M parents  </a:t>
             </a:r>
+            <a:pPr algn="ctr" indent="0" marL="0">
+              <a:lnSpc>
+                <a:spcPct val="100000"/>
+              </a:lnSpc>
+              <a:buNone/>
+            </a:pPr>
             <a:r>
               <a:rPr lang="en-US" sz="680" b="1" i="1" dirty="0">
                 <a:solidFill>
                   <a:srgbClr val="1F3D7A"/>
                 </a:solidFill>
-                <a:latin typeface="Arial" panose="020B0604020202090204" pitchFamily="34" charset="0"/>
-                <a:ea typeface="Arial" panose="020B0604020202090204" pitchFamily="34" charset="-122"/>
-                <a:cs typeface="Arial" panose="020B0604020202090204" pitchFamily="34" charset="-120"/>
+                <a:latin typeface="Arial" pitchFamily="34" charset="0"/>
+                <a:ea typeface="Arial" pitchFamily="34" charset="-122"/>
+                <a:cs typeface="Arial" pitchFamily="34" charset="-120"/>
               </a:rPr>
               <a:t>S</a:t>
             </a:r>
+            <a:pPr algn="ctr" indent="0" marL="0">
+              <a:lnSpc>
+                <a:spcPct val="100000"/>
+              </a:lnSpc>
+              <a:buNone/>
+            </a:pPr>
             <a:r>
               <a:rPr lang="en-US" sz="680" b="1" baseline="-40000" dirty="0">
                 <a:solidFill>
                   <a:srgbClr val="1F3D7A"/>
                 </a:solidFill>
-                <a:latin typeface="Arial" panose="020B0604020202090204" pitchFamily="34" charset="0"/>
-                <a:ea typeface="Arial" panose="020B0604020202090204" pitchFamily="34" charset="-122"/>
-                <a:cs typeface="Arial" panose="020B0604020202090204" pitchFamily="34" charset="-120"/>
+                <a:latin typeface="Arial" pitchFamily="34" charset="0"/>
+                <a:ea typeface="Arial" pitchFamily="34" charset="-122"/>
+                <a:cs typeface="Arial" pitchFamily="34" charset="-120"/>
               </a:rPr>
               <a:t>t</a:t>
             </a:r>
+            <a:pPr algn="ctr" indent="0" marL="0">
+              <a:lnSpc>
+                <a:spcPct val="100000"/>
+              </a:lnSpc>
+              <a:buNone/>
+            </a:pPr>
             <a:r>
               <a:rPr lang="en-US" sz="680" b="1" dirty="0">
                 <a:solidFill>
                   <a:srgbClr val="1F3D7A"/>
                 </a:solidFill>
-                <a:latin typeface="Arial" panose="020B0604020202090204" pitchFamily="34" charset="0"/>
-                <a:ea typeface="Arial" panose="020B0604020202090204" pitchFamily="34" charset="-122"/>
-                <a:cs typeface="Arial" panose="020B0604020202090204" pitchFamily="34" charset="-120"/>
-              </a:rPr>
-              <a:t>  </a:t>
-            </a:r>
-            <a:r>
-              <a:rPr lang="en-US" sz="800" b="1" dirty="0">
+                <a:latin typeface="Arial" pitchFamily="34" charset="0"/>
+                <a:ea typeface="Arial" pitchFamily="34" charset="-122"/>
+                <a:cs typeface="Arial" pitchFamily="34" charset="-120"/>
+              </a:rPr>
+              <a:t>  →  next iteration  (× </a:t>
+            </a:r>
+            <a:pPr algn="ctr" indent="0" marL="0">
+              <a:lnSpc>
+                <a:spcPct val="100000"/>
+              </a:lnSpc>
+              <a:buNone/>
+            </a:pPr>
+            <a:r>
+              <a:rPr lang="en-US" sz="680" b="1" i="1" dirty="0">
                 <a:solidFill>
                   <a:srgbClr val="1F3D7A"/>
                 </a:solidFill>
-                <a:latin typeface="Arial" panose="020B0604020202090204" pitchFamily="34" charset="0"/>
-                <a:ea typeface="Arial" panose="020B0604020202090204" pitchFamily="34" charset="-122"/>
-                <a:cs typeface="Arial" panose="020B0604020202090204" pitchFamily="34" charset="0"/>
-              </a:rPr>
-              <a:t>→</a:t>
-            </a:r>
+                <a:latin typeface="Arial" pitchFamily="34" charset="0"/>
+                <a:ea typeface="Arial" pitchFamily="34" charset="-122"/>
+                <a:cs typeface="Arial" pitchFamily="34" charset="-120"/>
+              </a:rPr>
+              <a:t>T</a:t>
+            </a:r>
+            <a:pPr algn="ctr" indent="0" marL="0">
+              <a:lnSpc>
+                <a:spcPct val="100000"/>
+              </a:lnSpc>
+              <a:buNone/>
+            </a:pPr>
             <a:r>
               <a:rPr lang="en-US" sz="680" b="1" dirty="0">
                 <a:solidFill>
                   <a:srgbClr val="1F3D7A"/>
                 </a:solidFill>
-                <a:latin typeface="Arial" panose="020B0604020202090204" pitchFamily="34" charset="0"/>
-                <a:ea typeface="Arial" panose="020B0604020202090204" pitchFamily="34" charset="-122"/>
-                <a:cs typeface="Arial" panose="020B0604020202090204" pitchFamily="34" charset="-120"/>
-              </a:rPr>
-              <a:t>  next iteration  (× </a:t>
-            </a:r>
-            <a:r>
-              <a:rPr lang="en-US" sz="680" b="1" i="1" dirty="0">
-                <a:solidFill>
-                  <a:srgbClr val="1F3D7A"/>
-                </a:solidFill>
-                <a:latin typeface="Arial" panose="020B0604020202090204" pitchFamily="34" charset="0"/>
-                <a:ea typeface="Arial" panose="020B0604020202090204" pitchFamily="34" charset="-122"/>
-                <a:cs typeface="Arial" panose="020B0604020202090204" pitchFamily="34" charset="-120"/>
-              </a:rPr>
-              <a:t>T </a:t>
-            </a:r>
-            <a:r>
-              <a:rPr lang="en-US" sz="680" b="1" dirty="0">
-                <a:solidFill>
-                  <a:srgbClr val="1F3D7A"/>
-                </a:solidFill>
-                <a:latin typeface="Arial" panose="020B0604020202090204" pitchFamily="34" charset="0"/>
-                <a:ea typeface="Arial" panose="020B0604020202090204" pitchFamily="34" charset="-122"/>
-                <a:cs typeface="Arial" panose="020B0604020202090204" pitchFamily="34" charset="-120"/>
+                <a:latin typeface="Arial" pitchFamily="34" charset="0"/>
+                <a:ea typeface="Arial" pitchFamily="34" charset="-122"/>
+                <a:cs typeface="Arial" pitchFamily="34" charset="-120"/>
               </a:rPr>
               <a:t>)</a:t>
             </a:r>
@@ -1190,25 +1218,26 @@
             <a:avLst/>
           </a:prstGeom>
           <a:noFill/>
+          <a:ln/>
         </p:spPr>
         <p:txBody>
           <a:bodyPr wrap="square" lIns="0" tIns="0" rIns="0" bIns="0" rtlCol="0" anchor="t"/>
           <a:lstStyle/>
           <a:p>
-            <a:pPr marL="0" indent="0" algn="ctr">
-              <a:lnSpc>
-                <a:spcPct val="100000"/>
-              </a:lnSpc>
-              <a:buNone/>
-            </a:pPr>
-            <a:r>
-              <a:rPr lang="en-US" sz="760" b="1" kern="0" spc="35" dirty="0">
+            <a:pPr algn="ctr" indent="0" marL="0">
+              <a:lnSpc>
+                <a:spcPct val="100000"/>
+              </a:lnSpc>
+              <a:buNone/>
+            </a:pPr>
+            <a:r>
+              <a:rPr lang="en-US" sz="760" b="1" spc="35" kern="0" dirty="0">
                 <a:solidFill>
                   <a:srgbClr val="0E7C7B"/>
                 </a:solidFill>
-                <a:latin typeface="Arial" panose="020B0604020202090204" pitchFamily="34" charset="0"/>
-                <a:ea typeface="Arial" panose="020B0604020202090204" pitchFamily="34" charset="-122"/>
-                <a:cs typeface="Arial" panose="020B0604020202090204" pitchFamily="34" charset="-120"/>
+                <a:latin typeface="Arial" pitchFamily="34" charset="0"/>
+                <a:ea typeface="Arial" pitchFamily="34" charset="-122"/>
+                <a:cs typeface="Arial" pitchFamily="34" charset="-120"/>
               </a:rPr>
               <a:t>PRIVACY-FREE</a:t>
             </a:r>
@@ -1258,25 +1287,26 @@
             <a:avLst/>
           </a:prstGeom>
           <a:noFill/>
+          <a:ln/>
         </p:spPr>
         <p:txBody>
           <a:bodyPr wrap="square" lIns="0" tIns="0" rIns="0" bIns="0" rtlCol="0" anchor="t"/>
           <a:lstStyle/>
           <a:p>
-            <a:pPr marL="0" indent="0" algn="ctr">
-              <a:lnSpc>
-                <a:spcPct val="100000"/>
-              </a:lnSpc>
-              <a:buNone/>
-            </a:pPr>
-            <a:r>
-              <a:rPr lang="en-US" sz="760" b="1" kern="0" spc="35" dirty="0">
+            <a:pPr algn="ctr" indent="0" marL="0">
+              <a:lnSpc>
+                <a:spcPct val="100000"/>
+              </a:lnSpc>
+              <a:buNone/>
+            </a:pPr>
+            <a:r>
+              <a:rPr lang="en-US" sz="760" b="1" spc="35" kern="0" dirty="0">
                 <a:solidFill>
                   <a:srgbClr val="1F3D7A"/>
                 </a:solidFill>
-                <a:latin typeface="Arial" panose="020B0604020202090204" pitchFamily="34" charset="0"/>
-                <a:ea typeface="Arial" panose="020B0604020202090204" pitchFamily="34" charset="-122"/>
-                <a:cs typeface="Arial" panose="020B0604020202090204" pitchFamily="34" charset="-120"/>
+                <a:latin typeface="Arial" pitchFamily="34" charset="0"/>
+                <a:ea typeface="Arial" pitchFamily="34" charset="-122"/>
+                <a:cs typeface="Arial" pitchFamily="34" charset="-120"/>
               </a:rPr>
               <a:t>PRIVATE-DATA ACCESS</a:t>
             </a:r>
@@ -1326,25 +1356,26 @@
             <a:avLst/>
           </a:prstGeom>
           <a:noFill/>
+          <a:ln/>
         </p:spPr>
         <p:txBody>
           <a:bodyPr wrap="square" lIns="0" tIns="0" rIns="0" bIns="0" rtlCol="0" anchor="t"/>
           <a:lstStyle/>
           <a:p>
-            <a:pPr marL="0" indent="0" algn="ctr">
-              <a:lnSpc>
-                <a:spcPct val="100000"/>
-              </a:lnSpc>
-              <a:buNone/>
-            </a:pPr>
-            <a:r>
-              <a:rPr lang="en-US" sz="760" b="1" kern="0" spc="35" dirty="0">
+            <a:pPr algn="ctr" indent="0" marL="0">
+              <a:lnSpc>
+                <a:spcPct val="100000"/>
+              </a:lnSpc>
+              <a:buNone/>
+            </a:pPr>
+            <a:r>
+              <a:rPr lang="en-US" sz="760" b="1" spc="35" kern="0" dirty="0">
                 <a:solidFill>
                   <a:srgbClr val="2E7D32"/>
                 </a:solidFill>
-                <a:latin typeface="Arial" panose="020B0604020202090204" pitchFamily="34" charset="0"/>
-                <a:ea typeface="Arial" panose="020B0604020202090204" pitchFamily="34" charset="-122"/>
-                <a:cs typeface="Arial" panose="020B0604020202090204" pitchFamily="34" charset="-120"/>
+                <a:latin typeface="Arial" pitchFamily="34" charset="0"/>
+                <a:ea typeface="Arial" pitchFamily="34" charset="-122"/>
+                <a:cs typeface="Arial" pitchFamily="34" charset="-120"/>
               </a:rPr>
               <a:t>POST-PROCESSING</a:t>
             </a:r>
@@ -1396,6 +1427,7 @@
           <a:solidFill>
             <a:srgbClr val="0E7C7B"/>
           </a:solidFill>
+          <a:ln/>
         </p:spPr>
       </p:sp>
       <p:sp>
@@ -1535,12 +1567,13 @@
             <a:avLst/>
           </a:prstGeom>
           <a:noFill/>
+          <a:ln/>
         </p:spPr>
         <p:txBody>
           <a:bodyPr wrap="square" lIns="0" tIns="0" rIns="0" bIns="0" rtlCol="0" anchor="ctr"/>
           <a:lstStyle/>
           <a:p>
-            <a:pPr marL="0" indent="0" algn="ctr">
+            <a:pPr algn="ctr" indent="0" marL="0">
               <a:lnSpc>
                 <a:spcPct val="104000"/>
               </a:lnSpc>
@@ -1551,16 +1584,16 @@
                 <a:solidFill>
                   <a:srgbClr val="0E7C7B"/>
                 </a:solidFill>
-                <a:latin typeface="Arial" panose="020B0604020202090204" pitchFamily="34" charset="0"/>
-                <a:ea typeface="Arial" panose="020B0604020202090204" pitchFamily="34" charset="-122"/>
-                <a:cs typeface="Arial" panose="020B0604020202090204" pitchFamily="34" charset="-120"/>
+                <a:latin typeface="Arial" pitchFamily="34" charset="0"/>
+                <a:ea typeface="Arial" pitchFamily="34" charset="-122"/>
+                <a:cs typeface="Arial" pitchFamily="34" charset="-120"/>
               </a:rPr>
               <a:t>Phase 1</a:t>
             </a:r>
             <a:endParaRPr lang="en-US" sz="780" dirty="0"/>
           </a:p>
           <a:p>
-            <a:pPr marL="0" indent="0" algn="ctr">
+            <a:pPr algn="ctr" indent="0" marL="0">
               <a:lnSpc>
                 <a:spcPct val="104000"/>
               </a:lnSpc>
@@ -1571,9 +1604,9 @@
                 <a:solidFill>
                   <a:srgbClr val="0E7C7B"/>
                 </a:solidFill>
-                <a:latin typeface="Arial" panose="020B0604020202090204" pitchFamily="34" charset="0"/>
-                <a:ea typeface="Arial" panose="020B0604020202090204" pitchFamily="34" charset="-122"/>
-                <a:cs typeface="Arial" panose="020B0604020202090204" pitchFamily="34" charset="-120"/>
+                <a:latin typeface="Arial" pitchFamily="34" charset="0"/>
+                <a:ea typeface="Arial" pitchFamily="34" charset="-122"/>
+                <a:cs typeface="Arial" pitchFamily="34" charset="-120"/>
               </a:rPr>
               <a:t>LLM mutation</a:t>
             </a:r>
@@ -1589,169 +1622,190 @@
         </p:nvSpPr>
         <p:spPr>
           <a:xfrm>
-            <a:off x="210312" y="1273302"/>
-            <a:ext cx="1581912" cy="118872"/>
+            <a:off x="256032" y="1353312"/>
+            <a:ext cx="1493520" cy="118872"/>
           </a:xfrm>
           <a:prstGeom prst="rect">
             <a:avLst/>
           </a:prstGeom>
           <a:noFill/>
+          <a:ln/>
         </p:spPr>
         <p:txBody>
           <a:bodyPr wrap="square" lIns="0" tIns="0" rIns="0" bIns="0" rtlCol="0" anchor="t"/>
           <a:lstStyle/>
           <a:p>
-            <a:pPr marL="0" indent="0" algn="ctr">
-              <a:lnSpc>
-                <a:spcPct val="100000"/>
-              </a:lnSpc>
-              <a:buNone/>
-            </a:pPr>
-            <a:r>
-              <a:rPr lang="en-US" sz="800" i="1" dirty="0">
+            <a:pPr algn="ctr" indent="0" marL="0">
+              <a:lnSpc>
+                <a:spcPct val="100000"/>
+              </a:lnSpc>
+              <a:buNone/>
+            </a:pPr>
+            <a:r>
+              <a:rPr lang="en-US" sz="760" i="1" dirty="0">
                 <a:solidFill>
                   <a:srgbClr val="1A1F2B"/>
                 </a:solidFill>
-                <a:latin typeface="Times New Roman Regular" panose="02020503050405090304" charset="0"/>
-                <a:ea typeface="Times New Roman" panose="02020503050405090304" pitchFamily="34" charset="-122"/>
-                <a:cs typeface="Times New Roman Regular" panose="02020503050405090304" charset="0"/>
+                <a:latin typeface="Times New Roman" pitchFamily="34" charset="0"/>
+                <a:ea typeface="Times New Roman" pitchFamily="34" charset="-122"/>
+                <a:cs typeface="Times New Roman" pitchFamily="34" charset="-120"/>
               </a:rPr>
               <a:t>P</a:t>
             </a:r>
-            <a:r>
-              <a:rPr lang="en-US" sz="800" baseline="-40000" dirty="0">
+            <a:pPr algn="ctr" indent="0" marL="0">
+              <a:lnSpc>
+                <a:spcPct val="100000"/>
+              </a:lnSpc>
+              <a:buNone/>
+            </a:pPr>
+            <a:r>
+              <a:rPr lang="en-US" sz="760" baseline="-40000" dirty="0">
                 <a:solidFill>
                   <a:srgbClr val="1A1F2B"/>
                 </a:solidFill>
-                <a:latin typeface="Times New Roman Regular" panose="02020503050405090304" charset="0"/>
-                <a:ea typeface="Times New Roman" panose="02020503050405090304" pitchFamily="34" charset="-122"/>
-                <a:cs typeface="Times New Roman Regular" panose="02020503050405090304" charset="0"/>
+                <a:latin typeface="Times New Roman" pitchFamily="34" charset="0"/>
+                <a:ea typeface="Times New Roman" pitchFamily="34" charset="-122"/>
+                <a:cs typeface="Times New Roman" pitchFamily="34" charset="-120"/>
               </a:rPr>
               <a:t>t</a:t>
             </a:r>
-            <a:r>
-              <a:rPr lang="en-US" sz="800" dirty="0">
+            <a:pPr algn="ctr" indent="0" marL="0">
+              <a:lnSpc>
+                <a:spcPct val="100000"/>
+              </a:lnSpc>
+              <a:buNone/>
+            </a:pPr>
+            <a:r>
+              <a:rPr lang="en-US" sz="760" dirty="0">
                 <a:solidFill>
                   <a:srgbClr val="1A1F2B"/>
                 </a:solidFill>
-                <a:latin typeface="Times New Roman Regular" panose="02020503050405090304" charset="0"/>
-                <a:ea typeface="Times New Roman" panose="02020503050405090304" pitchFamily="34" charset="-122"/>
-                <a:cs typeface="Times New Roman Regular" panose="02020503050405090304" charset="0"/>
+                <a:latin typeface="Times New Roman" pitchFamily="34" charset="0"/>
+                <a:ea typeface="Times New Roman" pitchFamily="34" charset="-122"/>
+                <a:cs typeface="Times New Roman" pitchFamily="34" charset="-120"/>
               </a:rPr>
               <a:t>  ←  Mutate-To-K(</a:t>
             </a:r>
-            <a:r>
-              <a:rPr lang="en-US" sz="800" i="1" dirty="0">
+            <a:pPr algn="ctr" indent="0" marL="0">
+              <a:lnSpc>
+                <a:spcPct val="100000"/>
+              </a:lnSpc>
+              <a:buNone/>
+            </a:pPr>
+            <a:r>
+              <a:rPr lang="en-US" sz="760" i="1" dirty="0">
                 <a:solidFill>
                   <a:srgbClr val="1A1F2B"/>
                 </a:solidFill>
-                <a:latin typeface="Times New Roman Regular" panose="02020503050405090304" charset="0"/>
-                <a:ea typeface="Times New Roman" panose="02020503050405090304" pitchFamily="34" charset="-122"/>
-                <a:cs typeface="Times New Roman Regular" panose="02020503050405090304" charset="0"/>
+                <a:latin typeface="Times New Roman" pitchFamily="34" charset="0"/>
+                <a:ea typeface="Times New Roman" pitchFamily="34" charset="-122"/>
+                <a:cs typeface="Times New Roman" pitchFamily="34" charset="-120"/>
               </a:rPr>
               <a:t>S</a:t>
             </a:r>
-            <a:r>
-              <a:rPr lang="en-US" sz="800" baseline="-40000" dirty="0">
+            <a:pPr algn="ctr" indent="0" marL="0">
+              <a:lnSpc>
+                <a:spcPct val="100000"/>
+              </a:lnSpc>
+              <a:buNone/>
+            </a:pPr>
+            <a:r>
+              <a:rPr lang="en-US" sz="760" baseline="-40000" dirty="0">
                 <a:solidFill>
                   <a:srgbClr val="1A1F2B"/>
                 </a:solidFill>
-                <a:latin typeface="Times New Roman Regular" panose="02020503050405090304" charset="0"/>
-                <a:ea typeface="Times New Roman" panose="02020503050405090304" pitchFamily="34" charset="-122"/>
-                <a:cs typeface="Times New Roman Regular" panose="02020503050405090304" charset="0"/>
+                <a:latin typeface="Times New Roman" pitchFamily="34" charset="0"/>
+                <a:ea typeface="Times New Roman" pitchFamily="34" charset="-122"/>
+                <a:cs typeface="Times New Roman" pitchFamily="34" charset="-120"/>
               </a:rPr>
               <a:t>t−1</a:t>
             </a:r>
-            <a:r>
-              <a:rPr lang="en-US" sz="800" dirty="0">
+            <a:pPr algn="ctr" indent="0" marL="0">
+              <a:lnSpc>
+                <a:spcPct val="100000"/>
+              </a:lnSpc>
+              <a:buNone/>
+            </a:pPr>
+            <a:r>
+              <a:rPr lang="en-US" sz="760" dirty="0">
                 <a:solidFill>
                   <a:srgbClr val="1A1F2B"/>
                 </a:solidFill>
-                <a:latin typeface="Times New Roman Regular" panose="02020503050405090304" charset="0"/>
-                <a:ea typeface="Times New Roman" panose="02020503050405090304" pitchFamily="34" charset="-122"/>
-                <a:cs typeface="Times New Roman Regular" panose="02020503050405090304" charset="0"/>
-              </a:rPr>
-              <a:t>), </a:t>
-            </a:r>
-            <a:endParaRPr lang="en-US" sz="800" dirty="0">
-              <a:solidFill>
-                <a:srgbClr val="1A1F2B"/>
-              </a:solidFill>
-              <a:latin typeface="Times New Roman Regular" panose="02020503050405090304" charset="0"/>
-              <a:ea typeface="Times New Roman" panose="02020503050405090304" pitchFamily="34" charset="-122"/>
-              <a:cs typeface="Times New Roman Regular" panose="02020503050405090304" charset="0"/>
-            </a:endParaRPr>
-          </a:p>
-          <a:p>
-            <a:pPr marL="0" indent="0" algn="ctr">
-              <a:lnSpc>
-                <a:spcPct val="100000"/>
-              </a:lnSpc>
-              <a:buNone/>
-            </a:pPr>
-            <a:r>
-              <a:rPr lang="en-US" sz="800" dirty="0">
+                <a:latin typeface="Times New Roman" pitchFamily="34" charset="0"/>
+                <a:ea typeface="Times New Roman" pitchFamily="34" charset="-122"/>
+                <a:cs typeface="Times New Roman" pitchFamily="34" charset="-120"/>
+              </a:rPr>
+              <a:t>),   |</a:t>
+            </a:r>
+            <a:pPr algn="ctr" indent="0" marL="0">
+              <a:lnSpc>
+                <a:spcPct val="100000"/>
+              </a:lnSpc>
+              <a:buNone/>
+            </a:pPr>
+            <a:r>
+              <a:rPr lang="en-US" sz="760" i="1" dirty="0">
                 <a:solidFill>
                   <a:srgbClr val="1A1F2B"/>
                 </a:solidFill>
-                <a:latin typeface="Times New Roman Regular" panose="02020503050405090304" charset="0"/>
-                <a:ea typeface="Times New Roman" panose="02020503050405090304" pitchFamily="34" charset="-122"/>
-                <a:cs typeface="Times New Roman Regular" panose="02020503050405090304" charset="0"/>
-              </a:rPr>
-              <a:t>  |</a:t>
-            </a:r>
-            <a:r>
-              <a:rPr lang="en-US" sz="800" i="1" dirty="0">
+                <a:latin typeface="Times New Roman" pitchFamily="34" charset="0"/>
+                <a:ea typeface="Times New Roman" pitchFamily="34" charset="-122"/>
+                <a:cs typeface="Times New Roman" pitchFamily="34" charset="-120"/>
+              </a:rPr>
+              <a:t>P</a:t>
+            </a:r>
+            <a:pPr algn="ctr" indent="0" marL="0">
+              <a:lnSpc>
+                <a:spcPct val="100000"/>
+              </a:lnSpc>
+              <a:buNone/>
+            </a:pPr>
+            <a:r>
+              <a:rPr lang="en-US" sz="760" baseline="-40000" dirty="0">
                 <a:solidFill>
                   <a:srgbClr val="1A1F2B"/>
                 </a:solidFill>
-                <a:latin typeface="Times New Roman Regular" panose="02020503050405090304" charset="0"/>
-                <a:ea typeface="Times New Roman" panose="02020503050405090304" pitchFamily="34" charset="-122"/>
-                <a:cs typeface="Times New Roman Regular" panose="02020503050405090304" charset="0"/>
-              </a:rPr>
-              <a:t>P</a:t>
-            </a:r>
-            <a:r>
-              <a:rPr lang="en-US" sz="800" baseline="-40000" dirty="0">
+                <a:latin typeface="Times New Roman" pitchFamily="34" charset="0"/>
+                <a:ea typeface="Times New Roman" pitchFamily="34" charset="-122"/>
+                <a:cs typeface="Times New Roman" pitchFamily="34" charset="-120"/>
+              </a:rPr>
+              <a:t>t</a:t>
+            </a:r>
+            <a:pPr algn="ctr" indent="0" marL="0">
+              <a:lnSpc>
+                <a:spcPct val="100000"/>
+              </a:lnSpc>
+              <a:buNone/>
+            </a:pPr>
+            <a:r>
+              <a:rPr lang="en-US" sz="760" dirty="0">
                 <a:solidFill>
                   <a:srgbClr val="1A1F2B"/>
                 </a:solidFill>
-                <a:latin typeface="Times New Roman Regular" panose="02020503050405090304" charset="0"/>
-                <a:ea typeface="Times New Roman" panose="02020503050405090304" pitchFamily="34" charset="-122"/>
-                <a:cs typeface="Times New Roman Regular" panose="02020503050405090304" charset="0"/>
-              </a:rPr>
-              <a:t>t</a:t>
-            </a:r>
-            <a:r>
-              <a:rPr lang="en-US" sz="800" dirty="0">
+                <a:latin typeface="Times New Roman" pitchFamily="34" charset="0"/>
+                <a:ea typeface="Times New Roman" pitchFamily="34" charset="-122"/>
+                <a:cs typeface="Times New Roman" pitchFamily="34" charset="-120"/>
+              </a:rPr>
+              <a:t>| = </a:t>
+            </a:r>
+            <a:pPr algn="ctr" indent="0" marL="0">
+              <a:lnSpc>
+                <a:spcPct val="100000"/>
+              </a:lnSpc>
+              <a:buNone/>
+            </a:pPr>
+            <a:r>
+              <a:rPr lang="en-US" sz="760" i="1" dirty="0">
                 <a:solidFill>
                   <a:srgbClr val="1A1F2B"/>
                 </a:solidFill>
-                <a:latin typeface="Times New Roman Regular" panose="02020503050405090304" charset="0"/>
-                <a:ea typeface="Times New Roman" panose="02020503050405090304" pitchFamily="34" charset="-122"/>
-                <a:cs typeface="Times New Roman Regular" panose="02020503050405090304" charset="0"/>
-              </a:rPr>
-              <a:t>| = </a:t>
-            </a:r>
-            <a:r>
-              <a:rPr lang="en-US" sz="800" i="1" dirty="0">
-                <a:solidFill>
-                  <a:srgbClr val="1A1F2B"/>
-                </a:solidFill>
-                <a:latin typeface="Times New Roman Regular" panose="02020503050405090304" charset="0"/>
-                <a:ea typeface="Times New Roman" panose="02020503050405090304" pitchFamily="34" charset="-122"/>
-                <a:cs typeface="Times New Roman Regular" panose="02020503050405090304" charset="0"/>
+                <a:latin typeface="Times New Roman" pitchFamily="34" charset="0"/>
+                <a:ea typeface="Times New Roman" pitchFamily="34" charset="-122"/>
+                <a:cs typeface="Times New Roman" pitchFamily="34" charset="-120"/>
               </a:rPr>
               <a:t>K</a:t>
             </a:r>
-            <a:endParaRPr lang="en-US" sz="800" i="1" dirty="0">
-              <a:solidFill>
-                <a:srgbClr val="1A1F2B"/>
-              </a:solidFill>
-              <a:latin typeface="Times New Roman Regular" panose="02020503050405090304" charset="0"/>
-              <a:ea typeface="Times New Roman" panose="02020503050405090304" pitchFamily="34" charset="-122"/>
-              <a:cs typeface="Times New Roman Regular" panose="02020503050405090304" charset="0"/>
-            </a:endParaRPr>
+            <a:endParaRPr lang="en-US" sz="760" dirty="0"/>
           </a:p>
         </p:txBody>
       </p:sp>
@@ -1770,58 +1824,64 @@
             <a:avLst/>
           </a:prstGeom>
           <a:noFill/>
+          <a:ln/>
         </p:spPr>
         <p:txBody>
           <a:bodyPr wrap="square" lIns="0" tIns="0" rIns="0" bIns="0" rtlCol="0" anchor="t"/>
           <a:lstStyle/>
           <a:p>
-            <a:pPr marL="0" indent="0" algn="l">
+            <a:pPr algn="l" indent="0" marL="0">
               <a:lnSpc>
                 <a:spcPct val="96000"/>
               </a:lnSpc>
               <a:buNone/>
             </a:pPr>
             <a:r>
-              <a:rPr lang="en-US" sz="700" dirty="0">
+              <a:rPr lang="en-US" sz="660" dirty="0">
                 <a:solidFill>
                   <a:srgbClr val="333B48"/>
                 </a:solidFill>
-                <a:latin typeface="Times New Roman Regular" panose="02020503050405090304" charset="0"/>
-                <a:ea typeface="Arial" panose="020B0604020202090204" pitchFamily="34" charset="-122"/>
-                <a:cs typeface="Times New Roman Regular" panose="02020503050405090304" charset="0"/>
+                <a:latin typeface="Arial" pitchFamily="34" charset="0"/>
+                <a:ea typeface="Arial" pitchFamily="34" charset="-122"/>
+                <a:cs typeface="Arial" pitchFamily="34" charset="-120"/>
               </a:rPr>
               <a:t>Builds a fixed K-candidate population from selected parents; never reads the private set </a:t>
             </a:r>
-            <a:r>
-              <a:rPr lang="en-US" sz="700" dirty="0">
+            <a:pPr algn="l" indent="0" marL="0">
+              <a:lnSpc>
+                <a:spcPct val="96000"/>
+              </a:lnSpc>
+              <a:buNone/>
+            </a:pPr>
+            <a:r>
+              <a:rPr lang="en-US" sz="660" dirty="0">
                 <a:solidFill>
                   <a:srgbClr val="333B48"/>
                 </a:solidFill>
-                <a:latin typeface="Times New Roman Regular" panose="02020503050405090304" charset="0"/>
+                <a:latin typeface="Cambria Math" pitchFamily="34" charset="0"/>
                 <a:ea typeface="Cambria Math" pitchFamily="34" charset="-122"/>
-                <a:cs typeface="Times New Roman Regular" panose="02020503050405090304" charset="0"/>
+                <a:cs typeface="Cambria Math" pitchFamily="34" charset="-120"/>
               </a:rPr>
               <a:t>𝒟</a:t>
             </a:r>
-            <a:r>
-              <a:rPr lang="en-US" sz="700" dirty="0">
+            <a:pPr algn="l" indent="0" marL="0">
+              <a:lnSpc>
+                <a:spcPct val="96000"/>
+              </a:lnSpc>
+              <a:buNone/>
+            </a:pPr>
+            <a:r>
+              <a:rPr lang="en-US" sz="660" dirty="0">
                 <a:solidFill>
                   <a:srgbClr val="333B48"/>
                 </a:solidFill>
-                <a:latin typeface="Times New Roman Regular" panose="02020503050405090304" charset="0"/>
-                <a:ea typeface="Arial" panose="020B0604020202090204" pitchFamily="34" charset="-122"/>
-                <a:cs typeface="Times New Roman Regular" panose="02020503050405090304" charset="0"/>
+                <a:latin typeface="Arial" pitchFamily="34" charset="0"/>
+                <a:ea typeface="Arial" pitchFamily="34" charset="-122"/>
+                <a:cs typeface="Arial" pitchFamily="34" charset="-120"/>
               </a:rPr>
               <a:t>.</a:t>
             </a:r>
-            <a:endParaRPr lang="en-US" sz="700" dirty="0">
-              <a:solidFill>
-                <a:srgbClr val="333B48"/>
-              </a:solidFill>
-              <a:latin typeface="Times New Roman Regular" panose="02020503050405090304" charset="0"/>
-              <a:ea typeface="Arial" panose="020B0604020202090204" pitchFamily="34" charset="-122"/>
-              <a:cs typeface="Times New Roman Regular" panose="02020503050405090304" charset="0"/>
-            </a:endParaRPr>
+            <a:endParaRPr lang="en-US" sz="660" dirty="0"/>
           </a:p>
         </p:txBody>
       </p:sp>
@@ -1844,6 +1904,7 @@
           <a:solidFill>
             <a:srgbClr val="0E7C7B"/>
           </a:solidFill>
+          <a:ln/>
         </p:spPr>
       </p:sp>
       <p:sp>
@@ -1861,12 +1922,13 @@
             <a:avLst/>
           </a:prstGeom>
           <a:noFill/>
+          <a:ln/>
         </p:spPr>
         <p:txBody>
           <a:bodyPr wrap="square" lIns="0" tIns="0" rIns="0" bIns="0" rtlCol="0" anchor="t"/>
           <a:lstStyle/>
           <a:p>
-            <a:pPr marL="0" indent="0" algn="ctr">
+            <a:pPr algn="ctr" indent="0" marL="0">
               <a:lnSpc>
                 <a:spcPct val="100000"/>
               </a:lnSpc>
@@ -1877,9 +1939,9 @@
                 <a:solidFill>
                   <a:srgbClr val="FFFFFF"/>
                 </a:solidFill>
-                <a:latin typeface="Arial" panose="020B0604020202090204" pitchFamily="34" charset="0"/>
-                <a:ea typeface="Arial" panose="020B0604020202090204" pitchFamily="34" charset="-122"/>
-                <a:cs typeface="Arial" panose="020B0604020202090204" pitchFamily="34" charset="-120"/>
+                <a:latin typeface="Arial" pitchFamily="34" charset="0"/>
+                <a:ea typeface="Arial" pitchFamily="34" charset="-122"/>
+                <a:cs typeface="Arial" pitchFamily="34" charset="-120"/>
               </a:rPr>
               <a:t>0 additional privacy loss</a:t>
             </a:r>
@@ -1931,6 +1993,7 @@
           <a:solidFill>
             <a:srgbClr val="1F3D7A"/>
           </a:solidFill>
+          <a:ln/>
         </p:spPr>
       </p:sp>
       <p:sp>
@@ -2016,6 +2079,7 @@
           <a:solidFill>
             <a:srgbClr val="FFFFFF"/>
           </a:solidFill>
+          <a:ln/>
         </p:spPr>
       </p:sp>
       <p:sp>
@@ -2033,12 +2097,13 @@
             <a:avLst/>
           </a:prstGeom>
           <a:noFill/>
+          <a:ln/>
         </p:spPr>
         <p:txBody>
           <a:bodyPr wrap="square" lIns="0" tIns="0" rIns="0" bIns="0" rtlCol="0" anchor="ctr"/>
           <a:lstStyle/>
           <a:p>
-            <a:pPr marL="0" indent="0" algn="ctr">
+            <a:pPr algn="ctr" indent="0" marL="0">
               <a:lnSpc>
                 <a:spcPct val="104000"/>
               </a:lnSpc>
@@ -2049,16 +2114,16 @@
                 <a:solidFill>
                   <a:srgbClr val="1F3D7A"/>
                 </a:solidFill>
-                <a:latin typeface="Arial" panose="020B0604020202090204" pitchFamily="34" charset="0"/>
-                <a:ea typeface="Arial" panose="020B0604020202090204" pitchFamily="34" charset="-122"/>
-                <a:cs typeface="Arial" panose="020B0604020202090204" pitchFamily="34" charset="-120"/>
+                <a:latin typeface="Arial" pitchFamily="34" charset="0"/>
+                <a:ea typeface="Arial" pitchFamily="34" charset="-122"/>
+                <a:cs typeface="Arial" pitchFamily="34" charset="-120"/>
               </a:rPr>
               <a:t>Phase 2</a:t>
             </a:r>
             <a:endParaRPr lang="en-US" sz="780" dirty="0"/>
           </a:p>
           <a:p>
-            <a:pPr marL="0" indent="0" algn="ctr">
+            <a:pPr algn="ctr" indent="0" marL="0">
               <a:lnSpc>
                 <a:spcPct val="104000"/>
               </a:lnSpc>
@@ -2069,9 +2134,9 @@
                 <a:solidFill>
                   <a:srgbClr val="1F3D7A"/>
                 </a:solidFill>
-                <a:latin typeface="Arial" panose="020B0604020202090204" pitchFamily="34" charset="0"/>
-                <a:ea typeface="Arial" panose="020B0604020202090204" pitchFamily="34" charset="-122"/>
-                <a:cs typeface="Arial" panose="020B0604020202090204" pitchFamily="34" charset="-120"/>
+                <a:latin typeface="Arial" pitchFamily="34" charset="0"/>
+                <a:ea typeface="Arial" pitchFamily="34" charset="-122"/>
+                <a:cs typeface="Arial" pitchFamily="34" charset="-120"/>
               </a:rPr>
               <a:t>DP scoring</a:t>
             </a:r>
@@ -2087,171 +2152,241 @@
         </p:nvSpPr>
         <p:spPr>
           <a:xfrm>
-            <a:off x="2133600" y="1286256"/>
+            <a:off x="2133600" y="1293876"/>
             <a:ext cx="1493520" cy="118872"/>
           </a:xfrm>
           <a:prstGeom prst="rect">
             <a:avLst/>
           </a:prstGeom>
           <a:noFill/>
+          <a:ln/>
         </p:spPr>
         <p:txBody>
           <a:bodyPr wrap="square" lIns="0" tIns="0" rIns="0" bIns="0" rtlCol="0" anchor="t"/>
           <a:lstStyle/>
           <a:p>
-            <a:pPr marL="0" indent="0" algn="ctr">
-              <a:lnSpc>
-                <a:spcPct val="100000"/>
-              </a:lnSpc>
-              <a:buNone/>
-            </a:pPr>
-            <a:r>
-              <a:rPr lang="en-US" sz="800" i="1" dirty="0">
+            <a:pPr algn="ctr" indent="0" marL="0">
+              <a:lnSpc>
+                <a:spcPct val="100000"/>
+              </a:lnSpc>
+              <a:buNone/>
+            </a:pPr>
+            <a:r>
+              <a:rPr lang="en-US" sz="740" i="1" dirty="0">
                 <a:solidFill>
                   <a:srgbClr val="1A1F2B"/>
                 </a:solidFill>
-                <a:latin typeface="Times New Roman Regular" panose="02020503050405090304" charset="0"/>
-                <a:ea typeface="Times New Roman" panose="02020503050405090304" pitchFamily="34" charset="-122"/>
-                <a:cs typeface="Times New Roman Regular" panose="02020503050405090304" charset="0"/>
+                <a:latin typeface="Times New Roman" pitchFamily="34" charset="0"/>
+                <a:ea typeface="Times New Roman" pitchFamily="34" charset="-122"/>
+                <a:cs typeface="Times New Roman" pitchFamily="34" charset="-120"/>
               </a:rPr>
               <a:t>s</a:t>
             </a:r>
-            <a:r>
-              <a:rPr lang="en-US" sz="800" baseline="-40000" dirty="0">
+            <a:pPr algn="ctr" indent="0" marL="0">
+              <a:lnSpc>
+                <a:spcPct val="100000"/>
+              </a:lnSpc>
+              <a:buNone/>
+            </a:pPr>
+            <a:r>
+              <a:rPr lang="en-US" sz="740" baseline="-40000" dirty="0">
                 <a:solidFill>
                   <a:srgbClr val="1A1F2B"/>
                 </a:solidFill>
-                <a:latin typeface="Times New Roman Regular" panose="02020503050405090304" charset="0"/>
-                <a:ea typeface="Times New Roman" panose="02020503050405090304" pitchFamily="34" charset="-122"/>
-                <a:cs typeface="Times New Roman Regular" panose="02020503050405090304" charset="0"/>
+                <a:latin typeface="Times New Roman" pitchFamily="34" charset="0"/>
+                <a:ea typeface="Times New Roman" pitchFamily="34" charset="-122"/>
+                <a:cs typeface="Times New Roman" pitchFamily="34" charset="-120"/>
               </a:rPr>
               <a:t>p</a:t>
             </a:r>
-            <a:r>
-              <a:rPr lang="en-US" sz="800" dirty="0">
+            <a:pPr algn="ctr" indent="0" marL="0">
+              <a:lnSpc>
+                <a:spcPct val="100000"/>
+              </a:lnSpc>
+              <a:buNone/>
+            </a:pPr>
+            <a:r>
+              <a:rPr lang="en-US" sz="740" dirty="0">
                 <a:solidFill>
                   <a:srgbClr val="1A1F2B"/>
                 </a:solidFill>
-                <a:latin typeface="Times New Roman Regular" panose="02020503050405090304" charset="0"/>
-                <a:ea typeface="Times New Roman" panose="02020503050405090304" pitchFamily="34" charset="-122"/>
-                <a:cs typeface="Times New Roman Regular" panose="02020503050405090304" charset="0"/>
+                <a:latin typeface="Times New Roman" pitchFamily="34" charset="0"/>
+                <a:ea typeface="Times New Roman" pitchFamily="34" charset="-122"/>
+                <a:cs typeface="Times New Roman" pitchFamily="34" charset="-120"/>
               </a:rPr>
               <a:t>(</a:t>
             </a:r>
-            <a:r>
-              <a:rPr lang="en-US" sz="800" i="1" dirty="0">
+            <a:pPr algn="ctr" indent="0" marL="0">
+              <a:lnSpc>
+                <a:spcPct val="100000"/>
+              </a:lnSpc>
+              <a:buNone/>
+            </a:pPr>
+            <a:r>
+              <a:rPr lang="en-US" sz="740" i="1" dirty="0">
                 <a:solidFill>
                   <a:srgbClr val="1A1F2B"/>
                 </a:solidFill>
-                <a:latin typeface="Times New Roman Regular" panose="02020503050405090304" charset="0"/>
-                <a:ea typeface="Times New Roman" panose="02020503050405090304" pitchFamily="34" charset="-122"/>
-                <a:cs typeface="Times New Roman Regular" panose="02020503050405090304" charset="0"/>
-              </a:rPr>
-              <a:t>B </a:t>
-            </a:r>
-            <a:r>
-              <a:rPr lang="en-US" sz="800" dirty="0">
+                <a:latin typeface="Times New Roman" pitchFamily="34" charset="0"/>
+                <a:ea typeface="Times New Roman" pitchFamily="34" charset="-122"/>
+                <a:cs typeface="Times New Roman" pitchFamily="34" charset="-120"/>
+              </a:rPr>
+              <a:t>B</a:t>
+            </a:r>
+            <a:pPr algn="ctr" indent="0" marL="0">
+              <a:lnSpc>
+                <a:spcPct val="100000"/>
+              </a:lnSpc>
+              <a:buNone/>
+            </a:pPr>
+            <a:r>
+              <a:rPr lang="en-US" sz="740" dirty="0">
                 <a:solidFill>
                   <a:srgbClr val="1A1F2B"/>
                 </a:solidFill>
-                <a:latin typeface="Times New Roman Regular" panose="02020503050405090304" charset="0"/>
-                <a:ea typeface="Times New Roman" panose="02020503050405090304" pitchFamily="34" charset="-122"/>
-                <a:cs typeface="Times New Roman Regular" panose="02020503050405090304" charset="0"/>
+                <a:latin typeface="Times New Roman" pitchFamily="34" charset="0"/>
+                <a:ea typeface="Times New Roman" pitchFamily="34" charset="-122"/>
+                <a:cs typeface="Times New Roman" pitchFamily="34" charset="-120"/>
               </a:rPr>
               <a:t>) = </a:t>
             </a:r>
-            <a:r>
-              <a:rPr lang="en-US" sz="800" i="1" dirty="0">
+            <a:pPr algn="ctr" indent="0" marL="0">
+              <a:lnSpc>
+                <a:spcPct val="100000"/>
+              </a:lnSpc>
+              <a:buNone/>
+            </a:pPr>
+            <a:r>
+              <a:rPr lang="en-US" sz="740" i="1" dirty="0">
                 <a:solidFill>
                   <a:srgbClr val="1A1F2B"/>
                 </a:solidFill>
-                <a:latin typeface="Times New Roman Regular" panose="02020503050405090304" charset="0"/>
-                <a:ea typeface="Times New Roman" panose="02020503050405090304" pitchFamily="34" charset="-122"/>
-                <a:cs typeface="Times New Roman Regular" panose="02020503050405090304" charset="0"/>
+                <a:latin typeface="Times New Roman" pitchFamily="34" charset="0"/>
+                <a:ea typeface="Times New Roman" pitchFamily="34" charset="-122"/>
+                <a:cs typeface="Times New Roman" pitchFamily="34" charset="-120"/>
               </a:rPr>
               <a:t>b</a:t>
             </a:r>
-            <a:r>
-              <a:rPr lang="en-US" sz="800" baseline="30000" dirty="0">
+            <a:pPr algn="ctr" indent="0" marL="0">
+              <a:lnSpc>
+                <a:spcPct val="100000"/>
+              </a:lnSpc>
+              <a:buNone/>
+            </a:pPr>
+            <a:r>
+              <a:rPr lang="en-US" sz="740" baseline="30000" dirty="0">
                 <a:solidFill>
                   <a:srgbClr val="1A1F2B"/>
                 </a:solidFill>
-                <a:latin typeface="Times New Roman Regular" panose="02020503050405090304" charset="0"/>
-                <a:ea typeface="Times New Roman" panose="02020503050405090304" pitchFamily="34" charset="-122"/>
-                <a:cs typeface="Times New Roman Regular" panose="02020503050405090304" charset="0"/>
+                <a:latin typeface="Times New Roman" pitchFamily="34" charset="0"/>
+                <a:ea typeface="Times New Roman" pitchFamily="34" charset="-122"/>
+                <a:cs typeface="Times New Roman" pitchFamily="34" charset="-120"/>
               </a:rPr>
               <a:t>−1</a:t>
             </a:r>
-            <a:r>
-              <a:rPr lang="en-US" sz="800" dirty="0">
+            <a:pPr algn="ctr" indent="0" marL="0">
+              <a:lnSpc>
+                <a:spcPct val="100000"/>
+              </a:lnSpc>
+              <a:buNone/>
+            </a:pPr>
+            <a:r>
+              <a:rPr lang="en-US" sz="740" dirty="0">
                 <a:solidFill>
                   <a:srgbClr val="1A1F2B"/>
                 </a:solidFill>
-                <a:latin typeface="Times New Roman Regular" panose="02020503050405090304" charset="0"/>
-                <a:ea typeface="Times New Roman" panose="02020503050405090304" pitchFamily="34" charset="-122"/>
-                <a:cs typeface="Times New Roman Regular" panose="02020503050405090304" charset="0"/>
+                <a:latin typeface="Times New Roman" pitchFamily="34" charset="0"/>
+                <a:ea typeface="Times New Roman" pitchFamily="34" charset="-122"/>
+                <a:cs typeface="Times New Roman" pitchFamily="34" charset="-120"/>
               </a:rPr>
               <a:t> Σ</a:t>
             </a:r>
-            <a:r>
-              <a:rPr lang="en-US" sz="800" baseline="-40000" dirty="0">
+            <a:pPr algn="ctr" indent="0" marL="0">
+              <a:lnSpc>
+                <a:spcPct val="100000"/>
+              </a:lnSpc>
+              <a:buNone/>
+            </a:pPr>
+            <a:r>
+              <a:rPr lang="en-US" sz="740" baseline="-40000" dirty="0">
                 <a:solidFill>
                   <a:srgbClr val="1A1F2B"/>
                 </a:solidFill>
-                <a:latin typeface="Times New Roman Regular" panose="02020503050405090304" charset="0"/>
-                <a:ea typeface="Times New Roman" panose="02020503050405090304" pitchFamily="34" charset="-122"/>
-                <a:cs typeface="Times New Roman Regular" panose="02020503050405090304" charset="0"/>
+                <a:latin typeface="Times New Roman" pitchFamily="34" charset="0"/>
+                <a:ea typeface="Times New Roman" pitchFamily="34" charset="-122"/>
+                <a:cs typeface="Times New Roman" pitchFamily="34" charset="-120"/>
               </a:rPr>
               <a:t>i∈B</a:t>
             </a:r>
-            <a:r>
-              <a:rPr lang="en-US" sz="800" dirty="0">
+            <a:pPr algn="ctr" indent="0" marL="0">
+              <a:lnSpc>
+                <a:spcPct val="100000"/>
+              </a:lnSpc>
+              <a:buNone/>
+            </a:pPr>
+            <a:r>
+              <a:rPr lang="en-US" sz="740" dirty="0">
                 <a:solidFill>
                   <a:srgbClr val="1A1F2B"/>
                 </a:solidFill>
-                <a:latin typeface="Times New Roman Regular" panose="02020503050405090304" charset="0"/>
-                <a:ea typeface="Times New Roman" panose="02020503050405090304" pitchFamily="34" charset="-122"/>
-                <a:cs typeface="Times New Roman Regular" panose="02020503050405090304" charset="0"/>
+                <a:latin typeface="Times New Roman" pitchFamily="34" charset="0"/>
+                <a:ea typeface="Times New Roman" pitchFamily="34" charset="-122"/>
+                <a:cs typeface="Times New Roman" pitchFamily="34" charset="-120"/>
               </a:rPr>
               <a:t> clip(</a:t>
             </a:r>
-            <a:r>
-              <a:rPr lang="en-US" sz="800" i="1" dirty="0">
+            <a:pPr algn="ctr" indent="0" marL="0">
+              <a:lnSpc>
+                <a:spcPct val="100000"/>
+              </a:lnSpc>
+              <a:buNone/>
+            </a:pPr>
+            <a:r>
+              <a:rPr lang="en-US" sz="740" i="1" dirty="0">
                 <a:solidFill>
                   <a:srgbClr val="1A1F2B"/>
                 </a:solidFill>
-                <a:latin typeface="Times New Roman Regular" panose="02020503050405090304" charset="0"/>
-                <a:ea typeface="Times New Roman" panose="02020503050405090304" pitchFamily="34" charset="-122"/>
-                <a:cs typeface="Times New Roman Regular" panose="02020503050405090304" charset="0"/>
+                <a:latin typeface="Times New Roman" pitchFamily="34" charset="0"/>
+                <a:ea typeface="Times New Roman" pitchFamily="34" charset="-122"/>
+                <a:cs typeface="Times New Roman" pitchFamily="34" charset="-120"/>
               </a:rPr>
               <a:t>u</a:t>
             </a:r>
-            <a:r>
-              <a:rPr lang="en-US" sz="800" baseline="-40000" dirty="0">
+            <a:pPr algn="ctr" indent="0" marL="0">
+              <a:lnSpc>
+                <a:spcPct val="100000"/>
+              </a:lnSpc>
+              <a:buNone/>
+            </a:pPr>
+            <a:r>
+              <a:rPr lang="en-US" sz="740" baseline="-40000" dirty="0">
                 <a:solidFill>
                   <a:srgbClr val="1A1F2B"/>
                 </a:solidFill>
-                <a:latin typeface="Times New Roman Regular" panose="02020503050405090304" charset="0"/>
-                <a:ea typeface="Times New Roman" panose="02020503050405090304" pitchFamily="34" charset="-122"/>
-                <a:cs typeface="Times New Roman Regular" panose="02020503050405090304" charset="0"/>
+                <a:latin typeface="Times New Roman" pitchFamily="34" charset="0"/>
+                <a:ea typeface="Times New Roman" pitchFamily="34" charset="-122"/>
+                <a:cs typeface="Times New Roman" pitchFamily="34" charset="-120"/>
               </a:rPr>
               <a:t>i</a:t>
             </a:r>
-            <a:r>
-              <a:rPr lang="en-US" sz="800" dirty="0">
+            <a:pPr algn="ctr" indent="0" marL="0">
+              <a:lnSpc>
+                <a:spcPct val="100000"/>
+              </a:lnSpc>
+              <a:buNone/>
+            </a:pPr>
+            <a:r>
+              <a:rPr lang="en-US" sz="740" dirty="0">
                 <a:solidFill>
                   <a:srgbClr val="1A1F2B"/>
                 </a:solidFill>
-                <a:latin typeface="Times New Roman Regular" panose="02020503050405090304" charset="0"/>
-                <a:ea typeface="Times New Roman" panose="02020503050405090304" pitchFamily="34" charset="-122"/>
-                <a:cs typeface="Times New Roman Regular" panose="02020503050405090304" charset="0"/>
+                <a:latin typeface="Times New Roman" pitchFamily="34" charset="0"/>
+                <a:ea typeface="Times New Roman" pitchFamily="34" charset="-122"/>
+                <a:cs typeface="Times New Roman" pitchFamily="34" charset="-120"/>
               </a:rPr>
               <a:t>)</a:t>
             </a:r>
-            <a:endParaRPr lang="en-US" sz="800" dirty="0">
-              <a:latin typeface="Times New Roman Regular" panose="02020503050405090304" charset="0"/>
-              <a:cs typeface="Times New Roman Regular" panose="02020503050405090304" charset="0"/>
-            </a:endParaRPr>
+            <a:endParaRPr lang="en-US" sz="740" dirty="0"/>
           </a:p>
         </p:txBody>
       </p:sp>
@@ -2263,153 +2398,207 @@
         </p:nvSpPr>
         <p:spPr>
           <a:xfrm>
-            <a:off x="2133600" y="1454658"/>
+            <a:off x="2133600" y="1412748"/>
             <a:ext cx="1493520" cy="118872"/>
           </a:xfrm>
           <a:prstGeom prst="rect">
             <a:avLst/>
           </a:prstGeom>
           <a:noFill/>
+          <a:ln/>
         </p:spPr>
         <p:txBody>
           <a:bodyPr wrap="square" lIns="0" tIns="0" rIns="0" bIns="0" rtlCol="0" anchor="t"/>
           <a:lstStyle/>
           <a:p>
-            <a:pPr marL="0" indent="0" algn="ctr">
-              <a:lnSpc>
-                <a:spcPct val="100000"/>
-              </a:lnSpc>
-              <a:buNone/>
-            </a:pPr>
-            <a:r>
-              <a:rPr lang="en-US" sz="800" dirty="0">
+            <a:pPr algn="ctr" indent="0" marL="0">
+              <a:lnSpc>
+                <a:spcPct val="100000"/>
+              </a:lnSpc>
+              <a:buNone/>
+            </a:pPr>
+            <a:r>
+              <a:rPr lang="en-US" sz="740" dirty="0">
                 <a:solidFill>
                   <a:srgbClr val="1A1F2B"/>
                 </a:solidFill>
-                <a:latin typeface="Times New Roman Regular" panose="02020503050405090304" charset="0"/>
-                <a:ea typeface="Times New Roman" panose="02020503050405090304" pitchFamily="34" charset="-122"/>
-                <a:cs typeface="Times New Roman Regular" panose="02020503050405090304" charset="0"/>
+                <a:latin typeface="Times New Roman" pitchFamily="34" charset="0"/>
+                <a:ea typeface="Times New Roman" pitchFamily="34" charset="-122"/>
+                <a:cs typeface="Times New Roman" pitchFamily="34" charset="-120"/>
               </a:rPr>
               <a:t>release  </a:t>
             </a:r>
-            <a:r>
-              <a:rPr lang="en-US" sz="800" i="1" dirty="0">
+            <a:pPr algn="ctr" indent="0" marL="0">
+              <a:lnSpc>
+                <a:spcPct val="100000"/>
+              </a:lnSpc>
+              <a:buNone/>
+            </a:pPr>
+            <a:r>
+              <a:rPr lang="en-US" sz="740" i="1" dirty="0">
                 <a:solidFill>
                   <a:srgbClr val="1A1F2B"/>
                 </a:solidFill>
-                <a:latin typeface="Times New Roman Regular" panose="02020503050405090304" charset="0"/>
-                <a:ea typeface="Times New Roman" panose="02020503050405090304" pitchFamily="34" charset="-122"/>
-                <a:cs typeface="Times New Roman Regular" panose="02020503050405090304" charset="0"/>
+                <a:latin typeface="Times New Roman" pitchFamily="34" charset="0"/>
+                <a:ea typeface="Times New Roman" pitchFamily="34" charset="-122"/>
+                <a:cs typeface="Times New Roman" pitchFamily="34" charset="-120"/>
               </a:rPr>
               <a:t>s</a:t>
             </a:r>
-            <a:r>
-              <a:rPr lang="en-US" sz="800" baseline="-40000" dirty="0">
+            <a:pPr algn="ctr" indent="0" marL="0">
+              <a:lnSpc>
+                <a:spcPct val="100000"/>
+              </a:lnSpc>
+              <a:buNone/>
+            </a:pPr>
+            <a:r>
+              <a:rPr lang="en-US" sz="740" baseline="-40000" dirty="0">
                 <a:solidFill>
                   <a:srgbClr val="1A1F2B"/>
                 </a:solidFill>
-                <a:latin typeface="Times New Roman Regular" panose="02020503050405090304" charset="0"/>
-                <a:ea typeface="Times New Roman" panose="02020503050405090304" pitchFamily="34" charset="-122"/>
-                <a:cs typeface="Times New Roman Regular" panose="02020503050405090304" charset="0"/>
+                <a:latin typeface="Times New Roman" pitchFamily="34" charset="0"/>
+                <a:ea typeface="Times New Roman" pitchFamily="34" charset="-122"/>
+                <a:cs typeface="Times New Roman" pitchFamily="34" charset="-120"/>
               </a:rPr>
               <a:t>p</a:t>
             </a:r>
-            <a:r>
-              <a:rPr lang="en-US" sz="800" dirty="0">
+            <a:pPr algn="ctr" indent="0" marL="0">
+              <a:lnSpc>
+                <a:spcPct val="100000"/>
+              </a:lnSpc>
+              <a:buNone/>
+            </a:pPr>
+            <a:r>
+              <a:rPr lang="en-US" sz="740" dirty="0">
                 <a:solidFill>
                   <a:srgbClr val="1A1F2B"/>
                 </a:solidFill>
-                <a:latin typeface="Times New Roman Regular" panose="02020503050405090304" charset="0"/>
-                <a:ea typeface="Times New Roman" panose="02020503050405090304" pitchFamily="34" charset="-122"/>
-                <a:cs typeface="Times New Roman Regular" panose="02020503050405090304" charset="0"/>
+                <a:latin typeface="Times New Roman" pitchFamily="34" charset="0"/>
+                <a:ea typeface="Times New Roman" pitchFamily="34" charset="-122"/>
+                <a:cs typeface="Times New Roman" pitchFamily="34" charset="-120"/>
               </a:rPr>
               <a:t> + </a:t>
             </a:r>
-            <a:r>
-              <a:rPr lang="en-US" sz="800" dirty="0">
+            <a:pPr algn="ctr" indent="0" marL="0">
+              <a:lnSpc>
+                <a:spcPct val="100000"/>
+              </a:lnSpc>
+              <a:buNone/>
+            </a:pPr>
+            <a:r>
+              <a:rPr lang="en-US" sz="740" dirty="0">
                 <a:solidFill>
                   <a:srgbClr val="1A1F2B"/>
                 </a:solidFill>
-                <a:latin typeface="Times New Roman Regular" panose="02020503050405090304" charset="0"/>
+                <a:latin typeface="Cambria Math" pitchFamily="34" charset="0"/>
                 <a:ea typeface="Cambria Math" pitchFamily="34" charset="-122"/>
-                <a:cs typeface="Times New Roman Regular" panose="02020503050405090304" charset="0"/>
+                <a:cs typeface="Cambria Math" pitchFamily="34" charset="-120"/>
               </a:rPr>
               <a:t>𝒩</a:t>
             </a:r>
-            <a:r>
-              <a:rPr lang="en-US" sz="800" dirty="0">
+            <a:pPr algn="ctr" indent="0" marL="0">
+              <a:lnSpc>
+                <a:spcPct val="100000"/>
+              </a:lnSpc>
+              <a:buNone/>
+            </a:pPr>
+            <a:r>
+              <a:rPr lang="en-US" sz="740" dirty="0">
                 <a:solidFill>
                   <a:srgbClr val="1A1F2B"/>
                 </a:solidFill>
-                <a:latin typeface="Times New Roman Regular" panose="02020503050405090304" charset="0"/>
-                <a:ea typeface="Times New Roman" panose="02020503050405090304" pitchFamily="34" charset="-122"/>
-                <a:cs typeface="Times New Roman Regular" panose="02020503050405090304" charset="0"/>
+                <a:latin typeface="Times New Roman" pitchFamily="34" charset="0"/>
+                <a:ea typeface="Times New Roman" pitchFamily="34" charset="-122"/>
+                <a:cs typeface="Times New Roman" pitchFamily="34" charset="-120"/>
               </a:rPr>
               <a:t>(0, (</a:t>
             </a:r>
-            <a:r>
-              <a:rPr lang="en-US" sz="800" i="1" dirty="0">
+            <a:pPr algn="ctr" indent="0" marL="0">
+              <a:lnSpc>
+                <a:spcPct val="100000"/>
+              </a:lnSpc>
+              <a:buNone/>
+            </a:pPr>
+            <a:r>
+              <a:rPr lang="en-US" sz="740" i="1" dirty="0">
                 <a:solidFill>
                   <a:srgbClr val="1A1F2B"/>
                 </a:solidFill>
-                <a:latin typeface="Times New Roman Regular" panose="02020503050405090304" charset="0"/>
-                <a:ea typeface="Times New Roman" panose="02020503050405090304" pitchFamily="34" charset="-122"/>
-                <a:cs typeface="Times New Roman Regular" panose="02020503050405090304" charset="0"/>
-              </a:rPr>
-              <a:t>z C</a:t>
-            </a:r>
-            <a:r>
-              <a:rPr lang="en-US" sz="800" baseline="-40000" dirty="0">
+                <a:latin typeface="Times New Roman" pitchFamily="34" charset="0"/>
+                <a:ea typeface="Times New Roman" pitchFamily="34" charset="-122"/>
+                <a:cs typeface="Times New Roman" pitchFamily="34" charset="-120"/>
+              </a:rPr>
+              <a:t>zC</a:t>
+            </a:r>
+            <a:pPr algn="ctr" indent="0" marL="0">
+              <a:lnSpc>
+                <a:spcPct val="100000"/>
+              </a:lnSpc>
+              <a:buNone/>
+            </a:pPr>
+            <a:r>
+              <a:rPr lang="en-US" sz="740" baseline="-40000" dirty="0">
                 <a:solidFill>
                   <a:srgbClr val="1A1F2B"/>
                 </a:solidFill>
-                <a:latin typeface="Times New Roman Regular" panose="02020503050405090304" charset="0"/>
-                <a:ea typeface="Times New Roman" panose="02020503050405090304" pitchFamily="34" charset="-122"/>
-                <a:cs typeface="Times New Roman Regular" panose="02020503050405090304" charset="0"/>
+                <a:latin typeface="Times New Roman" pitchFamily="34" charset="0"/>
+                <a:ea typeface="Times New Roman" pitchFamily="34" charset="-122"/>
+                <a:cs typeface="Times New Roman" pitchFamily="34" charset="-120"/>
               </a:rPr>
               <a:t>clip</a:t>
             </a:r>
-            <a:r>
-              <a:rPr lang="en-US" sz="800" dirty="0">
+            <a:pPr algn="ctr" indent="0" marL="0">
+              <a:lnSpc>
+                <a:spcPct val="100000"/>
+              </a:lnSpc>
+              <a:buNone/>
+            </a:pPr>
+            <a:r>
+              <a:rPr lang="en-US" sz="740" dirty="0">
                 <a:solidFill>
                   <a:srgbClr val="1A1F2B"/>
                 </a:solidFill>
-                <a:latin typeface="Times New Roman Regular" panose="02020503050405090304" charset="0"/>
-                <a:ea typeface="Times New Roman" panose="02020503050405090304" pitchFamily="34" charset="-122"/>
-                <a:cs typeface="Times New Roman Regular" panose="02020503050405090304" charset="0"/>
+                <a:latin typeface="Times New Roman" pitchFamily="34" charset="0"/>
+                <a:ea typeface="Times New Roman" pitchFamily="34" charset="-122"/>
+                <a:cs typeface="Times New Roman" pitchFamily="34" charset="-120"/>
               </a:rPr>
               <a:t>/</a:t>
             </a:r>
-            <a:r>
-              <a:rPr lang="en-US" sz="800" i="1" dirty="0">
+            <a:pPr algn="ctr" indent="0" marL="0">
+              <a:lnSpc>
+                <a:spcPct val="100000"/>
+              </a:lnSpc>
+              <a:buNone/>
+            </a:pPr>
+            <a:r>
+              <a:rPr lang="en-US" sz="740" i="1" dirty="0">
                 <a:solidFill>
                   <a:srgbClr val="1A1F2B"/>
                 </a:solidFill>
-                <a:latin typeface="Times New Roman Regular" panose="02020503050405090304" charset="0"/>
-                <a:ea typeface="Times New Roman" panose="02020503050405090304" pitchFamily="34" charset="-122"/>
-                <a:cs typeface="Times New Roman Regular" panose="02020503050405090304" charset="0"/>
+                <a:latin typeface="Times New Roman" pitchFamily="34" charset="0"/>
+                <a:ea typeface="Times New Roman" pitchFamily="34" charset="-122"/>
+                <a:cs typeface="Times New Roman" pitchFamily="34" charset="-120"/>
               </a:rPr>
               <a:t>b</a:t>
             </a:r>
-            <a:r>
-              <a:rPr lang="en-US" sz="800" dirty="0">
+            <a:pPr algn="ctr" indent="0" marL="0">
+              <a:lnSpc>
+                <a:spcPct val="100000"/>
+              </a:lnSpc>
+              <a:buNone/>
+            </a:pPr>
+            <a:r>
+              <a:rPr lang="en-US" sz="740" dirty="0">
                 <a:solidFill>
                   <a:srgbClr val="1A1F2B"/>
                 </a:solidFill>
-                <a:latin typeface="Times New Roman Regular" panose="02020503050405090304" charset="0"/>
-                <a:ea typeface="Times New Roman" panose="02020503050405090304" pitchFamily="34" charset="-122"/>
-                <a:cs typeface="Times New Roman Regular" panose="02020503050405090304" charset="0"/>
+                <a:latin typeface="Times New Roman" pitchFamily="34" charset="0"/>
+                <a:ea typeface="Times New Roman" pitchFamily="34" charset="-122"/>
+                <a:cs typeface="Times New Roman" pitchFamily="34" charset="-120"/>
               </a:rPr>
               <a:t>)²)</a:t>
             </a:r>
-            <a:endParaRPr lang="en-US" sz="800" dirty="0">
-              <a:solidFill>
-                <a:srgbClr val="1A1F2B"/>
-              </a:solidFill>
-              <a:latin typeface="Times New Roman Regular" panose="02020503050405090304" charset="0"/>
-              <a:ea typeface="Times New Roman" panose="02020503050405090304" pitchFamily="34" charset="-122"/>
-              <a:cs typeface="Times New Roman Regular" panose="02020503050405090304" charset="0"/>
-            </a:endParaRPr>
+            <a:endParaRPr lang="en-US" sz="740" dirty="0"/>
           </a:p>
         </p:txBody>
       </p:sp>
@@ -2421,65 +2610,71 @@
         </p:nvSpPr>
         <p:spPr>
           <a:xfrm>
-            <a:off x="2252345" y="1609344"/>
-            <a:ext cx="1367790" cy="301752"/>
+            <a:off x="2161032" y="1554480"/>
+            <a:ext cx="1438656" cy="329184"/>
           </a:xfrm>
           <a:prstGeom prst="rect">
             <a:avLst/>
           </a:prstGeom>
           <a:noFill/>
+          <a:ln/>
         </p:spPr>
         <p:txBody>
           <a:bodyPr wrap="square" lIns="0" tIns="0" rIns="0" bIns="0" rtlCol="0" anchor="t"/>
           <a:lstStyle/>
           <a:p>
-            <a:pPr marL="0" indent="0" algn="l">
+            <a:pPr algn="l" indent="0" marL="0">
               <a:lnSpc>
                 <a:spcPct val="96000"/>
               </a:lnSpc>
               <a:buNone/>
             </a:pPr>
             <a:r>
-              <a:rPr lang="en-US" sz="700" dirty="0">
+              <a:rPr lang="en-US" sz="660" dirty="0">
                 <a:solidFill>
                   <a:srgbClr val="333B48"/>
                 </a:solidFill>
-                <a:latin typeface="Times New Roman Regular" panose="02020503050405090304" charset="0"/>
-                <a:ea typeface="Arial" panose="020B0604020202090204" pitchFamily="34" charset="-122"/>
-                <a:cs typeface="Times New Roman Regular" panose="02020503050405090304" charset="0"/>
+                <a:latin typeface="Arial" pitchFamily="34" charset="0"/>
+                <a:ea typeface="Arial" pitchFamily="34" charset="-122"/>
+                <a:cs typeface="Arial" pitchFamily="34" charset="-120"/>
               </a:rPr>
               <a:t>Each candidate releases one clipped, sampled-Gaussian score from </a:t>
             </a:r>
-            <a:r>
-              <a:rPr lang="en-US" sz="700" dirty="0">
+            <a:pPr algn="l" indent="0" marL="0">
+              <a:lnSpc>
+                <a:spcPct val="96000"/>
+              </a:lnSpc>
+              <a:buNone/>
+            </a:pPr>
+            <a:r>
+              <a:rPr lang="en-US" sz="660" dirty="0">
                 <a:solidFill>
                   <a:srgbClr val="333B48"/>
                 </a:solidFill>
-                <a:latin typeface="Times New Roman Regular" panose="02020503050405090304" charset="0"/>
+                <a:latin typeface="Cambria Math" pitchFamily="34" charset="0"/>
                 <a:ea typeface="Cambria Math" pitchFamily="34" charset="-122"/>
-                <a:cs typeface="Times New Roman Regular" panose="02020503050405090304" charset="0"/>
+                <a:cs typeface="Cambria Math" pitchFamily="34" charset="-120"/>
               </a:rPr>
               <a:t>𝒟</a:t>
             </a:r>
-            <a:r>
-              <a:rPr lang="en-US" sz="700" dirty="0">
+            <a:pPr algn="l" indent="0" marL="0">
+              <a:lnSpc>
+                <a:spcPct val="96000"/>
+              </a:lnSpc>
+              <a:buNone/>
+            </a:pPr>
+            <a:r>
+              <a:rPr lang="en-US" sz="660" dirty="0">
                 <a:solidFill>
                   <a:srgbClr val="333B48"/>
                 </a:solidFill>
-                <a:latin typeface="Times New Roman Regular" panose="02020503050405090304" charset="0"/>
-                <a:ea typeface="Arial" panose="020B0604020202090204" pitchFamily="34" charset="-122"/>
-                <a:cs typeface="Times New Roman Regular" panose="02020503050405090304" charset="0"/>
+                <a:latin typeface="Arial" pitchFamily="34" charset="0"/>
+                <a:ea typeface="Arial" pitchFamily="34" charset="-122"/>
+                <a:cs typeface="Arial" pitchFamily="34" charset="-120"/>
               </a:rPr>
               <a:t>.</a:t>
             </a:r>
-            <a:endParaRPr lang="en-US" sz="700" dirty="0">
-              <a:solidFill>
-                <a:srgbClr val="333B48"/>
-              </a:solidFill>
-              <a:latin typeface="Times New Roman Regular" panose="02020503050405090304" charset="0"/>
-              <a:ea typeface="Arial" panose="020B0604020202090204" pitchFamily="34" charset="-122"/>
-              <a:cs typeface="Times New Roman Regular" panose="02020503050405090304" charset="0"/>
-            </a:endParaRPr>
+            <a:endParaRPr lang="en-US" sz="660" dirty="0"/>
           </a:p>
         </p:txBody>
       </p:sp>
@@ -2502,6 +2697,7 @@
           <a:solidFill>
             <a:srgbClr val="1F3D7A"/>
           </a:solidFill>
+          <a:ln/>
         </p:spPr>
       </p:sp>
       <p:sp>
@@ -2519,12 +2715,13 @@
             <a:avLst/>
           </a:prstGeom>
           <a:noFill/>
+          <a:ln/>
         </p:spPr>
         <p:txBody>
           <a:bodyPr wrap="square" lIns="0" tIns="0" rIns="0" bIns="0" rtlCol="0" anchor="t"/>
           <a:lstStyle/>
           <a:p>
-            <a:pPr marL="0" indent="0" algn="ctr">
+            <a:pPr algn="ctr" indent="0" marL="0">
               <a:lnSpc>
                 <a:spcPct val="100000"/>
               </a:lnSpc>
@@ -2535,31 +2732,43 @@
                 <a:solidFill>
                   <a:srgbClr val="FFFFFF"/>
                 </a:solidFill>
-                <a:latin typeface="Arial" panose="020B0604020202090204" pitchFamily="34" charset="0"/>
-                <a:ea typeface="Arial" panose="020B0604020202090204" pitchFamily="34" charset="-122"/>
-                <a:cs typeface="Arial" panose="020B0604020202090204" pitchFamily="34" charset="-120"/>
+                <a:latin typeface="Arial" pitchFamily="34" charset="0"/>
+                <a:ea typeface="Arial" pitchFamily="34" charset="-122"/>
+                <a:cs typeface="Arial" pitchFamily="34" charset="-120"/>
               </a:rPr>
               <a:t>≤ </a:t>
             </a:r>
+            <a:pPr algn="ctr" indent="0" marL="0">
+              <a:lnSpc>
+                <a:spcPct val="100000"/>
+              </a:lnSpc>
+              <a:buNone/>
+            </a:pPr>
             <a:r>
               <a:rPr lang="en-US" sz="640" b="1" i="1" dirty="0">
                 <a:solidFill>
                   <a:srgbClr val="FFFFFF"/>
                 </a:solidFill>
-                <a:latin typeface="Arial" panose="020B0604020202090204" pitchFamily="34" charset="0"/>
-                <a:ea typeface="Arial" panose="020B0604020202090204" pitchFamily="34" charset="-122"/>
-                <a:cs typeface="Arial" panose="020B0604020202090204" pitchFamily="34" charset="-120"/>
+                <a:latin typeface="Arial" pitchFamily="34" charset="0"/>
+                <a:ea typeface="Arial" pitchFamily="34" charset="-122"/>
+                <a:cs typeface="Arial" pitchFamily="34" charset="-120"/>
               </a:rPr>
               <a:t>TK</a:t>
             </a:r>
+            <a:pPr algn="ctr" indent="0" marL="0">
+              <a:lnSpc>
+                <a:spcPct val="100000"/>
+              </a:lnSpc>
+              <a:buNone/>
+            </a:pPr>
             <a:r>
               <a:rPr lang="en-US" sz="640" b="1" dirty="0">
                 <a:solidFill>
                   <a:srgbClr val="FFFFFF"/>
                 </a:solidFill>
-                <a:latin typeface="Arial" panose="020B0604020202090204" pitchFamily="34" charset="0"/>
-                <a:ea typeface="Arial" panose="020B0604020202090204" pitchFamily="34" charset="-122"/>
-                <a:cs typeface="Arial" panose="020B0604020202090204" pitchFamily="34" charset="-120"/>
+                <a:latin typeface="Arial" pitchFamily="34" charset="0"/>
+                <a:ea typeface="Arial" pitchFamily="34" charset="-122"/>
+                <a:cs typeface="Arial" pitchFamily="34" charset="-120"/>
               </a:rPr>
               <a:t> score releases total</a:t>
             </a:r>
@@ -2611,6 +2820,7 @@
           <a:solidFill>
             <a:srgbClr val="2E7D32"/>
           </a:solidFill>
+          <a:ln/>
         </p:spPr>
       </p:sp>
       <p:sp>
@@ -2657,6 +2867,7 @@
           <a:solidFill>
             <a:srgbClr val="FFFFFF"/>
           </a:solidFill>
+          <a:ln/>
         </p:spPr>
       </p:sp>
       <p:sp>
@@ -2674,12 +2885,13 @@
             <a:avLst/>
           </a:prstGeom>
           <a:noFill/>
+          <a:ln/>
         </p:spPr>
         <p:txBody>
           <a:bodyPr wrap="square" lIns="0" tIns="0" rIns="0" bIns="0" rtlCol="0" anchor="ctr"/>
           <a:lstStyle/>
           <a:p>
-            <a:pPr marL="0" indent="0" algn="ctr">
+            <a:pPr algn="ctr" indent="0" marL="0">
               <a:lnSpc>
                 <a:spcPct val="104000"/>
               </a:lnSpc>
@@ -2690,16 +2902,16 @@
                 <a:solidFill>
                   <a:srgbClr val="2E7D32"/>
                 </a:solidFill>
-                <a:latin typeface="Arial" panose="020B0604020202090204" pitchFamily="34" charset="0"/>
-                <a:ea typeface="Arial" panose="020B0604020202090204" pitchFamily="34" charset="-122"/>
-                <a:cs typeface="Arial" panose="020B0604020202090204" pitchFamily="34" charset="-120"/>
+                <a:latin typeface="Arial" pitchFamily="34" charset="0"/>
+                <a:ea typeface="Arial" pitchFamily="34" charset="-122"/>
+                <a:cs typeface="Arial" pitchFamily="34" charset="-120"/>
               </a:rPr>
               <a:t>Phase 3</a:t>
             </a:r>
             <a:endParaRPr lang="en-US" sz="780" dirty="0"/>
           </a:p>
           <a:p>
-            <a:pPr marL="0" indent="0" algn="ctr">
+            <a:pPr algn="ctr" indent="0" marL="0">
               <a:lnSpc>
                 <a:spcPct val="104000"/>
               </a:lnSpc>
@@ -2710,9 +2922,9 @@
                 <a:solidFill>
                   <a:srgbClr val="2E7D32"/>
                 </a:solidFill>
-                <a:latin typeface="Arial" panose="020B0604020202090204" pitchFamily="34" charset="0"/>
-                <a:ea typeface="Arial" panose="020B0604020202090204" pitchFamily="34" charset="-122"/>
-                <a:cs typeface="Arial" panose="020B0604020202090204" pitchFamily="34" charset="-120"/>
+                <a:latin typeface="Arial" pitchFamily="34" charset="0"/>
+                <a:ea typeface="Arial" pitchFamily="34" charset="-122"/>
+                <a:cs typeface="Arial" pitchFamily="34" charset="-120"/>
               </a:rPr>
               <a:t>Post-process &amp; select</a:t>
             </a:r>
@@ -2728,43 +2940,37 @@
         </p:nvSpPr>
         <p:spPr>
           <a:xfrm>
-            <a:off x="3950208" y="1261872"/>
-            <a:ext cx="1618488" cy="118872"/>
+            <a:off x="4011168" y="1293876"/>
+            <a:ext cx="1493520" cy="118872"/>
           </a:xfrm>
           <a:prstGeom prst="rect">
             <a:avLst/>
           </a:prstGeom>
           <a:noFill/>
+          <a:ln/>
         </p:spPr>
         <p:txBody>
           <a:bodyPr wrap="square" lIns="0" tIns="0" rIns="0" bIns="0" rtlCol="0" anchor="t"/>
           <a:lstStyle/>
           <a:p>
-            <a:pPr marL="0" indent="0" algn="ctr">
-              <a:lnSpc>
-                <a:spcPct val="100000"/>
-              </a:lnSpc>
-              <a:buNone/>
-            </a:pPr>
-            <a:r>
-              <a:rPr lang="en-US" sz="800" dirty="0">
+            <a:pPr algn="ctr" indent="0" marL="0">
+              <a:lnSpc>
+                <a:spcPct val="100000"/>
+              </a:lnSpc>
+              <a:buNone/>
+            </a:pPr>
+            <a:r>
+              <a:rPr lang="en-US" sz="720" dirty="0">
                 <a:solidFill>
                   <a:srgbClr val="1A1F2B"/>
                 </a:solidFill>
-                <a:latin typeface="Times New Roman Regular" panose="02020503050405090304" charset="0"/>
-                <a:ea typeface="Times New Roman" panose="02020503050405090304" pitchFamily="34" charset="-122"/>
-                <a:cs typeface="Times New Roman Regular" panose="02020503050405090304" charset="0"/>
+                <a:latin typeface="Times New Roman" pitchFamily="34" charset="0"/>
+                <a:ea typeface="Times New Roman" pitchFamily="34" charset="-122"/>
+                <a:cs typeface="Times New Roman" pitchFamily="34" charset="-120"/>
               </a:rPr>
               <a:t>Gumbel-smoothed or deterministic</a:t>
             </a:r>
-            <a:endParaRPr lang="en-US" sz="800" dirty="0">
-              <a:solidFill>
-                <a:srgbClr val="1A1F2B"/>
-              </a:solidFill>
-              <a:latin typeface="Times New Roman Regular" panose="02020503050405090304" charset="0"/>
-              <a:ea typeface="Times New Roman" panose="02020503050405090304" pitchFamily="34" charset="-122"/>
-              <a:cs typeface="Times New Roman Regular" panose="02020503050405090304" charset="0"/>
-            </a:endParaRPr>
+            <a:endParaRPr lang="en-US" sz="720" dirty="0"/>
           </a:p>
         </p:txBody>
       </p:sp>
@@ -2776,43 +2982,37 @@
         </p:nvSpPr>
         <p:spPr>
           <a:xfrm>
-            <a:off x="3950208" y="1472184"/>
-            <a:ext cx="1618488" cy="118872"/>
+            <a:off x="4011168" y="1412748"/>
+            <a:ext cx="1493520" cy="118872"/>
           </a:xfrm>
           <a:prstGeom prst="rect">
             <a:avLst/>
           </a:prstGeom>
           <a:noFill/>
+          <a:ln/>
         </p:spPr>
         <p:txBody>
           <a:bodyPr wrap="square" lIns="0" tIns="0" rIns="0" bIns="0" rtlCol="0" anchor="t"/>
           <a:lstStyle/>
           <a:p>
-            <a:pPr marL="0" indent="0" algn="ctr">
-              <a:lnSpc>
-                <a:spcPct val="100000"/>
-              </a:lnSpc>
-              <a:buNone/>
-            </a:pPr>
-            <a:r>
-              <a:rPr lang="en-US" sz="800" dirty="0">
+            <a:pPr algn="ctr" indent="0" marL="0">
+              <a:lnSpc>
+                <a:spcPct val="100000"/>
+              </a:lnSpc>
+              <a:buNone/>
+            </a:pPr>
+            <a:r>
+              <a:rPr lang="en-US" sz="720" dirty="0">
                 <a:solidFill>
                   <a:srgbClr val="1A1F2B"/>
                 </a:solidFill>
-                <a:latin typeface="Times New Roman Regular" panose="02020503050405090304" charset="0"/>
-                <a:ea typeface="Times New Roman" panose="02020503050405090304" pitchFamily="34" charset="-122"/>
-                <a:cs typeface="Times New Roman Regular" panose="02020503050405090304" charset="0"/>
+                <a:latin typeface="Times New Roman" pitchFamily="34" charset="0"/>
+                <a:ea typeface="Times New Roman" pitchFamily="34" charset="-122"/>
+                <a:cs typeface="Times New Roman" pitchFamily="34" charset="-120"/>
               </a:rPr>
               <a:t>Top-M(privatized scores)</a:t>
             </a:r>
-            <a:endParaRPr lang="en-US" sz="800" dirty="0">
-              <a:solidFill>
-                <a:srgbClr val="1A1F2B"/>
-              </a:solidFill>
-              <a:latin typeface="Times New Roman Regular" panose="02020503050405090304" charset="0"/>
-              <a:ea typeface="Times New Roman" panose="02020503050405090304" pitchFamily="34" charset="-122"/>
-              <a:cs typeface="Times New Roman Regular" panose="02020503050405090304" charset="0"/>
-            </a:endParaRPr>
+            <a:endParaRPr lang="en-US" sz="720" dirty="0"/>
           </a:p>
         </p:txBody>
       </p:sp>
@@ -2824,43 +3024,37 @@
         </p:nvSpPr>
         <p:spPr>
           <a:xfrm>
-            <a:off x="4109720" y="1659890"/>
+            <a:off x="4038600" y="1554480"/>
             <a:ext cx="1438656" cy="329184"/>
           </a:xfrm>
           <a:prstGeom prst="rect">
             <a:avLst/>
           </a:prstGeom>
           <a:noFill/>
+          <a:ln/>
         </p:spPr>
         <p:txBody>
           <a:bodyPr wrap="square" lIns="0" tIns="0" rIns="0" bIns="0" rtlCol="0" anchor="t"/>
           <a:lstStyle/>
           <a:p>
-            <a:pPr marL="0" indent="0" algn="l">
+            <a:pPr algn="l" indent="0" marL="0">
               <a:lnSpc>
                 <a:spcPct val="96000"/>
               </a:lnSpc>
               <a:buNone/>
             </a:pPr>
             <a:r>
-              <a:rPr lang="en-US" sz="700" dirty="0">
+              <a:rPr lang="en-US" sz="660" dirty="0">
                 <a:solidFill>
                   <a:srgbClr val="333B48"/>
                 </a:solidFill>
-                <a:latin typeface="Times New Roman Regular" panose="02020503050405090304" charset="0"/>
-                <a:ea typeface="Arial" panose="020B0604020202090204" pitchFamily="34" charset="-122"/>
-                <a:cs typeface="Times New Roman Regular" panose="02020503050405090304" charset="0"/>
+                <a:latin typeface="Arial" pitchFamily="34" charset="0"/>
+                <a:ea typeface="Arial" pitchFamily="34" charset="-122"/>
+                <a:cs typeface="Arial" pitchFamily="34" charset="-120"/>
               </a:rPr>
               <a:t>Top-M uses only released scores; both options are post-processing.</a:t>
             </a:r>
-            <a:endParaRPr lang="en-US" sz="700" dirty="0">
-              <a:solidFill>
-                <a:srgbClr val="333B48"/>
-              </a:solidFill>
-              <a:latin typeface="Times New Roman Regular" panose="02020503050405090304" charset="0"/>
-              <a:ea typeface="Arial" panose="020B0604020202090204" pitchFamily="34" charset="-122"/>
-              <a:cs typeface="Times New Roman Regular" panose="02020503050405090304" charset="0"/>
-            </a:endParaRPr>
+            <a:endParaRPr lang="en-US" sz="660" dirty="0"/>
           </a:p>
         </p:txBody>
       </p:sp>
@@ -2883,6 +3077,7 @@
           <a:solidFill>
             <a:srgbClr val="2E7D32"/>
           </a:solidFill>
+          <a:ln/>
         </p:spPr>
       </p:sp>
       <p:sp>
@@ -2900,12 +3095,13 @@
             <a:avLst/>
           </a:prstGeom>
           <a:noFill/>
+          <a:ln/>
         </p:spPr>
         <p:txBody>
           <a:bodyPr wrap="square" lIns="0" tIns="0" rIns="0" bIns="0" rtlCol="0" anchor="t"/>
           <a:lstStyle/>
           <a:p>
-            <a:pPr marL="0" indent="0" algn="ctr">
+            <a:pPr algn="ctr" indent="0" marL="0">
               <a:lnSpc>
                 <a:spcPct val="100000"/>
               </a:lnSpc>
@@ -2916,9 +3112,9 @@
                 <a:solidFill>
                   <a:srgbClr val="FFFFFF"/>
                 </a:solidFill>
-                <a:latin typeface="Arial" panose="020B0604020202090204" pitchFamily="34" charset="0"/>
-                <a:ea typeface="Arial" panose="020B0604020202090204" pitchFamily="34" charset="-122"/>
-                <a:cs typeface="Arial" panose="020B0604020202090204" pitchFamily="34" charset="-120"/>
+                <a:latin typeface="Arial" pitchFamily="34" charset="0"/>
+                <a:ea typeface="Arial" pitchFamily="34" charset="-122"/>
+                <a:cs typeface="Arial" pitchFamily="34" charset="-120"/>
               </a:rPr>
               <a:t>0 additional privacy loss</a:t>
             </a:r>
@@ -3037,66 +3233,67 @@
             <a:avLst/>
           </a:prstGeom>
           <a:noFill/>
+          <a:ln/>
         </p:spPr>
         <p:txBody>
           <a:bodyPr wrap="square" lIns="0" tIns="0" rIns="0" bIns="0" rtlCol="0" anchor="ctr"/>
           <a:lstStyle/>
           <a:p>
-            <a:pPr marL="0" indent="0" algn="l">
+            <a:pPr algn="l" indent="0" marL="0">
               <a:lnSpc>
                 <a:spcPct val="102000"/>
               </a:lnSpc>
               <a:buNone/>
             </a:pPr>
             <a:r>
-              <a:rPr lang="en-US" sz="800" b="1" dirty="0">
+              <a:rPr lang="en-US" sz="680" b="1" dirty="0">
                 <a:solidFill>
                   <a:srgbClr val="0E7C7B"/>
                 </a:solidFill>
-                <a:latin typeface="Times New Roman Regular" panose="02020503050405090304" charset="0"/>
-                <a:ea typeface="Arial" panose="020B0604020202090204" pitchFamily="34" charset="-122"/>
-                <a:cs typeface="Times New Roman Regular" panose="02020503050405090304" charset="0"/>
+                <a:latin typeface="Arial" pitchFamily="34" charset="0"/>
+                <a:ea typeface="Arial" pitchFamily="34" charset="-122"/>
+                <a:cs typeface="Arial" pitchFamily="34" charset="-120"/>
               </a:rPr>
               <a:t>Mutation never</a:t>
             </a:r>
-            <a:endParaRPr lang="en-US" sz="800" dirty="0">
-              <a:latin typeface="Times New Roman Regular" panose="02020503050405090304" charset="0"/>
-              <a:cs typeface="Times New Roman Regular" panose="02020503050405090304" charset="0"/>
-            </a:endParaRPr>
+            <a:endParaRPr lang="en-US" sz="680" dirty="0"/>
           </a:p>
           <a:p>
-            <a:pPr marL="0" indent="0" algn="l">
+            <a:pPr algn="l" indent="0" marL="0">
               <a:lnSpc>
                 <a:spcPct val="102000"/>
               </a:lnSpc>
               <a:buNone/>
             </a:pPr>
             <a:r>
-              <a:rPr lang="en-US" sz="800" b="1" dirty="0">
+              <a:rPr lang="en-US" sz="680" b="1" dirty="0">
                 <a:solidFill>
                   <a:srgbClr val="0E7C7B"/>
                 </a:solidFill>
-                <a:latin typeface="Times New Roman Regular" panose="02020503050405090304" charset="0"/>
-                <a:ea typeface="Arial" panose="020B0604020202090204" pitchFamily="34" charset="-122"/>
-                <a:cs typeface="Times New Roman Regular" panose="02020503050405090304" charset="0"/>
+                <a:latin typeface="Arial" pitchFamily="34" charset="0"/>
+                <a:ea typeface="Arial" pitchFamily="34" charset="-122"/>
+                <a:cs typeface="Arial" pitchFamily="34" charset="-120"/>
               </a:rPr>
               <a:t>reads </a:t>
             </a:r>
-            <a:r>
-              <a:rPr lang="en-US" sz="800" b="1" dirty="0">
+            <a:pPr algn="l" indent="0" marL="0">
+              <a:lnSpc>
+                <a:spcPct val="102000"/>
+              </a:lnSpc>
+              <a:buNone/>
+            </a:pPr>
+            <a:r>
+              <a:rPr lang="en-US" sz="680" b="1" dirty="0">
                 <a:solidFill>
                   <a:srgbClr val="0E7C7B"/>
                 </a:solidFill>
-                <a:latin typeface="Times New Roman Regular" panose="02020503050405090304" charset="0"/>
+                <a:latin typeface="Cambria Math" pitchFamily="34" charset="0"/>
                 <a:ea typeface="Cambria Math" pitchFamily="34" charset="-122"/>
-                <a:cs typeface="Times New Roman Regular" panose="02020503050405090304" charset="0"/>
+                <a:cs typeface="Cambria Math" pitchFamily="34" charset="-120"/>
               </a:rPr>
               <a:t>𝒟</a:t>
             </a:r>
-            <a:endParaRPr lang="en-US" sz="800" dirty="0">
-              <a:latin typeface="Times New Roman Regular" panose="02020503050405090304" charset="0"/>
-              <a:cs typeface="Times New Roman Regular" panose="02020503050405090304" charset="0"/>
-            </a:endParaRPr>
+            <a:endParaRPr lang="en-US" sz="680" dirty="0"/>
           </a:p>
         </p:txBody>
       </p:sp>
@@ -3140,110 +3337,135 @@
             <a:avLst/>
           </a:prstGeom>
           <a:noFill/>
+          <a:ln/>
         </p:spPr>
         <p:txBody>
           <a:bodyPr wrap="square" lIns="0" tIns="0" rIns="0" bIns="0" rtlCol="0" anchor="ctr"/>
           <a:lstStyle/>
           <a:p>
-            <a:pPr marL="0" indent="0" algn="l">
+            <a:pPr algn="l" indent="0" marL="0">
               <a:lnSpc>
                 <a:spcPct val="102000"/>
               </a:lnSpc>
               <a:buNone/>
             </a:pPr>
             <a:r>
-              <a:rPr lang="en-US" sz="800" dirty="0">
+              <a:rPr lang="en-US" sz="680" dirty="0">
                 <a:solidFill>
                   <a:srgbClr val="1F3D7A"/>
                 </a:solidFill>
-                <a:latin typeface="Times New Roman Regular" panose="02020503050405090304" charset="0"/>
+                <a:latin typeface="Cambria Math" pitchFamily="34" charset="0"/>
                 <a:ea typeface="Cambria Math" pitchFamily="34" charset="-122"/>
-                <a:cs typeface="Times New Roman Regular" panose="02020503050405090304" charset="0"/>
+                <a:cs typeface="Cambria Math" pitchFamily="34" charset="-120"/>
               </a:rPr>
               <a:t>𝒟</a:t>
             </a:r>
-            <a:r>
-              <a:rPr lang="en-US" sz="800" dirty="0">
+            <a:pPr algn="l" indent="0" marL="0">
+              <a:lnSpc>
+                <a:spcPct val="102000"/>
+              </a:lnSpc>
+              <a:buNone/>
+            </a:pPr>
+            <a:r>
+              <a:rPr lang="en-US" sz="680" dirty="0">
                 <a:solidFill>
                   <a:srgbClr val="1F3D7A"/>
                 </a:solidFill>
-                <a:latin typeface="Times New Roman Regular" panose="02020503050405090304" charset="0"/>
-                <a:ea typeface="Arial" panose="020B0604020202090204" pitchFamily="34" charset="-122"/>
-                <a:cs typeface="Times New Roman Regular" panose="02020503050405090304" charset="0"/>
+                <a:latin typeface="Arial" pitchFamily="34" charset="0"/>
+                <a:ea typeface="Arial" pitchFamily="34" charset="-122"/>
+                <a:cs typeface="Arial" pitchFamily="34" charset="-120"/>
               </a:rPr>
               <a:t>: </a:t>
             </a:r>
-            <a:r>
-              <a:rPr lang="en-US" sz="800" b="1" dirty="0">
+            <a:pPr algn="l" indent="0" marL="0">
+              <a:lnSpc>
+                <a:spcPct val="102000"/>
+              </a:lnSpc>
+              <a:buNone/>
+            </a:pPr>
+            <a:r>
+              <a:rPr lang="en-US" sz="680" b="1" dirty="0">
                 <a:solidFill>
                   <a:srgbClr val="1F3D7A"/>
                 </a:solidFill>
-                <a:latin typeface="Times New Roman Regular" panose="02020503050405090304" charset="0"/>
-                <a:ea typeface="Arial" panose="020B0604020202090204" pitchFamily="34" charset="-122"/>
-                <a:cs typeface="Times New Roman Regular" panose="02020503050405090304" charset="0"/>
+                <a:latin typeface="Arial" pitchFamily="34" charset="0"/>
+                <a:ea typeface="Arial" pitchFamily="34" charset="-122"/>
+                <a:cs typeface="Arial" pitchFamily="34" charset="-120"/>
               </a:rPr>
               <a:t>private</a:t>
             </a:r>
-            <a:r>
-              <a:rPr lang="en-US" sz="800" dirty="0">
+            <a:pPr algn="l" indent="0" marL="0">
+              <a:lnSpc>
+                <a:spcPct val="102000"/>
+              </a:lnSpc>
+              <a:buNone/>
+            </a:pPr>
+            <a:r>
+              <a:rPr lang="en-US" sz="680" dirty="0">
                 <a:solidFill>
                   <a:srgbClr val="1F3D7A"/>
                 </a:solidFill>
-                <a:latin typeface="Times New Roman Regular" panose="02020503050405090304" charset="0"/>
-                <a:ea typeface="Arial" panose="020B0604020202090204" pitchFamily="34" charset="-122"/>
-                <a:cs typeface="Times New Roman Regular" panose="02020503050405090304" charset="0"/>
+                <a:latin typeface="Arial" pitchFamily="34" charset="0"/>
+                <a:ea typeface="Arial" pitchFamily="34" charset="-122"/>
+                <a:cs typeface="Arial" pitchFamily="34" charset="-120"/>
               </a:rPr>
               <a:t> optimization</a:t>
             </a:r>
-            <a:endParaRPr lang="en-US" sz="800" dirty="0">
-              <a:latin typeface="Times New Roman Regular" panose="02020503050405090304" charset="0"/>
-              <a:cs typeface="Times New Roman Regular" panose="02020503050405090304" charset="0"/>
-            </a:endParaRPr>
+            <a:endParaRPr lang="en-US" sz="680" dirty="0"/>
           </a:p>
           <a:p>
-            <a:pPr marL="0" indent="0" algn="l">
+            <a:pPr algn="l" indent="0" marL="0">
               <a:lnSpc>
                 <a:spcPct val="102000"/>
               </a:lnSpc>
               <a:buNone/>
             </a:pPr>
             <a:r>
-              <a:rPr lang="en-US" sz="800" dirty="0">
+              <a:rPr lang="en-US" sz="680" dirty="0">
                 <a:solidFill>
                   <a:srgbClr val="1F3D7A"/>
                 </a:solidFill>
-                <a:latin typeface="Times New Roman Regular" panose="02020503050405090304" charset="0"/>
-                <a:ea typeface="Arial" panose="020B0604020202090204" pitchFamily="34" charset="-122"/>
-                <a:cs typeface="Times New Roman Regular" panose="02020503050405090304" charset="0"/>
+                <a:latin typeface="Arial" pitchFamily="34" charset="0"/>
+                <a:ea typeface="Arial" pitchFamily="34" charset="-122"/>
+                <a:cs typeface="Arial" pitchFamily="34" charset="-120"/>
               </a:rPr>
               <a:t>set (</a:t>
             </a:r>
-            <a:r>
-              <a:rPr lang="en-US" sz="800" i="1" dirty="0">
+            <a:pPr algn="l" indent="0" marL="0">
+              <a:lnSpc>
+                <a:spcPct val="102000"/>
+              </a:lnSpc>
+              <a:buNone/>
+            </a:pPr>
+            <a:r>
+              <a:rPr lang="en-US" sz="680" i="1" dirty="0">
                 <a:solidFill>
                   <a:srgbClr val="1F3D7A"/>
                 </a:solidFill>
-                <a:latin typeface="Times New Roman Regular" panose="02020503050405090304" charset="0"/>
-                <a:ea typeface="Arial" panose="020B0604020202090204" pitchFamily="34" charset="-122"/>
-                <a:cs typeface="Times New Roman Regular" panose="02020503050405090304" charset="0"/>
+                <a:latin typeface="Arial" pitchFamily="34" charset="0"/>
+                <a:ea typeface="Arial" pitchFamily="34" charset="-122"/>
+                <a:cs typeface="Arial" pitchFamily="34" charset="-120"/>
               </a:rPr>
               <a:t>n</a:t>
             </a:r>
-            <a:r>
-              <a:rPr lang="en-US" sz="800" dirty="0">
+            <a:pPr algn="l" indent="0" marL="0">
+              <a:lnSpc>
+                <a:spcPct val="102000"/>
+              </a:lnSpc>
+              <a:buNone/>
+            </a:pPr>
+            <a:r>
+              <a:rPr lang="en-US" sz="680" dirty="0">
                 <a:solidFill>
                   <a:srgbClr val="1F3D7A"/>
                 </a:solidFill>
-                <a:latin typeface="Times New Roman Regular" panose="02020503050405090304" charset="0"/>
-                <a:ea typeface="Arial" panose="020B0604020202090204" pitchFamily="34" charset="-122"/>
-                <a:cs typeface="Times New Roman Regular" panose="02020503050405090304" charset="0"/>
+                <a:latin typeface="Arial" pitchFamily="34" charset="0"/>
+                <a:ea typeface="Arial" pitchFamily="34" charset="-122"/>
+                <a:cs typeface="Arial" pitchFamily="34" charset="-120"/>
               </a:rPr>
               <a:t> records)</a:t>
             </a:r>
-            <a:endParaRPr lang="en-US" sz="800" dirty="0">
-              <a:latin typeface="Times New Roman Regular" panose="02020503050405090304" charset="0"/>
-              <a:cs typeface="Times New Roman Regular" panose="02020503050405090304" charset="0"/>
-            </a:endParaRPr>
+            <a:endParaRPr lang="en-US" sz="680" dirty="0"/>
           </a:p>
         </p:txBody>
       </p:sp>
@@ -3334,55 +3556,50 @@
             <a:avLst/>
           </a:prstGeom>
           <a:noFill/>
+          <a:ln/>
         </p:spPr>
         <p:txBody>
           <a:bodyPr wrap="square" lIns="0" tIns="0" rIns="0" bIns="0" rtlCol="0" anchor="ctr"/>
           <a:lstStyle/>
           <a:p>
-            <a:pPr marL="0" indent="0" algn="l">
+            <a:pPr algn="l" indent="0" marL="0">
               <a:lnSpc>
                 <a:spcPct val="102000"/>
               </a:lnSpc>
               <a:buNone/>
             </a:pPr>
             <a:r>
-              <a:rPr lang="en-US" sz="800" b="1" dirty="0">
+              <a:rPr lang="en-US" sz="680" b="1" dirty="0">
                 <a:solidFill>
                   <a:srgbClr val="2E7D32"/>
                 </a:solidFill>
-                <a:latin typeface="Times New Roman Regular" panose="02020503050405090304" charset="0"/>
-                <a:ea typeface="Arial" panose="020B0604020202090204" pitchFamily="34" charset="-122"/>
-                <a:cs typeface="Times New Roman Regular" panose="02020503050405090304" charset="0"/>
+                <a:latin typeface="Arial" pitchFamily="34" charset="0"/>
+                <a:ea typeface="Arial" pitchFamily="34" charset="-122"/>
+                <a:cs typeface="Arial" pitchFamily="34" charset="-120"/>
               </a:rPr>
               <a:t>Selection reads only</a:t>
             </a:r>
-            <a:endParaRPr lang="en-US" sz="800" dirty="0">
-              <a:latin typeface="Times New Roman Regular" panose="02020503050405090304" charset="0"/>
-              <a:cs typeface="Times New Roman Regular" panose="02020503050405090304" charset="0"/>
-            </a:endParaRPr>
+            <a:endParaRPr lang="en-US" sz="680" dirty="0"/>
           </a:p>
           <a:p>
-            <a:pPr marL="0" indent="0" algn="l">
+            <a:pPr algn="l" indent="0" marL="0">
               <a:lnSpc>
                 <a:spcPct val="102000"/>
               </a:lnSpc>
               <a:buNone/>
             </a:pPr>
             <a:r>
-              <a:rPr lang="en-US" sz="800" b="1" dirty="0">
+              <a:rPr lang="en-US" sz="680" b="1" dirty="0">
                 <a:solidFill>
                   <a:srgbClr val="2E7D32"/>
                 </a:solidFill>
-                <a:latin typeface="Times New Roman Regular" panose="02020503050405090304" charset="0"/>
-                <a:ea typeface="Arial" panose="020B0604020202090204" pitchFamily="34" charset="-122"/>
-                <a:cs typeface="Times New Roman Regular" panose="02020503050405090304" charset="0"/>
+                <a:latin typeface="Arial" pitchFamily="34" charset="0"/>
+                <a:ea typeface="Arial" pitchFamily="34" charset="-122"/>
+                <a:cs typeface="Arial" pitchFamily="34" charset="-120"/>
               </a:rPr>
               <a:t>privatized scores</a:t>
             </a:r>
-            <a:endParaRPr lang="en-US" sz="800" dirty="0">
-              <a:latin typeface="Times New Roman Regular" panose="02020503050405090304" charset="0"/>
-              <a:cs typeface="Times New Roman Regular" panose="02020503050405090304" charset="0"/>
-            </a:endParaRPr>
+            <a:endParaRPr lang="en-US" sz="680" dirty="0"/>
           </a:p>
         </p:txBody>
       </p:sp>
@@ -3428,47 +3645,81 @@
             <a:avLst/>
           </a:prstGeom>
           <a:noFill/>
+          <a:ln/>
         </p:spPr>
         <p:txBody>
           <a:bodyPr wrap="square" lIns="0" tIns="0" rIns="0" bIns="0" rtlCol="0" anchor="t"/>
           <a:lstStyle/>
           <a:p>
-            <a:pPr marL="0" indent="0" algn="ctr">
-              <a:lnSpc>
-                <a:spcPct val="100000"/>
-              </a:lnSpc>
-              <a:buNone/>
-            </a:pPr>
-            <a:r>
-              <a:rPr lang="en-US" sz="800" b="1" dirty="0">
+            <a:pPr algn="ctr" indent="0" marL="0">
+              <a:lnSpc>
+                <a:spcPct val="100000"/>
+              </a:lnSpc>
+              <a:buNone/>
+            </a:pPr>
+            <a:r>
+              <a:rPr lang="en-US" sz="720" b="1" dirty="0">
                 <a:solidFill>
                   <a:srgbClr val="1F3D7A"/>
                 </a:solidFill>
-                <a:latin typeface="Times New Roman" panose="02020503050405090304" pitchFamily="34" charset="0"/>
-                <a:ea typeface="Arial" panose="020B0604020202090204" pitchFamily="34" charset="-122"/>
-                <a:cs typeface="Times New Roman" panose="02020503050405090304" pitchFamily="34" charset="0"/>
-              </a:rPr>
-              <a:t>Privacy accounting: </a:t>
-            </a:r>
-            <a:r>
-              <a:rPr lang="en-US" sz="800" dirty="0">
+                <a:latin typeface="Arial" pitchFamily="34" charset="0"/>
+                <a:ea typeface="Arial" pitchFamily="34" charset="-122"/>
+                <a:cs typeface="Arial" pitchFamily="34" charset="-120"/>
+              </a:rPr>
+              <a:t>Privacy accounting:</a:t>
+            </a:r>
+            <a:pPr algn="ctr" indent="0" marL="0">
+              <a:lnSpc>
+                <a:spcPct val="100000"/>
+              </a:lnSpc>
+              <a:buNone/>
+            </a:pPr>
+            <a:r>
+              <a:rPr lang="en-US" sz="720" dirty="0">
                 <a:solidFill>
                   <a:srgbClr val="1F3D7A"/>
                 </a:solidFill>
-                <a:latin typeface="Times New Roman" panose="02020503050405090304" pitchFamily="34" charset="0"/>
-                <a:ea typeface="Arial" panose="020B0604020202090204" pitchFamily="34" charset="-122"/>
-                <a:cs typeface="Times New Roman" panose="02020503050405090304" pitchFamily="34" charset="0"/>
-              </a:rPr>
-              <a:t> at most TK sampled-Gaussian score releases compose in one</a:t>
-            </a:r>
-            <a:endParaRPr lang="en-US" sz="800" dirty="0">
-              <a:solidFill>
-                <a:srgbClr val="1F3D7A"/>
-              </a:solidFill>
-              <a:latin typeface="Times New Roman" panose="02020503050405090304" pitchFamily="34" charset="0"/>
-              <a:ea typeface="Arial" panose="020B0604020202090204" pitchFamily="34" charset="-122"/>
-              <a:cs typeface="Times New Roman" panose="02020503050405090304" pitchFamily="34" charset="0"/>
-            </a:endParaRPr>
+                <a:latin typeface="Arial" pitchFamily="34" charset="0"/>
+                <a:ea typeface="Arial" pitchFamily="34" charset="-122"/>
+                <a:cs typeface="Arial" pitchFamily="34" charset="-120"/>
+              </a:rPr>
+              <a:t>  at most </a:t>
+            </a:r>
+            <a:pPr algn="ctr" indent="0" marL="0">
+              <a:lnSpc>
+                <a:spcPct val="100000"/>
+              </a:lnSpc>
+              <a:buNone/>
+            </a:pPr>
+            <a:r>
+              <a:rPr lang="en-US" sz="720" i="1" dirty="0">
+                <a:solidFill>
+                  <a:srgbClr val="1F3D7A"/>
+                </a:solidFill>
+                <a:latin typeface="Arial" pitchFamily="34" charset="0"/>
+                <a:ea typeface="Arial" pitchFamily="34" charset="-122"/>
+                <a:cs typeface="Arial" pitchFamily="34" charset="-120"/>
+              </a:rPr>
+              <a:t>TK</a:t>
+            </a:r>
+            <a:pPr algn="ctr" indent="0" marL="0">
+              <a:lnSpc>
+                <a:spcPct val="100000"/>
+              </a:lnSpc>
+              <a:buNone/>
+            </a:pPr>
+            <a:r>
+              <a:rPr lang="en-US" sz="720" dirty="0">
+                <a:solidFill>
+                  <a:srgbClr val="1F3D7A"/>
+                </a:solidFill>
+                <a:latin typeface="Arial" pitchFamily="34" charset="0"/>
+                <a:ea typeface="Arial" pitchFamily="34" charset="-122"/>
+                <a:cs typeface="Arial" pitchFamily="34" charset="-120"/>
+              </a:rPr>
+              <a:t> sampled-Gaussian score releases compose in one</a:t>
+            </a:r>
+            <a:endParaRPr lang="en-US" sz="720" dirty="0"/>
           </a:p>
         </p:txBody>
       </p:sp>
@@ -3487,36 +3738,30 @@
             <a:avLst/>
           </a:prstGeom>
           <a:noFill/>
+          <a:ln/>
         </p:spPr>
         <p:txBody>
           <a:bodyPr wrap="square" lIns="0" tIns="0" rIns="0" bIns="0" rtlCol="0" anchor="t"/>
           <a:lstStyle/>
           <a:p>
-            <a:pPr marL="0" indent="0" algn="ctr">
-              <a:lnSpc>
-                <a:spcPct val="100000"/>
-              </a:lnSpc>
-              <a:buNone/>
-            </a:pPr>
-            <a:r>
-              <a:rPr lang="en-US" sz="800" dirty="0">
+            <a:pPr algn="ctr" indent="0" marL="0">
+              <a:lnSpc>
+                <a:spcPct val="100000"/>
+              </a:lnSpc>
+              <a:buNone/>
+            </a:pPr>
+            <a:r>
+              <a:rPr lang="en-US" sz="720" dirty="0">
                 <a:solidFill>
                   <a:srgbClr val="1F3D7A"/>
                 </a:solidFill>
-                <a:latin typeface="Times New Roman" panose="02020503050405090304" pitchFamily="34" charset="0"/>
-                <a:ea typeface="Arial" panose="020B0604020202090204" pitchFamily="34" charset="-122"/>
-                <a:cs typeface="Times New Roman" panose="02020503050405090304" pitchFamily="34" charset="0"/>
+                <a:latin typeface="Arial" pitchFamily="34" charset="0"/>
+                <a:ea typeface="Arial" pitchFamily="34" charset="-122"/>
+                <a:cs typeface="Arial" pitchFamily="34" charset="-120"/>
               </a:rPr>
               <a:t>RDP accountant  ⟹  overall (ε, δ)-DP.   Mutation and selection add no privacy loss.</a:t>
             </a:r>
-            <a:endParaRPr lang="en-US" sz="800" dirty="0">
-              <a:solidFill>
-                <a:srgbClr val="1F3D7A"/>
-              </a:solidFill>
-              <a:latin typeface="Times New Roman" panose="02020503050405090304" pitchFamily="34" charset="0"/>
-              <a:ea typeface="Arial" panose="020B0604020202090204" pitchFamily="34" charset="-122"/>
-              <a:cs typeface="Times New Roman" panose="02020503050405090304" pitchFamily="34" charset="0"/>
-            </a:endParaRPr>
+            <a:endParaRPr lang="en-US" sz="720" dirty="0"/>
           </a:p>
         </p:txBody>
       </p:sp>
@@ -3535,12 +3780,13 @@
             <a:avLst/>
           </a:prstGeom>
           <a:noFill/>
+          <a:ln/>
         </p:spPr>
         <p:txBody>
           <a:bodyPr wrap="square" lIns="0" tIns="0" rIns="0" bIns="0" rtlCol="0" anchor="t"/>
           <a:lstStyle/>
           <a:p>
-            <a:pPr marL="0" indent="0" algn="l">
+            <a:pPr algn="l" indent="0" marL="0">
               <a:lnSpc>
                 <a:spcPct val="100000"/>
               </a:lnSpc>
@@ -3551,53 +3797,77 @@
                 <a:solidFill>
                   <a:srgbClr val="1A1F2B"/>
                 </a:solidFill>
-                <a:latin typeface="Arial" panose="020B0604020202090204" pitchFamily="34" charset="0"/>
-                <a:ea typeface="Arial" panose="020B0604020202090204" pitchFamily="34" charset="-122"/>
-                <a:cs typeface="Arial" panose="020B0604020202090204" pitchFamily="34" charset="-120"/>
+                <a:latin typeface="Arial" pitchFamily="34" charset="0"/>
+                <a:ea typeface="Arial" pitchFamily="34" charset="-122"/>
+                <a:cs typeface="Arial" pitchFamily="34" charset="-120"/>
               </a:rPr>
               <a:t>(b)   </a:t>
             </a:r>
+            <a:pPr algn="l" indent="0" marL="0">
+              <a:lnSpc>
+                <a:spcPct val="100000"/>
+              </a:lnSpc>
+              <a:buNone/>
+            </a:pPr>
             <a:r>
               <a:rPr lang="en-US" sz="900" b="1" dirty="0">
                 <a:solidFill>
                   <a:srgbClr val="0E7C7B"/>
                 </a:solidFill>
-                <a:latin typeface="Arial" panose="020B0604020202090204" pitchFamily="34" charset="0"/>
-                <a:ea typeface="Arial" panose="020B0604020202090204" pitchFamily="34" charset="-122"/>
-                <a:cs typeface="Arial" panose="020B0604020202090204" pitchFamily="34" charset="-120"/>
+                <a:latin typeface="Arial" pitchFamily="34" charset="0"/>
+                <a:ea typeface="Arial" pitchFamily="34" charset="-122"/>
+                <a:cs typeface="Arial" pitchFamily="34" charset="-120"/>
               </a:rPr>
               <a:t>DP-ES</a:t>
             </a:r>
+            <a:pPr algn="l" indent="0" marL="0">
+              <a:lnSpc>
+                <a:spcPct val="100000"/>
+              </a:lnSpc>
+              <a:buNone/>
+            </a:pPr>
             <a:r>
               <a:rPr lang="en-US" sz="900" b="1" dirty="0">
                 <a:solidFill>
                   <a:srgbClr val="1A1F2B"/>
                 </a:solidFill>
-                <a:latin typeface="Arial" panose="020B0604020202090204" pitchFamily="34" charset="0"/>
-                <a:ea typeface="Arial" panose="020B0604020202090204" pitchFamily="34" charset="-122"/>
-                <a:cs typeface="Arial" panose="020B0604020202090204" pitchFamily="34" charset="-120"/>
+                <a:latin typeface="Arial" pitchFamily="34" charset="0"/>
+                <a:ea typeface="Arial" pitchFamily="34" charset="-122"/>
+                <a:cs typeface="Arial" pitchFamily="34" charset="-120"/>
               </a:rPr>
               <a:t> vs. </a:t>
             </a:r>
+            <a:pPr algn="l" indent="0" marL="0">
+              <a:lnSpc>
+                <a:spcPct val="100000"/>
+              </a:lnSpc>
+              <a:buNone/>
+            </a:pPr>
             <a:r>
               <a:rPr lang="en-US" sz="900" b="1" dirty="0">
                 <a:solidFill>
                   <a:srgbClr val="B23124"/>
                 </a:solidFill>
-                <a:latin typeface="Arial" panose="020B0604020202090204" pitchFamily="34" charset="0"/>
-                <a:ea typeface="Arial" panose="020B0604020202090204" pitchFamily="34" charset="-122"/>
-                <a:cs typeface="Arial" panose="020B0604020202090204" pitchFamily="34" charset="-120"/>
+                <a:latin typeface="Arial" pitchFamily="34" charset="0"/>
+                <a:ea typeface="Arial" pitchFamily="34" charset="-122"/>
+                <a:cs typeface="Arial" pitchFamily="34" charset="-120"/>
               </a:rPr>
               <a:t>DP-OPT</a:t>
             </a:r>
+            <a:pPr algn="l" indent="0" marL="0">
+              <a:lnSpc>
+                <a:spcPct val="100000"/>
+              </a:lnSpc>
+              <a:buNone/>
+            </a:pPr>
             <a:r>
               <a:rPr lang="en-US" sz="900" b="1" dirty="0">
                 <a:solidFill>
                   <a:srgbClr val="1A1F2B"/>
                 </a:solidFill>
-                <a:latin typeface="Arial" panose="020B0604020202090204" pitchFamily="34" charset="0"/>
-                <a:ea typeface="Arial" panose="020B0604020202090204" pitchFamily="34" charset="-122"/>
-                <a:cs typeface="Arial" panose="020B0604020202090204" pitchFamily="34" charset="-120"/>
+                <a:latin typeface="Arial" pitchFamily="34" charset="0"/>
+                <a:ea typeface="Arial" pitchFamily="34" charset="-122"/>
+                <a:cs typeface="Arial" pitchFamily="34" charset="-120"/>
               </a:rPr>
               <a:t>: mechanism and observed stability</a:t>
             </a:r>
@@ -3607,11 +3877,17 @@
       </p:sp>
       <p:graphicFrame>
         <p:nvGraphicFramePr>
-          <p:cNvPr id="60" name="b.table"/>
+          <p:cNvPr id="2" name="b.table"/>
           <p:cNvGraphicFramePr>
             <a:graphicFrameLocks noGrp="1"/>
           </p:cNvGraphicFramePr>
-          <p:nvPr/>
+          <p:nvPr>
+            <p:extLst>
+              <p:ext uri="{D42A27DB-BD31-4B8C-83A1-F6EECF244321}">
+                <p14:modId xmlns:p14="http://schemas.microsoft.com/office/powerpoint/2010/main" val="1579011935"/>
+              </p:ext>
+            </p:extLst>
+          </p:nvPr>
         </p:nvGraphicFramePr>
         <p:xfrm>
           <a:off x="109728" y="3474720"/>
@@ -3632,7 +3908,7 @@
                     <a:bodyPr/>
                     <a:lstStyle/>
                     <a:p>
-                      <a:pPr marL="0" indent="0" algn="ctr">
+                      <a:pPr algn="ctr" indent="0" marL="0">
                         <a:buNone/>
                       </a:pPr>
                       <a:r>
@@ -3640,9 +3916,9 @@
                           <a:solidFill>
                             <a:srgbClr val="1A1F2B"/>
                           </a:solidFill>
-                          <a:latin typeface="Arial" panose="020B0604020202090204" pitchFamily="34" charset="0"/>
-                          <a:ea typeface="Arial" panose="020B0604020202090204" pitchFamily="34" charset="-122"/>
-                          <a:cs typeface="Arial" panose="020B0604020202090204" pitchFamily="34" charset="-120"/>
+                          <a:latin typeface="Arial" pitchFamily="34" charset="0"/>
+                          <a:ea typeface="Arial" pitchFamily="34" charset="-122"/>
+                          <a:cs typeface="Arial" pitchFamily="34" charset="-120"/>
                         </a:rPr>
                         <a:t>Aspect</a:t>
                       </a:r>
@@ -3681,7 +3957,7 @@
                     <a:bodyPr/>
                     <a:lstStyle/>
                     <a:p>
-                      <a:pPr marL="0" indent="0" algn="ctr">
+                      <a:pPr algn="ctr" indent="0" marL="0">
                         <a:buNone/>
                       </a:pPr>
                       <a:r>
@@ -3689,9 +3965,9 @@
                           <a:solidFill>
                             <a:srgbClr val="0E7C7B"/>
                           </a:solidFill>
-                          <a:latin typeface="Arial" panose="020B0604020202090204" pitchFamily="34" charset="0"/>
-                          <a:ea typeface="Arial" panose="020B0604020202090204" pitchFamily="34" charset="-122"/>
-                          <a:cs typeface="Arial" panose="020B0604020202090204" pitchFamily="34" charset="-120"/>
+                          <a:latin typeface="Arial" pitchFamily="34" charset="0"/>
+                          <a:ea typeface="Arial" pitchFamily="34" charset="-122"/>
+                          <a:cs typeface="Arial" pitchFamily="34" charset="-120"/>
                         </a:rPr>
                         <a:t>DP-ES (ours)</a:t>
                       </a:r>
@@ -3730,7 +4006,7 @@
                     <a:bodyPr/>
                     <a:lstStyle/>
                     <a:p>
-                      <a:pPr marL="0" indent="0" algn="ctr">
+                      <a:pPr algn="ctr" indent="0" marL="0">
                         <a:buNone/>
                       </a:pPr>
                       <a:r>
@@ -3738,9 +4014,9 @@
                           <a:solidFill>
                             <a:srgbClr val="B23124"/>
                           </a:solidFill>
-                          <a:latin typeface="Arial" panose="020B0604020202090204" pitchFamily="34" charset="0"/>
-                          <a:ea typeface="Arial" panose="020B0604020202090204" pitchFamily="34" charset="-122"/>
-                          <a:cs typeface="Arial" panose="020B0604020202090204" pitchFamily="34" charset="-120"/>
+                          <a:latin typeface="Arial" pitchFamily="34" charset="0"/>
+                          <a:ea typeface="Arial" pitchFamily="34" charset="-122"/>
+                          <a:cs typeface="Arial" pitchFamily="34" charset="-120"/>
                         </a:rPr>
                         <a:t>DP-OPT</a:t>
                       </a:r>
@@ -3781,7 +4057,7 @@
                     <a:bodyPr/>
                     <a:lstStyle/>
                     <a:p>
-                      <a:pPr marL="0" indent="0" algn="ctr">
+                      <a:pPr algn="ctr" indent="0" marL="0">
                         <a:buNone/>
                       </a:pPr>
                       <a:r>
@@ -3789,9 +4065,9 @@
                           <a:solidFill>
                             <a:srgbClr val="1A1F2B"/>
                           </a:solidFill>
-                          <a:latin typeface="Arial" panose="020B0604020202090204" pitchFamily="34" charset="0"/>
-                          <a:ea typeface="Arial" panose="020B0604020202090204" pitchFamily="34" charset="-122"/>
-                          <a:cs typeface="Arial" panose="020B0604020202090204" pitchFamily="34" charset="-120"/>
+                          <a:latin typeface="Arial" pitchFamily="34" charset="0"/>
+                          <a:ea typeface="Arial" pitchFamily="34" charset="-122"/>
+                          <a:cs typeface="Arial" pitchFamily="34" charset="-120"/>
                         </a:rPr>
                         <a:t>Search unit</a:t>
                       </a:r>
@@ -3824,28 +4100,21 @@
                     <a:bodyPr/>
                     <a:lstStyle/>
                     <a:p>
-                      <a:pPr marL="0" indent="0" algn="ctr">
+                      <a:pPr algn="ctr" indent="0" marL="0">
                         <a:buNone/>
                       </a:pPr>
                       <a:r>
-                        <a:rPr lang="en-US" sz="700" dirty="0">
+                        <a:rPr lang="en-US" sz="680" dirty="0">
                           <a:solidFill>
                             <a:srgbClr val="1A1F2B"/>
                           </a:solidFill>
-                          <a:latin typeface="Times New Roman" panose="02020503050405090304" pitchFamily="34" charset="0"/>
-                          <a:ea typeface="Arial" panose="020B0604020202090204" pitchFamily="34" charset="-122"/>
-                          <a:cs typeface="Times New Roman" panose="02020503050405090304" pitchFamily="34" charset="0"/>
+                          <a:latin typeface="Arial" pitchFamily="34" charset="0"/>
+                          <a:ea typeface="Arial" pitchFamily="34" charset="-122"/>
+                          <a:cs typeface="Arial" pitchFamily="34" charset="-120"/>
                         </a:rPr>
                         <a:t>Population of complete prompts</a:t>
                       </a:r>
-                      <a:endParaRPr lang="en-US" sz="700" dirty="0">
-                        <a:solidFill>
-                          <a:srgbClr val="1A1F2B"/>
-                        </a:solidFill>
-                        <a:latin typeface="Times New Roman" panose="02020503050405090304" pitchFamily="34" charset="0"/>
-                        <a:ea typeface="Arial" panose="020B0604020202090204" pitchFamily="34" charset="-122"/>
-                        <a:cs typeface="Times New Roman" panose="02020503050405090304" pitchFamily="34" charset="0"/>
-                      </a:endParaRPr>
+                      <a:endParaRPr lang="en-US" sz="1200" dirty="0"/>
                     </a:p>
                   </a:txBody>
                   <a:tcPr marL="38100" marR="38100" marT="12700" marB="12700" anchor="ctr">
@@ -3874,31 +4143,21 @@
                     <a:bodyPr/>
                     <a:lstStyle/>
                     <a:p>
-                      <a:pPr marL="0" algn="ctr">
-                        <a:buClrTx/>
-                        <a:buSzTx/>
-                        <a:buFontTx/>
+                      <a:pPr algn="ctr" indent="0" marL="0">
                         <a:buNone/>
                       </a:pPr>
                       <a:r>
-                        <a:rPr lang="en-US" sz="700" dirty="0">
+                        <a:rPr lang="en-US" sz="680" dirty="0">
                           <a:solidFill>
                             <a:srgbClr val="1A1F2B"/>
                           </a:solidFill>
-                          <a:latin typeface="Times New Roman" panose="02020503050405090304" pitchFamily="34" charset="0"/>
-                          <a:ea typeface="Arial" panose="020B0604020202090204" pitchFamily="34" charset="-122"/>
-                          <a:cs typeface="Times New Roman" panose="02020503050405090304" pitchFamily="34" charset="0"/>
+                          <a:latin typeface="Arial" pitchFamily="34" charset="0"/>
+                          <a:ea typeface="Arial" pitchFamily="34" charset="-122"/>
+                          <a:cs typeface="Arial" pitchFamily="34" charset="-120"/>
                         </a:rPr>
                         <a:t>Greedy token-by-token construction</a:t>
                       </a:r>
-                      <a:endParaRPr lang="en-US" sz="700" dirty="0">
-                        <a:solidFill>
-                          <a:srgbClr val="1A1F2B"/>
-                        </a:solidFill>
-                        <a:latin typeface="Times New Roman" panose="02020503050405090304" pitchFamily="34" charset="0"/>
-                        <a:ea typeface="Arial" panose="020B0604020202090204" pitchFamily="34" charset="-122"/>
-                        <a:cs typeface="Times New Roman" panose="02020503050405090304" pitchFamily="34" charset="0"/>
-                      </a:endParaRPr>
+                      <a:endParaRPr lang="en-US" sz="1200" dirty="0"/>
                     </a:p>
                   </a:txBody>
                   <a:tcPr marL="38100" marR="38100" marT="12700" marB="12700" anchor="ctr">
@@ -3929,7 +4188,7 @@
                     <a:bodyPr/>
                     <a:lstStyle/>
                     <a:p>
-                      <a:pPr marL="0" indent="0" algn="ctr">
+                      <a:pPr algn="ctr" indent="0" marL="0">
                         <a:buNone/>
                       </a:pPr>
                       <a:r>
@@ -3937,9 +4196,9 @@
                           <a:solidFill>
                             <a:srgbClr val="1A1F2B"/>
                           </a:solidFill>
-                          <a:latin typeface="Arial" panose="020B0604020202090204" pitchFamily="34" charset="0"/>
-                          <a:ea typeface="Arial" panose="020B0604020202090204" pitchFamily="34" charset="-122"/>
-                          <a:cs typeface="Arial" panose="020B0604020202090204" pitchFamily="34" charset="-120"/>
+                          <a:latin typeface="Arial" pitchFamily="34" charset="0"/>
+                          <a:ea typeface="Arial" pitchFamily="34" charset="-122"/>
+                          <a:cs typeface="Arial" pitchFamily="34" charset="-120"/>
                         </a:rPr>
                         <a:t>Private-data access</a:t>
                       </a:r>
@@ -3972,31 +4231,21 @@
                     <a:bodyPr/>
                     <a:lstStyle/>
                     <a:p>
-                      <a:pPr marL="0" algn="ctr">
-                        <a:buClrTx/>
-                        <a:buSzTx/>
-                        <a:buFontTx/>
+                      <a:pPr algn="ctr" indent="0" marL="0">
                         <a:buNone/>
                       </a:pPr>
                       <a:r>
-                        <a:rPr lang="en-US" sz="700" dirty="0">
+                        <a:rPr lang="en-US" sz="680" dirty="0">
                           <a:solidFill>
                             <a:srgbClr val="1A1F2B"/>
                           </a:solidFill>
-                          <a:latin typeface="Times New Roman" panose="02020503050405090304" pitchFamily="34" charset="0"/>
-                          <a:ea typeface="Arial" panose="020B0604020202090204" pitchFamily="34" charset="-122"/>
-                          <a:cs typeface="Times New Roman" panose="02020503050405090304" pitchFamily="34" charset="0"/>
+                          <a:latin typeface="Arial" pitchFamily="34" charset="0"/>
+                          <a:ea typeface="Arial" pitchFamily="34" charset="-122"/>
+                          <a:cs typeface="Arial" pitchFamily="34" charset="-120"/>
                         </a:rPr>
                         <a:t>Sampled utility scoring only</a:t>
                       </a:r>
-                      <a:endParaRPr lang="en-US" sz="700" dirty="0">
-                        <a:solidFill>
-                          <a:srgbClr val="1A1F2B"/>
-                        </a:solidFill>
-                        <a:latin typeface="Times New Roman" panose="02020503050405090304" pitchFamily="34" charset="0"/>
-                        <a:ea typeface="Arial" panose="020B0604020202090204" pitchFamily="34" charset="-122"/>
-                        <a:cs typeface="Times New Roman" panose="02020503050405090304" pitchFamily="34" charset="0"/>
-                      </a:endParaRPr>
+                      <a:endParaRPr lang="en-US" sz="1200" dirty="0"/>
                     </a:p>
                   </a:txBody>
                   <a:tcPr marL="38100" marR="38100" marT="12700" marB="12700" anchor="ctr">
@@ -4025,31 +4274,21 @@
                     <a:bodyPr/>
                     <a:lstStyle/>
                     <a:p>
-                      <a:pPr marL="0" algn="ctr">
-                        <a:buClrTx/>
-                        <a:buSzTx/>
-                        <a:buFontTx/>
+                      <a:pPr algn="ctr" indent="0" marL="0">
                         <a:buNone/>
                       </a:pPr>
                       <a:r>
-                        <a:rPr lang="en-US" sz="700" dirty="0">
+                        <a:rPr lang="en-US" sz="680" dirty="0">
                           <a:solidFill>
                             <a:srgbClr val="1A1F2B"/>
                           </a:solidFill>
-                          <a:latin typeface="Times New Roman" panose="02020503050405090304" pitchFamily="34" charset="0"/>
-                          <a:ea typeface="Arial" panose="020B0604020202090204" pitchFamily="34" charset="-122"/>
-                          <a:cs typeface="Times New Roman" panose="02020503050405090304" pitchFamily="34" charset="0"/>
+                          <a:latin typeface="Arial" pitchFamily="34" charset="0"/>
+                          <a:ea typeface="Arial" pitchFamily="34" charset="-122"/>
+                          <a:cs typeface="Arial" pitchFamily="34" charset="-120"/>
                         </a:rPr>
                         <a:t>Private histogram queries during construction</a:t>
                       </a:r>
-                      <a:endParaRPr lang="en-US" sz="700" dirty="0">
-                        <a:solidFill>
-                          <a:srgbClr val="1A1F2B"/>
-                        </a:solidFill>
-                        <a:latin typeface="Times New Roman" panose="02020503050405090304" pitchFamily="34" charset="0"/>
-                        <a:ea typeface="Arial" panose="020B0604020202090204" pitchFamily="34" charset="-122"/>
-                        <a:cs typeface="Times New Roman" panose="02020503050405090304" pitchFamily="34" charset="0"/>
-                      </a:endParaRPr>
+                      <a:endParaRPr lang="en-US" sz="1200" dirty="0"/>
                     </a:p>
                   </a:txBody>
                   <a:tcPr marL="38100" marR="38100" marT="12700" marB="12700" anchor="ctr">
@@ -4080,7 +4319,7 @@
                     <a:bodyPr/>
                     <a:lstStyle/>
                     <a:p>
-                      <a:pPr marL="0" indent="0" algn="ctr">
+                      <a:pPr algn="ctr" indent="0" marL="0">
                         <a:buNone/>
                       </a:pPr>
                       <a:r>
@@ -4088,9 +4327,9 @@
                           <a:solidFill>
                             <a:srgbClr val="1A1F2B"/>
                           </a:solidFill>
-                          <a:latin typeface="Arial" panose="020B0604020202090204" pitchFamily="34" charset="0"/>
-                          <a:ea typeface="Arial" panose="020B0604020202090204" pitchFamily="34" charset="-122"/>
-                          <a:cs typeface="Arial" panose="020B0604020202090204" pitchFamily="34" charset="-120"/>
+                          <a:latin typeface="Arial" pitchFamily="34" charset="0"/>
+                          <a:ea typeface="Arial" pitchFamily="34" charset="-122"/>
+                          <a:cs typeface="Arial" pitchFamily="34" charset="-120"/>
                         </a:rPr>
                         <a:t>Selection / recovery</a:t>
                       </a:r>
@@ -4123,31 +4362,21 @@
                     <a:bodyPr/>
                     <a:lstStyle/>
                     <a:p>
-                      <a:pPr marL="0" algn="ctr">
-                        <a:buClrTx/>
-                        <a:buSzTx/>
-                        <a:buFontTx/>
+                      <a:pPr algn="ctr" indent="0" marL="0">
                         <a:buNone/>
                       </a:pPr>
                       <a:r>
-                        <a:rPr lang="en-US" sz="700" dirty="0">
+                        <a:rPr lang="en-US" sz="680" dirty="0">
                           <a:solidFill>
                             <a:srgbClr val="1A1F2B"/>
                           </a:solidFill>
-                          <a:latin typeface="Times New Roman" panose="02020503050405090304" pitchFamily="34" charset="0"/>
-                          <a:ea typeface="Arial" panose="020B0604020202090204" pitchFamily="34" charset="-122"/>
-                          <a:cs typeface="Times New Roman" panose="02020503050405090304" pitchFamily="34" charset="0"/>
+                          <a:latin typeface="Arial" pitchFamily="34" charset="0"/>
+                          <a:ea typeface="Arial" pitchFamily="34" charset="-122"/>
+                          <a:cs typeface="Arial" pitchFamily="34" charset="-120"/>
                         </a:rPr>
                         <a:t>Top-M on privatized scores; alternatives persist</a:t>
                       </a:r>
-                      <a:endParaRPr lang="en-US" sz="700" dirty="0">
-                        <a:solidFill>
-                          <a:srgbClr val="1A1F2B"/>
-                        </a:solidFill>
-                        <a:latin typeface="Times New Roman" panose="02020503050405090304" pitchFamily="34" charset="0"/>
-                        <a:ea typeface="Arial" panose="020B0604020202090204" pitchFamily="34" charset="-122"/>
-                        <a:cs typeface="Times New Roman" panose="02020503050405090304" pitchFamily="34" charset="0"/>
-                      </a:endParaRPr>
+                      <a:endParaRPr lang="en-US" sz="1200" dirty="0"/>
                     </a:p>
                   </a:txBody>
                   <a:tcPr marL="38100" marR="38100" marT="12700" marB="12700" anchor="ctr">
@@ -4176,31 +4405,21 @@
                     <a:bodyPr/>
                     <a:lstStyle/>
                     <a:p>
-                      <a:pPr marL="0" algn="ctr">
-                        <a:buClrTx/>
-                        <a:buSzTx/>
-                        <a:buFontTx/>
+                      <a:pPr algn="ctr" indent="0" marL="0">
                         <a:buNone/>
                       </a:pPr>
                       <a:r>
-                        <a:rPr lang="en-US" sz="700" dirty="0">
+                        <a:rPr lang="en-US" sz="680" dirty="0">
                           <a:solidFill>
                             <a:srgbClr val="1A1F2B"/>
                           </a:solidFill>
-                          <a:latin typeface="Times New Roman" panose="02020503050405090304" pitchFamily="34" charset="0"/>
-                          <a:ea typeface="Arial" panose="020B0604020202090204" pitchFamily="34" charset="-122"/>
-                          <a:cs typeface="Times New Roman" panose="02020503050405090304" pitchFamily="34" charset="0"/>
+                          <a:latin typeface="Arial" pitchFamily="34" charset="0"/>
+                          <a:ea typeface="Arial" pitchFamily="34" charset="-122"/>
+                          <a:cs typeface="Arial" pitchFamily="34" charset="-120"/>
                         </a:rPr>
                         <a:t>Private token releases; no token-level backtracking</a:t>
                       </a:r>
-                      <a:endParaRPr lang="en-US" sz="700" dirty="0">
-                        <a:solidFill>
-                          <a:srgbClr val="1A1F2B"/>
-                        </a:solidFill>
-                        <a:latin typeface="Times New Roman" panose="02020503050405090304" pitchFamily="34" charset="0"/>
-                        <a:ea typeface="Arial" panose="020B0604020202090204" pitchFamily="34" charset="-122"/>
-                        <a:cs typeface="Times New Roman" panose="02020503050405090304" pitchFamily="34" charset="0"/>
-                      </a:endParaRPr>
+                      <a:endParaRPr lang="en-US" sz="1200" dirty="0"/>
                     </a:p>
                   </a:txBody>
                   <a:tcPr marL="38100" marR="38100" marT="12700" marB="12700" anchor="ctr">
@@ -4231,7 +4450,7 @@
                     <a:bodyPr/>
                     <a:lstStyle/>
                     <a:p>
-                      <a:pPr marL="0" indent="0" algn="ctr">
+                      <a:pPr algn="ctr" indent="0" marL="0">
                         <a:buNone/>
                       </a:pPr>
                       <a:r>
@@ -4239,9 +4458,9 @@
                           <a:solidFill>
                             <a:srgbClr val="1A1F2B"/>
                           </a:solidFill>
-                          <a:latin typeface="Arial" panose="020B0604020202090204" pitchFamily="34" charset="0"/>
-                          <a:ea typeface="Arial" panose="020B0604020202090204" pitchFamily="34" charset="-122"/>
-                          <a:cs typeface="Arial" panose="020B0604020202090204" pitchFamily="34" charset="-120"/>
+                          <a:latin typeface="Arial" pitchFamily="34" charset="0"/>
+                          <a:ea typeface="Arial" pitchFamily="34" charset="-122"/>
+                          <a:cs typeface="Arial" pitchFamily="34" charset="-120"/>
                         </a:rPr>
                         <a:t>GSM8K (30 runs)</a:t>
                       </a:r>
@@ -4274,7 +4493,7 @@
                     <a:bodyPr/>
                     <a:lstStyle/>
                     <a:p>
-                      <a:pPr marL="0" indent="0" algn="ctr">
+                      <a:pPr algn="ctr" indent="0" marL="0">
                         <a:buNone/>
                       </a:pPr>
                       <a:r>
@@ -4282,9 +4501,9 @@
                           <a:solidFill>
                             <a:srgbClr val="0E7C7B"/>
                           </a:solidFill>
-                          <a:latin typeface="Arial" panose="020B0604020202090204" pitchFamily="34" charset="0"/>
-                          <a:ea typeface="Arial" panose="020B0604020202090204" pitchFamily="34" charset="-122"/>
-                          <a:cs typeface="Arial" panose="020B0604020202090204" pitchFamily="34" charset="-120"/>
+                          <a:latin typeface="Arial" pitchFamily="34" charset="0"/>
+                          <a:ea typeface="Arial" pitchFamily="34" charset="-122"/>
+                          <a:cs typeface="Arial" pitchFamily="34" charset="-120"/>
                         </a:rPr>
                         <a:t>88.1 ± 3.2%</a:t>
                       </a:r>
@@ -4320,7 +4539,7 @@
                     <a:bodyPr/>
                     <a:lstStyle/>
                     <a:p>
-                      <a:pPr marL="0" indent="0" algn="ctr">
+                      <a:pPr algn="ctr" indent="0" marL="0">
                         <a:buNone/>
                       </a:pPr>
                       <a:r>
@@ -4328,9 +4547,9 @@
                           <a:solidFill>
                             <a:srgbClr val="B23124"/>
                           </a:solidFill>
-                          <a:latin typeface="Arial" panose="020B0604020202090204" pitchFamily="34" charset="0"/>
-                          <a:ea typeface="Arial" panose="020B0604020202090204" pitchFamily="34" charset="-122"/>
-                          <a:cs typeface="Arial" panose="020B0604020202090204" pitchFamily="34" charset="-120"/>
+                          <a:latin typeface="Arial" pitchFamily="34" charset="0"/>
+                          <a:ea typeface="Arial" pitchFamily="34" charset="-122"/>
+                          <a:cs typeface="Arial" pitchFamily="34" charset="-120"/>
                         </a:rPr>
                         <a:t>49.5 ± 28.5%</a:t>
                       </a:r>
@@ -4417,7 +4636,7 @@
     </a:clrScheme>
     <a:fontScheme name="Office">
       <a:majorFont>
-        <a:latin typeface="Calibri Light"/>
+        <a:latin typeface="Calibri Light" panose="020F0302020204030204"/>
         <a:ea typeface=""/>
         <a:cs typeface=""/>
         <a:font script="Jpan" typeface="游ゴシック Light"/>
@@ -4450,9 +4669,26 @@
         <a:font script="Viet" typeface="Times New Roman"/>
         <a:font script="Uigh" typeface="Microsoft Uighur"/>
         <a:font script="Geor" typeface="Sylfaen"/>
+        <a:font script="Armn" typeface="Arial"/>
+        <a:font script="Bugi" typeface="Leelawadee UI"/>
+        <a:font script="Bopo" typeface="Microsoft JhengHei"/>
+        <a:font script="Java" typeface="Javanese Text"/>
+        <a:font script="Lisu" typeface="Segoe UI"/>
+        <a:font script="Mymr" typeface="Myanmar Text"/>
+        <a:font script="Nkoo" typeface="Ebrima"/>
+        <a:font script="Olck" typeface="Nirmala UI"/>
+        <a:font script="Osma" typeface="Ebrima"/>
+        <a:font script="Phag" typeface="Phagspa"/>
+        <a:font script="Syrn" typeface="Estrangelo Edessa"/>
+        <a:font script="Syrj" typeface="Estrangelo Edessa"/>
+        <a:font script="Syre" typeface="Estrangelo Edessa"/>
+        <a:font script="Sora" typeface="Nirmala UI"/>
+        <a:font script="Tale" typeface="Microsoft Tai Le"/>
+        <a:font script="Talu" typeface="Microsoft New Tai Lue"/>
+        <a:font script="Tfng" typeface="Ebrima"/>
       </a:majorFont>
       <a:minorFont>
-        <a:latin typeface="Calibri"/>
+        <a:latin typeface="Calibri" panose="020F0502020204030204"/>
         <a:ea typeface=""/>
         <a:cs typeface=""/>
         <a:font script="Jpan" typeface="游ゴシック"/>
@@ -4485,6 +4721,23 @@
         <a:font script="Viet" typeface="Arial"/>
         <a:font script="Uigh" typeface="Microsoft Uighur"/>
         <a:font script="Geor" typeface="Sylfaen"/>
+        <a:font script="Armn" typeface="Arial"/>
+        <a:font script="Bugi" typeface="Leelawadee UI"/>
+        <a:font script="Bopo" typeface="Microsoft JhengHei"/>
+        <a:font script="Java" typeface="Javanese Text"/>
+        <a:font script="Lisu" typeface="Segoe UI"/>
+        <a:font script="Mymr" typeface="Myanmar Text"/>
+        <a:font script="Nkoo" typeface="Ebrima"/>
+        <a:font script="Olck" typeface="Nirmala UI"/>
+        <a:font script="Osma" typeface="Ebrima"/>
+        <a:font script="Phag" typeface="Phagspa"/>
+        <a:font script="Syrn" typeface="Estrangelo Edessa"/>
+        <a:font script="Syrj" typeface="Estrangelo Edessa"/>
+        <a:font script="Syre" typeface="Estrangelo Edessa"/>
+        <a:font script="Sora" typeface="Nirmala UI"/>
+        <a:font script="Tale" typeface="Microsoft Tai Le"/>
+        <a:font script="Talu" typeface="Microsoft New Tai Lue"/>
+        <a:font script="Tfng" typeface="Ebrima"/>
       </a:minorFont>
     </a:fontScheme>
     <a:fmtScheme name="Office">
@@ -4625,265 +4878,8 @@
       </a:bgFillStyleLst>
     </a:fmtScheme>
   </a:themeElements>
-  <a:extLst>
-    <a:ext uri="{05A4C25C-085E-4340-85A3-A5531E510DB2}">
-      <thm15:themeFamily xmlns:thm15="http://schemas.microsoft.com/office/thememl/2012/main" name="Office Theme" id="{62F939B6-93AF-4DB8-9C6B-D6C7DFDC589F}" vid="{4A3C46E8-61CC-4603-A589-7422A47A8E4A}"/>
-    </a:ext>
-  </a:extLst>
-</a:theme>
-</file>
-
-<file path=ppt/theme/theme2.xml><?xml version="1.0" encoding="utf-8"?>
-<a:theme xmlns:a="http://schemas.openxmlformats.org/drawingml/2006/main" name="Office Theme">
-  <a:themeElements>
-    <a:clrScheme name="Office">
-      <a:dk1>
-        <a:sysClr val="windowText" lastClr="000000"/>
-      </a:dk1>
-      <a:lt1>
-        <a:sysClr val="window" lastClr="FFFFFF"/>
-      </a:lt1>
-      <a:dk2>
-        <a:srgbClr val="44546A"/>
-      </a:dk2>
-      <a:lt2>
-        <a:srgbClr val="E7E6E6"/>
-      </a:lt2>
-      <a:accent1>
-        <a:srgbClr val="4472C4"/>
-      </a:accent1>
-      <a:accent2>
-        <a:srgbClr val="ED7D31"/>
-      </a:accent2>
-      <a:accent3>
-        <a:srgbClr val="A5A5A5"/>
-      </a:accent3>
-      <a:accent4>
-        <a:srgbClr val="FFC000"/>
-      </a:accent4>
-      <a:accent5>
-        <a:srgbClr val="5B9BD5"/>
-      </a:accent5>
-      <a:accent6>
-        <a:srgbClr val="70AD47"/>
-      </a:accent6>
-      <a:hlink>
-        <a:srgbClr val="0563C1"/>
-      </a:hlink>
-      <a:folHlink>
-        <a:srgbClr val="954F72"/>
-      </a:folHlink>
-    </a:clrScheme>
-    <a:fontScheme name="Office">
-      <a:majorFont>
-        <a:latin typeface="Calibri Light"/>
-        <a:ea typeface=""/>
-        <a:cs typeface=""/>
-        <a:font script="Jpan" typeface="游ゴシック Light"/>
-        <a:font script="Hang" typeface="맑은 고딕"/>
-        <a:font script="Hans" typeface="等线 Light"/>
-        <a:font script="Hant" typeface="新細明體"/>
-        <a:font script="Arab" typeface="Times New Roman"/>
-        <a:font script="Hebr" typeface="Times New Roman"/>
-        <a:font script="Thai" typeface="Angsana New"/>
-        <a:font script="Ethi" typeface="Nyala"/>
-        <a:font script="Beng" typeface="Vrinda"/>
-        <a:font script="Gujr" typeface="Shruti"/>
-        <a:font script="Khmr" typeface="MoolBoran"/>
-        <a:font script="Knda" typeface="Tunga"/>
-        <a:font script="Guru" typeface="Raavi"/>
-        <a:font script="Cans" typeface="Euphemia"/>
-        <a:font script="Cher" typeface="Plantagenet Cherokee"/>
-        <a:font script="Yiii" typeface="Microsoft Yi Baiti"/>
-        <a:font script="Tibt" typeface="Microsoft Himalaya"/>
-        <a:font script="Thaa" typeface="MV Boli"/>
-        <a:font script="Deva" typeface="Mangal"/>
-        <a:font script="Telu" typeface="Gautami"/>
-        <a:font script="Taml" typeface="Latha"/>
-        <a:font script="Syrc" typeface="Estrangelo Edessa"/>
-        <a:font script="Orya" typeface="Kalinga"/>
-        <a:font script="Mlym" typeface="Kartika"/>
-        <a:font script="Laoo" typeface="DokChampa"/>
-        <a:font script="Sinh" typeface="Iskoola Pota"/>
-        <a:font script="Mong" typeface="Mongolian Baiti"/>
-        <a:font script="Viet" typeface="Times New Roman"/>
-        <a:font script="Uigh" typeface="Microsoft Uighur"/>
-        <a:font script="Geor" typeface="Sylfaen"/>
-      </a:majorFont>
-      <a:minorFont>
-        <a:latin typeface="Calibri"/>
-        <a:ea typeface=""/>
-        <a:cs typeface=""/>
-        <a:font script="Jpan" typeface="游ゴシック"/>
-        <a:font script="Hang" typeface="맑은 고딕"/>
-        <a:font script="Hans" typeface="等线"/>
-        <a:font script="Hant" typeface="新細明體"/>
-        <a:font script="Arab" typeface="Arial"/>
-        <a:font script="Hebr" typeface="Arial"/>
-        <a:font script="Thai" typeface="Cordia New"/>
-        <a:font script="Ethi" typeface="Nyala"/>
-        <a:font script="Beng" typeface="Vrinda"/>
-        <a:font script="Gujr" typeface="Shruti"/>
-        <a:font script="Khmr" typeface="DaunPenh"/>
-        <a:font script="Knda" typeface="Tunga"/>
-        <a:font script="Guru" typeface="Raavi"/>
-        <a:font script="Cans" typeface="Euphemia"/>
-        <a:font script="Cher" typeface="Plantagenet Cherokee"/>
-        <a:font script="Yiii" typeface="Microsoft Yi Baiti"/>
-        <a:font script="Tibt" typeface="Microsoft Himalaya"/>
-        <a:font script="Thaa" typeface="MV Boli"/>
-        <a:font script="Deva" typeface="Mangal"/>
-        <a:font script="Telu" typeface="Gautami"/>
-        <a:font script="Taml" typeface="Latha"/>
-        <a:font script="Syrc" typeface="Estrangelo Edessa"/>
-        <a:font script="Orya" typeface="Kalinga"/>
-        <a:font script="Mlym" typeface="Kartika"/>
-        <a:font script="Laoo" typeface="DokChampa"/>
-        <a:font script="Sinh" typeface="Iskoola Pota"/>
-        <a:font script="Mong" typeface="Mongolian Baiti"/>
-        <a:font script="Viet" typeface="Arial"/>
-        <a:font script="Uigh" typeface="Microsoft Uighur"/>
-        <a:font script="Geor" typeface="Sylfaen"/>
-      </a:minorFont>
-    </a:fontScheme>
-    <a:fmtScheme name="Office">
-      <a:fillStyleLst>
-        <a:solidFill>
-          <a:schemeClr val="phClr"/>
-        </a:solidFill>
-        <a:gradFill rotWithShape="1">
-          <a:gsLst>
-            <a:gs pos="0">
-              <a:schemeClr val="phClr">
-                <a:lumMod val="110000"/>
-                <a:satMod val="105000"/>
-                <a:tint val="67000"/>
-              </a:schemeClr>
-            </a:gs>
-            <a:gs pos="50000">
-              <a:schemeClr val="phClr">
-                <a:lumMod val="105000"/>
-                <a:satMod val="103000"/>
-                <a:tint val="73000"/>
-              </a:schemeClr>
-            </a:gs>
-            <a:gs pos="100000">
-              <a:schemeClr val="phClr">
-                <a:lumMod val="105000"/>
-                <a:satMod val="109000"/>
-                <a:tint val="81000"/>
-              </a:schemeClr>
-            </a:gs>
-          </a:gsLst>
-          <a:lin ang="5400000" scaled="0"/>
-        </a:gradFill>
-        <a:gradFill rotWithShape="1">
-          <a:gsLst>
-            <a:gs pos="0">
-              <a:schemeClr val="phClr">
-                <a:satMod val="103000"/>
-                <a:lumMod val="102000"/>
-                <a:tint val="94000"/>
-              </a:schemeClr>
-            </a:gs>
-            <a:gs pos="50000">
-              <a:schemeClr val="phClr">
-                <a:satMod val="110000"/>
-                <a:lumMod val="100000"/>
-                <a:shade val="100000"/>
-              </a:schemeClr>
-            </a:gs>
-            <a:gs pos="100000">
-              <a:schemeClr val="phClr">
-                <a:lumMod val="99000"/>
-                <a:satMod val="120000"/>
-                <a:shade val="78000"/>
-              </a:schemeClr>
-            </a:gs>
-          </a:gsLst>
-          <a:lin ang="5400000" scaled="0"/>
-        </a:gradFill>
-      </a:fillStyleLst>
-      <a:lnStyleLst>
-        <a:ln w="6350" cap="flat" cmpd="sng" algn="ctr">
-          <a:solidFill>
-            <a:schemeClr val="phClr"/>
-          </a:solidFill>
-          <a:prstDash val="solid"/>
-          <a:miter lim="800000"/>
-        </a:ln>
-        <a:ln w="12700" cap="flat" cmpd="sng" algn="ctr">
-          <a:solidFill>
-            <a:schemeClr val="phClr"/>
-          </a:solidFill>
-          <a:prstDash val="solid"/>
-          <a:miter lim="800000"/>
-        </a:ln>
-        <a:ln w="19050" cap="flat" cmpd="sng" algn="ctr">
-          <a:solidFill>
-            <a:schemeClr val="phClr"/>
-          </a:solidFill>
-          <a:prstDash val="solid"/>
-          <a:miter lim="800000"/>
-        </a:ln>
-      </a:lnStyleLst>
-      <a:effectStyleLst>
-        <a:effectStyle>
-          <a:effectLst/>
-        </a:effectStyle>
-        <a:effectStyle>
-          <a:effectLst/>
-        </a:effectStyle>
-        <a:effectStyle>
-          <a:effectLst>
-            <a:outerShdw blurRad="57150" dist="19050" dir="5400000" algn="ctr" rotWithShape="0">
-              <a:srgbClr val="000000">
-                <a:alpha val="63000"/>
-              </a:srgbClr>
-            </a:outerShdw>
-          </a:effectLst>
-        </a:effectStyle>
-      </a:effectStyleLst>
-      <a:bgFillStyleLst>
-        <a:solidFill>
-          <a:schemeClr val="phClr"/>
-        </a:solidFill>
-        <a:solidFill>
-          <a:schemeClr val="phClr">
-            <a:tint val="95000"/>
-            <a:satMod val="170000"/>
-          </a:schemeClr>
-        </a:solidFill>
-        <a:gradFill rotWithShape="1">
-          <a:gsLst>
-            <a:gs pos="0">
-              <a:schemeClr val="phClr">
-                <a:tint val="93000"/>
-                <a:satMod val="150000"/>
-                <a:shade val="98000"/>
-                <a:lumMod val="102000"/>
-              </a:schemeClr>
-            </a:gs>
-            <a:gs pos="50000">
-              <a:schemeClr val="phClr">
-                <a:tint val="98000"/>
-                <a:satMod val="130000"/>
-                <a:shade val="90000"/>
-                <a:lumMod val="103000"/>
-              </a:schemeClr>
-            </a:gs>
-            <a:gs pos="100000">
-              <a:schemeClr val="phClr">
-                <a:shade val="63000"/>
-                <a:satMod val="120000"/>
-              </a:schemeClr>
-            </a:gs>
-          </a:gsLst>
-          <a:lin ang="5400000" scaled="0"/>
-        </a:gradFill>
-      </a:bgFillStyleLst>
-    </a:fmtScheme>
-  </a:themeElements>
+  <a:objectDefaults/>
+  <a:extraClrSchemeLst/>
   <a:extLst>
     <a:ext uri="{05A4C25C-085E-4340-85A3-A5531E510DB2}">
       <thm15:themeFamily xmlns:thm15="http://schemas.microsoft.com/office/thememl/2012/main" name="Office Theme" id="{62F939B6-93AF-4DB8-9C6B-D6C7DFDC589F}" vid="{4A3C46E8-61CC-4603-A589-7422A47A8E4A}"/>

</xml_diff>

<commit_message>
Update Figure 1 typography and diversity label placement
</commit_message>
<xml_diff>
--- a/paper/figures/DPES_Figure1_v2_editable.pptx
+++ b/paper/figures/DPES_Figure1_v2_editable.pptx
@@ -1,17 +1,17 @@
 
 <file path=ppt/presentation.xml><?xml version="1.0" encoding="utf-8"?>
-<p:presentation xmlns:a="http://schemas.openxmlformats.org/drawingml/2006/main" xmlns:r="http://schemas.openxmlformats.org/officeDocument/2006/relationships" xmlns:p="http://schemas.openxmlformats.org/presentationml/2006/main" saveSubsetFonts="1" autoCompressPictures="0">
+<p:presentation xmlns:a="http://schemas.openxmlformats.org/drawingml/2006/main" xmlns:r="http://schemas.openxmlformats.org/officeDocument/2006/relationships" xmlns:p="http://schemas.openxmlformats.org/presentationml/2006/main" autoCompressPictures="0">
   <p:sldMasterIdLst>
     <p:sldMasterId id="2147483648" r:id="rId1"/>
   </p:sldMasterIdLst>
+  <p:notesMasterIdLst>
+    <p:notesMasterId r:id="rId4"/>
+  </p:notesMasterIdLst>
   <p:sldIdLst>
-    <p:sldId id="256" r:id="rId2"/>
+    <p:sldId id="256" r:id="rId3"/>
   </p:sldIdLst>
-  <p:notesMasterIdLst>
-    <p:notesMasterId r:id="rId3"/>
-  </p:notesMasterIdLst>
-  <p:sldSz cx="5760720" cy="4453128"/>
-  <p:notesSz cx="4453128" cy="5760720"/>
+  <p:sldSz cx="5760720" cy="4452620"/>
+  <p:notesSz cx="4452620" cy="5760720"/>
   <p:defaultTextStyle>
     <a:lvl1pPr marL="0" algn="l" defTabSz="914400" rtl="0" eaLnBrk="1" latinLnBrk="0" hangingPunct="1">
       <a:defRPr sz="1800" kern="1200">
@@ -189,7 +189,6 @@
           <a:p>
             <a:fld id="{5282F153-3F37-0F45-9E97-73ACFA13230C}" type="datetimeFigureOut">
               <a:rPr lang="en-US"/>
-              <a:t>7/23/19</a:t>
             </a:fld>
             <a:endParaRPr lang="en-US"/>
           </a:p>
@@ -256,6 +255,7 @@
               <a:rPr lang="en-US"/>
               <a:t>Click to edit Master text styles</a:t>
             </a:r>
+            <a:endParaRPr lang="en-US"/>
           </a:p>
           <a:p>
             <a:pPr lvl="1"/>
@@ -263,6 +263,7 @@
               <a:rPr lang="en-US"/>
               <a:t>Second level</a:t>
             </a:r>
+            <a:endParaRPr lang="en-US"/>
           </a:p>
           <a:p>
             <a:pPr lvl="2"/>
@@ -270,6 +271,7 @@
               <a:rPr lang="en-US"/>
               <a:t>Third level</a:t>
             </a:r>
+            <a:endParaRPr lang="en-US"/>
           </a:p>
           <a:p>
             <a:pPr lvl="3"/>
@@ -277,6 +279,7 @@
               <a:rPr lang="en-US"/>
               <a:t>Fourth level</a:t>
             </a:r>
+            <a:endParaRPr lang="en-US"/>
           </a:p>
           <a:p>
             <a:pPr lvl="4"/>
@@ -284,6 +287,7 @@
               <a:rPr lang="en-US"/>
               <a:t>Fifth level</a:t>
             </a:r>
+            <a:endParaRPr lang="en-US"/>
           </a:p>
         </p:txBody>
       </p:sp>
@@ -347,18 +351,12 @@
           <a:p>
             <a:fld id="{CE5E9CC1-C706-0F49-92D6-E571CC5EEA8F}" type="slidenum">
               <a:rPr lang="en-US"/>
-              <a:t>‹#›</a:t>
             </a:fld>
             <a:endParaRPr lang="en-US"/>
           </a:p>
         </p:txBody>
       </p:sp>
     </p:spTree>
-    <p:extLst>
-      <p:ext uri="{BB962C8B-B14F-4D97-AF65-F5344CB8AC3E}">
-        <p14:creationId xmlns:p14="http://schemas.microsoft.com/office/powerpoint/2010/main" val="1024086991"/>
-      </p:ext>
-    </p:extLst>
   </p:cSld>
   <p:clrMap bg1="lt1" tx1="dk1" bg2="lt2" tx2="dk2" accent1="accent1" accent2="accent2" accent3="accent3" accent4="accent4" accent5="accent5" accent6="accent6" hlink="hlink" folHlink="folHlink"/>
   <p:notesStyle>
@@ -500,10 +498,6 @@
           <a:bodyPr/>
           <a:lstStyle/>
           <a:p>
-            <a:r>
-              <a:rPr lang="en-US" dirty="0"/>
-              <a:t/>
-            </a:r>
             <a:endParaRPr lang="en-US" dirty="0"/>
           </a:p>
         </p:txBody>
@@ -525,18 +519,12 @@
           <a:p>
             <a:fld id="{F7021451-1387-4CA6-816F-3879F97B5CBC}" type="slidenum">
               <a:rPr lang="en-US"/>
-              <a:t>1</a:t>
             </a:fld>
             <a:endParaRPr lang="en-US"/>
           </a:p>
         </p:txBody>
       </p:sp>
     </p:spTree>
-    <p:extLst>
-      <p:ext uri="{BB962C8B-B14F-4D97-AF65-F5344CB8AC3E}">
-        <p14:creationId xmlns:p14="http://schemas.microsoft.com/office/powerpoint/2010/main" val="1024086991"/>
-      </p:ext>
-    </p:extLst>
   </p:cSld>
   <p:clrMapOvr>
     <a:masterClrMapping/>
@@ -577,6 +565,11 @@
 <file path=ppt/slideMasters/slideMaster1.xml><?xml version="1.0" encoding="utf-8"?>
 <p:sldMaster xmlns:a="http://schemas.openxmlformats.org/drawingml/2006/main" xmlns:r="http://schemas.openxmlformats.org/officeDocument/2006/relationships" xmlns:p="http://schemas.openxmlformats.org/presentationml/2006/main">
   <p:cSld>
+    <p:bg>
+      <p:bgRef idx="1001">
+        <a:schemeClr val="bg1"/>
+      </p:bgRef>
+    </p:bg>
     <p:spTree>
       <p:nvGrpSpPr>
         <p:cNvPr id="1" name=""/>
@@ -620,7 +613,7 @@
         <a:spcBef>
           <a:spcPct val="20000"/>
         </a:spcBef>
-        <a:buFont typeface="Arial" pitchFamily="34" charset="0"/>
+        <a:buFont typeface="Arial" panose="020B0604020202090204" pitchFamily="34" charset="0"/>
         <a:buChar char="•"/>
         <a:defRPr sz="3200" kern="1200">
           <a:solidFill>
@@ -635,7 +628,7 @@
         <a:spcBef>
           <a:spcPct val="20000"/>
         </a:spcBef>
-        <a:buFont typeface="Arial" pitchFamily="34" charset="0"/>
+        <a:buFont typeface="Arial" panose="020B0604020202090204" pitchFamily="34" charset="0"/>
         <a:buChar char="–"/>
         <a:defRPr sz="2800" kern="1200">
           <a:solidFill>
@@ -650,7 +643,7 @@
         <a:spcBef>
           <a:spcPct val="20000"/>
         </a:spcBef>
-        <a:buFont typeface="Arial" pitchFamily="34" charset="0"/>
+        <a:buFont typeface="Arial" panose="020B0604020202090204" pitchFamily="34" charset="0"/>
         <a:buChar char="•"/>
         <a:defRPr sz="2400" kern="1200">
           <a:solidFill>
@@ -665,7 +658,7 @@
         <a:spcBef>
           <a:spcPct val="20000"/>
         </a:spcBef>
-        <a:buFont typeface="Arial" pitchFamily="34" charset="0"/>
+        <a:buFont typeface="Arial" panose="020B0604020202090204" pitchFamily="34" charset="0"/>
         <a:buChar char="–"/>
         <a:defRPr sz="2000" kern="1200">
           <a:solidFill>
@@ -680,7 +673,7 @@
         <a:spcBef>
           <a:spcPct val="20000"/>
         </a:spcBef>
-        <a:buFont typeface="Arial" pitchFamily="34" charset="0"/>
+        <a:buFont typeface="Arial" panose="020B0604020202090204" pitchFamily="34" charset="0"/>
         <a:buChar char="»"/>
         <a:defRPr sz="2000" kern="1200">
           <a:solidFill>
@@ -695,7 +688,7 @@
         <a:spcBef>
           <a:spcPct val="20000"/>
         </a:spcBef>
-        <a:buFont typeface="Arial" pitchFamily="34" charset="0"/>
+        <a:buFont typeface="Arial" panose="020B0604020202090204" pitchFamily="34" charset="0"/>
         <a:buChar char="•"/>
         <a:defRPr sz="2000" kern="1200">
           <a:solidFill>
@@ -710,7 +703,7 @@
         <a:spcBef>
           <a:spcPct val="20000"/>
         </a:spcBef>
-        <a:buFont typeface="Arial" pitchFamily="34" charset="0"/>
+        <a:buFont typeface="Arial" panose="020B0604020202090204" pitchFamily="34" charset="0"/>
         <a:buChar char="•"/>
         <a:defRPr sz="2000" kern="1200">
           <a:solidFill>
@@ -725,7 +718,7 @@
         <a:spcBef>
           <a:spcPct val="20000"/>
         </a:spcBef>
-        <a:buFont typeface="Arial" pitchFamily="34" charset="0"/>
+        <a:buFont typeface="Arial" panose="020B0604020202090204" pitchFamily="34" charset="0"/>
         <a:buChar char="•"/>
         <a:defRPr sz="2000" kern="1200">
           <a:solidFill>
@@ -740,7 +733,7 @@
         <a:spcBef>
           <a:spcPct val="20000"/>
         </a:spcBef>
-        <a:buFont typeface="Arial" pitchFamily="34" charset="0"/>
+        <a:buFont typeface="Arial" panose="020B0604020202090204" pitchFamily="34" charset="0"/>
         <a:buChar char="•"/>
         <a:defRPr sz="2000" kern="1200">
           <a:solidFill>
@@ -853,12 +846,13 @@
 
 <file path=ppt/slides/slide1.xml><?xml version="1.0" encoding="utf-8"?>
 <p:sld xmlns:a="http://schemas.openxmlformats.org/drawingml/2006/main" xmlns:r="http://schemas.openxmlformats.org/officeDocument/2006/relationships" xmlns:p="http://schemas.openxmlformats.org/presentationml/2006/main">
-  <p:cSld name="Slide 1">
+  <p:cSld>
     <p:bg>
       <p:bgPr>
         <a:solidFill>
           <a:srgbClr val="FFFFFF"/>
         </a:solidFill>
+        <a:effectLst/>
       </p:bgPr>
     </p:bg>
     <p:spTree>
@@ -890,13 +884,12 @@
             <a:avLst/>
           </a:prstGeom>
           <a:noFill/>
-          <a:ln/>
         </p:spPr>
         <p:txBody>
           <a:bodyPr wrap="square" lIns="0" tIns="0" rIns="0" bIns="0" rtlCol="0" anchor="t"/>
           <a:lstStyle/>
           <a:p>
-            <a:pPr algn="l" indent="0" marL="0">
+            <a:pPr marL="0" indent="0" algn="l">
               <a:lnSpc>
                 <a:spcPct val="100000"/>
               </a:lnSpc>
@@ -907,47 +900,38 @@
                 <a:solidFill>
                   <a:srgbClr val="1A1F2B"/>
                 </a:solidFill>
-                <a:latin typeface="Arial" pitchFamily="34" charset="0"/>
-                <a:ea typeface="Arial" pitchFamily="34" charset="-122"/>
-                <a:cs typeface="Arial" pitchFamily="34" charset="-120"/>
+                <a:latin typeface="Comic Sans MS Bold" panose="030F0902030302020204" charset="0"/>
+                <a:ea typeface="Arial" panose="020B0604020202090204" pitchFamily="34" charset="-122"/>
+                <a:cs typeface="Comic Sans MS Bold" panose="030F0902030302020204" charset="0"/>
               </a:rPr>
               <a:t>(a)   One </a:t>
             </a:r>
-            <a:pPr algn="l" indent="0" marL="0">
-              <a:lnSpc>
-                <a:spcPct val="100000"/>
-              </a:lnSpc>
-              <a:buNone/>
-            </a:pPr>
+            <a:r>
+              <a:rPr lang="en-US" sz="900" dirty="0">
+                <a:solidFill>
+                  <a:srgbClr val="1A1F2B"/>
+                </a:solidFill>
+                <a:latin typeface="Comic Sans MS Bold" panose="030F0902030302020204" charset="0"/>
+                <a:ea typeface="Arial" panose="020B0604020202090204" pitchFamily="34" charset="-122"/>
+                <a:cs typeface="Comic Sans MS Bold" panose="030F0902030302020204" charset="0"/>
+              </a:rPr>
+              <a:t>DP-ES iter</a:t>
+            </a:r>
             <a:r>
               <a:rPr lang="en-US" sz="900" b="1" dirty="0">
                 <a:solidFill>
                   <a:srgbClr val="1A1F2B"/>
                 </a:solidFill>
-                <a:latin typeface="Arial" pitchFamily="34" charset="0"/>
-                <a:ea typeface="Arial" pitchFamily="34" charset="-122"/>
-                <a:cs typeface="Arial" pitchFamily="34" charset="-120"/>
-              </a:rPr>
-              <a:t>DP-ES</a:t>
-            </a:r>
-            <a:pPr algn="l" indent="0" marL="0">
-              <a:lnSpc>
-                <a:spcPct val="100000"/>
-              </a:lnSpc>
-              <a:buNone/>
-            </a:pPr>
-            <a:r>
-              <a:rPr lang="en-US" sz="900" b="1" dirty="0">
-                <a:solidFill>
-                  <a:srgbClr val="1A1F2B"/>
-                </a:solidFill>
-                <a:latin typeface="Arial" pitchFamily="34" charset="0"/>
-                <a:ea typeface="Arial" pitchFamily="34" charset="-122"/>
-                <a:cs typeface="Arial" pitchFamily="34" charset="-120"/>
-              </a:rPr>
-              <a:t> iteration: privacy-free exploration, private scoring</a:t>
-            </a:r>
-            <a:endParaRPr lang="en-US" sz="900" dirty="0"/>
+                <a:latin typeface="Comic Sans MS Bold" panose="030F0902030302020204" charset="0"/>
+                <a:ea typeface="Arial" panose="020B0604020202090204" pitchFamily="34" charset="-122"/>
+                <a:cs typeface="Comic Sans MS Bold" panose="030F0902030302020204" charset="0"/>
+              </a:rPr>
+              <a:t>ation: privacy-free exploration, private scoring</a:t>
+            </a:r>
+            <a:endParaRPr lang="en-US" sz="900" dirty="0">
+              <a:latin typeface="Comic Sans MS Bold" panose="030F0902030302020204" charset="0"/>
+              <a:cs typeface="Comic Sans MS Bold" panose="030F0902030302020204" charset="0"/>
+            </a:endParaRPr>
           </a:p>
         </p:txBody>
       </p:sp>
@@ -1057,122 +1041,76 @@
         </p:nvSpPr>
         <p:spPr>
           <a:xfrm>
-            <a:off x="1691640" y="315468"/>
+            <a:off x="1691640" y="307848"/>
             <a:ext cx="2377440" cy="118872"/>
           </a:xfrm>
           <a:prstGeom prst="rect">
             <a:avLst/>
           </a:prstGeom>
           <a:noFill/>
-          <a:ln/>
         </p:spPr>
         <p:txBody>
           <a:bodyPr wrap="square" lIns="0" tIns="0" rIns="0" bIns="0" rtlCol="0" anchor="t"/>
           <a:lstStyle/>
           <a:p>
-            <a:pPr algn="ctr" indent="0" marL="0">
+            <a:pPr marL="0" indent="0" algn="ctr">
               <a:lnSpc>
                 <a:spcPct val="100000"/>
               </a:lnSpc>
               <a:buNone/>
             </a:pPr>
             <a:r>
-              <a:rPr lang="en-US" sz="680" b="1" dirty="0">
+              <a:rPr lang="en-US" sz="700" b="1" dirty="0">
                 <a:solidFill>
                   <a:srgbClr val="1F3D7A"/>
                 </a:solidFill>
-                <a:latin typeface="Arial" pitchFamily="34" charset="0"/>
-                <a:ea typeface="Arial" pitchFamily="34" charset="-122"/>
-                <a:cs typeface="Arial" pitchFamily="34" charset="-120"/>
-              </a:rPr>
-              <a:t>Top-M parents  </a:t>
-            </a:r>
-            <a:pPr algn="ctr" indent="0" marL="0">
-              <a:lnSpc>
-                <a:spcPct val="100000"/>
-              </a:lnSpc>
-              <a:buNone/>
-            </a:pPr>
-            <a:r>
-              <a:rPr lang="en-US" sz="680" b="1" i="1" dirty="0">
+                <a:latin typeface="Comic Sans MS" panose="030F0902030302020204" charset="0"/>
+                <a:ea typeface="Arial" panose="020B0604020202090204" pitchFamily="34" charset="-122"/>
+                <a:cs typeface="Comic Sans MS" panose="030F0902030302020204" charset="0"/>
+              </a:rPr>
+              <a:t>Top-M parents  S</a:t>
+            </a:r>
+            <a:r>
+              <a:rPr lang="en-US" sz="700" b="1" baseline="-40000" dirty="0">
                 <a:solidFill>
                   <a:srgbClr val="1F3D7A"/>
                 </a:solidFill>
-                <a:latin typeface="Arial" pitchFamily="34" charset="0"/>
-                <a:ea typeface="Arial" pitchFamily="34" charset="-122"/>
-                <a:cs typeface="Arial" pitchFamily="34" charset="-120"/>
-              </a:rPr>
-              <a:t>S</a:t>
-            </a:r>
-            <a:pPr algn="ctr" indent="0" marL="0">
-              <a:lnSpc>
-                <a:spcPct val="100000"/>
-              </a:lnSpc>
-              <a:buNone/>
-            </a:pPr>
-            <a:r>
-              <a:rPr lang="en-US" sz="680" b="1" baseline="-40000" dirty="0">
+                <a:latin typeface="Comic Sans MS" panose="030F0902030302020204" charset="0"/>
+                <a:ea typeface="Arial" panose="020B0604020202090204" pitchFamily="34" charset="-122"/>
+                <a:cs typeface="Comic Sans MS" panose="030F0902030302020204" charset="0"/>
+              </a:rPr>
+              <a:t>t</a:t>
+            </a:r>
+            <a:r>
+              <a:rPr lang="en-US" sz="700" b="1" dirty="0">
                 <a:solidFill>
                   <a:srgbClr val="1F3D7A"/>
                 </a:solidFill>
-                <a:latin typeface="Arial" pitchFamily="34" charset="0"/>
-                <a:ea typeface="Arial" pitchFamily="34" charset="-122"/>
-                <a:cs typeface="Arial" pitchFamily="34" charset="-120"/>
-              </a:rPr>
-              <a:t>t</a:t>
-            </a:r>
-            <a:pPr algn="ctr" indent="0" marL="0">
-              <a:lnSpc>
-                <a:spcPct val="100000"/>
-              </a:lnSpc>
-              <a:buNone/>
-            </a:pPr>
-            <a:r>
-              <a:rPr lang="en-US" sz="680" b="1" dirty="0">
+                <a:latin typeface="Comic Sans MS" panose="030F0902030302020204" charset="0"/>
+                <a:ea typeface="Arial" panose="020B0604020202090204" pitchFamily="34" charset="-122"/>
+                <a:cs typeface="Comic Sans MS" panose="030F0902030302020204" charset="0"/>
+              </a:rPr>
+              <a:t>  →</a:t>
+            </a:r>
+            <a:r>
+              <a:rPr lang="en-US" sz="700" b="1" dirty="0">
                 <a:solidFill>
                   <a:srgbClr val="1F3D7A"/>
                 </a:solidFill>
-                <a:latin typeface="Arial" pitchFamily="34" charset="0"/>
-                <a:ea typeface="Arial" pitchFamily="34" charset="-122"/>
-                <a:cs typeface="Arial" pitchFamily="34" charset="-120"/>
-              </a:rPr>
-              <a:t>  →  next iteration  (× </a:t>
-            </a:r>
-            <a:pPr algn="ctr" indent="0" marL="0">
-              <a:lnSpc>
-                <a:spcPct val="100000"/>
-              </a:lnSpc>
-              <a:buNone/>
-            </a:pPr>
-            <a:r>
-              <a:rPr lang="en-US" sz="680" b="1" i="1" dirty="0">
-                <a:solidFill>
-                  <a:srgbClr val="1F3D7A"/>
-                </a:solidFill>
-                <a:latin typeface="Arial" pitchFamily="34" charset="0"/>
-                <a:ea typeface="Arial" pitchFamily="34" charset="-122"/>
-                <a:cs typeface="Arial" pitchFamily="34" charset="-120"/>
-              </a:rPr>
-              <a:t>T</a:t>
-            </a:r>
-            <a:pPr algn="ctr" indent="0" marL="0">
-              <a:lnSpc>
-                <a:spcPct val="100000"/>
-              </a:lnSpc>
-              <a:buNone/>
-            </a:pPr>
-            <a:r>
-              <a:rPr lang="en-US" sz="680" b="1" dirty="0">
-                <a:solidFill>
-                  <a:srgbClr val="1F3D7A"/>
-                </a:solidFill>
-                <a:latin typeface="Arial" pitchFamily="34" charset="0"/>
-                <a:ea typeface="Arial" pitchFamily="34" charset="-122"/>
-                <a:cs typeface="Arial" pitchFamily="34" charset="-120"/>
-              </a:rPr>
-              <a:t>)</a:t>
-            </a:r>
-            <a:endParaRPr lang="en-US" sz="680" dirty="0"/>
+                <a:latin typeface="Comic Sans MS" panose="030F0902030302020204" charset="0"/>
+                <a:ea typeface="Arial" panose="020B0604020202090204" pitchFamily="34" charset="-122"/>
+                <a:cs typeface="Comic Sans MS" panose="030F0902030302020204" charset="0"/>
+              </a:rPr>
+              <a:t>  next iteration  (× T )</a:t>
+            </a:r>
+            <a:endParaRPr lang="en-US" sz="700" b="1" dirty="0">
+              <a:solidFill>
+                <a:srgbClr val="1F3D7A"/>
+              </a:solidFill>
+              <a:latin typeface="Comic Sans MS" panose="030F0902030302020204" charset="0"/>
+              <a:ea typeface="Arial" panose="020B0604020202090204" pitchFamily="34" charset="-122"/>
+              <a:cs typeface="Comic Sans MS" panose="030F0902030302020204" charset="0"/>
+            </a:endParaRPr>
           </a:p>
         </p:txBody>
       </p:sp>
@@ -1218,30 +1156,36 @@
             <a:avLst/>
           </a:prstGeom>
           <a:noFill/>
-          <a:ln/>
         </p:spPr>
         <p:txBody>
           <a:bodyPr wrap="square" lIns="0" tIns="0" rIns="0" bIns="0" rtlCol="0" anchor="t"/>
           <a:lstStyle/>
           <a:p>
-            <a:pPr algn="ctr" indent="0" marL="0">
+            <a:pPr marL="0" indent="0" algn="ctr">
               <a:lnSpc>
                 <a:spcPct val="100000"/>
               </a:lnSpc>
               <a:buNone/>
             </a:pPr>
             <a:r>
-              <a:rPr lang="en-US" sz="760" b="1" spc="35" kern="0" dirty="0">
+              <a:rPr lang="en-US" sz="760" b="1" kern="0" spc="35" dirty="0">
                 <a:solidFill>
                   <a:srgbClr val="0E7C7B"/>
                 </a:solidFill>
-                <a:latin typeface="Arial" pitchFamily="34" charset="0"/>
-                <a:ea typeface="Arial" pitchFamily="34" charset="-122"/>
-                <a:cs typeface="Arial" pitchFamily="34" charset="-120"/>
+                <a:latin typeface="Comic Sans MS" panose="030F0902030302020204" charset="0"/>
+                <a:ea typeface="Arial" panose="020B0604020202090204" pitchFamily="34" charset="-122"/>
+                <a:cs typeface="Comic Sans MS" panose="030F0902030302020204" charset="0"/>
               </a:rPr>
               <a:t>PRIVACY-FREE</a:t>
             </a:r>
-            <a:endParaRPr lang="en-US" sz="760" dirty="0"/>
+            <a:endParaRPr lang="en-US" sz="760" b="1" kern="0" spc="35" dirty="0">
+              <a:solidFill>
+                <a:srgbClr val="0E7C7B"/>
+              </a:solidFill>
+              <a:latin typeface="Comic Sans MS" panose="030F0902030302020204" charset="0"/>
+              <a:ea typeface="Arial" panose="020B0604020202090204" pitchFamily="34" charset="-122"/>
+              <a:cs typeface="Comic Sans MS" panose="030F0902030302020204" charset="0"/>
+            </a:endParaRPr>
           </a:p>
         </p:txBody>
       </p:sp>
@@ -1287,30 +1231,36 @@
             <a:avLst/>
           </a:prstGeom>
           <a:noFill/>
-          <a:ln/>
         </p:spPr>
         <p:txBody>
           <a:bodyPr wrap="square" lIns="0" tIns="0" rIns="0" bIns="0" rtlCol="0" anchor="t"/>
           <a:lstStyle/>
           <a:p>
-            <a:pPr algn="ctr" indent="0" marL="0">
+            <a:pPr marL="0" indent="0" algn="ctr">
               <a:lnSpc>
                 <a:spcPct val="100000"/>
               </a:lnSpc>
               <a:buNone/>
             </a:pPr>
             <a:r>
-              <a:rPr lang="en-US" sz="760" b="1" spc="35" kern="0" dirty="0">
+              <a:rPr lang="en-US" sz="760" b="1" kern="0" spc="35" dirty="0">
                 <a:solidFill>
                   <a:srgbClr val="1F3D7A"/>
                 </a:solidFill>
-                <a:latin typeface="Arial" pitchFamily="34" charset="0"/>
-                <a:ea typeface="Arial" pitchFamily="34" charset="-122"/>
-                <a:cs typeface="Arial" pitchFamily="34" charset="-120"/>
+                <a:latin typeface="Comic Sans MS" panose="030F0902030302020204" charset="0"/>
+                <a:ea typeface="Arial" panose="020B0604020202090204" pitchFamily="34" charset="-122"/>
+                <a:cs typeface="Comic Sans MS" panose="030F0902030302020204" charset="0"/>
               </a:rPr>
               <a:t>PRIVATE-DATA ACCESS</a:t>
             </a:r>
-            <a:endParaRPr lang="en-US" sz="760" dirty="0"/>
+            <a:endParaRPr lang="en-US" sz="760" b="1" kern="0" spc="35" dirty="0">
+              <a:solidFill>
+                <a:srgbClr val="1F3D7A"/>
+              </a:solidFill>
+              <a:latin typeface="Comic Sans MS" panose="030F0902030302020204" charset="0"/>
+              <a:ea typeface="Arial" panose="020B0604020202090204" pitchFamily="34" charset="-122"/>
+              <a:cs typeface="Comic Sans MS" panose="030F0902030302020204" charset="0"/>
+            </a:endParaRPr>
           </a:p>
         </p:txBody>
       </p:sp>
@@ -1356,30 +1306,36 @@
             <a:avLst/>
           </a:prstGeom>
           <a:noFill/>
-          <a:ln/>
         </p:spPr>
         <p:txBody>
           <a:bodyPr wrap="square" lIns="0" tIns="0" rIns="0" bIns="0" rtlCol="0" anchor="t"/>
           <a:lstStyle/>
           <a:p>
-            <a:pPr algn="ctr" indent="0" marL="0">
+            <a:pPr marL="0" indent="0" algn="ctr">
               <a:lnSpc>
                 <a:spcPct val="100000"/>
               </a:lnSpc>
               <a:buNone/>
             </a:pPr>
             <a:r>
-              <a:rPr lang="en-US" sz="760" b="1" spc="35" kern="0" dirty="0">
+              <a:rPr lang="en-US" sz="760" b="1" kern="0" spc="35" dirty="0">
                 <a:solidFill>
                   <a:srgbClr val="2E7D32"/>
                 </a:solidFill>
-                <a:latin typeface="Arial" pitchFamily="34" charset="0"/>
-                <a:ea typeface="Arial" pitchFamily="34" charset="-122"/>
-                <a:cs typeface="Arial" pitchFamily="34" charset="-120"/>
+                <a:latin typeface="Comic Sans MS" panose="030F0902030302020204" charset="0"/>
+                <a:ea typeface="Arial" panose="020B0604020202090204" pitchFamily="34" charset="-122"/>
+                <a:cs typeface="Comic Sans MS" panose="030F0902030302020204" charset="0"/>
               </a:rPr>
               <a:t>POST-PROCESSING</a:t>
             </a:r>
-            <a:endParaRPr lang="en-US" sz="760" dirty="0"/>
+            <a:endParaRPr lang="en-US" sz="760" b="1" kern="0" spc="35" dirty="0">
+              <a:solidFill>
+                <a:srgbClr val="2E7D32"/>
+              </a:solidFill>
+              <a:latin typeface="Comic Sans MS" panose="030F0902030302020204" charset="0"/>
+              <a:ea typeface="Arial" panose="020B0604020202090204" pitchFamily="34" charset="-122"/>
+              <a:cs typeface="Comic Sans MS" panose="030F0902030302020204" charset="0"/>
+            </a:endParaRPr>
           </a:p>
         </p:txBody>
       </p:sp>
@@ -1427,7 +1383,6 @@
           <a:solidFill>
             <a:srgbClr val="0E7C7B"/>
           </a:solidFill>
-          <a:ln/>
         </p:spPr>
       </p:sp>
       <p:sp>
@@ -1567,13 +1522,12 @@
             <a:avLst/>
           </a:prstGeom>
           <a:noFill/>
-          <a:ln/>
         </p:spPr>
         <p:txBody>
           <a:bodyPr wrap="square" lIns="0" tIns="0" rIns="0" bIns="0" rtlCol="0" anchor="ctr"/>
           <a:lstStyle/>
           <a:p>
-            <a:pPr algn="ctr" indent="0" marL="0">
+            <a:pPr marL="0" indent="0" algn="ctr">
               <a:lnSpc>
                 <a:spcPct val="104000"/>
               </a:lnSpc>
@@ -1584,16 +1538,19 @@
                 <a:solidFill>
                   <a:srgbClr val="0E7C7B"/>
                 </a:solidFill>
-                <a:latin typeface="Arial" pitchFamily="34" charset="0"/>
-                <a:ea typeface="Arial" pitchFamily="34" charset="-122"/>
-                <a:cs typeface="Arial" pitchFamily="34" charset="-120"/>
+                <a:latin typeface="Comic Sans MS Regular" panose="030F0902030302020204" charset="0"/>
+                <a:ea typeface="Arial" panose="020B0604020202090204" pitchFamily="34" charset="-122"/>
+                <a:cs typeface="Comic Sans MS Regular" panose="030F0902030302020204" charset="0"/>
               </a:rPr>
               <a:t>Phase 1</a:t>
             </a:r>
-            <a:endParaRPr lang="en-US" sz="780" dirty="0"/>
+            <a:endParaRPr lang="en-US" sz="780" dirty="0">
+              <a:latin typeface="Comic Sans MS Regular" panose="030F0902030302020204" charset="0"/>
+              <a:cs typeface="Comic Sans MS Regular" panose="030F0902030302020204" charset="0"/>
+            </a:endParaRPr>
           </a:p>
           <a:p>
-            <a:pPr algn="ctr" indent="0" marL="0">
+            <a:pPr marL="0" indent="0" algn="ctr">
               <a:lnSpc>
                 <a:spcPct val="104000"/>
               </a:lnSpc>
@@ -1604,13 +1561,16 @@
                 <a:solidFill>
                   <a:srgbClr val="0E7C7B"/>
                 </a:solidFill>
-                <a:latin typeface="Arial" pitchFamily="34" charset="0"/>
-                <a:ea typeface="Arial" pitchFamily="34" charset="-122"/>
-                <a:cs typeface="Arial" pitchFamily="34" charset="-120"/>
+                <a:latin typeface="Comic Sans MS Regular" panose="030F0902030302020204" charset="0"/>
+                <a:ea typeface="Arial" panose="020B0604020202090204" pitchFamily="34" charset="-122"/>
+                <a:cs typeface="Comic Sans MS Regular" panose="030F0902030302020204" charset="0"/>
               </a:rPr>
               <a:t>LLM mutation</a:t>
             </a:r>
-            <a:endParaRPr lang="en-US" sz="780" dirty="0"/>
+            <a:endParaRPr lang="en-US" sz="780" dirty="0">
+              <a:latin typeface="Comic Sans MS Regular" panose="030F0902030302020204" charset="0"/>
+              <a:cs typeface="Comic Sans MS Regular" panose="030F0902030302020204" charset="0"/>
+            </a:endParaRPr>
           </a:p>
         </p:txBody>
       </p:sp>
@@ -1622,330 +1582,275 @@
         </p:nvSpPr>
         <p:spPr>
           <a:xfrm>
-            <a:off x="256032" y="1353312"/>
+            <a:off x="256032" y="1273302"/>
             <a:ext cx="1493520" cy="118872"/>
           </a:xfrm>
           <a:prstGeom prst="rect">
             <a:avLst/>
           </a:prstGeom>
           <a:noFill/>
-          <a:ln/>
         </p:spPr>
         <p:txBody>
           <a:bodyPr wrap="square" lIns="0" tIns="0" rIns="0" bIns="0" rtlCol="0" anchor="t"/>
           <a:lstStyle/>
           <a:p>
-            <a:pPr algn="ctr" indent="0" marL="0">
+            <a:pPr marL="0" indent="0" algn="ctr">
               <a:lnSpc>
                 <a:spcPct val="100000"/>
               </a:lnSpc>
               <a:buNone/>
             </a:pPr>
             <a:r>
-              <a:rPr lang="en-US" sz="760" i="1" dirty="0">
+              <a:rPr lang="en-US" sz="800" dirty="0">
                 <a:solidFill>
                   <a:srgbClr val="1A1F2B"/>
                 </a:solidFill>
-                <a:latin typeface="Times New Roman" pitchFamily="34" charset="0"/>
-                <a:ea typeface="Times New Roman" pitchFamily="34" charset="-122"/>
-                <a:cs typeface="Times New Roman" pitchFamily="34" charset="-120"/>
+                <a:latin typeface="Comic Sans MS" panose="030F0902030302020204" charset="0"/>
+                <a:ea typeface="Times New Roman" panose="02020503050405090304" pitchFamily="34" charset="-122"/>
+                <a:cs typeface="Comic Sans MS" panose="030F0902030302020204" charset="0"/>
               </a:rPr>
               <a:t>P</a:t>
             </a:r>
-            <a:pPr algn="ctr" indent="0" marL="0">
+            <a:r>
+              <a:rPr lang="en-US" sz="800" baseline="-40000" dirty="0">
+                <a:solidFill>
+                  <a:srgbClr val="1A1F2B"/>
+                </a:solidFill>
+                <a:latin typeface="Comic Sans MS" panose="030F0902030302020204" charset="0"/>
+                <a:ea typeface="Times New Roman" panose="02020503050405090304" pitchFamily="34" charset="-122"/>
+                <a:cs typeface="Comic Sans MS" panose="030F0902030302020204" charset="0"/>
+              </a:rPr>
+              <a:t>t</a:t>
+            </a:r>
+            <a:r>
+              <a:rPr lang="en-US" sz="800" dirty="0">
+                <a:solidFill>
+                  <a:srgbClr val="1A1F2B"/>
+                </a:solidFill>
+                <a:latin typeface="Comic Sans MS" panose="030F0902030302020204" charset="0"/>
+                <a:ea typeface="Times New Roman" panose="02020503050405090304" pitchFamily="34" charset="-122"/>
+                <a:cs typeface="Comic Sans MS" panose="030F0902030302020204" charset="0"/>
+              </a:rPr>
+              <a:t>  ←  Mutate-To-K(S</a:t>
+            </a:r>
+            <a:r>
+              <a:rPr lang="en-US" sz="800" baseline="-40000" dirty="0">
+                <a:solidFill>
+                  <a:srgbClr val="1A1F2B"/>
+                </a:solidFill>
+                <a:latin typeface="Comic Sans MS" panose="030F0902030302020204" charset="0"/>
+                <a:ea typeface="Times New Roman" panose="02020503050405090304" pitchFamily="34" charset="-122"/>
+                <a:cs typeface="Comic Sans MS" panose="030F0902030302020204" charset="0"/>
+              </a:rPr>
+              <a:t>t−1</a:t>
+            </a:r>
+            <a:r>
+              <a:rPr lang="en-US" sz="800" dirty="0">
+                <a:solidFill>
+                  <a:srgbClr val="1A1F2B"/>
+                </a:solidFill>
+                <a:latin typeface="Comic Sans MS" panose="030F0902030302020204" charset="0"/>
+                <a:ea typeface="Times New Roman" panose="02020503050405090304" pitchFamily="34" charset="-122"/>
+                <a:cs typeface="Comic Sans MS" panose="030F0902030302020204" charset="0"/>
+              </a:rPr>
+              <a:t>), </a:t>
+            </a:r>
+            <a:endParaRPr lang="en-US" sz="800" dirty="0">
+              <a:solidFill>
+                <a:srgbClr val="1A1F2B"/>
+              </a:solidFill>
+              <a:latin typeface="Comic Sans MS" panose="030F0902030302020204" charset="0"/>
+              <a:ea typeface="Times New Roman" panose="02020503050405090304" pitchFamily="34" charset="-122"/>
+              <a:cs typeface="Comic Sans MS" panose="030F0902030302020204" charset="0"/>
+            </a:endParaRPr>
+          </a:p>
+          <a:p>
+            <a:pPr marL="0" indent="0" algn="ctr">
               <a:lnSpc>
                 <a:spcPct val="100000"/>
               </a:lnSpc>
               <a:buNone/>
             </a:pPr>
             <a:r>
-              <a:rPr lang="en-US" sz="760" baseline="-40000" dirty="0">
+              <a:rPr lang="en-US" sz="800" dirty="0">
                 <a:solidFill>
                   <a:srgbClr val="1A1F2B"/>
                 </a:solidFill>
-                <a:latin typeface="Times New Roman" pitchFamily="34" charset="0"/>
-                <a:ea typeface="Times New Roman" pitchFamily="34" charset="-122"/>
-                <a:cs typeface="Times New Roman" pitchFamily="34" charset="-120"/>
+                <a:latin typeface="Comic Sans MS" panose="030F0902030302020204" charset="0"/>
+                <a:ea typeface="Times New Roman" panose="02020503050405090304" pitchFamily="34" charset="-122"/>
+                <a:cs typeface="Comic Sans MS" panose="030F0902030302020204" charset="0"/>
+              </a:rPr>
+              <a:t>  |P</a:t>
+            </a:r>
+            <a:r>
+              <a:rPr lang="en-US" sz="800" baseline="-40000" dirty="0">
+                <a:solidFill>
+                  <a:srgbClr val="1A1F2B"/>
+                </a:solidFill>
+                <a:latin typeface="Comic Sans MS" panose="030F0902030302020204" charset="0"/>
+                <a:ea typeface="Times New Roman" panose="02020503050405090304" pitchFamily="34" charset="-122"/>
+                <a:cs typeface="Comic Sans MS" panose="030F0902030302020204" charset="0"/>
               </a:rPr>
               <a:t>t</a:t>
             </a:r>
-            <a:pPr algn="ctr" indent="0" marL="0">
+            <a:r>
+              <a:rPr lang="en-US" sz="800" dirty="0">
+                <a:solidFill>
+                  <a:srgbClr val="1A1F2B"/>
+                </a:solidFill>
+                <a:latin typeface="Comic Sans MS" panose="030F0902030302020204" charset="0"/>
+                <a:ea typeface="Times New Roman" panose="02020503050405090304" pitchFamily="34" charset="-122"/>
+                <a:cs typeface="Comic Sans MS" panose="030F0902030302020204" charset="0"/>
+              </a:rPr>
+              <a:t>| = K</a:t>
+            </a:r>
+            <a:endParaRPr lang="en-US" sz="800" dirty="0">
+              <a:solidFill>
+                <a:srgbClr val="1A1F2B"/>
+              </a:solidFill>
+              <a:latin typeface="Comic Sans MS" panose="030F0902030302020204" charset="0"/>
+              <a:ea typeface="Times New Roman" panose="02020503050405090304" pitchFamily="34" charset="-122"/>
+              <a:cs typeface="Comic Sans MS" panose="030F0902030302020204" charset="0"/>
+            </a:endParaRPr>
+          </a:p>
+        </p:txBody>
+      </p:sp>
+      <p:sp>
+        <p:nvSpPr>
+          <p:cNvPr id="22" name="a.p1.body"/>
+          <p:cNvSpPr txBox="1"/>
+          <p:nvPr/>
+        </p:nvSpPr>
+        <p:spPr>
+          <a:xfrm>
+            <a:off x="283464" y="1554480"/>
+            <a:ext cx="1438656" cy="329184"/>
+          </a:xfrm>
+          <a:prstGeom prst="rect">
+            <a:avLst/>
+          </a:prstGeom>
+          <a:noFill/>
+        </p:spPr>
+        <p:txBody>
+          <a:bodyPr wrap="square" lIns="0" tIns="0" rIns="0" bIns="0" rtlCol="0" anchor="t"/>
+          <a:lstStyle/>
+          <a:p>
+            <a:pPr marL="0" indent="0" algn="l">
+              <a:lnSpc>
+                <a:spcPct val="96000"/>
+              </a:lnSpc>
+              <a:buNone/>
+            </a:pPr>
+            <a:r>
+              <a:rPr lang="en-US" sz="700" dirty="0">
+                <a:solidFill>
+                  <a:srgbClr val="333B48"/>
+                </a:solidFill>
+                <a:latin typeface="Comic Sans MS" panose="030F0902030302020204" charset="0"/>
+                <a:ea typeface="Arial" panose="020B0604020202090204" pitchFamily="34" charset="-122"/>
+                <a:cs typeface="Comic Sans MS" panose="030F0902030302020204" charset="0"/>
+              </a:rPr>
+              <a:t>Builds a fixed K-candidate population from selected parents; never reads the private set </a:t>
+            </a:r>
+            <a:r>
+              <a:rPr lang="en-US" sz="700" dirty="0">
+                <a:solidFill>
+                  <a:srgbClr val="333B48"/>
+                </a:solidFill>
+                <a:latin typeface="Comic Sans MS" panose="030F0902030302020204" charset="0"/>
+                <a:ea typeface="Cambria Math" pitchFamily="34" charset="-122"/>
+                <a:cs typeface="Comic Sans MS" panose="030F0902030302020204" charset="0"/>
+              </a:rPr>
+              <a:t>𝒟</a:t>
+            </a:r>
+            <a:r>
+              <a:rPr lang="en-US" sz="700" dirty="0">
+                <a:solidFill>
+                  <a:srgbClr val="333B48"/>
+                </a:solidFill>
+                <a:latin typeface="Comic Sans MS" panose="030F0902030302020204" charset="0"/>
+                <a:ea typeface="Arial" panose="020B0604020202090204" pitchFamily="34" charset="-122"/>
+                <a:cs typeface="Comic Sans MS" panose="030F0902030302020204" charset="0"/>
+              </a:rPr>
+              <a:t>.</a:t>
+            </a:r>
+            <a:endParaRPr lang="en-US" sz="700" dirty="0">
+              <a:solidFill>
+                <a:srgbClr val="333B48"/>
+              </a:solidFill>
+              <a:latin typeface="Comic Sans MS" panose="030F0902030302020204" charset="0"/>
+              <a:ea typeface="Arial" panose="020B0604020202090204" pitchFamily="34" charset="-122"/>
+              <a:cs typeface="Comic Sans MS" panose="030F0902030302020204" charset="0"/>
+            </a:endParaRPr>
+          </a:p>
+        </p:txBody>
+      </p:sp>
+      <p:sp>
+        <p:nvSpPr>
+          <p:cNvPr id="23" name="a.p1.costPill"/>
+          <p:cNvSpPr/>
+          <p:nvPr/>
+        </p:nvSpPr>
+        <p:spPr>
+          <a:xfrm>
+            <a:off x="374904" y="1929384"/>
+            <a:ext cx="1255776" cy="182880"/>
+          </a:xfrm>
+          <a:prstGeom prst="roundRect">
+            <a:avLst>
+              <a:gd name="adj" fmla="val 25000"/>
+            </a:avLst>
+          </a:prstGeom>
+          <a:solidFill>
+            <a:srgbClr val="0E7C7B"/>
+          </a:solidFill>
+        </p:spPr>
+      </p:sp>
+      <p:sp>
+        <p:nvSpPr>
+          <p:cNvPr id="24" name="a.p1.costLabel"/>
+          <p:cNvSpPr txBox="1"/>
+          <p:nvPr/>
+        </p:nvSpPr>
+        <p:spPr>
+          <a:xfrm>
+            <a:off x="374904" y="1958645"/>
+            <a:ext cx="1255776" cy="137160"/>
+          </a:xfrm>
+          <a:prstGeom prst="rect">
+            <a:avLst/>
+          </a:prstGeom>
+          <a:noFill/>
+        </p:spPr>
+        <p:txBody>
+          <a:bodyPr wrap="square" lIns="0" tIns="0" rIns="0" bIns="0" rtlCol="0" anchor="t"/>
+          <a:lstStyle/>
+          <a:p>
+            <a:pPr marL="0" indent="0" algn="ctr">
               <a:lnSpc>
                 <a:spcPct val="100000"/>
               </a:lnSpc>
               <a:buNone/>
             </a:pPr>
             <a:r>
-              <a:rPr lang="en-US" sz="760" dirty="0">
-                <a:solidFill>
-                  <a:srgbClr val="1A1F2B"/>
-                </a:solidFill>
-                <a:latin typeface="Times New Roman" pitchFamily="34" charset="0"/>
-                <a:ea typeface="Times New Roman" pitchFamily="34" charset="-122"/>
-                <a:cs typeface="Times New Roman" pitchFamily="34" charset="-120"/>
-              </a:rPr>
-              <a:t>  ←  Mutate-To-K(</a:t>
-            </a:r>
-            <a:pPr algn="ctr" indent="0" marL="0">
-              <a:lnSpc>
-                <a:spcPct val="100000"/>
-              </a:lnSpc>
-              <a:buNone/>
-            </a:pPr>
-            <a:r>
-              <a:rPr lang="en-US" sz="760" i="1" dirty="0">
-                <a:solidFill>
-                  <a:srgbClr val="1A1F2B"/>
-                </a:solidFill>
-                <a:latin typeface="Times New Roman" pitchFamily="34" charset="0"/>
-                <a:ea typeface="Times New Roman" pitchFamily="34" charset="-122"/>
-                <a:cs typeface="Times New Roman" pitchFamily="34" charset="-120"/>
-              </a:rPr>
-              <a:t>S</a:t>
-            </a:r>
-            <a:pPr algn="ctr" indent="0" marL="0">
-              <a:lnSpc>
-                <a:spcPct val="100000"/>
-              </a:lnSpc>
-              <a:buNone/>
-            </a:pPr>
-            <a:r>
-              <a:rPr lang="en-US" sz="760" baseline="-40000" dirty="0">
-                <a:solidFill>
-                  <a:srgbClr val="1A1F2B"/>
-                </a:solidFill>
-                <a:latin typeface="Times New Roman" pitchFamily="34" charset="0"/>
-                <a:ea typeface="Times New Roman" pitchFamily="34" charset="-122"/>
-                <a:cs typeface="Times New Roman" pitchFamily="34" charset="-120"/>
-              </a:rPr>
-              <a:t>t−1</a:t>
-            </a:r>
-            <a:pPr algn="ctr" indent="0" marL="0">
-              <a:lnSpc>
-                <a:spcPct val="100000"/>
-              </a:lnSpc>
-              <a:buNone/>
-            </a:pPr>
-            <a:r>
-              <a:rPr lang="en-US" sz="760" dirty="0">
-                <a:solidFill>
-                  <a:srgbClr val="1A1F2B"/>
-                </a:solidFill>
-                <a:latin typeface="Times New Roman" pitchFamily="34" charset="0"/>
-                <a:ea typeface="Times New Roman" pitchFamily="34" charset="-122"/>
-                <a:cs typeface="Times New Roman" pitchFamily="34" charset="-120"/>
-              </a:rPr>
-              <a:t>),   |</a:t>
-            </a:r>
-            <a:pPr algn="ctr" indent="0" marL="0">
-              <a:lnSpc>
-                <a:spcPct val="100000"/>
-              </a:lnSpc>
-              <a:buNone/>
-            </a:pPr>
-            <a:r>
-              <a:rPr lang="en-US" sz="760" i="1" dirty="0">
-                <a:solidFill>
-                  <a:srgbClr val="1A1F2B"/>
-                </a:solidFill>
-                <a:latin typeface="Times New Roman" pitchFamily="34" charset="0"/>
-                <a:ea typeface="Times New Roman" pitchFamily="34" charset="-122"/>
-                <a:cs typeface="Times New Roman" pitchFamily="34" charset="-120"/>
-              </a:rPr>
-              <a:t>P</a:t>
-            </a:r>
-            <a:pPr algn="ctr" indent="0" marL="0">
-              <a:lnSpc>
-                <a:spcPct val="100000"/>
-              </a:lnSpc>
-              <a:buNone/>
-            </a:pPr>
-            <a:r>
-              <a:rPr lang="en-US" sz="760" baseline="-40000" dirty="0">
-                <a:solidFill>
-                  <a:srgbClr val="1A1F2B"/>
-                </a:solidFill>
-                <a:latin typeface="Times New Roman" pitchFamily="34" charset="0"/>
-                <a:ea typeface="Times New Roman" pitchFamily="34" charset="-122"/>
-                <a:cs typeface="Times New Roman" pitchFamily="34" charset="-120"/>
-              </a:rPr>
-              <a:t>t</a:t>
-            </a:r>
-            <a:pPr algn="ctr" indent="0" marL="0">
-              <a:lnSpc>
-                <a:spcPct val="100000"/>
-              </a:lnSpc>
-              <a:buNone/>
-            </a:pPr>
-            <a:r>
-              <a:rPr lang="en-US" sz="760" dirty="0">
-                <a:solidFill>
-                  <a:srgbClr val="1A1F2B"/>
-                </a:solidFill>
-                <a:latin typeface="Times New Roman" pitchFamily="34" charset="0"/>
-                <a:ea typeface="Times New Roman" pitchFamily="34" charset="-122"/>
-                <a:cs typeface="Times New Roman" pitchFamily="34" charset="-120"/>
-              </a:rPr>
-              <a:t>| = </a:t>
-            </a:r>
-            <a:pPr algn="ctr" indent="0" marL="0">
-              <a:lnSpc>
-                <a:spcPct val="100000"/>
-              </a:lnSpc>
-              <a:buNone/>
-            </a:pPr>
-            <a:r>
-              <a:rPr lang="en-US" sz="760" i="1" dirty="0">
-                <a:solidFill>
-                  <a:srgbClr val="1A1F2B"/>
-                </a:solidFill>
-                <a:latin typeface="Times New Roman" pitchFamily="34" charset="0"/>
-                <a:ea typeface="Times New Roman" pitchFamily="34" charset="-122"/>
-                <a:cs typeface="Times New Roman" pitchFamily="34" charset="-120"/>
-              </a:rPr>
-              <a:t>K</a:t>
-            </a:r>
-            <a:endParaRPr lang="en-US" sz="760" dirty="0"/>
-          </a:p>
-        </p:txBody>
-      </p:sp>
-      <p:sp>
-        <p:nvSpPr>
-          <p:cNvPr id="22" name="a.p1.body"/>
-          <p:cNvSpPr txBox="1"/>
-          <p:nvPr/>
-        </p:nvSpPr>
-        <p:spPr>
-          <a:xfrm>
-            <a:off x="283464" y="1554480"/>
-            <a:ext cx="1438656" cy="329184"/>
-          </a:xfrm>
-          <a:prstGeom prst="rect">
-            <a:avLst/>
-          </a:prstGeom>
-          <a:noFill/>
-          <a:ln/>
-        </p:spPr>
-        <p:txBody>
-          <a:bodyPr wrap="square" lIns="0" tIns="0" rIns="0" bIns="0" rtlCol="0" anchor="t"/>
-          <a:lstStyle/>
-          <a:p>
-            <a:pPr algn="l" indent="0" marL="0">
-              <a:lnSpc>
-                <a:spcPct val="96000"/>
-              </a:lnSpc>
-              <a:buNone/>
-            </a:pPr>
-            <a:r>
-              <a:rPr lang="en-US" sz="660" dirty="0">
-                <a:solidFill>
-                  <a:srgbClr val="333B48"/>
-                </a:solidFill>
-                <a:latin typeface="Arial" pitchFamily="34" charset="0"/>
-                <a:ea typeface="Arial" pitchFamily="34" charset="-122"/>
-                <a:cs typeface="Arial" pitchFamily="34" charset="-120"/>
-              </a:rPr>
-              <a:t>Builds a fixed K-candidate population from selected parents; never reads the private set </a:t>
-            </a:r>
-            <a:pPr algn="l" indent="0" marL="0">
-              <a:lnSpc>
-                <a:spcPct val="96000"/>
-              </a:lnSpc>
-              <a:buNone/>
-            </a:pPr>
-            <a:r>
-              <a:rPr lang="en-US" sz="660" dirty="0">
-                <a:solidFill>
-                  <a:srgbClr val="333B48"/>
-                </a:solidFill>
-                <a:latin typeface="Cambria Math" pitchFamily="34" charset="0"/>
-                <a:ea typeface="Cambria Math" pitchFamily="34" charset="-122"/>
-                <a:cs typeface="Cambria Math" pitchFamily="34" charset="-120"/>
-              </a:rPr>
-              <a:t>𝒟</a:t>
-            </a:r>
-            <a:pPr algn="l" indent="0" marL="0">
-              <a:lnSpc>
-                <a:spcPct val="96000"/>
-              </a:lnSpc>
-              <a:buNone/>
-            </a:pPr>
-            <a:r>
-              <a:rPr lang="en-US" sz="660" dirty="0">
-                <a:solidFill>
-                  <a:srgbClr val="333B48"/>
-                </a:solidFill>
-                <a:latin typeface="Arial" pitchFamily="34" charset="0"/>
-                <a:ea typeface="Arial" pitchFamily="34" charset="-122"/>
-                <a:cs typeface="Arial" pitchFamily="34" charset="-120"/>
-              </a:rPr>
-              <a:t>.</a:t>
-            </a:r>
-            <a:endParaRPr lang="en-US" sz="660" dirty="0"/>
-          </a:p>
-        </p:txBody>
-      </p:sp>
-      <p:sp>
-        <p:nvSpPr>
-          <p:cNvPr id="23" name="a.p1.costPill"/>
-          <p:cNvSpPr/>
-          <p:nvPr/>
-        </p:nvSpPr>
-        <p:spPr>
-          <a:xfrm>
-            <a:off x="374904" y="1929384"/>
-            <a:ext cx="1255776" cy="182880"/>
-          </a:xfrm>
-          <a:prstGeom prst="roundRect">
-            <a:avLst>
-              <a:gd name="adj" fmla="val 25000"/>
-            </a:avLst>
-          </a:prstGeom>
-          <a:solidFill>
-            <a:srgbClr val="0E7C7B"/>
-          </a:solidFill>
-          <a:ln/>
-        </p:spPr>
-      </p:sp>
-      <p:sp>
-        <p:nvSpPr>
-          <p:cNvPr id="24" name="a.p1.costLabel"/>
-          <p:cNvSpPr txBox="1"/>
-          <p:nvPr/>
-        </p:nvSpPr>
-        <p:spPr>
-          <a:xfrm>
-            <a:off x="374904" y="1958645"/>
-            <a:ext cx="1255776" cy="137160"/>
-          </a:xfrm>
-          <a:prstGeom prst="rect">
-            <a:avLst/>
-          </a:prstGeom>
-          <a:noFill/>
-          <a:ln/>
-        </p:spPr>
-        <p:txBody>
-          <a:bodyPr wrap="square" lIns="0" tIns="0" rIns="0" bIns="0" rtlCol="0" anchor="t"/>
-          <a:lstStyle/>
-          <a:p>
-            <a:pPr algn="ctr" indent="0" marL="0">
-              <a:lnSpc>
-                <a:spcPct val="100000"/>
-              </a:lnSpc>
-              <a:buNone/>
-            </a:pPr>
-            <a:r>
               <a:rPr lang="en-US" sz="640" b="1" dirty="0">
                 <a:solidFill>
                   <a:srgbClr val="FFFFFF"/>
                 </a:solidFill>
-                <a:latin typeface="Arial" pitchFamily="34" charset="0"/>
-                <a:ea typeface="Arial" pitchFamily="34" charset="-122"/>
-                <a:cs typeface="Arial" pitchFamily="34" charset="-120"/>
+                <a:latin typeface="Comic Sans MS Regular" panose="030F0902030302020204" charset="0"/>
+                <a:ea typeface="Arial" panose="020B0604020202090204" pitchFamily="34" charset="-122"/>
+                <a:cs typeface="Comic Sans MS Regular" panose="030F0902030302020204" charset="0"/>
               </a:rPr>
               <a:t>0 additional privacy loss</a:t>
             </a:r>
-            <a:endParaRPr lang="en-US" sz="640" dirty="0"/>
+            <a:endParaRPr lang="en-US" sz="640" b="1" dirty="0">
+              <a:solidFill>
+                <a:srgbClr val="FFFFFF"/>
+              </a:solidFill>
+              <a:latin typeface="Comic Sans MS Regular" panose="030F0902030302020204" charset="0"/>
+              <a:ea typeface="Arial" panose="020B0604020202090204" pitchFamily="34" charset="-122"/>
+              <a:cs typeface="Comic Sans MS Regular" panose="030F0902030302020204" charset="0"/>
+            </a:endParaRPr>
           </a:p>
         </p:txBody>
       </p:sp>
@@ -1993,7 +1898,6 @@
           <a:solidFill>
             <a:srgbClr val="1F3D7A"/>
           </a:solidFill>
-          <a:ln/>
         </p:spPr>
       </p:sp>
       <p:sp>
@@ -2079,7 +1983,6 @@
           <a:solidFill>
             <a:srgbClr val="FFFFFF"/>
           </a:solidFill>
-          <a:ln/>
         </p:spPr>
       </p:sp>
       <p:sp>
@@ -2097,13 +2000,12 @@
             <a:avLst/>
           </a:prstGeom>
           <a:noFill/>
-          <a:ln/>
         </p:spPr>
         <p:txBody>
           <a:bodyPr wrap="square" lIns="0" tIns="0" rIns="0" bIns="0" rtlCol="0" anchor="ctr"/>
           <a:lstStyle/>
           <a:p>
-            <a:pPr algn="ctr" indent="0" marL="0">
+            <a:pPr marL="0" indent="0" algn="ctr">
               <a:lnSpc>
                 <a:spcPct val="104000"/>
               </a:lnSpc>
@@ -2114,16 +2016,19 @@
                 <a:solidFill>
                   <a:srgbClr val="1F3D7A"/>
                 </a:solidFill>
-                <a:latin typeface="Arial" pitchFamily="34" charset="0"/>
-                <a:ea typeface="Arial" pitchFamily="34" charset="-122"/>
-                <a:cs typeface="Arial" pitchFamily="34" charset="-120"/>
+                <a:latin typeface="Comic Sans MS Regular" panose="030F0902030302020204" charset="0"/>
+                <a:ea typeface="Arial" panose="020B0604020202090204" pitchFamily="34" charset="-122"/>
+                <a:cs typeface="Comic Sans MS Regular" panose="030F0902030302020204" charset="0"/>
               </a:rPr>
               <a:t>Phase 2</a:t>
             </a:r>
-            <a:endParaRPr lang="en-US" sz="780" dirty="0"/>
+            <a:endParaRPr lang="en-US" sz="780" dirty="0">
+              <a:latin typeface="Comic Sans MS Regular" panose="030F0902030302020204" charset="0"/>
+              <a:cs typeface="Comic Sans MS Regular" panose="030F0902030302020204" charset="0"/>
+            </a:endParaRPr>
           </a:p>
           <a:p>
-            <a:pPr algn="ctr" indent="0" marL="0">
+            <a:pPr marL="0" indent="0" algn="ctr">
               <a:lnSpc>
                 <a:spcPct val="104000"/>
               </a:lnSpc>
@@ -2134,13 +2039,16 @@
                 <a:solidFill>
                   <a:srgbClr val="1F3D7A"/>
                 </a:solidFill>
-                <a:latin typeface="Arial" pitchFamily="34" charset="0"/>
-                <a:ea typeface="Arial" pitchFamily="34" charset="-122"/>
-                <a:cs typeface="Arial" pitchFamily="34" charset="-120"/>
+                <a:latin typeface="Comic Sans MS Regular" panose="030F0902030302020204" charset="0"/>
+                <a:ea typeface="Arial" panose="020B0604020202090204" pitchFamily="34" charset="-122"/>
+                <a:cs typeface="Comic Sans MS Regular" panose="030F0902030302020204" charset="0"/>
               </a:rPr>
               <a:t>DP scoring</a:t>
             </a:r>
-            <a:endParaRPr lang="en-US" sz="780" dirty="0"/>
+            <a:endParaRPr lang="en-US" sz="780" dirty="0">
+              <a:latin typeface="Comic Sans MS Regular" panose="030F0902030302020204" charset="0"/>
+              <a:cs typeface="Comic Sans MS Regular" panose="030F0902030302020204" charset="0"/>
+            </a:endParaRPr>
           </a:p>
         </p:txBody>
       </p:sp>
@@ -2152,627 +2060,428 @@
         </p:nvSpPr>
         <p:spPr>
           <a:xfrm>
-            <a:off x="2133600" y="1293876"/>
+            <a:off x="2133600" y="1263396"/>
             <a:ext cx="1493520" cy="118872"/>
           </a:xfrm>
           <a:prstGeom prst="rect">
             <a:avLst/>
           </a:prstGeom>
           <a:noFill/>
-          <a:ln/>
         </p:spPr>
         <p:txBody>
           <a:bodyPr wrap="square" lIns="0" tIns="0" rIns="0" bIns="0" rtlCol="0" anchor="t"/>
           <a:lstStyle/>
           <a:p>
-            <a:pPr algn="ctr" indent="0" marL="0">
+            <a:pPr marL="0" indent="0" algn="ctr">
               <a:lnSpc>
                 <a:spcPct val="100000"/>
               </a:lnSpc>
               <a:buNone/>
             </a:pPr>
             <a:r>
-              <a:rPr lang="en-US" sz="740" i="1" dirty="0">
+              <a:rPr lang="en-US" sz="800" dirty="0">
                 <a:solidFill>
                   <a:srgbClr val="1A1F2B"/>
                 </a:solidFill>
-                <a:latin typeface="Times New Roman" pitchFamily="34" charset="0"/>
-                <a:ea typeface="Times New Roman" pitchFamily="34" charset="-122"/>
-                <a:cs typeface="Times New Roman" pitchFamily="34" charset="-120"/>
+                <a:latin typeface="Comic Sans MS" panose="030F0902030302020204" charset="0"/>
+                <a:ea typeface="Times New Roman" panose="02020503050405090304" pitchFamily="34" charset="-122"/>
+                <a:cs typeface="Comic Sans MS" panose="030F0902030302020204" charset="0"/>
               </a:rPr>
               <a:t>s</a:t>
             </a:r>
-            <a:pPr algn="ctr" indent="0" marL="0">
+            <a:r>
+              <a:rPr lang="en-US" sz="800" baseline="-40000" dirty="0">
+                <a:solidFill>
+                  <a:srgbClr val="1A1F2B"/>
+                </a:solidFill>
+                <a:latin typeface="Comic Sans MS" panose="030F0902030302020204" charset="0"/>
+                <a:ea typeface="Times New Roman" panose="02020503050405090304" pitchFamily="34" charset="-122"/>
+                <a:cs typeface="Comic Sans MS" panose="030F0902030302020204" charset="0"/>
+              </a:rPr>
+              <a:t>p</a:t>
+            </a:r>
+            <a:r>
+              <a:rPr lang="en-US" sz="800" dirty="0">
+                <a:solidFill>
+                  <a:srgbClr val="1A1F2B"/>
+                </a:solidFill>
+                <a:latin typeface="Comic Sans MS" panose="030F0902030302020204" charset="0"/>
+                <a:ea typeface="Times New Roman" panose="02020503050405090304" pitchFamily="34" charset="-122"/>
+                <a:cs typeface="Comic Sans MS" panose="030F0902030302020204" charset="0"/>
+              </a:rPr>
+              <a:t>(B </a:t>
+            </a:r>
+            <a:r>
+              <a:rPr lang="en-US" sz="800" dirty="0">
+                <a:solidFill>
+                  <a:srgbClr val="1A1F2B"/>
+                </a:solidFill>
+                <a:latin typeface="Comic Sans MS" panose="030F0902030302020204" charset="0"/>
+                <a:ea typeface="Times New Roman" panose="02020503050405090304" pitchFamily="34" charset="-122"/>
+                <a:cs typeface="Comic Sans MS" panose="030F0902030302020204" charset="0"/>
+              </a:rPr>
+              <a:t>) = b</a:t>
+            </a:r>
+            <a:r>
+              <a:rPr lang="en-US" sz="800" baseline="30000" dirty="0">
+                <a:solidFill>
+                  <a:srgbClr val="1A1F2B"/>
+                </a:solidFill>
+                <a:latin typeface="Comic Sans MS" panose="030F0902030302020204" charset="0"/>
+                <a:ea typeface="Times New Roman" panose="02020503050405090304" pitchFamily="34" charset="-122"/>
+                <a:cs typeface="Comic Sans MS" panose="030F0902030302020204" charset="0"/>
+              </a:rPr>
+              <a:t>−1</a:t>
+            </a:r>
+            <a:r>
+              <a:rPr lang="en-US" sz="800" dirty="0">
+                <a:solidFill>
+                  <a:srgbClr val="1A1F2B"/>
+                </a:solidFill>
+                <a:latin typeface="Comic Sans MS" panose="030F0902030302020204" charset="0"/>
+                <a:ea typeface="Times New Roman" panose="02020503050405090304" pitchFamily="34" charset="-122"/>
+                <a:cs typeface="Comic Sans MS" panose="030F0902030302020204" charset="0"/>
+              </a:rPr>
+              <a:t> Σ</a:t>
+            </a:r>
+            <a:r>
+              <a:rPr lang="en-US" sz="800" baseline="-40000" dirty="0">
+                <a:solidFill>
+                  <a:srgbClr val="1A1F2B"/>
+                </a:solidFill>
+                <a:latin typeface="Comic Sans MS" panose="030F0902030302020204" charset="0"/>
+                <a:ea typeface="Times New Roman" panose="02020503050405090304" pitchFamily="34" charset="-122"/>
+                <a:cs typeface="Comic Sans MS" panose="030F0902030302020204" charset="0"/>
+              </a:rPr>
+              <a:t>i∈B</a:t>
+            </a:r>
+            <a:r>
+              <a:rPr lang="en-US" sz="800" dirty="0">
+                <a:solidFill>
+                  <a:srgbClr val="1A1F2B"/>
+                </a:solidFill>
+                <a:latin typeface="Comic Sans MS" panose="030F0902030302020204" charset="0"/>
+                <a:ea typeface="Times New Roman" panose="02020503050405090304" pitchFamily="34" charset="-122"/>
+                <a:cs typeface="Comic Sans MS" panose="030F0902030302020204" charset="0"/>
+              </a:rPr>
+              <a:t> clip(u</a:t>
+            </a:r>
+            <a:r>
+              <a:rPr lang="en-US" sz="800" baseline="-40000" dirty="0">
+                <a:solidFill>
+                  <a:srgbClr val="1A1F2B"/>
+                </a:solidFill>
+                <a:latin typeface="Comic Sans MS" panose="030F0902030302020204" charset="0"/>
+                <a:ea typeface="Times New Roman" panose="02020503050405090304" pitchFamily="34" charset="-122"/>
+                <a:cs typeface="Comic Sans MS" panose="030F0902030302020204" charset="0"/>
+              </a:rPr>
+              <a:t>i</a:t>
+            </a:r>
+            <a:r>
+              <a:rPr lang="en-US" sz="800" dirty="0">
+                <a:solidFill>
+                  <a:srgbClr val="1A1F2B"/>
+                </a:solidFill>
+                <a:latin typeface="Comic Sans MS" panose="030F0902030302020204" charset="0"/>
+                <a:ea typeface="Times New Roman" panose="02020503050405090304" pitchFamily="34" charset="-122"/>
+                <a:cs typeface="Comic Sans MS" panose="030F0902030302020204" charset="0"/>
+              </a:rPr>
+              <a:t>)</a:t>
+            </a:r>
+            <a:endParaRPr lang="en-US" sz="800" dirty="0">
+              <a:latin typeface="Comic Sans MS" panose="030F0902030302020204" charset="0"/>
+              <a:cs typeface="Comic Sans MS" panose="030F0902030302020204" charset="0"/>
+            </a:endParaRPr>
+          </a:p>
+        </p:txBody>
+      </p:sp>
+      <p:sp>
+        <p:nvSpPr>
+          <p:cNvPr id="32" name="a.p2.formula2"/>
+          <p:cNvSpPr txBox="1"/>
+          <p:nvPr/>
+        </p:nvSpPr>
+        <p:spPr>
+          <a:xfrm>
+            <a:off x="2133600" y="1420368"/>
+            <a:ext cx="1493520" cy="118872"/>
+          </a:xfrm>
+          <a:prstGeom prst="rect">
+            <a:avLst/>
+          </a:prstGeom>
+          <a:noFill/>
+        </p:spPr>
+        <p:txBody>
+          <a:bodyPr wrap="square" lIns="0" tIns="0" rIns="0" bIns="0" rtlCol="0" anchor="t"/>
+          <a:lstStyle/>
+          <a:p>
+            <a:pPr marL="0" indent="0" algn="ctr">
               <a:lnSpc>
                 <a:spcPct val="100000"/>
               </a:lnSpc>
               <a:buNone/>
             </a:pPr>
             <a:r>
-              <a:rPr lang="en-US" sz="740" baseline="-40000" dirty="0">
+              <a:rPr lang="en-US" sz="800" dirty="0">
                 <a:solidFill>
                   <a:srgbClr val="1A1F2B"/>
                 </a:solidFill>
-                <a:latin typeface="Times New Roman" pitchFamily="34" charset="0"/>
-                <a:ea typeface="Times New Roman" pitchFamily="34" charset="-122"/>
-                <a:cs typeface="Times New Roman" pitchFamily="34" charset="-120"/>
+                <a:latin typeface="Comic Sans MS" panose="030F0902030302020204" charset="0"/>
+                <a:ea typeface="Times New Roman" panose="02020503050405090304" pitchFamily="34" charset="-122"/>
+                <a:cs typeface="Comic Sans MS" panose="030F0902030302020204" charset="0"/>
+              </a:rPr>
+              <a:t>release  s</a:t>
+            </a:r>
+            <a:r>
+              <a:rPr lang="en-US" sz="800" baseline="-40000" dirty="0">
+                <a:solidFill>
+                  <a:srgbClr val="1A1F2B"/>
+                </a:solidFill>
+                <a:latin typeface="Comic Sans MS" panose="030F0902030302020204" charset="0"/>
+                <a:ea typeface="Times New Roman" panose="02020503050405090304" pitchFamily="34" charset="-122"/>
+                <a:cs typeface="Comic Sans MS" panose="030F0902030302020204" charset="0"/>
               </a:rPr>
               <a:t>p</a:t>
             </a:r>
-            <a:pPr algn="ctr" indent="0" marL="0">
+            <a:r>
+              <a:rPr lang="en-US" sz="800" dirty="0">
+                <a:solidFill>
+                  <a:srgbClr val="1A1F2B"/>
+                </a:solidFill>
+                <a:latin typeface="Comic Sans MS" panose="030F0902030302020204" charset="0"/>
+                <a:ea typeface="Times New Roman" panose="02020503050405090304" pitchFamily="34" charset="-122"/>
+                <a:cs typeface="Comic Sans MS" panose="030F0902030302020204" charset="0"/>
+              </a:rPr>
+              <a:t> + </a:t>
+            </a:r>
+            <a:r>
+              <a:rPr lang="en-US" sz="800" dirty="0">
+                <a:solidFill>
+                  <a:srgbClr val="1A1F2B"/>
+                </a:solidFill>
+                <a:latin typeface="Comic Sans MS" panose="030F0902030302020204" charset="0"/>
+                <a:ea typeface="Cambria Math" pitchFamily="34" charset="-122"/>
+                <a:cs typeface="Comic Sans MS" panose="030F0902030302020204" charset="0"/>
+              </a:rPr>
+              <a:t>𝒩</a:t>
+            </a:r>
+            <a:r>
+              <a:rPr lang="en-US" sz="800" dirty="0">
+                <a:solidFill>
+                  <a:srgbClr val="1A1F2B"/>
+                </a:solidFill>
+                <a:latin typeface="Comic Sans MS" panose="030F0902030302020204" charset="0"/>
+                <a:ea typeface="Times New Roman" panose="02020503050405090304" pitchFamily="34" charset="-122"/>
+                <a:cs typeface="Comic Sans MS" panose="030F0902030302020204" charset="0"/>
+              </a:rPr>
+              <a:t>(0, (z C</a:t>
+            </a:r>
+            <a:r>
+              <a:rPr lang="en-US" sz="800" baseline="-40000" dirty="0">
+                <a:solidFill>
+                  <a:srgbClr val="1A1F2B"/>
+                </a:solidFill>
+                <a:latin typeface="Comic Sans MS" panose="030F0902030302020204" charset="0"/>
+                <a:ea typeface="Times New Roman" panose="02020503050405090304" pitchFamily="34" charset="-122"/>
+                <a:cs typeface="Comic Sans MS" panose="030F0902030302020204" charset="0"/>
+              </a:rPr>
+              <a:t>clip</a:t>
+            </a:r>
+            <a:r>
+              <a:rPr lang="en-US" sz="800" dirty="0">
+                <a:solidFill>
+                  <a:srgbClr val="1A1F2B"/>
+                </a:solidFill>
+                <a:latin typeface="Comic Sans MS" panose="030F0902030302020204" charset="0"/>
+                <a:ea typeface="Times New Roman" panose="02020503050405090304" pitchFamily="34" charset="-122"/>
+                <a:cs typeface="Comic Sans MS" panose="030F0902030302020204" charset="0"/>
+              </a:rPr>
+              <a:t>/</a:t>
+            </a:r>
+            <a:r>
+              <a:rPr lang="en-US" sz="800" dirty="0">
+                <a:solidFill>
+                  <a:srgbClr val="1A1F2B"/>
+                </a:solidFill>
+                <a:latin typeface="Comic Sans MS" panose="030F0902030302020204" charset="0"/>
+                <a:ea typeface="Times New Roman" panose="02020503050405090304" pitchFamily="34" charset="-122"/>
+                <a:cs typeface="Comic Sans MS" panose="030F0902030302020204" charset="0"/>
+              </a:rPr>
+              <a:t>b)²)</a:t>
+            </a:r>
+            <a:endParaRPr lang="en-US" sz="800" dirty="0">
+              <a:solidFill>
+                <a:srgbClr val="1A1F2B"/>
+              </a:solidFill>
+              <a:latin typeface="Comic Sans MS" panose="030F0902030302020204" charset="0"/>
+              <a:ea typeface="Times New Roman" panose="02020503050405090304" pitchFamily="34" charset="-122"/>
+              <a:cs typeface="Comic Sans MS" panose="030F0902030302020204" charset="0"/>
+            </a:endParaRPr>
+          </a:p>
+        </p:txBody>
+      </p:sp>
+      <p:sp>
+        <p:nvSpPr>
+          <p:cNvPr id="33" name="a.p2.body"/>
+          <p:cNvSpPr txBox="1"/>
+          <p:nvPr/>
+        </p:nvSpPr>
+        <p:spPr>
+          <a:xfrm>
+            <a:off x="2252345" y="1579880"/>
+            <a:ext cx="1367790" cy="328930"/>
+          </a:xfrm>
+          <a:prstGeom prst="rect">
+            <a:avLst/>
+          </a:prstGeom>
+          <a:noFill/>
+        </p:spPr>
+        <p:txBody>
+          <a:bodyPr wrap="square" lIns="0" tIns="0" rIns="0" bIns="0" rtlCol="0" anchor="t">
+            <a:noAutofit/>
+          </a:bodyPr>
+          <a:lstStyle/>
+          <a:p>
+            <a:pPr lvl="0" algn="l">
+              <a:lnSpc>
+                <a:spcPct val="96000"/>
+              </a:lnSpc>
+              <a:buClrTx/>
+              <a:buSzTx/>
+              <a:buFontTx/>
+            </a:pPr>
+            <a:r>
+              <a:rPr lang="en-US" sz="700" dirty="0">
+                <a:solidFill>
+                  <a:srgbClr val="333B48"/>
+                </a:solidFill>
+                <a:latin typeface="Comic Sans MS" panose="030F0902030302020204" charset="0"/>
+                <a:ea typeface="Arial" panose="020B0604020202090204" pitchFamily="34" charset="-122"/>
+                <a:cs typeface="Comic Sans MS" panose="030F0902030302020204" charset="0"/>
+                <a:sym typeface="+mn-ea"/>
+              </a:rPr>
+              <a:t>Each candidate releases one clipped, sampled-Gaussian score from </a:t>
+            </a:r>
+            <a:r>
+              <a:rPr lang="en-US" sz="700" dirty="0">
+                <a:solidFill>
+                  <a:srgbClr val="333B48"/>
+                </a:solidFill>
+                <a:latin typeface="Comic Sans MS" panose="030F0902030302020204" charset="0"/>
+                <a:ea typeface="Arial" panose="020B0604020202090204" pitchFamily="34" charset="-122"/>
+                <a:cs typeface="Comic Sans MS" panose="030F0902030302020204" charset="0"/>
+                <a:sym typeface="+mn-ea"/>
+              </a:rPr>
+              <a:t>𝒟</a:t>
+            </a:r>
+            <a:r>
+              <a:rPr lang="en-US" sz="700" dirty="0">
+                <a:solidFill>
+                  <a:srgbClr val="333B48"/>
+                </a:solidFill>
+                <a:latin typeface="Comic Sans MS" panose="030F0902030302020204" charset="0"/>
+                <a:ea typeface="Arial" panose="020B0604020202090204" pitchFamily="34" charset="-122"/>
+                <a:cs typeface="Comic Sans MS" panose="030F0902030302020204" charset="0"/>
+                <a:sym typeface="+mn-ea"/>
+              </a:rPr>
+              <a:t>.</a:t>
+            </a:r>
+            <a:endParaRPr lang="en-US" sz="700" dirty="0">
+              <a:solidFill>
+                <a:srgbClr val="333B48"/>
+              </a:solidFill>
+              <a:latin typeface="Comic Sans MS" panose="030F0902030302020204" charset="0"/>
+              <a:ea typeface="Arial" panose="020B0604020202090204" pitchFamily="34" charset="-122"/>
+              <a:cs typeface="Comic Sans MS" panose="030F0902030302020204" charset="0"/>
+              <a:sym typeface="+mn-ea"/>
+            </a:endParaRPr>
+          </a:p>
+        </p:txBody>
+      </p:sp>
+      <p:sp>
+        <p:nvSpPr>
+          <p:cNvPr id="34" name="a.p2.costPill"/>
+          <p:cNvSpPr/>
+          <p:nvPr/>
+        </p:nvSpPr>
+        <p:spPr>
+          <a:xfrm>
+            <a:off x="2252472" y="1929384"/>
+            <a:ext cx="1255776" cy="182880"/>
+          </a:xfrm>
+          <a:prstGeom prst="roundRect">
+            <a:avLst>
+              <a:gd name="adj" fmla="val 25000"/>
+            </a:avLst>
+          </a:prstGeom>
+          <a:solidFill>
+            <a:srgbClr val="1F3D7A"/>
+          </a:solidFill>
+        </p:spPr>
+      </p:sp>
+      <p:sp>
+        <p:nvSpPr>
+          <p:cNvPr id="35" name="a.p2.costLabel"/>
+          <p:cNvSpPr txBox="1"/>
+          <p:nvPr/>
+        </p:nvSpPr>
+        <p:spPr>
+          <a:xfrm>
+            <a:off x="2252472" y="1958645"/>
+            <a:ext cx="1255776" cy="137160"/>
+          </a:xfrm>
+          <a:prstGeom prst="rect">
+            <a:avLst/>
+          </a:prstGeom>
+          <a:noFill/>
+        </p:spPr>
+        <p:txBody>
+          <a:bodyPr wrap="square" lIns="0" tIns="0" rIns="0" bIns="0" rtlCol="0" anchor="t"/>
+          <a:lstStyle/>
+          <a:p>
+            <a:pPr marL="0" indent="0" algn="ctr">
               <a:lnSpc>
                 <a:spcPct val="100000"/>
               </a:lnSpc>
               <a:buNone/>
             </a:pPr>
             <a:r>
-              <a:rPr lang="en-US" sz="740" dirty="0">
-                <a:solidFill>
-                  <a:srgbClr val="1A1F2B"/>
-                </a:solidFill>
-                <a:latin typeface="Times New Roman" pitchFamily="34" charset="0"/>
-                <a:ea typeface="Times New Roman" pitchFamily="34" charset="-122"/>
-                <a:cs typeface="Times New Roman" pitchFamily="34" charset="-120"/>
-              </a:rPr>
-              <a:t>(</a:t>
-            </a:r>
-            <a:pPr algn="ctr" indent="0" marL="0">
-              <a:lnSpc>
-                <a:spcPct val="100000"/>
-              </a:lnSpc>
-              <a:buNone/>
-            </a:pPr>
-            <a:r>
-              <a:rPr lang="en-US" sz="740" i="1" dirty="0">
-                <a:solidFill>
-                  <a:srgbClr val="1A1F2B"/>
-                </a:solidFill>
-                <a:latin typeface="Times New Roman" pitchFamily="34" charset="0"/>
-                <a:ea typeface="Times New Roman" pitchFamily="34" charset="-122"/>
-                <a:cs typeface="Times New Roman" pitchFamily="34" charset="-120"/>
-              </a:rPr>
-              <a:t>B</a:t>
-            </a:r>
-            <a:pPr algn="ctr" indent="0" marL="0">
-              <a:lnSpc>
-                <a:spcPct val="100000"/>
-              </a:lnSpc>
-              <a:buNone/>
-            </a:pPr>
-            <a:r>
-              <a:rPr lang="en-US" sz="740" dirty="0">
-                <a:solidFill>
-                  <a:srgbClr val="1A1F2B"/>
-                </a:solidFill>
-                <a:latin typeface="Times New Roman" pitchFamily="34" charset="0"/>
-                <a:ea typeface="Times New Roman" pitchFamily="34" charset="-122"/>
-                <a:cs typeface="Times New Roman" pitchFamily="34" charset="-120"/>
-              </a:rPr>
-              <a:t>) = </a:t>
-            </a:r>
-            <a:pPr algn="ctr" indent="0" marL="0">
-              <a:lnSpc>
-                <a:spcPct val="100000"/>
-              </a:lnSpc>
-              <a:buNone/>
-            </a:pPr>
-            <a:r>
-              <a:rPr lang="en-US" sz="740" i="1" dirty="0">
-                <a:solidFill>
-                  <a:srgbClr val="1A1F2B"/>
-                </a:solidFill>
-                <a:latin typeface="Times New Roman" pitchFamily="34" charset="0"/>
-                <a:ea typeface="Times New Roman" pitchFamily="34" charset="-122"/>
-                <a:cs typeface="Times New Roman" pitchFamily="34" charset="-120"/>
-              </a:rPr>
-              <a:t>b</a:t>
-            </a:r>
-            <a:pPr algn="ctr" indent="0" marL="0">
-              <a:lnSpc>
-                <a:spcPct val="100000"/>
-              </a:lnSpc>
-              <a:buNone/>
-            </a:pPr>
-            <a:r>
-              <a:rPr lang="en-US" sz="740" baseline="30000" dirty="0">
-                <a:solidFill>
-                  <a:srgbClr val="1A1F2B"/>
-                </a:solidFill>
-                <a:latin typeface="Times New Roman" pitchFamily="34" charset="0"/>
-                <a:ea typeface="Times New Roman" pitchFamily="34" charset="-122"/>
-                <a:cs typeface="Times New Roman" pitchFamily="34" charset="-120"/>
-              </a:rPr>
-              <a:t>−1</a:t>
-            </a:r>
-            <a:pPr algn="ctr" indent="0" marL="0">
-              <a:lnSpc>
-                <a:spcPct val="100000"/>
-              </a:lnSpc>
-              <a:buNone/>
-            </a:pPr>
-            <a:r>
-              <a:rPr lang="en-US" sz="740" dirty="0">
-                <a:solidFill>
-                  <a:srgbClr val="1A1F2B"/>
-                </a:solidFill>
-                <a:latin typeface="Times New Roman" pitchFamily="34" charset="0"/>
-                <a:ea typeface="Times New Roman" pitchFamily="34" charset="-122"/>
-                <a:cs typeface="Times New Roman" pitchFamily="34" charset="-120"/>
-              </a:rPr>
-              <a:t> Σ</a:t>
-            </a:r>
-            <a:pPr algn="ctr" indent="0" marL="0">
-              <a:lnSpc>
-                <a:spcPct val="100000"/>
-              </a:lnSpc>
-              <a:buNone/>
-            </a:pPr>
-            <a:r>
-              <a:rPr lang="en-US" sz="740" baseline="-40000" dirty="0">
-                <a:solidFill>
-                  <a:srgbClr val="1A1F2B"/>
-                </a:solidFill>
-                <a:latin typeface="Times New Roman" pitchFamily="34" charset="0"/>
-                <a:ea typeface="Times New Roman" pitchFamily="34" charset="-122"/>
-                <a:cs typeface="Times New Roman" pitchFamily="34" charset="-120"/>
-              </a:rPr>
-              <a:t>i∈B</a:t>
-            </a:r>
-            <a:pPr algn="ctr" indent="0" marL="0">
-              <a:lnSpc>
-                <a:spcPct val="100000"/>
-              </a:lnSpc>
-              <a:buNone/>
-            </a:pPr>
-            <a:r>
-              <a:rPr lang="en-US" sz="740" dirty="0">
-                <a:solidFill>
-                  <a:srgbClr val="1A1F2B"/>
-                </a:solidFill>
-                <a:latin typeface="Times New Roman" pitchFamily="34" charset="0"/>
-                <a:ea typeface="Times New Roman" pitchFamily="34" charset="-122"/>
-                <a:cs typeface="Times New Roman" pitchFamily="34" charset="-120"/>
-              </a:rPr>
-              <a:t> clip(</a:t>
-            </a:r>
-            <a:pPr algn="ctr" indent="0" marL="0">
-              <a:lnSpc>
-                <a:spcPct val="100000"/>
-              </a:lnSpc>
-              <a:buNone/>
-            </a:pPr>
-            <a:r>
-              <a:rPr lang="en-US" sz="740" i="1" dirty="0">
-                <a:solidFill>
-                  <a:srgbClr val="1A1F2B"/>
-                </a:solidFill>
-                <a:latin typeface="Times New Roman" pitchFamily="34" charset="0"/>
-                <a:ea typeface="Times New Roman" pitchFamily="34" charset="-122"/>
-                <a:cs typeface="Times New Roman" pitchFamily="34" charset="-120"/>
-              </a:rPr>
-              <a:t>u</a:t>
-            </a:r>
-            <a:pPr algn="ctr" indent="0" marL="0">
-              <a:lnSpc>
-                <a:spcPct val="100000"/>
-              </a:lnSpc>
-              <a:buNone/>
-            </a:pPr>
-            <a:r>
-              <a:rPr lang="en-US" sz="740" baseline="-40000" dirty="0">
-                <a:solidFill>
-                  <a:srgbClr val="1A1F2B"/>
-                </a:solidFill>
-                <a:latin typeface="Times New Roman" pitchFamily="34" charset="0"/>
-                <a:ea typeface="Times New Roman" pitchFamily="34" charset="-122"/>
-                <a:cs typeface="Times New Roman" pitchFamily="34" charset="-120"/>
-              </a:rPr>
-              <a:t>i</a:t>
-            </a:r>
-            <a:pPr algn="ctr" indent="0" marL="0">
-              <a:lnSpc>
-                <a:spcPct val="100000"/>
-              </a:lnSpc>
-              <a:buNone/>
-            </a:pPr>
-            <a:r>
-              <a:rPr lang="en-US" sz="740" dirty="0">
-                <a:solidFill>
-                  <a:srgbClr val="1A1F2B"/>
-                </a:solidFill>
-                <a:latin typeface="Times New Roman" pitchFamily="34" charset="0"/>
-                <a:ea typeface="Times New Roman" pitchFamily="34" charset="-122"/>
-                <a:cs typeface="Times New Roman" pitchFamily="34" charset="-120"/>
-              </a:rPr>
-              <a:t>)</a:t>
-            </a:r>
-            <a:endParaRPr lang="en-US" sz="740" dirty="0"/>
-          </a:p>
-        </p:txBody>
-      </p:sp>
-      <p:sp>
-        <p:nvSpPr>
-          <p:cNvPr id="32" name="a.p2.formula2"/>
-          <p:cNvSpPr txBox="1"/>
-          <p:nvPr/>
-        </p:nvSpPr>
-        <p:spPr>
-          <a:xfrm>
-            <a:off x="2133600" y="1412748"/>
-            <a:ext cx="1493520" cy="118872"/>
-          </a:xfrm>
-          <a:prstGeom prst="rect">
-            <a:avLst/>
-          </a:prstGeom>
-          <a:noFill/>
-          <a:ln/>
-        </p:spPr>
-        <p:txBody>
-          <a:bodyPr wrap="square" lIns="0" tIns="0" rIns="0" bIns="0" rtlCol="0" anchor="t"/>
-          <a:lstStyle/>
-          <a:p>
-            <a:pPr algn="ctr" indent="0" marL="0">
-              <a:lnSpc>
-                <a:spcPct val="100000"/>
-              </a:lnSpc>
-              <a:buNone/>
-            </a:pPr>
-            <a:r>
-              <a:rPr lang="en-US" sz="740" dirty="0">
-                <a:solidFill>
-                  <a:srgbClr val="1A1F2B"/>
-                </a:solidFill>
-                <a:latin typeface="Times New Roman" pitchFamily="34" charset="0"/>
-                <a:ea typeface="Times New Roman" pitchFamily="34" charset="-122"/>
-                <a:cs typeface="Times New Roman" pitchFamily="34" charset="-120"/>
-              </a:rPr>
-              <a:t>release  </a:t>
-            </a:r>
-            <a:pPr algn="ctr" indent="0" marL="0">
-              <a:lnSpc>
-                <a:spcPct val="100000"/>
-              </a:lnSpc>
-              <a:buNone/>
-            </a:pPr>
-            <a:r>
-              <a:rPr lang="en-US" sz="740" i="1" dirty="0">
-                <a:solidFill>
-                  <a:srgbClr val="1A1F2B"/>
-                </a:solidFill>
-                <a:latin typeface="Times New Roman" pitchFamily="34" charset="0"/>
-                <a:ea typeface="Times New Roman" pitchFamily="34" charset="-122"/>
-                <a:cs typeface="Times New Roman" pitchFamily="34" charset="-120"/>
-              </a:rPr>
-              <a:t>s</a:t>
-            </a:r>
-            <a:pPr algn="ctr" indent="0" marL="0">
-              <a:lnSpc>
-                <a:spcPct val="100000"/>
-              </a:lnSpc>
-              <a:buNone/>
-            </a:pPr>
-            <a:r>
-              <a:rPr lang="en-US" sz="740" baseline="-40000" dirty="0">
-                <a:solidFill>
-                  <a:srgbClr val="1A1F2B"/>
-                </a:solidFill>
-                <a:latin typeface="Times New Roman" pitchFamily="34" charset="0"/>
-                <a:ea typeface="Times New Roman" pitchFamily="34" charset="-122"/>
-                <a:cs typeface="Times New Roman" pitchFamily="34" charset="-120"/>
-              </a:rPr>
-              <a:t>p</a:t>
-            </a:r>
-            <a:pPr algn="ctr" indent="0" marL="0">
-              <a:lnSpc>
-                <a:spcPct val="100000"/>
-              </a:lnSpc>
-              <a:buNone/>
-            </a:pPr>
-            <a:r>
-              <a:rPr lang="en-US" sz="740" dirty="0">
-                <a:solidFill>
-                  <a:srgbClr val="1A1F2B"/>
-                </a:solidFill>
-                <a:latin typeface="Times New Roman" pitchFamily="34" charset="0"/>
-                <a:ea typeface="Times New Roman" pitchFamily="34" charset="-122"/>
-                <a:cs typeface="Times New Roman" pitchFamily="34" charset="-120"/>
-              </a:rPr>
-              <a:t> + </a:t>
-            </a:r>
-            <a:pPr algn="ctr" indent="0" marL="0">
-              <a:lnSpc>
-                <a:spcPct val="100000"/>
-              </a:lnSpc>
-              <a:buNone/>
-            </a:pPr>
-            <a:r>
-              <a:rPr lang="en-US" sz="740" dirty="0">
-                <a:solidFill>
-                  <a:srgbClr val="1A1F2B"/>
-                </a:solidFill>
-                <a:latin typeface="Cambria Math" pitchFamily="34" charset="0"/>
-                <a:ea typeface="Cambria Math" pitchFamily="34" charset="-122"/>
-                <a:cs typeface="Cambria Math" pitchFamily="34" charset="-120"/>
-              </a:rPr>
-              <a:t>𝒩</a:t>
-            </a:r>
-            <a:pPr algn="ctr" indent="0" marL="0">
-              <a:lnSpc>
-                <a:spcPct val="100000"/>
-              </a:lnSpc>
-              <a:buNone/>
-            </a:pPr>
-            <a:r>
-              <a:rPr lang="en-US" sz="740" dirty="0">
-                <a:solidFill>
-                  <a:srgbClr val="1A1F2B"/>
-                </a:solidFill>
-                <a:latin typeface="Times New Roman" pitchFamily="34" charset="0"/>
-                <a:ea typeface="Times New Roman" pitchFamily="34" charset="-122"/>
-                <a:cs typeface="Times New Roman" pitchFamily="34" charset="-120"/>
-              </a:rPr>
-              <a:t>(0, (</a:t>
-            </a:r>
-            <a:pPr algn="ctr" indent="0" marL="0">
-              <a:lnSpc>
-                <a:spcPct val="100000"/>
-              </a:lnSpc>
-              <a:buNone/>
-            </a:pPr>
-            <a:r>
-              <a:rPr lang="en-US" sz="740" i="1" dirty="0">
-                <a:solidFill>
-                  <a:srgbClr val="1A1F2B"/>
-                </a:solidFill>
-                <a:latin typeface="Times New Roman" pitchFamily="34" charset="0"/>
-                <a:ea typeface="Times New Roman" pitchFamily="34" charset="-122"/>
-                <a:cs typeface="Times New Roman" pitchFamily="34" charset="-120"/>
-              </a:rPr>
-              <a:t>zC</a:t>
-            </a:r>
-            <a:pPr algn="ctr" indent="0" marL="0">
-              <a:lnSpc>
-                <a:spcPct val="100000"/>
-              </a:lnSpc>
-              <a:buNone/>
-            </a:pPr>
-            <a:r>
-              <a:rPr lang="en-US" sz="740" baseline="-40000" dirty="0">
-                <a:solidFill>
-                  <a:srgbClr val="1A1F2B"/>
-                </a:solidFill>
-                <a:latin typeface="Times New Roman" pitchFamily="34" charset="0"/>
-                <a:ea typeface="Times New Roman" pitchFamily="34" charset="-122"/>
-                <a:cs typeface="Times New Roman" pitchFamily="34" charset="-120"/>
-              </a:rPr>
-              <a:t>clip</a:t>
-            </a:r>
-            <a:pPr algn="ctr" indent="0" marL="0">
-              <a:lnSpc>
-                <a:spcPct val="100000"/>
-              </a:lnSpc>
-              <a:buNone/>
-            </a:pPr>
-            <a:r>
-              <a:rPr lang="en-US" sz="740" dirty="0">
-                <a:solidFill>
-                  <a:srgbClr val="1A1F2B"/>
-                </a:solidFill>
-                <a:latin typeface="Times New Roman" pitchFamily="34" charset="0"/>
-                <a:ea typeface="Times New Roman" pitchFamily="34" charset="-122"/>
-                <a:cs typeface="Times New Roman" pitchFamily="34" charset="-120"/>
-              </a:rPr>
-              <a:t>/</a:t>
-            </a:r>
-            <a:pPr algn="ctr" indent="0" marL="0">
-              <a:lnSpc>
-                <a:spcPct val="100000"/>
-              </a:lnSpc>
-              <a:buNone/>
-            </a:pPr>
-            <a:r>
-              <a:rPr lang="en-US" sz="740" i="1" dirty="0">
-                <a:solidFill>
-                  <a:srgbClr val="1A1F2B"/>
-                </a:solidFill>
-                <a:latin typeface="Times New Roman" pitchFamily="34" charset="0"/>
-                <a:ea typeface="Times New Roman" pitchFamily="34" charset="-122"/>
-                <a:cs typeface="Times New Roman" pitchFamily="34" charset="-120"/>
-              </a:rPr>
-              <a:t>b</a:t>
-            </a:r>
-            <a:pPr algn="ctr" indent="0" marL="0">
-              <a:lnSpc>
-                <a:spcPct val="100000"/>
-              </a:lnSpc>
-              <a:buNone/>
-            </a:pPr>
-            <a:r>
-              <a:rPr lang="en-US" sz="740" dirty="0">
-                <a:solidFill>
-                  <a:srgbClr val="1A1F2B"/>
-                </a:solidFill>
-                <a:latin typeface="Times New Roman" pitchFamily="34" charset="0"/>
-                <a:ea typeface="Times New Roman" pitchFamily="34" charset="-122"/>
-                <a:cs typeface="Times New Roman" pitchFamily="34" charset="-120"/>
-              </a:rPr>
-              <a:t>)²)</a:t>
-            </a:r>
-            <a:endParaRPr lang="en-US" sz="740" dirty="0"/>
-          </a:p>
-        </p:txBody>
-      </p:sp>
-      <p:sp>
-        <p:nvSpPr>
-          <p:cNvPr id="33" name="a.p2.body"/>
-          <p:cNvSpPr txBox="1"/>
-          <p:nvPr/>
-        </p:nvSpPr>
-        <p:spPr>
-          <a:xfrm>
-            <a:off x="2161032" y="1554480"/>
-            <a:ext cx="1438656" cy="329184"/>
-          </a:xfrm>
-          <a:prstGeom prst="rect">
-            <a:avLst/>
-          </a:prstGeom>
-          <a:noFill/>
-          <a:ln/>
-        </p:spPr>
-        <p:txBody>
-          <a:bodyPr wrap="square" lIns="0" tIns="0" rIns="0" bIns="0" rtlCol="0" anchor="t"/>
-          <a:lstStyle/>
-          <a:p>
-            <a:pPr algn="l" indent="0" marL="0">
-              <a:lnSpc>
-                <a:spcPct val="96000"/>
-              </a:lnSpc>
-              <a:buNone/>
-            </a:pPr>
-            <a:r>
-              <a:rPr lang="en-US" sz="660" dirty="0">
-                <a:solidFill>
-                  <a:srgbClr val="333B48"/>
-                </a:solidFill>
-                <a:latin typeface="Arial" pitchFamily="34" charset="0"/>
-                <a:ea typeface="Arial" pitchFamily="34" charset="-122"/>
-                <a:cs typeface="Arial" pitchFamily="34" charset="-120"/>
-              </a:rPr>
-              <a:t>Each candidate releases one clipped, sampled-Gaussian score from </a:t>
-            </a:r>
-            <a:pPr algn="l" indent="0" marL="0">
-              <a:lnSpc>
-                <a:spcPct val="96000"/>
-              </a:lnSpc>
-              <a:buNone/>
-            </a:pPr>
-            <a:r>
-              <a:rPr lang="en-US" sz="660" dirty="0">
-                <a:solidFill>
-                  <a:srgbClr val="333B48"/>
-                </a:solidFill>
-                <a:latin typeface="Cambria Math" pitchFamily="34" charset="0"/>
-                <a:ea typeface="Cambria Math" pitchFamily="34" charset="-122"/>
-                <a:cs typeface="Cambria Math" pitchFamily="34" charset="-120"/>
-              </a:rPr>
-              <a:t>𝒟</a:t>
-            </a:r>
-            <a:pPr algn="l" indent="0" marL="0">
-              <a:lnSpc>
-                <a:spcPct val="96000"/>
-              </a:lnSpc>
-              <a:buNone/>
-            </a:pPr>
-            <a:r>
-              <a:rPr lang="en-US" sz="660" dirty="0">
-                <a:solidFill>
-                  <a:srgbClr val="333B48"/>
-                </a:solidFill>
-                <a:latin typeface="Arial" pitchFamily="34" charset="0"/>
-                <a:ea typeface="Arial" pitchFamily="34" charset="-122"/>
-                <a:cs typeface="Arial" pitchFamily="34" charset="-120"/>
-              </a:rPr>
-              <a:t>.</a:t>
-            </a:r>
-            <a:endParaRPr lang="en-US" sz="660" dirty="0"/>
-          </a:p>
-        </p:txBody>
-      </p:sp>
-      <p:sp>
-        <p:nvSpPr>
-          <p:cNvPr id="34" name="a.p2.costPill"/>
-          <p:cNvSpPr/>
-          <p:nvPr/>
-        </p:nvSpPr>
-        <p:spPr>
-          <a:xfrm>
-            <a:off x="2252472" y="1929384"/>
-            <a:ext cx="1255776" cy="182880"/>
-          </a:xfrm>
-          <a:prstGeom prst="roundRect">
-            <a:avLst>
-              <a:gd name="adj" fmla="val 25000"/>
-            </a:avLst>
-          </a:prstGeom>
-          <a:solidFill>
-            <a:srgbClr val="1F3D7A"/>
-          </a:solidFill>
-          <a:ln/>
-        </p:spPr>
-      </p:sp>
-      <p:sp>
-        <p:nvSpPr>
-          <p:cNvPr id="35" name="a.p2.costLabel"/>
-          <p:cNvSpPr txBox="1"/>
-          <p:nvPr/>
-        </p:nvSpPr>
-        <p:spPr>
-          <a:xfrm>
-            <a:off x="2252472" y="1958645"/>
-            <a:ext cx="1255776" cy="137160"/>
-          </a:xfrm>
-          <a:prstGeom prst="rect">
-            <a:avLst/>
-          </a:prstGeom>
-          <a:noFill/>
-          <a:ln/>
-        </p:spPr>
-        <p:txBody>
-          <a:bodyPr wrap="square" lIns="0" tIns="0" rIns="0" bIns="0" rtlCol="0" anchor="t"/>
-          <a:lstStyle/>
-          <a:p>
-            <a:pPr algn="ctr" indent="0" marL="0">
-              <a:lnSpc>
-                <a:spcPct val="100000"/>
-              </a:lnSpc>
-              <a:buNone/>
-            </a:pPr>
-            <a:r>
               <a:rPr lang="en-US" sz="640" b="1" dirty="0">
                 <a:solidFill>
                   <a:srgbClr val="FFFFFF"/>
                 </a:solidFill>
-                <a:latin typeface="Arial" pitchFamily="34" charset="0"/>
-                <a:ea typeface="Arial" pitchFamily="34" charset="-122"/>
-                <a:cs typeface="Arial" pitchFamily="34" charset="-120"/>
-              </a:rPr>
-              <a:t>≤ </a:t>
-            </a:r>
-            <a:pPr algn="ctr" indent="0" marL="0">
-              <a:lnSpc>
-                <a:spcPct val="100000"/>
-              </a:lnSpc>
-              <a:buNone/>
-            </a:pPr>
+                <a:latin typeface="Comic Sans MS Regular" panose="030F0902030302020204" charset="0"/>
+                <a:ea typeface="Arial" panose="020B0604020202090204" pitchFamily="34" charset="-122"/>
+                <a:cs typeface="Comic Sans MS Regular" panose="030F0902030302020204" charset="0"/>
+              </a:rPr>
+              <a:t>≤</a:t>
+            </a:r>
             <a:r>
               <a:rPr lang="en-US" sz="640" b="1" i="1" dirty="0">
                 <a:solidFill>
                   <a:srgbClr val="FFFFFF"/>
                 </a:solidFill>
-                <a:latin typeface="Arial" pitchFamily="34" charset="0"/>
-                <a:ea typeface="Arial" pitchFamily="34" charset="-122"/>
-                <a:cs typeface="Arial" pitchFamily="34" charset="-120"/>
+                <a:latin typeface="Comic Sans MS Regular" panose="030F0902030302020204" charset="0"/>
+                <a:ea typeface="Arial" panose="020B0604020202090204" pitchFamily="34" charset="-122"/>
+                <a:cs typeface="Comic Sans MS Regular" panose="030F0902030302020204" charset="0"/>
               </a:rPr>
               <a:t>TK</a:t>
             </a:r>
-            <a:pPr algn="ctr" indent="0" marL="0">
-              <a:lnSpc>
-                <a:spcPct val="100000"/>
-              </a:lnSpc>
-              <a:buNone/>
-            </a:pPr>
             <a:r>
               <a:rPr lang="en-US" sz="640" b="1" dirty="0">
                 <a:solidFill>
                   <a:srgbClr val="FFFFFF"/>
                 </a:solidFill>
-                <a:latin typeface="Arial" pitchFamily="34" charset="0"/>
-                <a:ea typeface="Arial" pitchFamily="34" charset="-122"/>
-                <a:cs typeface="Arial" pitchFamily="34" charset="-120"/>
+                <a:latin typeface="Comic Sans MS Regular" panose="030F0902030302020204" charset="0"/>
+                <a:ea typeface="Arial" panose="020B0604020202090204" pitchFamily="34" charset="-122"/>
+                <a:cs typeface="Comic Sans MS Regular" panose="030F0902030302020204" charset="0"/>
               </a:rPr>
               <a:t> score releases total</a:t>
             </a:r>
-            <a:endParaRPr lang="en-US" sz="640" dirty="0"/>
+            <a:endParaRPr lang="en-US" sz="640" dirty="0">
+              <a:latin typeface="Comic Sans MS Regular" panose="030F0902030302020204" charset="0"/>
+              <a:cs typeface="Comic Sans MS Regular" panose="030F0902030302020204" charset="0"/>
+            </a:endParaRPr>
           </a:p>
         </p:txBody>
       </p:sp>
@@ -2820,7 +2529,6 @@
           <a:solidFill>
             <a:srgbClr val="2E7D32"/>
           </a:solidFill>
-          <a:ln/>
         </p:spPr>
       </p:sp>
       <p:sp>
@@ -2867,7 +2575,6 @@
           <a:solidFill>
             <a:srgbClr val="FFFFFF"/>
           </a:solidFill>
-          <a:ln/>
         </p:spPr>
       </p:sp>
       <p:sp>
@@ -2885,13 +2592,12 @@
             <a:avLst/>
           </a:prstGeom>
           <a:noFill/>
-          <a:ln/>
         </p:spPr>
         <p:txBody>
           <a:bodyPr wrap="square" lIns="0" tIns="0" rIns="0" bIns="0" rtlCol="0" anchor="ctr"/>
           <a:lstStyle/>
           <a:p>
-            <a:pPr algn="ctr" indent="0" marL="0">
+            <a:pPr marL="0" indent="0" algn="ctr">
               <a:lnSpc>
                 <a:spcPct val="104000"/>
               </a:lnSpc>
@@ -2902,16 +2608,19 @@
                 <a:solidFill>
                   <a:srgbClr val="2E7D32"/>
                 </a:solidFill>
-                <a:latin typeface="Arial" pitchFamily="34" charset="0"/>
-                <a:ea typeface="Arial" pitchFamily="34" charset="-122"/>
-                <a:cs typeface="Arial" pitchFamily="34" charset="-120"/>
+                <a:latin typeface="Comic Sans MS Regular" panose="030F0902030302020204" charset="0"/>
+                <a:ea typeface="Arial" panose="020B0604020202090204" pitchFamily="34" charset="-122"/>
+                <a:cs typeface="Comic Sans MS Regular" panose="030F0902030302020204" charset="0"/>
               </a:rPr>
               <a:t>Phase 3</a:t>
             </a:r>
-            <a:endParaRPr lang="en-US" sz="780" dirty="0"/>
+            <a:endParaRPr lang="en-US" sz="780" dirty="0">
+              <a:latin typeface="Comic Sans MS Regular" panose="030F0902030302020204" charset="0"/>
+              <a:cs typeface="Comic Sans MS Regular" panose="030F0902030302020204" charset="0"/>
+            </a:endParaRPr>
           </a:p>
           <a:p>
-            <a:pPr algn="ctr" indent="0" marL="0">
+            <a:pPr marL="0" indent="0" algn="ctr">
               <a:lnSpc>
                 <a:spcPct val="104000"/>
               </a:lnSpc>
@@ -2922,13 +2631,16 @@
                 <a:solidFill>
                   <a:srgbClr val="2E7D32"/>
                 </a:solidFill>
-                <a:latin typeface="Arial" pitchFamily="34" charset="0"/>
-                <a:ea typeface="Arial" pitchFamily="34" charset="-122"/>
-                <a:cs typeface="Arial" pitchFamily="34" charset="-120"/>
+                <a:latin typeface="Comic Sans MS Regular" panose="030F0902030302020204" charset="0"/>
+                <a:ea typeface="Arial" panose="020B0604020202090204" pitchFamily="34" charset="-122"/>
+                <a:cs typeface="Comic Sans MS Regular" panose="030F0902030302020204" charset="0"/>
               </a:rPr>
               <a:t>Post-process &amp; select</a:t>
             </a:r>
-            <a:endParaRPr lang="en-US" sz="780" dirty="0"/>
+            <a:endParaRPr lang="en-US" sz="780" dirty="0">
+              <a:latin typeface="Comic Sans MS Regular" panose="030F0902030302020204" charset="0"/>
+              <a:cs typeface="Comic Sans MS Regular" panose="030F0902030302020204" charset="0"/>
+            </a:endParaRPr>
           </a:p>
         </p:txBody>
       </p:sp>
@@ -2940,37 +2652,43 @@
         </p:nvSpPr>
         <p:spPr>
           <a:xfrm>
-            <a:off x="4011168" y="1293876"/>
-            <a:ext cx="1493520" cy="118872"/>
+            <a:off x="3883025" y="1290320"/>
+            <a:ext cx="1755775" cy="118745"/>
           </a:xfrm>
           <a:prstGeom prst="rect">
             <a:avLst/>
           </a:prstGeom>
           <a:noFill/>
-          <a:ln/>
         </p:spPr>
         <p:txBody>
           <a:bodyPr wrap="square" lIns="0" tIns="0" rIns="0" bIns="0" rtlCol="0" anchor="t"/>
           <a:lstStyle/>
           <a:p>
-            <a:pPr algn="ctr" indent="0" marL="0">
+            <a:pPr marL="0" indent="0" algn="ctr">
               <a:lnSpc>
                 <a:spcPct val="100000"/>
               </a:lnSpc>
               <a:buNone/>
             </a:pPr>
             <a:r>
-              <a:rPr lang="en-US" sz="720" dirty="0">
+              <a:rPr lang="en-US" sz="780" dirty="0">
                 <a:solidFill>
                   <a:srgbClr val="1A1F2B"/>
                 </a:solidFill>
-                <a:latin typeface="Times New Roman" pitchFamily="34" charset="0"/>
-                <a:ea typeface="Times New Roman" pitchFamily="34" charset="-122"/>
-                <a:cs typeface="Times New Roman" pitchFamily="34" charset="-120"/>
+                <a:latin typeface="Comic Sans MS" panose="030F0902030302020204" charset="0"/>
+                <a:ea typeface="Times New Roman" panose="02020503050405090304" pitchFamily="34" charset="-122"/>
+                <a:cs typeface="Comic Sans MS" panose="030F0902030302020204" charset="0"/>
               </a:rPr>
               <a:t>Gumbel-smoothed or deterministic</a:t>
             </a:r>
-            <a:endParaRPr lang="en-US" sz="720" dirty="0"/>
+            <a:endParaRPr lang="en-US" sz="780" dirty="0">
+              <a:solidFill>
+                <a:srgbClr val="1A1F2B"/>
+              </a:solidFill>
+              <a:latin typeface="Comic Sans MS" panose="030F0902030302020204" charset="0"/>
+              <a:ea typeface="Times New Roman" panose="02020503050405090304" pitchFamily="34" charset="-122"/>
+              <a:cs typeface="Comic Sans MS" panose="030F0902030302020204" charset="0"/>
+            </a:endParaRPr>
           </a:p>
         </p:txBody>
       </p:sp>
@@ -2982,37 +2700,43 @@
         </p:nvSpPr>
         <p:spPr>
           <a:xfrm>
-            <a:off x="4011168" y="1412748"/>
+            <a:off x="4011168" y="1454658"/>
             <a:ext cx="1493520" cy="118872"/>
           </a:xfrm>
           <a:prstGeom prst="rect">
             <a:avLst/>
           </a:prstGeom>
           <a:noFill/>
-          <a:ln/>
         </p:spPr>
         <p:txBody>
           <a:bodyPr wrap="square" lIns="0" tIns="0" rIns="0" bIns="0" rtlCol="0" anchor="t"/>
           <a:lstStyle/>
           <a:p>
-            <a:pPr algn="ctr" indent="0" marL="0">
+            <a:pPr marL="0" indent="0" algn="ctr">
               <a:lnSpc>
                 <a:spcPct val="100000"/>
               </a:lnSpc>
               <a:buNone/>
             </a:pPr>
             <a:r>
-              <a:rPr lang="en-US" sz="720" dirty="0">
+              <a:rPr lang="en-US" sz="800" dirty="0">
                 <a:solidFill>
                   <a:srgbClr val="1A1F2B"/>
                 </a:solidFill>
-                <a:latin typeface="Times New Roman" pitchFamily="34" charset="0"/>
-                <a:ea typeface="Times New Roman" pitchFamily="34" charset="-122"/>
-                <a:cs typeface="Times New Roman" pitchFamily="34" charset="-120"/>
+                <a:latin typeface="Comic Sans MS" panose="030F0902030302020204" charset="0"/>
+                <a:ea typeface="Times New Roman" panose="02020503050405090304" pitchFamily="34" charset="-122"/>
+                <a:cs typeface="Comic Sans MS" panose="030F0902030302020204" charset="0"/>
               </a:rPr>
               <a:t>Top-M(privatized scores)</a:t>
             </a:r>
-            <a:endParaRPr lang="en-US" sz="720" dirty="0"/>
+            <a:endParaRPr lang="en-US" sz="800" dirty="0">
+              <a:solidFill>
+                <a:srgbClr val="1A1F2B"/>
+              </a:solidFill>
+              <a:latin typeface="Comic Sans MS" panose="030F0902030302020204" charset="0"/>
+              <a:ea typeface="Times New Roman" panose="02020503050405090304" pitchFamily="34" charset="-122"/>
+              <a:cs typeface="Comic Sans MS" panose="030F0902030302020204" charset="0"/>
+            </a:endParaRPr>
           </a:p>
         </p:txBody>
       </p:sp>
@@ -3024,84 +2748,94 @@
         </p:nvSpPr>
         <p:spPr>
           <a:xfrm>
-            <a:off x="4038600" y="1554480"/>
+            <a:off x="4102100" y="1629410"/>
             <a:ext cx="1438656" cy="329184"/>
           </a:xfrm>
           <a:prstGeom prst="rect">
             <a:avLst/>
           </a:prstGeom>
           <a:noFill/>
-          <a:ln/>
+        </p:spPr>
+        <p:txBody>
+          <a:bodyPr wrap="square" lIns="0" tIns="0" rIns="0" bIns="0" rtlCol="0" anchor="t">
+            <a:noAutofit/>
+          </a:bodyPr>
+          <a:lstStyle/>
+          <a:p>
+            <a:pPr lvl="0" algn="l">
+              <a:lnSpc>
+                <a:spcPct val="96000"/>
+              </a:lnSpc>
+              <a:buClrTx/>
+              <a:buSzTx/>
+              <a:buFontTx/>
+            </a:pPr>
+            <a:r>
+              <a:rPr lang="en-US" sz="700" dirty="0">
+                <a:solidFill>
+                  <a:srgbClr val="333B48"/>
+                </a:solidFill>
+                <a:latin typeface="Comic Sans MS" panose="030F0902030302020204" charset="0"/>
+                <a:ea typeface="Arial" panose="020B0604020202090204" pitchFamily="34" charset="-122"/>
+                <a:cs typeface="Comic Sans MS" panose="030F0902030302020204" charset="0"/>
+                <a:sym typeface="+mn-ea"/>
+              </a:rPr>
+              <a:t>Top-M uses only released scores; both options are post-processing.</a:t>
+            </a:r>
+            <a:endParaRPr lang="en-US" sz="700" dirty="0">
+              <a:solidFill>
+                <a:srgbClr val="333B48"/>
+              </a:solidFill>
+              <a:latin typeface="Comic Sans MS" panose="030F0902030302020204" charset="0"/>
+              <a:ea typeface="Arial" panose="020B0604020202090204" pitchFamily="34" charset="-122"/>
+              <a:cs typeface="Comic Sans MS" panose="030F0902030302020204" charset="0"/>
+              <a:sym typeface="+mn-ea"/>
+            </a:endParaRPr>
+          </a:p>
+        </p:txBody>
+      </p:sp>
+      <p:sp>
+        <p:nvSpPr>
+          <p:cNvPr id="43" name="a.p3.costPill"/>
+          <p:cNvSpPr/>
+          <p:nvPr/>
+        </p:nvSpPr>
+        <p:spPr>
+          <a:xfrm>
+            <a:off x="4130040" y="1929384"/>
+            <a:ext cx="1255776" cy="182880"/>
+          </a:xfrm>
+          <a:prstGeom prst="roundRect">
+            <a:avLst>
+              <a:gd name="adj" fmla="val 25000"/>
+            </a:avLst>
+          </a:prstGeom>
+          <a:solidFill>
+            <a:srgbClr val="2E7D32"/>
+          </a:solidFill>
+        </p:spPr>
+      </p:sp>
+      <p:sp>
+        <p:nvSpPr>
+          <p:cNvPr id="44" name="a.p3.costLabel"/>
+          <p:cNvSpPr txBox="1"/>
+          <p:nvPr/>
+        </p:nvSpPr>
+        <p:spPr>
+          <a:xfrm>
+            <a:off x="4130040" y="1958645"/>
+            <a:ext cx="1255776" cy="137160"/>
+          </a:xfrm>
+          <a:prstGeom prst="rect">
+            <a:avLst/>
+          </a:prstGeom>
+          <a:noFill/>
         </p:spPr>
         <p:txBody>
           <a:bodyPr wrap="square" lIns="0" tIns="0" rIns="0" bIns="0" rtlCol="0" anchor="t"/>
           <a:lstStyle/>
           <a:p>
-            <a:pPr algn="l" indent="0" marL="0">
-              <a:lnSpc>
-                <a:spcPct val="96000"/>
-              </a:lnSpc>
-              <a:buNone/>
-            </a:pPr>
-            <a:r>
-              <a:rPr lang="en-US" sz="660" dirty="0">
-                <a:solidFill>
-                  <a:srgbClr val="333B48"/>
-                </a:solidFill>
-                <a:latin typeface="Arial" pitchFamily="34" charset="0"/>
-                <a:ea typeface="Arial" pitchFamily="34" charset="-122"/>
-                <a:cs typeface="Arial" pitchFamily="34" charset="-120"/>
-              </a:rPr>
-              <a:t>Top-M uses only released scores; both options are post-processing.</a:t>
-            </a:r>
-            <a:endParaRPr lang="en-US" sz="660" dirty="0"/>
-          </a:p>
-        </p:txBody>
-      </p:sp>
-      <p:sp>
-        <p:nvSpPr>
-          <p:cNvPr id="43" name="a.p3.costPill"/>
-          <p:cNvSpPr/>
-          <p:nvPr/>
-        </p:nvSpPr>
-        <p:spPr>
-          <a:xfrm>
-            <a:off x="4130040" y="1929384"/>
-            <a:ext cx="1255776" cy="182880"/>
-          </a:xfrm>
-          <a:prstGeom prst="roundRect">
-            <a:avLst>
-              <a:gd name="adj" fmla="val 25000"/>
-            </a:avLst>
-          </a:prstGeom>
-          <a:solidFill>
-            <a:srgbClr val="2E7D32"/>
-          </a:solidFill>
-          <a:ln/>
-        </p:spPr>
-      </p:sp>
-      <p:sp>
-        <p:nvSpPr>
-          <p:cNvPr id="44" name="a.p3.costLabel"/>
-          <p:cNvSpPr txBox="1"/>
-          <p:nvPr/>
-        </p:nvSpPr>
-        <p:spPr>
-          <a:xfrm>
-            <a:off x="4130040" y="1958645"/>
-            <a:ext cx="1255776" cy="137160"/>
-          </a:xfrm>
-          <a:prstGeom prst="rect">
-            <a:avLst/>
-          </a:prstGeom>
-          <a:noFill/>
-          <a:ln/>
-        </p:spPr>
-        <p:txBody>
-          <a:bodyPr wrap="square" lIns="0" tIns="0" rIns="0" bIns="0" rtlCol="0" anchor="t"/>
-          <a:lstStyle/>
-          <a:p>
-            <a:pPr algn="ctr" indent="0" marL="0">
+            <a:pPr marL="0" indent="0" algn="ctr">
               <a:lnSpc>
                 <a:spcPct val="100000"/>
               </a:lnSpc>
@@ -3112,13 +2846,20 @@
                 <a:solidFill>
                   <a:srgbClr val="FFFFFF"/>
                 </a:solidFill>
-                <a:latin typeface="Arial" pitchFamily="34" charset="0"/>
-                <a:ea typeface="Arial" pitchFamily="34" charset="-122"/>
-                <a:cs typeface="Arial" pitchFamily="34" charset="-120"/>
+                <a:latin typeface="Comic Sans MS Regular" panose="030F0902030302020204" charset="0"/>
+                <a:ea typeface="Arial" panose="020B0604020202090204" pitchFamily="34" charset="-122"/>
+                <a:cs typeface="Comic Sans MS Regular" panose="030F0902030302020204" charset="0"/>
               </a:rPr>
               <a:t>0 additional privacy loss</a:t>
             </a:r>
-            <a:endParaRPr lang="en-US" sz="640" dirty="0"/>
+            <a:endParaRPr lang="en-US" sz="640" b="1" dirty="0">
+              <a:solidFill>
+                <a:srgbClr val="FFFFFF"/>
+              </a:solidFill>
+              <a:latin typeface="Comic Sans MS Regular" panose="030F0902030302020204" charset="0"/>
+              <a:ea typeface="Arial" panose="020B0604020202090204" pitchFamily="34" charset="-122"/>
+              <a:cs typeface="Comic Sans MS Regular" panose="030F0902030302020204" charset="0"/>
+            </a:endParaRPr>
           </a:p>
         </p:txBody>
       </p:sp>
@@ -3233,67 +2974,66 @@
             <a:avLst/>
           </a:prstGeom>
           <a:noFill/>
-          <a:ln/>
         </p:spPr>
         <p:txBody>
           <a:bodyPr wrap="square" lIns="0" tIns="0" rIns="0" bIns="0" rtlCol="0" anchor="ctr"/>
           <a:lstStyle/>
           <a:p>
-            <a:pPr algn="l" indent="0" marL="0">
+            <a:pPr marL="0" indent="0" algn="l">
               <a:lnSpc>
                 <a:spcPct val="102000"/>
               </a:lnSpc>
               <a:buNone/>
             </a:pPr>
             <a:r>
-              <a:rPr lang="en-US" sz="680" b="1" dirty="0">
+              <a:rPr lang="en-US" sz="800" b="1" dirty="0">
                 <a:solidFill>
                   <a:srgbClr val="0E7C7B"/>
                 </a:solidFill>
-                <a:latin typeface="Arial" pitchFamily="34" charset="0"/>
-                <a:ea typeface="Arial" pitchFamily="34" charset="-122"/>
-                <a:cs typeface="Arial" pitchFamily="34" charset="-120"/>
+                <a:latin typeface="Comic Sans MS Regular" panose="030F0902030302020204" charset="0"/>
+                <a:ea typeface="Arial" panose="020B0604020202090204" pitchFamily="34" charset="-122"/>
+                <a:cs typeface="Comic Sans MS Regular" panose="030F0902030302020204" charset="0"/>
               </a:rPr>
               <a:t>Mutation never</a:t>
             </a:r>
-            <a:endParaRPr lang="en-US" sz="680" dirty="0"/>
+            <a:endParaRPr lang="en-US" sz="800" dirty="0">
+              <a:latin typeface="Comic Sans MS Regular" panose="030F0902030302020204" charset="0"/>
+              <a:cs typeface="Comic Sans MS Regular" panose="030F0902030302020204" charset="0"/>
+            </a:endParaRPr>
           </a:p>
           <a:p>
-            <a:pPr algn="l" indent="0" marL="0">
+            <a:pPr marL="0" indent="0" algn="l">
               <a:lnSpc>
                 <a:spcPct val="102000"/>
               </a:lnSpc>
               <a:buNone/>
             </a:pPr>
             <a:r>
-              <a:rPr lang="en-US" sz="680" b="1" dirty="0">
+              <a:rPr lang="en-US" sz="800" b="1" dirty="0">
                 <a:solidFill>
                   <a:srgbClr val="0E7C7B"/>
                 </a:solidFill>
-                <a:latin typeface="Arial" pitchFamily="34" charset="0"/>
-                <a:ea typeface="Arial" pitchFamily="34" charset="-122"/>
-                <a:cs typeface="Arial" pitchFamily="34" charset="-120"/>
+                <a:latin typeface="Comic Sans MS Regular" panose="030F0902030302020204" charset="0"/>
+                <a:ea typeface="Arial" panose="020B0604020202090204" pitchFamily="34" charset="-122"/>
+                <a:cs typeface="Comic Sans MS Regular" panose="030F0902030302020204" charset="0"/>
               </a:rPr>
               <a:t>reads </a:t>
             </a:r>
-            <a:pPr algn="l" indent="0" marL="0">
-              <a:lnSpc>
-                <a:spcPct val="102000"/>
-              </a:lnSpc>
-              <a:buNone/>
-            </a:pPr>
-            <a:r>
-              <a:rPr lang="en-US" sz="680" b="1" dirty="0">
+            <a:r>
+              <a:rPr lang="en-US" sz="800" b="1" dirty="0">
                 <a:solidFill>
                   <a:srgbClr val="0E7C7B"/>
                 </a:solidFill>
-                <a:latin typeface="Cambria Math" pitchFamily="34" charset="0"/>
+                <a:latin typeface="Comic Sans MS Regular" panose="030F0902030302020204" charset="0"/>
                 <a:ea typeface="Cambria Math" pitchFamily="34" charset="-122"/>
-                <a:cs typeface="Cambria Math" pitchFamily="34" charset="-120"/>
+                <a:cs typeface="Comic Sans MS Regular" panose="030F0902030302020204" charset="0"/>
               </a:rPr>
               <a:t>𝒟</a:t>
             </a:r>
-            <a:endParaRPr lang="en-US" sz="680" dirty="0"/>
+            <a:endParaRPr lang="en-US" sz="800" dirty="0">
+              <a:latin typeface="Comic Sans MS Regular" panose="030F0902030302020204" charset="0"/>
+              <a:cs typeface="Comic Sans MS Regular" panose="030F0902030302020204" charset="0"/>
+            </a:endParaRPr>
           </a:p>
         </p:txBody>
       </p:sp>
@@ -3337,135 +3077,110 @@
             <a:avLst/>
           </a:prstGeom>
           <a:noFill/>
-          <a:ln/>
         </p:spPr>
         <p:txBody>
           <a:bodyPr wrap="square" lIns="0" tIns="0" rIns="0" bIns="0" rtlCol="0" anchor="ctr"/>
           <a:lstStyle/>
           <a:p>
-            <a:pPr algn="l" indent="0" marL="0">
+            <a:pPr marL="0" indent="0" algn="l">
               <a:lnSpc>
                 <a:spcPct val="102000"/>
               </a:lnSpc>
               <a:buNone/>
             </a:pPr>
             <a:r>
-              <a:rPr lang="en-US" sz="680" dirty="0">
+              <a:rPr lang="en-US" sz="800" dirty="0">
                 <a:solidFill>
                   <a:srgbClr val="1F3D7A"/>
                 </a:solidFill>
-                <a:latin typeface="Cambria Math" pitchFamily="34" charset="0"/>
+                <a:latin typeface="Comic Sans MS Regular" panose="030F0902030302020204" charset="0"/>
                 <a:ea typeface="Cambria Math" pitchFamily="34" charset="-122"/>
-                <a:cs typeface="Cambria Math" pitchFamily="34" charset="-120"/>
+                <a:cs typeface="Comic Sans MS Regular" panose="030F0902030302020204" charset="0"/>
               </a:rPr>
               <a:t>𝒟</a:t>
             </a:r>
-            <a:pPr algn="l" indent="0" marL="0">
+            <a:r>
+              <a:rPr lang="en-US" sz="800" dirty="0">
+                <a:solidFill>
+                  <a:srgbClr val="1F3D7A"/>
+                </a:solidFill>
+                <a:latin typeface="Comic Sans MS Regular" panose="030F0902030302020204" charset="0"/>
+                <a:ea typeface="Arial" panose="020B0604020202090204" pitchFamily="34" charset="-122"/>
+                <a:cs typeface="Comic Sans MS Regular" panose="030F0902030302020204" charset="0"/>
+              </a:rPr>
+              <a:t>: </a:t>
+            </a:r>
+            <a:r>
+              <a:rPr lang="en-US" sz="800" b="1" dirty="0">
+                <a:solidFill>
+                  <a:srgbClr val="1F3D7A"/>
+                </a:solidFill>
+                <a:latin typeface="Comic Sans MS Regular" panose="030F0902030302020204" charset="0"/>
+                <a:ea typeface="Arial" panose="020B0604020202090204" pitchFamily="34" charset="-122"/>
+                <a:cs typeface="Comic Sans MS Regular" panose="030F0902030302020204" charset="0"/>
+              </a:rPr>
+              <a:t>private</a:t>
+            </a:r>
+            <a:r>
+              <a:rPr lang="en-US" sz="800" dirty="0">
+                <a:solidFill>
+                  <a:srgbClr val="1F3D7A"/>
+                </a:solidFill>
+                <a:latin typeface="Comic Sans MS Regular" panose="030F0902030302020204" charset="0"/>
+                <a:ea typeface="Arial" panose="020B0604020202090204" pitchFamily="34" charset="-122"/>
+                <a:cs typeface="Comic Sans MS Regular" panose="030F0902030302020204" charset="0"/>
+              </a:rPr>
+              <a:t> optimization</a:t>
+            </a:r>
+            <a:endParaRPr lang="en-US" sz="800" dirty="0">
+              <a:latin typeface="Comic Sans MS Regular" panose="030F0902030302020204" charset="0"/>
+              <a:cs typeface="Comic Sans MS Regular" panose="030F0902030302020204" charset="0"/>
+            </a:endParaRPr>
+          </a:p>
+          <a:p>
+            <a:pPr marL="0" indent="0" algn="l">
               <a:lnSpc>
                 <a:spcPct val="102000"/>
               </a:lnSpc>
               <a:buNone/>
             </a:pPr>
             <a:r>
-              <a:rPr lang="en-US" sz="680" dirty="0">
+              <a:rPr lang="en-US" sz="800" dirty="0">
                 <a:solidFill>
                   <a:srgbClr val="1F3D7A"/>
                 </a:solidFill>
-                <a:latin typeface="Arial" pitchFamily="34" charset="0"/>
-                <a:ea typeface="Arial" pitchFamily="34" charset="-122"/>
-                <a:cs typeface="Arial" pitchFamily="34" charset="-120"/>
-              </a:rPr>
-              <a:t>: </a:t>
-            </a:r>
-            <a:pPr algn="l" indent="0" marL="0">
-              <a:lnSpc>
-                <a:spcPct val="102000"/>
-              </a:lnSpc>
-              <a:buNone/>
-            </a:pPr>
-            <a:r>
-              <a:rPr lang="en-US" sz="680" b="1" dirty="0">
+                <a:latin typeface="Comic Sans MS Regular" panose="030F0902030302020204" charset="0"/>
+                <a:ea typeface="Arial" panose="020B0604020202090204" pitchFamily="34" charset="-122"/>
+                <a:cs typeface="Comic Sans MS Regular" panose="030F0902030302020204" charset="0"/>
+              </a:rPr>
+              <a:t>set (</a:t>
+            </a:r>
+            <a:r>
+              <a:rPr lang="en-US" sz="800" i="1" dirty="0">
                 <a:solidFill>
                   <a:srgbClr val="1F3D7A"/>
                 </a:solidFill>
-                <a:latin typeface="Arial" pitchFamily="34" charset="0"/>
-                <a:ea typeface="Arial" pitchFamily="34" charset="-122"/>
-                <a:cs typeface="Arial" pitchFamily="34" charset="-120"/>
-              </a:rPr>
-              <a:t>private</a:t>
-            </a:r>
-            <a:pPr algn="l" indent="0" marL="0">
-              <a:lnSpc>
-                <a:spcPct val="102000"/>
-              </a:lnSpc>
-              <a:buNone/>
-            </a:pPr>
-            <a:r>
-              <a:rPr lang="en-US" sz="680" dirty="0">
+                <a:latin typeface="Comic Sans MS Regular" panose="030F0902030302020204" charset="0"/>
+                <a:ea typeface="Arial" panose="020B0604020202090204" pitchFamily="34" charset="-122"/>
+                <a:cs typeface="Comic Sans MS Regular" panose="030F0902030302020204" charset="0"/>
+              </a:rPr>
+              <a:t>n</a:t>
+            </a:r>
+            <a:r>
+              <a:rPr lang="en-US" sz="800" dirty="0">
                 <a:solidFill>
                   <a:srgbClr val="1F3D7A"/>
                 </a:solidFill>
-                <a:latin typeface="Arial" pitchFamily="34" charset="0"/>
-                <a:ea typeface="Arial" pitchFamily="34" charset="-122"/>
-                <a:cs typeface="Arial" pitchFamily="34" charset="-120"/>
-              </a:rPr>
-              <a:t> optimization</a:t>
-            </a:r>
-            <a:endParaRPr lang="en-US" sz="680" dirty="0"/>
-          </a:p>
-          <a:p>
-            <a:pPr algn="l" indent="0" marL="0">
-              <a:lnSpc>
-                <a:spcPct val="102000"/>
-              </a:lnSpc>
-              <a:buNone/>
-            </a:pPr>
-            <a:r>
-              <a:rPr lang="en-US" sz="680" dirty="0">
-                <a:solidFill>
-                  <a:srgbClr val="1F3D7A"/>
-                </a:solidFill>
-                <a:latin typeface="Arial" pitchFamily="34" charset="0"/>
-                <a:ea typeface="Arial" pitchFamily="34" charset="-122"/>
-                <a:cs typeface="Arial" pitchFamily="34" charset="-120"/>
-              </a:rPr>
-              <a:t>set (</a:t>
-            </a:r>
-            <a:pPr algn="l" indent="0" marL="0">
-              <a:lnSpc>
-                <a:spcPct val="102000"/>
-              </a:lnSpc>
-              <a:buNone/>
-            </a:pPr>
-            <a:r>
-              <a:rPr lang="en-US" sz="680" i="1" dirty="0">
-                <a:solidFill>
-                  <a:srgbClr val="1F3D7A"/>
-                </a:solidFill>
-                <a:latin typeface="Arial" pitchFamily="34" charset="0"/>
-                <a:ea typeface="Arial" pitchFamily="34" charset="-122"/>
-                <a:cs typeface="Arial" pitchFamily="34" charset="-120"/>
-              </a:rPr>
-              <a:t>n</a:t>
-            </a:r>
-            <a:pPr algn="l" indent="0" marL="0">
-              <a:lnSpc>
-                <a:spcPct val="102000"/>
-              </a:lnSpc>
-              <a:buNone/>
-            </a:pPr>
-            <a:r>
-              <a:rPr lang="en-US" sz="680" dirty="0">
-                <a:solidFill>
-                  <a:srgbClr val="1F3D7A"/>
-                </a:solidFill>
-                <a:latin typeface="Arial" pitchFamily="34" charset="0"/>
-                <a:ea typeface="Arial" pitchFamily="34" charset="-122"/>
-                <a:cs typeface="Arial" pitchFamily="34" charset="-120"/>
+                <a:latin typeface="Comic Sans MS Regular" panose="030F0902030302020204" charset="0"/>
+                <a:ea typeface="Arial" panose="020B0604020202090204" pitchFamily="34" charset="-122"/>
+                <a:cs typeface="Comic Sans MS Regular" panose="030F0902030302020204" charset="0"/>
               </a:rPr>
               <a:t> records)</a:t>
             </a:r>
-            <a:endParaRPr lang="en-US" sz="680" dirty="0"/>
+            <a:endParaRPr lang="en-US" sz="800" dirty="0">
+              <a:latin typeface="Comic Sans MS Regular" panose="030F0902030302020204" charset="0"/>
+              <a:cs typeface="Comic Sans MS Regular" panose="030F0902030302020204" charset="0"/>
+            </a:endParaRPr>
           </a:p>
         </p:txBody>
       </p:sp>
@@ -3556,50 +3271,55 @@
             <a:avLst/>
           </a:prstGeom>
           <a:noFill/>
-          <a:ln/>
         </p:spPr>
         <p:txBody>
           <a:bodyPr wrap="square" lIns="0" tIns="0" rIns="0" bIns="0" rtlCol="0" anchor="ctr"/>
           <a:lstStyle/>
           <a:p>
-            <a:pPr algn="l" indent="0" marL="0">
+            <a:pPr marL="0" indent="0" algn="l">
               <a:lnSpc>
                 <a:spcPct val="102000"/>
               </a:lnSpc>
               <a:buNone/>
             </a:pPr>
             <a:r>
-              <a:rPr lang="en-US" sz="680" b="1" dirty="0">
+              <a:rPr lang="en-US" sz="800" b="1" dirty="0">
                 <a:solidFill>
                   <a:srgbClr val="2E7D32"/>
                 </a:solidFill>
-                <a:latin typeface="Arial" pitchFamily="34" charset="0"/>
-                <a:ea typeface="Arial" pitchFamily="34" charset="-122"/>
-                <a:cs typeface="Arial" pitchFamily="34" charset="-120"/>
+                <a:latin typeface="Comic Sans MS Regular" panose="030F0902030302020204" charset="0"/>
+                <a:ea typeface="Arial" panose="020B0604020202090204" pitchFamily="34" charset="-122"/>
+                <a:cs typeface="Comic Sans MS Regular" panose="030F0902030302020204" charset="0"/>
               </a:rPr>
               <a:t>Selection reads only</a:t>
             </a:r>
-            <a:endParaRPr lang="en-US" sz="680" dirty="0"/>
+            <a:endParaRPr lang="en-US" sz="800" dirty="0">
+              <a:latin typeface="Comic Sans MS Regular" panose="030F0902030302020204" charset="0"/>
+              <a:cs typeface="Comic Sans MS Regular" panose="030F0902030302020204" charset="0"/>
+            </a:endParaRPr>
           </a:p>
           <a:p>
-            <a:pPr algn="l" indent="0" marL="0">
+            <a:pPr marL="0" indent="0" algn="l">
               <a:lnSpc>
                 <a:spcPct val="102000"/>
               </a:lnSpc>
               <a:buNone/>
             </a:pPr>
             <a:r>
-              <a:rPr lang="en-US" sz="680" b="1" dirty="0">
+              <a:rPr lang="en-US" sz="800" b="1" dirty="0">
                 <a:solidFill>
                   <a:srgbClr val="2E7D32"/>
                 </a:solidFill>
-                <a:latin typeface="Arial" pitchFamily="34" charset="0"/>
-                <a:ea typeface="Arial" pitchFamily="34" charset="-122"/>
-                <a:cs typeface="Arial" pitchFamily="34" charset="-120"/>
+                <a:latin typeface="Comic Sans MS Regular" panose="030F0902030302020204" charset="0"/>
+                <a:ea typeface="Arial" panose="020B0604020202090204" pitchFamily="34" charset="-122"/>
+                <a:cs typeface="Comic Sans MS Regular" panose="030F0902030302020204" charset="0"/>
               </a:rPr>
               <a:t>privatized scores</a:t>
             </a:r>
-            <a:endParaRPr lang="en-US" sz="680" dirty="0"/>
+            <a:endParaRPr lang="en-US" sz="800" dirty="0">
+              <a:latin typeface="Comic Sans MS Regular" panose="030F0902030302020204" charset="0"/>
+              <a:cs typeface="Comic Sans MS Regular" panose="030F0902030302020204" charset="0"/>
+            </a:endParaRPr>
           </a:p>
         </p:txBody>
       </p:sp>
@@ -3645,249 +3365,193 @@
             <a:avLst/>
           </a:prstGeom>
           <a:noFill/>
-          <a:ln/>
         </p:spPr>
         <p:txBody>
           <a:bodyPr wrap="square" lIns="0" tIns="0" rIns="0" bIns="0" rtlCol="0" anchor="t"/>
           <a:lstStyle/>
           <a:p>
-            <a:pPr algn="ctr" indent="0" marL="0">
+            <a:pPr marL="0" indent="0" algn="ctr">
               <a:lnSpc>
                 <a:spcPct val="100000"/>
               </a:lnSpc>
               <a:buNone/>
             </a:pPr>
             <a:r>
-              <a:rPr lang="en-US" sz="720" b="1" dirty="0">
+              <a:rPr lang="en-US" sz="800" b="1" dirty="0">
                 <a:solidFill>
                   <a:srgbClr val="1F3D7A"/>
                 </a:solidFill>
-                <a:latin typeface="Arial" pitchFamily="34" charset="0"/>
-                <a:ea typeface="Arial" pitchFamily="34" charset="-122"/>
-                <a:cs typeface="Arial" pitchFamily="34" charset="-120"/>
+                <a:latin typeface="Comic Sans MS" panose="030F0902030302020204" charset="0"/>
+                <a:ea typeface="Arial" panose="020B0604020202090204" pitchFamily="34" charset="-122"/>
+                <a:cs typeface="Comic Sans MS" panose="030F0902030302020204" charset="0"/>
               </a:rPr>
               <a:t>Privacy accounting:</a:t>
             </a:r>
-            <a:pPr algn="ctr" indent="0" marL="0">
+            <a:r>
+              <a:rPr lang="en-US" sz="800" dirty="0">
+                <a:solidFill>
+                  <a:srgbClr val="1F3D7A"/>
+                </a:solidFill>
+                <a:latin typeface="Comic Sans MS" panose="030F0902030302020204" charset="0"/>
+                <a:ea typeface="Arial" panose="020B0604020202090204" pitchFamily="34" charset="-122"/>
+                <a:cs typeface="Comic Sans MS" panose="030F0902030302020204" charset="0"/>
+              </a:rPr>
+              <a:t>  at most TK sampled-Gaussian score releases compose in one</a:t>
+            </a:r>
+            <a:endParaRPr lang="en-US" sz="800" dirty="0">
+              <a:solidFill>
+                <a:srgbClr val="1F3D7A"/>
+              </a:solidFill>
+              <a:latin typeface="Comic Sans MS" panose="030F0902030302020204" charset="0"/>
+              <a:ea typeface="Arial" panose="020B0604020202090204" pitchFamily="34" charset="-122"/>
+              <a:cs typeface="Comic Sans MS" panose="030F0902030302020204" charset="0"/>
+            </a:endParaRPr>
+          </a:p>
+        </p:txBody>
+      </p:sp>
+      <p:sp>
+        <p:nvSpPr>
+          <p:cNvPr id="58" name="a.acct.line2"/>
+          <p:cNvSpPr txBox="1"/>
+          <p:nvPr/>
+        </p:nvSpPr>
+        <p:spPr>
+          <a:xfrm>
+            <a:off x="521208" y="2948940"/>
+            <a:ext cx="4718304" cy="128016"/>
+          </a:xfrm>
+          <a:prstGeom prst="rect">
+            <a:avLst/>
+          </a:prstGeom>
+          <a:noFill/>
+        </p:spPr>
+        <p:txBody>
+          <a:bodyPr wrap="square" lIns="0" tIns="0" rIns="0" bIns="0" rtlCol="0" anchor="t"/>
+          <a:lstStyle/>
+          <a:p>
+            <a:pPr marL="0" indent="0" algn="ctr">
               <a:lnSpc>
                 <a:spcPct val="100000"/>
               </a:lnSpc>
               <a:buNone/>
             </a:pPr>
             <a:r>
-              <a:rPr lang="en-US" sz="720" dirty="0">
+              <a:rPr lang="en-US" sz="800" dirty="0">
                 <a:solidFill>
                   <a:srgbClr val="1F3D7A"/>
                 </a:solidFill>
-                <a:latin typeface="Arial" pitchFamily="34" charset="0"/>
-                <a:ea typeface="Arial" pitchFamily="34" charset="-122"/>
-                <a:cs typeface="Arial" pitchFamily="34" charset="-120"/>
-              </a:rPr>
-              <a:t>  at most </a:t>
-            </a:r>
-            <a:pPr algn="ctr" indent="0" marL="0">
+                <a:latin typeface="Comic Sans MS" panose="030F0902030302020204" charset="0"/>
+                <a:ea typeface="Arial" panose="020B0604020202090204" pitchFamily="34" charset="-122"/>
+                <a:cs typeface="Comic Sans MS" panose="030F0902030302020204" charset="0"/>
+              </a:rPr>
+              <a:t>RDP accountant  ⟹  overall (ε, δ)-DP.   Mutation and selection add no privacy loss.</a:t>
+            </a:r>
+            <a:endParaRPr lang="en-US" sz="800" dirty="0">
+              <a:solidFill>
+                <a:srgbClr val="1F3D7A"/>
+              </a:solidFill>
+              <a:latin typeface="Comic Sans MS" panose="030F0902030302020204" charset="0"/>
+              <a:ea typeface="Arial" panose="020B0604020202090204" pitchFamily="34" charset="-122"/>
+              <a:cs typeface="Comic Sans MS" panose="030F0902030302020204" charset="0"/>
+            </a:endParaRPr>
+          </a:p>
+        </p:txBody>
+      </p:sp>
+      <p:sp>
+        <p:nvSpPr>
+          <p:cNvPr id="59" name="b.title"/>
+          <p:cNvSpPr txBox="1"/>
+          <p:nvPr/>
+        </p:nvSpPr>
+        <p:spPr>
+          <a:xfrm>
+            <a:off x="109728" y="3246120"/>
+            <a:ext cx="5541264" cy="155448"/>
+          </a:xfrm>
+          <a:prstGeom prst="rect">
+            <a:avLst/>
+          </a:prstGeom>
+          <a:noFill/>
+        </p:spPr>
+        <p:txBody>
+          <a:bodyPr wrap="square" lIns="0" tIns="0" rIns="0" bIns="0" rtlCol="0" anchor="t"/>
+          <a:lstStyle/>
+          <a:p>
+            <a:pPr marL="0" indent="0" algn="l">
               <a:lnSpc>
                 <a:spcPct val="100000"/>
               </a:lnSpc>
               <a:buNone/>
             </a:pPr>
             <a:r>
-              <a:rPr lang="en-US" sz="720" i="1" dirty="0">
-                <a:solidFill>
-                  <a:srgbClr val="1F3D7A"/>
-                </a:solidFill>
-                <a:latin typeface="Arial" pitchFamily="34" charset="0"/>
-                <a:ea typeface="Arial" pitchFamily="34" charset="-122"/>
-                <a:cs typeface="Arial" pitchFamily="34" charset="-120"/>
-              </a:rPr>
-              <a:t>TK</a:t>
-            </a:r>
-            <a:pPr algn="ctr" indent="0" marL="0">
-              <a:lnSpc>
-                <a:spcPct val="100000"/>
-              </a:lnSpc>
-              <a:buNone/>
-            </a:pPr>
-            <a:r>
-              <a:rPr lang="en-US" sz="720" dirty="0">
-                <a:solidFill>
-                  <a:srgbClr val="1F3D7A"/>
-                </a:solidFill>
-                <a:latin typeface="Arial" pitchFamily="34" charset="0"/>
-                <a:ea typeface="Arial" pitchFamily="34" charset="-122"/>
-                <a:cs typeface="Arial" pitchFamily="34" charset="-120"/>
-              </a:rPr>
-              <a:t> sampled-Gaussian score releases compose in one</a:t>
-            </a:r>
-            <a:endParaRPr lang="en-US" sz="720" dirty="0"/>
+              <a:rPr lang="en-US" sz="900" b="1" dirty="0">
+                <a:solidFill>
+                  <a:srgbClr val="1A1F2B"/>
+                </a:solidFill>
+                <a:latin typeface="Comic Sans MS" panose="030F0902030302020204" charset="0"/>
+                <a:ea typeface="Arial" panose="020B0604020202090204" pitchFamily="34" charset="-122"/>
+                <a:cs typeface="Comic Sans MS" panose="030F0902030302020204" charset="0"/>
+              </a:rPr>
+              <a:t>(b)   </a:t>
+            </a:r>
+            <a:r>
+              <a:rPr lang="en-US" sz="900" b="1" dirty="0">
+                <a:solidFill>
+                  <a:srgbClr val="0E7C7B"/>
+                </a:solidFill>
+                <a:latin typeface="Comic Sans MS" panose="030F0902030302020204" charset="0"/>
+                <a:ea typeface="Arial" panose="020B0604020202090204" pitchFamily="34" charset="-122"/>
+                <a:cs typeface="Comic Sans MS" panose="030F0902030302020204" charset="0"/>
+              </a:rPr>
+              <a:t>DP-ES</a:t>
+            </a:r>
+            <a:r>
+              <a:rPr lang="en-US" sz="900" b="1" dirty="0">
+                <a:solidFill>
+                  <a:srgbClr val="1A1F2B"/>
+                </a:solidFill>
+                <a:latin typeface="Comic Sans MS" panose="030F0902030302020204" charset="0"/>
+                <a:ea typeface="Arial" panose="020B0604020202090204" pitchFamily="34" charset="-122"/>
+                <a:cs typeface="Comic Sans MS" panose="030F0902030302020204" charset="0"/>
+              </a:rPr>
+              <a:t> vs. </a:t>
+            </a:r>
+            <a:r>
+              <a:rPr lang="en-US" sz="900" b="1" dirty="0">
+                <a:solidFill>
+                  <a:srgbClr val="B23124"/>
+                </a:solidFill>
+                <a:latin typeface="Comic Sans MS" panose="030F0902030302020204" charset="0"/>
+                <a:ea typeface="Arial" panose="020B0604020202090204" pitchFamily="34" charset="-122"/>
+                <a:cs typeface="Comic Sans MS" panose="030F0902030302020204" charset="0"/>
+              </a:rPr>
+              <a:t>DP-OPT</a:t>
+            </a:r>
+            <a:r>
+              <a:rPr lang="en-US" sz="900" b="1" dirty="0">
+                <a:solidFill>
+                  <a:srgbClr val="1A1F2B"/>
+                </a:solidFill>
+                <a:latin typeface="Comic Sans MS" panose="030F0902030302020204" charset="0"/>
+                <a:ea typeface="Arial" panose="020B0604020202090204" pitchFamily="34" charset="-122"/>
+                <a:cs typeface="Comic Sans MS" panose="030F0902030302020204" charset="0"/>
+              </a:rPr>
+              <a:t>: mechanism and observed stability</a:t>
+            </a:r>
+            <a:endParaRPr lang="en-US" sz="900" b="1" dirty="0">
+              <a:latin typeface="Comic Sans MS" panose="030F0902030302020204" charset="0"/>
+              <a:cs typeface="Comic Sans MS" panose="030F0902030302020204" charset="0"/>
+            </a:endParaRPr>
           </a:p>
         </p:txBody>
       </p:sp>
-      <p:sp>
-        <p:nvSpPr>
-          <p:cNvPr id="58" name="a.acct.line2"/>
-          <p:cNvSpPr txBox="1"/>
-          <p:nvPr/>
-        </p:nvSpPr>
-        <p:spPr>
-          <a:xfrm>
-            <a:off x="521208" y="2948940"/>
-            <a:ext cx="4718304" cy="128016"/>
-          </a:xfrm>
-          <a:prstGeom prst="rect">
-            <a:avLst/>
-          </a:prstGeom>
-          <a:noFill/>
-          <a:ln/>
-        </p:spPr>
-        <p:txBody>
-          <a:bodyPr wrap="square" lIns="0" tIns="0" rIns="0" bIns="0" rtlCol="0" anchor="t"/>
-          <a:lstStyle/>
-          <a:p>
-            <a:pPr algn="ctr" indent="0" marL="0">
-              <a:lnSpc>
-                <a:spcPct val="100000"/>
-              </a:lnSpc>
-              <a:buNone/>
-            </a:pPr>
-            <a:r>
-              <a:rPr lang="en-US" sz="720" dirty="0">
-                <a:solidFill>
-                  <a:srgbClr val="1F3D7A"/>
-                </a:solidFill>
-                <a:latin typeface="Arial" pitchFamily="34" charset="0"/>
-                <a:ea typeface="Arial" pitchFamily="34" charset="-122"/>
-                <a:cs typeface="Arial" pitchFamily="34" charset="-120"/>
-              </a:rPr>
-              <a:t>RDP accountant  ⟹  overall (ε, δ)-DP.   Mutation and selection add no privacy loss.</a:t>
-            </a:r>
-            <a:endParaRPr lang="en-US" sz="720" dirty="0"/>
-          </a:p>
-        </p:txBody>
-      </p:sp>
-      <p:sp>
-        <p:nvSpPr>
-          <p:cNvPr id="59" name="b.title"/>
-          <p:cNvSpPr txBox="1"/>
-          <p:nvPr/>
-        </p:nvSpPr>
-        <p:spPr>
-          <a:xfrm>
-            <a:off x="109728" y="3246120"/>
-            <a:ext cx="5541264" cy="155448"/>
-          </a:xfrm>
-          <a:prstGeom prst="rect">
-            <a:avLst/>
-          </a:prstGeom>
-          <a:noFill/>
-          <a:ln/>
-        </p:spPr>
-        <p:txBody>
-          <a:bodyPr wrap="square" lIns="0" tIns="0" rIns="0" bIns="0" rtlCol="0" anchor="t"/>
-          <a:lstStyle/>
-          <a:p>
-            <a:pPr algn="l" indent="0" marL="0">
-              <a:lnSpc>
-                <a:spcPct val="100000"/>
-              </a:lnSpc>
-              <a:buNone/>
-            </a:pPr>
-            <a:r>
-              <a:rPr lang="en-US" sz="900" b="1" dirty="0">
-                <a:solidFill>
-                  <a:srgbClr val="1A1F2B"/>
-                </a:solidFill>
-                <a:latin typeface="Arial" pitchFamily="34" charset="0"/>
-                <a:ea typeface="Arial" pitchFamily="34" charset="-122"/>
-                <a:cs typeface="Arial" pitchFamily="34" charset="-120"/>
-              </a:rPr>
-              <a:t>(b)   </a:t>
-            </a:r>
-            <a:pPr algn="l" indent="0" marL="0">
-              <a:lnSpc>
-                <a:spcPct val="100000"/>
-              </a:lnSpc>
-              <a:buNone/>
-            </a:pPr>
-            <a:r>
-              <a:rPr lang="en-US" sz="900" b="1" dirty="0">
-                <a:solidFill>
-                  <a:srgbClr val="0E7C7B"/>
-                </a:solidFill>
-                <a:latin typeface="Arial" pitchFamily="34" charset="0"/>
-                <a:ea typeface="Arial" pitchFamily="34" charset="-122"/>
-                <a:cs typeface="Arial" pitchFamily="34" charset="-120"/>
-              </a:rPr>
-              <a:t>DP-ES</a:t>
-            </a:r>
-            <a:pPr algn="l" indent="0" marL="0">
-              <a:lnSpc>
-                <a:spcPct val="100000"/>
-              </a:lnSpc>
-              <a:buNone/>
-            </a:pPr>
-            <a:r>
-              <a:rPr lang="en-US" sz="900" b="1" dirty="0">
-                <a:solidFill>
-                  <a:srgbClr val="1A1F2B"/>
-                </a:solidFill>
-                <a:latin typeface="Arial" pitchFamily="34" charset="0"/>
-                <a:ea typeface="Arial" pitchFamily="34" charset="-122"/>
-                <a:cs typeface="Arial" pitchFamily="34" charset="-120"/>
-              </a:rPr>
-              <a:t> vs. </a:t>
-            </a:r>
-            <a:pPr algn="l" indent="0" marL="0">
-              <a:lnSpc>
-                <a:spcPct val="100000"/>
-              </a:lnSpc>
-              <a:buNone/>
-            </a:pPr>
-            <a:r>
-              <a:rPr lang="en-US" sz="900" b="1" dirty="0">
-                <a:solidFill>
-                  <a:srgbClr val="B23124"/>
-                </a:solidFill>
-                <a:latin typeface="Arial" pitchFamily="34" charset="0"/>
-                <a:ea typeface="Arial" pitchFamily="34" charset="-122"/>
-                <a:cs typeface="Arial" pitchFamily="34" charset="-120"/>
-              </a:rPr>
-              <a:t>DP-OPT</a:t>
-            </a:r>
-            <a:pPr algn="l" indent="0" marL="0">
-              <a:lnSpc>
-                <a:spcPct val="100000"/>
-              </a:lnSpc>
-              <a:buNone/>
-            </a:pPr>
-            <a:r>
-              <a:rPr lang="en-US" sz="900" b="1" dirty="0">
-                <a:solidFill>
-                  <a:srgbClr val="1A1F2B"/>
-                </a:solidFill>
-                <a:latin typeface="Arial" pitchFamily="34" charset="0"/>
-                <a:ea typeface="Arial" pitchFamily="34" charset="-122"/>
-                <a:cs typeface="Arial" pitchFamily="34" charset="-120"/>
-              </a:rPr>
-              <a:t>: mechanism and observed stability</a:t>
-            </a:r>
-            <a:endParaRPr lang="en-US" sz="900" dirty="0"/>
-          </a:p>
-        </p:txBody>
-      </p:sp>
       <p:graphicFrame>
         <p:nvGraphicFramePr>
-          <p:cNvPr id="2" name="b.table"/>
+          <p:cNvPr id="60" name="b.table"/>
           <p:cNvGraphicFramePr>
             <a:graphicFrameLocks noGrp="1"/>
           </p:cNvGraphicFramePr>
-          <p:nvPr>
-            <p:extLst>
-              <p:ext uri="{D42A27DB-BD31-4B8C-83A1-F6EECF244321}">
-                <p14:modId xmlns:p14="http://schemas.microsoft.com/office/powerpoint/2010/main" val="1579011935"/>
-              </p:ext>
-            </p:extLst>
-          </p:nvPr>
+          <p:nvPr/>
         </p:nvGraphicFramePr>
         <p:xfrm>
           <a:off x="109728" y="3474720"/>
@@ -3908,7 +3572,7 @@
                     <a:bodyPr/>
                     <a:lstStyle/>
                     <a:p>
-                      <a:pPr algn="ctr" indent="0" marL="0">
+                      <a:pPr marL="0" indent="0" algn="ctr">
                         <a:buNone/>
                       </a:pPr>
                       <a:r>
@@ -3916,13 +3580,20 @@
                           <a:solidFill>
                             <a:srgbClr val="1A1F2B"/>
                           </a:solidFill>
-                          <a:latin typeface="Arial" pitchFamily="34" charset="0"/>
-                          <a:ea typeface="Arial" pitchFamily="34" charset="-122"/>
-                          <a:cs typeface="Arial" pitchFamily="34" charset="-120"/>
+                          <a:latin typeface="Comic Sans MS" panose="030F0902030302020204" charset="0"/>
+                          <a:ea typeface="Arial" panose="020B0604020202090204" pitchFamily="34" charset="-122"/>
+                          <a:cs typeface="Comic Sans MS" panose="030F0902030302020204" charset="0"/>
                         </a:rPr>
                         <a:t>Aspect</a:t>
                       </a:r>
-                      <a:endParaRPr lang="en-US" sz="1200" dirty="0"/>
+                      <a:endParaRPr lang="en-US" sz="740" b="1" dirty="0">
+                        <a:solidFill>
+                          <a:srgbClr val="1A1F2B"/>
+                        </a:solidFill>
+                        <a:latin typeface="Comic Sans MS" panose="030F0902030302020204" charset="0"/>
+                        <a:ea typeface="Arial" panose="020B0604020202090204" pitchFamily="34" charset="-122"/>
+                        <a:cs typeface="Comic Sans MS" panose="030F0902030302020204" charset="0"/>
+                      </a:endParaRPr>
                     </a:p>
                   </a:txBody>
                   <a:tcPr marL="38100" marR="38100" marT="12700" marB="12700" anchor="ctr">
@@ -3957,7 +3628,7 @@
                     <a:bodyPr/>
                     <a:lstStyle/>
                     <a:p>
-                      <a:pPr algn="ctr" indent="0" marL="0">
+                      <a:pPr marL="0" indent="0" algn="ctr">
                         <a:buNone/>
                       </a:pPr>
                       <a:r>
@@ -3965,13 +3636,20 @@
                           <a:solidFill>
                             <a:srgbClr val="0E7C7B"/>
                           </a:solidFill>
-                          <a:latin typeface="Arial" pitchFamily="34" charset="0"/>
-                          <a:ea typeface="Arial" pitchFamily="34" charset="-122"/>
-                          <a:cs typeface="Arial" pitchFamily="34" charset="-120"/>
+                          <a:latin typeface="Comic Sans MS" panose="030F0902030302020204" charset="0"/>
+                          <a:ea typeface="Arial" panose="020B0604020202090204" pitchFamily="34" charset="-122"/>
+                          <a:cs typeface="Comic Sans MS" panose="030F0902030302020204" charset="0"/>
                         </a:rPr>
                         <a:t>DP-ES (ours)</a:t>
                       </a:r>
-                      <a:endParaRPr lang="en-US" sz="1200" dirty="0"/>
+                      <a:endParaRPr lang="en-US" sz="740" b="1" dirty="0">
+                        <a:solidFill>
+                          <a:srgbClr val="0E7C7B"/>
+                        </a:solidFill>
+                        <a:latin typeface="Comic Sans MS" panose="030F0902030302020204" charset="0"/>
+                        <a:ea typeface="Arial" panose="020B0604020202090204" pitchFamily="34" charset="-122"/>
+                        <a:cs typeface="Comic Sans MS" panose="030F0902030302020204" charset="0"/>
+                      </a:endParaRPr>
                     </a:p>
                   </a:txBody>
                   <a:tcPr marL="38100" marR="38100" marT="12700" marB="12700" anchor="ctr">
@@ -4006,7 +3684,7 @@
                     <a:bodyPr/>
                     <a:lstStyle/>
                     <a:p>
-                      <a:pPr algn="ctr" indent="0" marL="0">
+                      <a:pPr marL="0" indent="0" algn="ctr">
                         <a:buNone/>
                       </a:pPr>
                       <a:r>
@@ -4014,13 +3692,20 @@
                           <a:solidFill>
                             <a:srgbClr val="B23124"/>
                           </a:solidFill>
-                          <a:latin typeface="Arial" pitchFamily="34" charset="0"/>
-                          <a:ea typeface="Arial" pitchFamily="34" charset="-122"/>
-                          <a:cs typeface="Arial" pitchFamily="34" charset="-120"/>
+                          <a:latin typeface="Comic Sans MS" panose="030F0902030302020204" charset="0"/>
+                          <a:ea typeface="Arial" panose="020B0604020202090204" pitchFamily="34" charset="-122"/>
+                          <a:cs typeface="Comic Sans MS" panose="030F0902030302020204" charset="0"/>
                         </a:rPr>
                         <a:t>DP-OPT</a:t>
                       </a:r>
-                      <a:endParaRPr lang="en-US" sz="1200" dirty="0"/>
+                      <a:endParaRPr lang="en-US" sz="740" b="1" dirty="0">
+                        <a:solidFill>
+                          <a:srgbClr val="B23124"/>
+                        </a:solidFill>
+                        <a:latin typeface="Comic Sans MS" panose="030F0902030302020204" charset="0"/>
+                        <a:ea typeface="Arial" panose="020B0604020202090204" pitchFamily="34" charset="-122"/>
+                        <a:cs typeface="Comic Sans MS" panose="030F0902030302020204" charset="0"/>
+                      </a:endParaRPr>
                     </a:p>
                   </a:txBody>
                   <a:tcPr marL="38100" marR="38100" marT="12700" marB="12700" anchor="ctr">
@@ -4057,7 +3742,7 @@
                     <a:bodyPr/>
                     <a:lstStyle/>
                     <a:p>
-                      <a:pPr algn="ctr" indent="0" marL="0">
+                      <a:pPr marL="0" indent="0" algn="ctr">
                         <a:buNone/>
                       </a:pPr>
                       <a:r>
@@ -4065,13 +3750,20 @@
                           <a:solidFill>
                             <a:srgbClr val="1A1F2B"/>
                           </a:solidFill>
-                          <a:latin typeface="Arial" pitchFamily="34" charset="0"/>
-                          <a:ea typeface="Arial" pitchFamily="34" charset="-122"/>
-                          <a:cs typeface="Arial" pitchFamily="34" charset="-120"/>
+                          <a:latin typeface="Comic Sans MS" panose="030F0902030302020204" charset="0"/>
+                          <a:ea typeface="Arial" panose="020B0604020202090204" pitchFamily="34" charset="-122"/>
+                          <a:cs typeface="Comic Sans MS" panose="030F0902030302020204" charset="0"/>
                         </a:rPr>
                         <a:t>Search unit</a:t>
                       </a:r>
-                      <a:endParaRPr lang="en-US" sz="1200" dirty="0"/>
+                      <a:endParaRPr lang="en-US" sz="700" b="1" dirty="0">
+                        <a:solidFill>
+                          <a:srgbClr val="1A1F2B"/>
+                        </a:solidFill>
+                        <a:latin typeface="Comic Sans MS" panose="030F0902030302020204" charset="0"/>
+                        <a:ea typeface="Arial" panose="020B0604020202090204" pitchFamily="34" charset="-122"/>
+                        <a:cs typeface="Comic Sans MS" panose="030F0902030302020204" charset="0"/>
+                      </a:endParaRPr>
                     </a:p>
                   </a:txBody>
                   <a:tcPr marL="38100" marR="38100" marT="12700" marB="12700" anchor="ctr">
@@ -4100,21 +3792,28 @@
                     <a:bodyPr/>
                     <a:lstStyle/>
                     <a:p>
-                      <a:pPr algn="ctr" indent="0" marL="0">
+                      <a:pPr marL="0" indent="0" algn="ctr">
                         <a:buNone/>
                       </a:pPr>
                       <a:r>
-                        <a:rPr lang="en-US" sz="680" dirty="0">
+                        <a:rPr lang="en-US" sz="700" dirty="0">
                           <a:solidFill>
                             <a:srgbClr val="1A1F2B"/>
                           </a:solidFill>
-                          <a:latin typeface="Arial" pitchFamily="34" charset="0"/>
-                          <a:ea typeface="Arial" pitchFamily="34" charset="-122"/>
-                          <a:cs typeface="Arial" pitchFamily="34" charset="-120"/>
+                          <a:latin typeface="Palatino Regular" charset="0"/>
+                          <a:ea typeface="Arial" panose="020B0604020202090204" pitchFamily="34" charset="-122"/>
+                          <a:cs typeface="Palatino Regular" charset="0"/>
                         </a:rPr>
                         <a:t>Population of complete prompts</a:t>
                       </a:r>
-                      <a:endParaRPr lang="en-US" sz="1200" dirty="0"/>
+                      <a:endParaRPr lang="en-US" sz="700" dirty="0">
+                        <a:solidFill>
+                          <a:srgbClr val="1A1F2B"/>
+                        </a:solidFill>
+                        <a:latin typeface="Palatino Regular" charset="0"/>
+                        <a:ea typeface="Arial" panose="020B0604020202090204" pitchFamily="34" charset="-122"/>
+                        <a:cs typeface="Palatino Regular" charset="0"/>
+                      </a:endParaRPr>
                     </a:p>
                   </a:txBody>
                   <a:tcPr marL="38100" marR="38100" marT="12700" marB="12700" anchor="ctr">
@@ -4143,21 +3842,31 @@
                     <a:bodyPr/>
                     <a:lstStyle/>
                     <a:p>
-                      <a:pPr algn="ctr" indent="0" marL="0">
+                      <a:pPr marL="0" algn="ctr">
+                        <a:buClrTx/>
+                        <a:buSzTx/>
+                        <a:buFontTx/>
                         <a:buNone/>
                       </a:pPr>
                       <a:r>
-                        <a:rPr lang="en-US" sz="680" dirty="0">
+                        <a:rPr lang="en-US" sz="700" dirty="0">
                           <a:solidFill>
                             <a:srgbClr val="1A1F2B"/>
                           </a:solidFill>
-                          <a:latin typeface="Arial" pitchFamily="34" charset="0"/>
-                          <a:ea typeface="Arial" pitchFamily="34" charset="-122"/>
-                          <a:cs typeface="Arial" pitchFamily="34" charset="-120"/>
+                          <a:latin typeface="Palatino Regular" charset="0"/>
+                          <a:ea typeface="Arial" panose="020B0604020202090204" pitchFamily="34" charset="-122"/>
+                          <a:cs typeface="Palatino Regular" charset="0"/>
                         </a:rPr>
                         <a:t>Greedy token-by-token construction</a:t>
                       </a:r>
-                      <a:endParaRPr lang="en-US" sz="1200" dirty="0"/>
+                      <a:endParaRPr lang="en-US" sz="700" dirty="0">
+                        <a:solidFill>
+                          <a:srgbClr val="1A1F2B"/>
+                        </a:solidFill>
+                        <a:latin typeface="Palatino Regular" charset="0"/>
+                        <a:ea typeface="Arial" panose="020B0604020202090204" pitchFamily="34" charset="-122"/>
+                        <a:cs typeface="Palatino Regular" charset="0"/>
+                      </a:endParaRPr>
                     </a:p>
                   </a:txBody>
                   <a:tcPr marL="38100" marR="38100" marT="12700" marB="12700" anchor="ctr">
@@ -4188,7 +3897,7 @@
                     <a:bodyPr/>
                     <a:lstStyle/>
                     <a:p>
-                      <a:pPr algn="ctr" indent="0" marL="0">
+                      <a:pPr marL="0" indent="0" algn="ctr">
                         <a:buNone/>
                       </a:pPr>
                       <a:r>
@@ -4196,13 +3905,20 @@
                           <a:solidFill>
                             <a:srgbClr val="1A1F2B"/>
                           </a:solidFill>
-                          <a:latin typeface="Arial" pitchFamily="34" charset="0"/>
-                          <a:ea typeface="Arial" pitchFamily="34" charset="-122"/>
-                          <a:cs typeface="Arial" pitchFamily="34" charset="-120"/>
+                          <a:latin typeface="Comic Sans MS" panose="030F0902030302020204" charset="0"/>
+                          <a:ea typeface="Arial" panose="020B0604020202090204" pitchFamily="34" charset="-122"/>
+                          <a:cs typeface="Comic Sans MS" panose="030F0902030302020204" charset="0"/>
                         </a:rPr>
                         <a:t>Private-data access</a:t>
                       </a:r>
-                      <a:endParaRPr lang="en-US" sz="1200" dirty="0"/>
+                      <a:endParaRPr lang="en-US" sz="700" b="1" dirty="0">
+                        <a:solidFill>
+                          <a:srgbClr val="1A1F2B"/>
+                        </a:solidFill>
+                        <a:latin typeface="Comic Sans MS" panose="030F0902030302020204" charset="0"/>
+                        <a:ea typeface="Arial" panose="020B0604020202090204" pitchFamily="34" charset="-122"/>
+                        <a:cs typeface="Comic Sans MS" panose="030F0902030302020204" charset="0"/>
+                      </a:endParaRPr>
                     </a:p>
                   </a:txBody>
                   <a:tcPr marL="38100" marR="38100" marT="12700" marB="12700" anchor="ctr">
@@ -4231,21 +3947,31 @@
                     <a:bodyPr/>
                     <a:lstStyle/>
                     <a:p>
-                      <a:pPr algn="ctr" indent="0" marL="0">
+                      <a:pPr marL="0" algn="ctr">
+                        <a:buClrTx/>
+                        <a:buSzTx/>
+                        <a:buFontTx/>
                         <a:buNone/>
                       </a:pPr>
                       <a:r>
-                        <a:rPr lang="en-US" sz="680" dirty="0">
+                        <a:rPr lang="en-US" sz="700" dirty="0">
                           <a:solidFill>
                             <a:srgbClr val="1A1F2B"/>
                           </a:solidFill>
-                          <a:latin typeface="Arial" pitchFamily="34" charset="0"/>
-                          <a:ea typeface="Arial" pitchFamily="34" charset="-122"/>
-                          <a:cs typeface="Arial" pitchFamily="34" charset="-120"/>
+                          <a:latin typeface="Palatino Regular" charset="0"/>
+                          <a:ea typeface="Arial" panose="020B0604020202090204" pitchFamily="34" charset="-122"/>
+                          <a:cs typeface="Palatino Regular" charset="0"/>
                         </a:rPr>
                         <a:t>Sampled utility scoring only</a:t>
                       </a:r>
-                      <a:endParaRPr lang="en-US" sz="1200" dirty="0"/>
+                      <a:endParaRPr lang="en-US" sz="700" dirty="0">
+                        <a:solidFill>
+                          <a:srgbClr val="1A1F2B"/>
+                        </a:solidFill>
+                        <a:latin typeface="Palatino Regular" charset="0"/>
+                        <a:ea typeface="Arial" panose="020B0604020202090204" pitchFamily="34" charset="-122"/>
+                        <a:cs typeface="Palatino Regular" charset="0"/>
+                      </a:endParaRPr>
                     </a:p>
                   </a:txBody>
                   <a:tcPr marL="38100" marR="38100" marT="12700" marB="12700" anchor="ctr">
@@ -4274,21 +4000,31 @@
                     <a:bodyPr/>
                     <a:lstStyle/>
                     <a:p>
-                      <a:pPr algn="ctr" indent="0" marL="0">
+                      <a:pPr marL="0" algn="ctr">
+                        <a:buClrTx/>
+                        <a:buSzTx/>
+                        <a:buFontTx/>
                         <a:buNone/>
                       </a:pPr>
                       <a:r>
-                        <a:rPr lang="en-US" sz="680" dirty="0">
+                        <a:rPr lang="en-US" sz="700" dirty="0">
                           <a:solidFill>
                             <a:srgbClr val="1A1F2B"/>
                           </a:solidFill>
-                          <a:latin typeface="Arial" pitchFamily="34" charset="0"/>
-                          <a:ea typeface="Arial" pitchFamily="34" charset="-122"/>
-                          <a:cs typeface="Arial" pitchFamily="34" charset="-120"/>
+                          <a:latin typeface="Palatino Regular" charset="0"/>
+                          <a:ea typeface="Arial" panose="020B0604020202090204" pitchFamily="34" charset="-122"/>
+                          <a:cs typeface="Palatino Regular" charset="0"/>
                         </a:rPr>
                         <a:t>Private histogram queries during construction</a:t>
                       </a:r>
-                      <a:endParaRPr lang="en-US" sz="1200" dirty="0"/>
+                      <a:endParaRPr lang="en-US" sz="700" dirty="0">
+                        <a:solidFill>
+                          <a:srgbClr val="1A1F2B"/>
+                        </a:solidFill>
+                        <a:latin typeface="Palatino Regular" charset="0"/>
+                        <a:ea typeface="Arial" panose="020B0604020202090204" pitchFamily="34" charset="-122"/>
+                        <a:cs typeface="Palatino Regular" charset="0"/>
+                      </a:endParaRPr>
                     </a:p>
                   </a:txBody>
                   <a:tcPr marL="38100" marR="38100" marT="12700" marB="12700" anchor="ctr">
@@ -4319,7 +4055,7 @@
                     <a:bodyPr/>
                     <a:lstStyle/>
                     <a:p>
-                      <a:pPr algn="ctr" indent="0" marL="0">
+                      <a:pPr marL="0" indent="0" algn="ctr">
                         <a:buNone/>
                       </a:pPr>
                       <a:r>
@@ -4327,13 +4063,20 @@
                           <a:solidFill>
                             <a:srgbClr val="1A1F2B"/>
                           </a:solidFill>
-                          <a:latin typeface="Arial" pitchFamily="34" charset="0"/>
-                          <a:ea typeface="Arial" pitchFamily="34" charset="-122"/>
-                          <a:cs typeface="Arial" pitchFamily="34" charset="-120"/>
+                          <a:latin typeface="Comic Sans MS" panose="030F0902030302020204" charset="0"/>
+                          <a:ea typeface="Arial" panose="020B0604020202090204" pitchFamily="34" charset="-122"/>
+                          <a:cs typeface="Comic Sans MS" panose="030F0902030302020204" charset="0"/>
                         </a:rPr>
                         <a:t>Selection / recovery</a:t>
                       </a:r>
-                      <a:endParaRPr lang="en-US" sz="1200" dirty="0"/>
+                      <a:endParaRPr lang="en-US" sz="700" b="1" dirty="0">
+                        <a:solidFill>
+                          <a:srgbClr val="1A1F2B"/>
+                        </a:solidFill>
+                        <a:latin typeface="Comic Sans MS" panose="030F0902030302020204" charset="0"/>
+                        <a:ea typeface="Arial" panose="020B0604020202090204" pitchFamily="34" charset="-122"/>
+                        <a:cs typeface="Comic Sans MS" panose="030F0902030302020204" charset="0"/>
+                      </a:endParaRPr>
                     </a:p>
                   </a:txBody>
                   <a:tcPr marL="38100" marR="38100" marT="12700" marB="12700" anchor="ctr">
@@ -4362,21 +4105,31 @@
                     <a:bodyPr/>
                     <a:lstStyle/>
                     <a:p>
-                      <a:pPr algn="ctr" indent="0" marL="0">
+                      <a:pPr marL="0" algn="ctr">
+                        <a:buClrTx/>
+                        <a:buSzTx/>
+                        <a:buFontTx/>
                         <a:buNone/>
                       </a:pPr>
                       <a:r>
-                        <a:rPr lang="en-US" sz="680" dirty="0">
+                        <a:rPr lang="en-US" sz="700" dirty="0">
                           <a:solidFill>
                             <a:srgbClr val="1A1F2B"/>
                           </a:solidFill>
-                          <a:latin typeface="Arial" pitchFamily="34" charset="0"/>
-                          <a:ea typeface="Arial" pitchFamily="34" charset="-122"/>
-                          <a:cs typeface="Arial" pitchFamily="34" charset="-120"/>
+                          <a:latin typeface="Palatino Regular" charset="0"/>
+                          <a:ea typeface="Arial" panose="020B0604020202090204" pitchFamily="34" charset="-122"/>
+                          <a:cs typeface="Palatino Regular" charset="0"/>
                         </a:rPr>
                         <a:t>Top-M on privatized scores; alternatives persist</a:t>
                       </a:r>
-                      <a:endParaRPr lang="en-US" sz="1200" dirty="0"/>
+                      <a:endParaRPr lang="en-US" sz="700" dirty="0">
+                        <a:solidFill>
+                          <a:srgbClr val="1A1F2B"/>
+                        </a:solidFill>
+                        <a:latin typeface="Palatino Regular" charset="0"/>
+                        <a:ea typeface="Arial" panose="020B0604020202090204" pitchFamily="34" charset="-122"/>
+                        <a:cs typeface="Palatino Regular" charset="0"/>
+                      </a:endParaRPr>
                     </a:p>
                   </a:txBody>
                   <a:tcPr marL="38100" marR="38100" marT="12700" marB="12700" anchor="ctr">
@@ -4405,21 +4158,31 @@
                     <a:bodyPr/>
                     <a:lstStyle/>
                     <a:p>
-                      <a:pPr algn="ctr" indent="0" marL="0">
+                      <a:pPr marL="0" algn="ctr">
+                        <a:buClrTx/>
+                        <a:buSzTx/>
+                        <a:buFontTx/>
                         <a:buNone/>
                       </a:pPr>
                       <a:r>
-                        <a:rPr lang="en-US" sz="680" dirty="0">
+                        <a:rPr lang="en-US" sz="700" dirty="0">
                           <a:solidFill>
                             <a:srgbClr val="1A1F2B"/>
                           </a:solidFill>
-                          <a:latin typeface="Arial" pitchFamily="34" charset="0"/>
-                          <a:ea typeface="Arial" pitchFamily="34" charset="-122"/>
-                          <a:cs typeface="Arial" pitchFamily="34" charset="-120"/>
+                          <a:latin typeface="Palatino Regular" charset="0"/>
+                          <a:ea typeface="Arial" panose="020B0604020202090204" pitchFamily="34" charset="-122"/>
+                          <a:cs typeface="Palatino Regular" charset="0"/>
                         </a:rPr>
                         <a:t>Private token releases; no token-level backtracking</a:t>
                       </a:r>
-                      <a:endParaRPr lang="en-US" sz="1200" dirty="0"/>
+                      <a:endParaRPr lang="en-US" sz="700" dirty="0">
+                        <a:solidFill>
+                          <a:srgbClr val="1A1F2B"/>
+                        </a:solidFill>
+                        <a:latin typeface="Palatino Regular" charset="0"/>
+                        <a:ea typeface="Arial" panose="020B0604020202090204" pitchFamily="34" charset="-122"/>
+                        <a:cs typeface="Palatino Regular" charset="0"/>
+                      </a:endParaRPr>
                     </a:p>
                   </a:txBody>
                   <a:tcPr marL="38100" marR="38100" marT="12700" marB="12700" anchor="ctr">
@@ -4450,7 +4213,7 @@
                     <a:bodyPr/>
                     <a:lstStyle/>
                     <a:p>
-                      <a:pPr algn="ctr" indent="0" marL="0">
+                      <a:pPr marL="0" indent="0" algn="ctr">
                         <a:buNone/>
                       </a:pPr>
                       <a:r>
@@ -4458,13 +4221,20 @@
                           <a:solidFill>
                             <a:srgbClr val="1A1F2B"/>
                           </a:solidFill>
-                          <a:latin typeface="Arial" pitchFamily="34" charset="0"/>
-                          <a:ea typeface="Arial" pitchFamily="34" charset="-122"/>
-                          <a:cs typeface="Arial" pitchFamily="34" charset="-120"/>
+                          <a:latin typeface="Comic Sans MS" panose="030F0902030302020204" charset="0"/>
+                          <a:ea typeface="Arial" panose="020B0604020202090204" pitchFamily="34" charset="-122"/>
+                          <a:cs typeface="Comic Sans MS" panose="030F0902030302020204" charset="0"/>
                         </a:rPr>
                         <a:t>GSM8K (30 runs)</a:t>
                       </a:r>
-                      <a:endParaRPr lang="en-US" sz="1200" dirty="0"/>
+                      <a:endParaRPr lang="en-US" sz="700" b="1" dirty="0">
+                        <a:solidFill>
+                          <a:srgbClr val="1A1F2B"/>
+                        </a:solidFill>
+                        <a:latin typeface="Comic Sans MS" panose="030F0902030302020204" charset="0"/>
+                        <a:ea typeface="Arial" panose="020B0604020202090204" pitchFamily="34" charset="-122"/>
+                        <a:cs typeface="Comic Sans MS" panose="030F0902030302020204" charset="0"/>
+                      </a:endParaRPr>
                     </a:p>
                   </a:txBody>
                   <a:tcPr marL="38100" marR="38100" marT="12700" marB="12700" anchor="ctr">
@@ -4493,7 +4263,7 @@
                     <a:bodyPr/>
                     <a:lstStyle/>
                     <a:p>
-                      <a:pPr algn="ctr" indent="0" marL="0">
+                      <a:pPr marL="0" indent="0" algn="ctr">
                         <a:buNone/>
                       </a:pPr>
                       <a:r>
@@ -4501,13 +4271,20 @@
                           <a:solidFill>
                             <a:srgbClr val="0E7C7B"/>
                           </a:solidFill>
-                          <a:latin typeface="Arial" pitchFamily="34" charset="0"/>
-                          <a:ea typeface="Arial" pitchFamily="34" charset="-122"/>
-                          <a:cs typeface="Arial" pitchFamily="34" charset="-120"/>
+                          <a:latin typeface="Palatino Regular" charset="0"/>
+                          <a:ea typeface="Arial" panose="020B0604020202090204" pitchFamily="34" charset="-122"/>
+                          <a:cs typeface="Palatino Regular" charset="0"/>
                         </a:rPr>
                         <a:t>88.1 ± 3.2%</a:t>
                       </a:r>
-                      <a:endParaRPr lang="en-US" sz="1200" dirty="0"/>
+                      <a:endParaRPr lang="en-US" sz="800" b="1" dirty="0">
+                        <a:solidFill>
+                          <a:srgbClr val="0E7C7B"/>
+                        </a:solidFill>
+                        <a:latin typeface="Palatino Regular" charset="0"/>
+                        <a:ea typeface="Arial" panose="020B0604020202090204" pitchFamily="34" charset="-122"/>
+                        <a:cs typeface="Palatino Regular" charset="0"/>
+                      </a:endParaRPr>
                     </a:p>
                   </a:txBody>
                   <a:tcPr marL="38100" marR="38100" marT="12700" marB="12700" anchor="ctr">
@@ -4539,7 +4316,7 @@
                     <a:bodyPr/>
                     <a:lstStyle/>
                     <a:p>
-                      <a:pPr algn="ctr" indent="0" marL="0">
+                      <a:pPr marL="0" indent="0" algn="ctr">
                         <a:buNone/>
                       </a:pPr>
                       <a:r>
@@ -4547,13 +4324,20 @@
                           <a:solidFill>
                             <a:srgbClr val="B23124"/>
                           </a:solidFill>
-                          <a:latin typeface="Arial" pitchFamily="34" charset="0"/>
-                          <a:ea typeface="Arial" pitchFamily="34" charset="-122"/>
-                          <a:cs typeface="Arial" pitchFamily="34" charset="-120"/>
+                          <a:latin typeface="Palatino Regular" charset="0"/>
+                          <a:ea typeface="Arial" panose="020B0604020202090204" pitchFamily="34" charset="-122"/>
+                          <a:cs typeface="Palatino Regular" charset="0"/>
                         </a:rPr>
                         <a:t>49.5 ± 28.5%</a:t>
                       </a:r>
-                      <a:endParaRPr lang="en-US" sz="1200" dirty="0"/>
+                      <a:endParaRPr lang="en-US" sz="800" b="1" dirty="0">
+                        <a:solidFill>
+                          <a:srgbClr val="B23124"/>
+                        </a:solidFill>
+                        <a:latin typeface="Palatino Regular" charset="0"/>
+                        <a:ea typeface="Arial" panose="020B0604020202090204" pitchFamily="34" charset="-122"/>
+                        <a:cs typeface="Palatino Regular" charset="0"/>
+                      </a:endParaRPr>
                     </a:p>
                   </a:txBody>
                   <a:tcPr marL="38100" marR="38100" marT="12700" marB="12700" anchor="ctr">
@@ -4636,7 +4420,7 @@
     </a:clrScheme>
     <a:fontScheme name="Office">
       <a:majorFont>
-        <a:latin typeface="Calibri Light" panose="020F0302020204030204"/>
+        <a:latin typeface="Calibri Light"/>
         <a:ea typeface=""/>
         <a:cs typeface=""/>
         <a:font script="Jpan" typeface="游ゴシック Light"/>
@@ -4669,26 +4453,9 @@
         <a:font script="Viet" typeface="Times New Roman"/>
         <a:font script="Uigh" typeface="Microsoft Uighur"/>
         <a:font script="Geor" typeface="Sylfaen"/>
-        <a:font script="Armn" typeface="Arial"/>
-        <a:font script="Bugi" typeface="Leelawadee UI"/>
-        <a:font script="Bopo" typeface="Microsoft JhengHei"/>
-        <a:font script="Java" typeface="Javanese Text"/>
-        <a:font script="Lisu" typeface="Segoe UI"/>
-        <a:font script="Mymr" typeface="Myanmar Text"/>
-        <a:font script="Nkoo" typeface="Ebrima"/>
-        <a:font script="Olck" typeface="Nirmala UI"/>
-        <a:font script="Osma" typeface="Ebrima"/>
-        <a:font script="Phag" typeface="Phagspa"/>
-        <a:font script="Syrn" typeface="Estrangelo Edessa"/>
-        <a:font script="Syrj" typeface="Estrangelo Edessa"/>
-        <a:font script="Syre" typeface="Estrangelo Edessa"/>
-        <a:font script="Sora" typeface="Nirmala UI"/>
-        <a:font script="Tale" typeface="Microsoft Tai Le"/>
-        <a:font script="Talu" typeface="Microsoft New Tai Lue"/>
-        <a:font script="Tfng" typeface="Ebrima"/>
       </a:majorFont>
       <a:minorFont>
-        <a:latin typeface="Calibri" panose="020F0502020204030204"/>
+        <a:latin typeface="Calibri"/>
         <a:ea typeface=""/>
         <a:cs typeface=""/>
         <a:font script="Jpan" typeface="游ゴシック"/>
@@ -4721,23 +4488,6 @@
         <a:font script="Viet" typeface="Arial"/>
         <a:font script="Uigh" typeface="Microsoft Uighur"/>
         <a:font script="Geor" typeface="Sylfaen"/>
-        <a:font script="Armn" typeface="Arial"/>
-        <a:font script="Bugi" typeface="Leelawadee UI"/>
-        <a:font script="Bopo" typeface="Microsoft JhengHei"/>
-        <a:font script="Java" typeface="Javanese Text"/>
-        <a:font script="Lisu" typeface="Segoe UI"/>
-        <a:font script="Mymr" typeface="Myanmar Text"/>
-        <a:font script="Nkoo" typeface="Ebrima"/>
-        <a:font script="Olck" typeface="Nirmala UI"/>
-        <a:font script="Osma" typeface="Ebrima"/>
-        <a:font script="Phag" typeface="Phagspa"/>
-        <a:font script="Syrn" typeface="Estrangelo Edessa"/>
-        <a:font script="Syrj" typeface="Estrangelo Edessa"/>
-        <a:font script="Syre" typeface="Estrangelo Edessa"/>
-        <a:font script="Sora" typeface="Nirmala UI"/>
-        <a:font script="Tale" typeface="Microsoft Tai Le"/>
-        <a:font script="Talu" typeface="Microsoft New Tai Lue"/>
-        <a:font script="Tfng" typeface="Ebrima"/>
       </a:minorFont>
     </a:fontScheme>
     <a:fmtScheme name="Office">
@@ -4878,8 +4628,265 @@
       </a:bgFillStyleLst>
     </a:fmtScheme>
   </a:themeElements>
-  <a:objectDefaults/>
-  <a:extraClrSchemeLst/>
+  <a:extLst>
+    <a:ext uri="{05A4C25C-085E-4340-85A3-A5531E510DB2}">
+      <thm15:themeFamily xmlns:thm15="http://schemas.microsoft.com/office/thememl/2012/main" name="Office Theme" id="{62F939B6-93AF-4DB8-9C6B-D6C7DFDC589F}" vid="{4A3C46E8-61CC-4603-A589-7422A47A8E4A}"/>
+    </a:ext>
+  </a:extLst>
+</a:theme>
+</file>
+
+<file path=ppt/theme/theme2.xml><?xml version="1.0" encoding="utf-8"?>
+<a:theme xmlns:a="http://schemas.openxmlformats.org/drawingml/2006/main" name="Office Theme">
+  <a:themeElements>
+    <a:clrScheme name="Office">
+      <a:dk1>
+        <a:sysClr val="windowText" lastClr="000000"/>
+      </a:dk1>
+      <a:lt1>
+        <a:sysClr val="window" lastClr="FFFFFF"/>
+      </a:lt1>
+      <a:dk2>
+        <a:srgbClr val="44546A"/>
+      </a:dk2>
+      <a:lt2>
+        <a:srgbClr val="E7E6E6"/>
+      </a:lt2>
+      <a:accent1>
+        <a:srgbClr val="4472C4"/>
+      </a:accent1>
+      <a:accent2>
+        <a:srgbClr val="ED7D31"/>
+      </a:accent2>
+      <a:accent3>
+        <a:srgbClr val="A5A5A5"/>
+      </a:accent3>
+      <a:accent4>
+        <a:srgbClr val="FFC000"/>
+      </a:accent4>
+      <a:accent5>
+        <a:srgbClr val="5B9BD5"/>
+      </a:accent5>
+      <a:accent6>
+        <a:srgbClr val="70AD47"/>
+      </a:accent6>
+      <a:hlink>
+        <a:srgbClr val="0563C1"/>
+      </a:hlink>
+      <a:folHlink>
+        <a:srgbClr val="954F72"/>
+      </a:folHlink>
+    </a:clrScheme>
+    <a:fontScheme name="Office">
+      <a:majorFont>
+        <a:latin typeface="Calibri Light"/>
+        <a:ea typeface=""/>
+        <a:cs typeface=""/>
+        <a:font script="Jpan" typeface="游ゴシック Light"/>
+        <a:font script="Hang" typeface="맑은 고딕"/>
+        <a:font script="Hans" typeface="等线 Light"/>
+        <a:font script="Hant" typeface="新細明體"/>
+        <a:font script="Arab" typeface="Times New Roman"/>
+        <a:font script="Hebr" typeface="Times New Roman"/>
+        <a:font script="Thai" typeface="Angsana New"/>
+        <a:font script="Ethi" typeface="Nyala"/>
+        <a:font script="Beng" typeface="Vrinda"/>
+        <a:font script="Gujr" typeface="Shruti"/>
+        <a:font script="Khmr" typeface="MoolBoran"/>
+        <a:font script="Knda" typeface="Tunga"/>
+        <a:font script="Guru" typeface="Raavi"/>
+        <a:font script="Cans" typeface="Euphemia"/>
+        <a:font script="Cher" typeface="Plantagenet Cherokee"/>
+        <a:font script="Yiii" typeface="Microsoft Yi Baiti"/>
+        <a:font script="Tibt" typeface="Microsoft Himalaya"/>
+        <a:font script="Thaa" typeface="MV Boli"/>
+        <a:font script="Deva" typeface="Mangal"/>
+        <a:font script="Telu" typeface="Gautami"/>
+        <a:font script="Taml" typeface="Latha"/>
+        <a:font script="Syrc" typeface="Estrangelo Edessa"/>
+        <a:font script="Orya" typeface="Kalinga"/>
+        <a:font script="Mlym" typeface="Kartika"/>
+        <a:font script="Laoo" typeface="DokChampa"/>
+        <a:font script="Sinh" typeface="Iskoola Pota"/>
+        <a:font script="Mong" typeface="Mongolian Baiti"/>
+        <a:font script="Viet" typeface="Times New Roman"/>
+        <a:font script="Uigh" typeface="Microsoft Uighur"/>
+        <a:font script="Geor" typeface="Sylfaen"/>
+      </a:majorFont>
+      <a:minorFont>
+        <a:latin typeface="Calibri"/>
+        <a:ea typeface=""/>
+        <a:cs typeface=""/>
+        <a:font script="Jpan" typeface="游ゴシック"/>
+        <a:font script="Hang" typeface="맑은 고딕"/>
+        <a:font script="Hans" typeface="等线"/>
+        <a:font script="Hant" typeface="新細明體"/>
+        <a:font script="Arab" typeface="Arial"/>
+        <a:font script="Hebr" typeface="Arial"/>
+        <a:font script="Thai" typeface="Cordia New"/>
+        <a:font script="Ethi" typeface="Nyala"/>
+        <a:font script="Beng" typeface="Vrinda"/>
+        <a:font script="Gujr" typeface="Shruti"/>
+        <a:font script="Khmr" typeface="DaunPenh"/>
+        <a:font script="Knda" typeface="Tunga"/>
+        <a:font script="Guru" typeface="Raavi"/>
+        <a:font script="Cans" typeface="Euphemia"/>
+        <a:font script="Cher" typeface="Plantagenet Cherokee"/>
+        <a:font script="Yiii" typeface="Microsoft Yi Baiti"/>
+        <a:font script="Tibt" typeface="Microsoft Himalaya"/>
+        <a:font script="Thaa" typeface="MV Boli"/>
+        <a:font script="Deva" typeface="Mangal"/>
+        <a:font script="Telu" typeface="Gautami"/>
+        <a:font script="Taml" typeface="Latha"/>
+        <a:font script="Syrc" typeface="Estrangelo Edessa"/>
+        <a:font script="Orya" typeface="Kalinga"/>
+        <a:font script="Mlym" typeface="Kartika"/>
+        <a:font script="Laoo" typeface="DokChampa"/>
+        <a:font script="Sinh" typeface="Iskoola Pota"/>
+        <a:font script="Mong" typeface="Mongolian Baiti"/>
+        <a:font script="Viet" typeface="Arial"/>
+        <a:font script="Uigh" typeface="Microsoft Uighur"/>
+        <a:font script="Geor" typeface="Sylfaen"/>
+      </a:minorFont>
+    </a:fontScheme>
+    <a:fmtScheme name="Office">
+      <a:fillStyleLst>
+        <a:solidFill>
+          <a:schemeClr val="phClr"/>
+        </a:solidFill>
+        <a:gradFill rotWithShape="1">
+          <a:gsLst>
+            <a:gs pos="0">
+              <a:schemeClr val="phClr">
+                <a:lumMod val="110000"/>
+                <a:satMod val="105000"/>
+                <a:tint val="67000"/>
+              </a:schemeClr>
+            </a:gs>
+            <a:gs pos="50000">
+              <a:schemeClr val="phClr">
+                <a:lumMod val="105000"/>
+                <a:satMod val="103000"/>
+                <a:tint val="73000"/>
+              </a:schemeClr>
+            </a:gs>
+            <a:gs pos="100000">
+              <a:schemeClr val="phClr">
+                <a:lumMod val="105000"/>
+                <a:satMod val="109000"/>
+                <a:tint val="81000"/>
+              </a:schemeClr>
+            </a:gs>
+          </a:gsLst>
+          <a:lin ang="5400000" scaled="0"/>
+        </a:gradFill>
+        <a:gradFill rotWithShape="1">
+          <a:gsLst>
+            <a:gs pos="0">
+              <a:schemeClr val="phClr">
+                <a:satMod val="103000"/>
+                <a:lumMod val="102000"/>
+                <a:tint val="94000"/>
+              </a:schemeClr>
+            </a:gs>
+            <a:gs pos="50000">
+              <a:schemeClr val="phClr">
+                <a:satMod val="110000"/>
+                <a:lumMod val="100000"/>
+                <a:shade val="100000"/>
+              </a:schemeClr>
+            </a:gs>
+            <a:gs pos="100000">
+              <a:schemeClr val="phClr">
+                <a:lumMod val="99000"/>
+                <a:satMod val="120000"/>
+                <a:shade val="78000"/>
+              </a:schemeClr>
+            </a:gs>
+          </a:gsLst>
+          <a:lin ang="5400000" scaled="0"/>
+        </a:gradFill>
+      </a:fillStyleLst>
+      <a:lnStyleLst>
+        <a:ln w="6350" cap="flat" cmpd="sng" algn="ctr">
+          <a:solidFill>
+            <a:schemeClr val="phClr"/>
+          </a:solidFill>
+          <a:prstDash val="solid"/>
+          <a:miter lim="800000"/>
+        </a:ln>
+        <a:ln w="12700" cap="flat" cmpd="sng" algn="ctr">
+          <a:solidFill>
+            <a:schemeClr val="phClr"/>
+          </a:solidFill>
+          <a:prstDash val="solid"/>
+          <a:miter lim="800000"/>
+        </a:ln>
+        <a:ln w="19050" cap="flat" cmpd="sng" algn="ctr">
+          <a:solidFill>
+            <a:schemeClr val="phClr"/>
+          </a:solidFill>
+          <a:prstDash val="solid"/>
+          <a:miter lim="800000"/>
+        </a:ln>
+      </a:lnStyleLst>
+      <a:effectStyleLst>
+        <a:effectStyle>
+          <a:effectLst/>
+        </a:effectStyle>
+        <a:effectStyle>
+          <a:effectLst/>
+        </a:effectStyle>
+        <a:effectStyle>
+          <a:effectLst>
+            <a:outerShdw blurRad="57150" dist="19050" dir="5400000" algn="ctr" rotWithShape="0">
+              <a:srgbClr val="000000">
+                <a:alpha val="63000"/>
+              </a:srgbClr>
+            </a:outerShdw>
+          </a:effectLst>
+        </a:effectStyle>
+      </a:effectStyleLst>
+      <a:bgFillStyleLst>
+        <a:solidFill>
+          <a:schemeClr val="phClr"/>
+        </a:solidFill>
+        <a:solidFill>
+          <a:schemeClr val="phClr">
+            <a:tint val="95000"/>
+            <a:satMod val="170000"/>
+          </a:schemeClr>
+        </a:solidFill>
+        <a:gradFill rotWithShape="1">
+          <a:gsLst>
+            <a:gs pos="0">
+              <a:schemeClr val="phClr">
+                <a:tint val="93000"/>
+                <a:satMod val="150000"/>
+                <a:shade val="98000"/>
+                <a:lumMod val="102000"/>
+              </a:schemeClr>
+            </a:gs>
+            <a:gs pos="50000">
+              <a:schemeClr val="phClr">
+                <a:tint val="98000"/>
+                <a:satMod val="130000"/>
+                <a:shade val="90000"/>
+                <a:lumMod val="103000"/>
+              </a:schemeClr>
+            </a:gs>
+            <a:gs pos="100000">
+              <a:schemeClr val="phClr">
+                <a:shade val="63000"/>
+                <a:satMod val="120000"/>
+              </a:schemeClr>
+            </a:gs>
+          </a:gsLst>
+          <a:lin ang="5400000" scaled="0"/>
+        </a:gradFill>
+      </a:bgFillStyleLst>
+    </a:fmtScheme>
+  </a:themeElements>
   <a:extLst>
     <a:ext uri="{05A4C25C-085E-4340-85A3-A5531E510DB2}">
       <thm15:themeFamily xmlns:thm15="http://schemas.microsoft.com/office/thememl/2012/main" name="Office Theme" id="{62F939B6-93AF-4DB8-9C6B-D6C7DFDC589F}" vid="{4A3C46E8-61CC-4603-A589-7422A47A8E4A}"/>

</xml_diff>

<commit_message>
Finalize Figure 1 typography and notation
</commit_message>
<xml_diff>
--- a/paper/figures/DPES_Figure1_v2_editable.pptx
+++ b/paper/figures/DPES_Figure1_v2_editable.pptx
@@ -1,17 +1,17 @@
 
 <file path=ppt/presentation.xml><?xml version="1.0" encoding="utf-8"?>
-<p:presentation xmlns:a="http://schemas.openxmlformats.org/drawingml/2006/main" xmlns:r="http://schemas.openxmlformats.org/officeDocument/2006/relationships" xmlns:p="http://schemas.openxmlformats.org/presentationml/2006/main" autoCompressPictures="0">
+<p:presentation xmlns:a="http://schemas.openxmlformats.org/drawingml/2006/main" xmlns:r="http://schemas.openxmlformats.org/officeDocument/2006/relationships" xmlns:p="http://schemas.openxmlformats.org/presentationml/2006/main" saveSubsetFonts="1" autoCompressPictures="0">
   <p:sldMasterIdLst>
     <p:sldMasterId id="2147483648" r:id="rId1"/>
   </p:sldMasterIdLst>
+  <p:sldIdLst>
+    <p:sldId id="256" r:id="rId2"/>
+  </p:sldIdLst>
   <p:notesMasterIdLst>
-    <p:notesMasterId r:id="rId4"/>
+    <p:notesMasterId r:id="rId3"/>
   </p:notesMasterIdLst>
-  <p:sldIdLst>
-    <p:sldId id="256" r:id="rId3"/>
-  </p:sldIdLst>
-  <p:sldSz cx="5760720" cy="4452620"/>
-  <p:notesSz cx="4452620" cy="5760720"/>
+  <p:sldSz cx="5760720" cy="4453128"/>
+  <p:notesSz cx="4453128" cy="5760720"/>
   <p:defaultTextStyle>
     <a:lvl1pPr marL="0" algn="l" defTabSz="914400" rtl="0" eaLnBrk="1" latinLnBrk="0" hangingPunct="1">
       <a:defRPr sz="1800" kern="1200">
@@ -189,6 +189,7 @@
           <a:p>
             <a:fld id="{5282F153-3F37-0F45-9E97-73ACFA13230C}" type="datetimeFigureOut">
               <a:rPr lang="en-US"/>
+              <a:t>7/23/19</a:t>
             </a:fld>
             <a:endParaRPr lang="en-US"/>
           </a:p>
@@ -255,7 +256,6 @@
               <a:rPr lang="en-US"/>
               <a:t>Click to edit Master text styles</a:t>
             </a:r>
-            <a:endParaRPr lang="en-US"/>
           </a:p>
           <a:p>
             <a:pPr lvl="1"/>
@@ -263,7 +263,6 @@
               <a:rPr lang="en-US"/>
               <a:t>Second level</a:t>
             </a:r>
-            <a:endParaRPr lang="en-US"/>
           </a:p>
           <a:p>
             <a:pPr lvl="2"/>
@@ -271,7 +270,6 @@
               <a:rPr lang="en-US"/>
               <a:t>Third level</a:t>
             </a:r>
-            <a:endParaRPr lang="en-US"/>
           </a:p>
           <a:p>
             <a:pPr lvl="3"/>
@@ -279,7 +277,6 @@
               <a:rPr lang="en-US"/>
               <a:t>Fourth level</a:t>
             </a:r>
-            <a:endParaRPr lang="en-US"/>
           </a:p>
           <a:p>
             <a:pPr lvl="4"/>
@@ -287,7 +284,6 @@
               <a:rPr lang="en-US"/>
               <a:t>Fifth level</a:t>
             </a:r>
-            <a:endParaRPr lang="en-US"/>
           </a:p>
         </p:txBody>
       </p:sp>
@@ -351,12 +347,18 @@
           <a:p>
             <a:fld id="{CE5E9CC1-C706-0F49-92D6-E571CC5EEA8F}" type="slidenum">
               <a:rPr lang="en-US"/>
+              <a:t>‹#›</a:t>
             </a:fld>
             <a:endParaRPr lang="en-US"/>
           </a:p>
         </p:txBody>
       </p:sp>
     </p:spTree>
+    <p:extLst>
+      <p:ext uri="{BB962C8B-B14F-4D97-AF65-F5344CB8AC3E}">
+        <p14:creationId xmlns:p14="http://schemas.microsoft.com/office/powerpoint/2010/main" val="1024086991"/>
+      </p:ext>
+    </p:extLst>
   </p:cSld>
   <p:clrMap bg1="lt1" tx1="dk1" bg2="lt2" tx2="dk2" accent1="accent1" accent2="accent2" accent3="accent3" accent4="accent4" accent5="accent5" accent6="accent6" hlink="hlink" folHlink="folHlink"/>
   <p:notesStyle>
@@ -498,6 +500,10 @@
           <a:bodyPr/>
           <a:lstStyle/>
           <a:p>
+            <a:r>
+              <a:rPr lang="en-US" dirty="0"/>
+              <a:t/>
+            </a:r>
             <a:endParaRPr lang="en-US" dirty="0"/>
           </a:p>
         </p:txBody>
@@ -519,12 +525,18 @@
           <a:p>
             <a:fld id="{F7021451-1387-4CA6-816F-3879F97B5CBC}" type="slidenum">
               <a:rPr lang="en-US"/>
+              <a:t>1</a:t>
             </a:fld>
             <a:endParaRPr lang="en-US"/>
           </a:p>
         </p:txBody>
       </p:sp>
     </p:spTree>
+    <p:extLst>
+      <p:ext uri="{BB962C8B-B14F-4D97-AF65-F5344CB8AC3E}">
+        <p14:creationId xmlns:p14="http://schemas.microsoft.com/office/powerpoint/2010/main" val="1024086991"/>
+      </p:ext>
+    </p:extLst>
   </p:cSld>
   <p:clrMapOvr>
     <a:masterClrMapping/>
@@ -565,11 +577,6 @@
 <file path=ppt/slideMasters/slideMaster1.xml><?xml version="1.0" encoding="utf-8"?>
 <p:sldMaster xmlns:a="http://schemas.openxmlformats.org/drawingml/2006/main" xmlns:r="http://schemas.openxmlformats.org/officeDocument/2006/relationships" xmlns:p="http://schemas.openxmlformats.org/presentationml/2006/main">
   <p:cSld>
-    <p:bg>
-      <p:bgRef idx="1001">
-        <a:schemeClr val="bg1"/>
-      </p:bgRef>
-    </p:bg>
     <p:spTree>
       <p:nvGrpSpPr>
         <p:cNvPr id="1" name=""/>
@@ -613,7 +620,7 @@
         <a:spcBef>
           <a:spcPct val="20000"/>
         </a:spcBef>
-        <a:buFont typeface="Arial" panose="020B0604020202090204" pitchFamily="34" charset="0"/>
+        <a:buFont typeface="Arial" pitchFamily="34" charset="0"/>
         <a:buChar char="•"/>
         <a:defRPr sz="3200" kern="1200">
           <a:solidFill>
@@ -628,7 +635,7 @@
         <a:spcBef>
           <a:spcPct val="20000"/>
         </a:spcBef>
-        <a:buFont typeface="Arial" panose="020B0604020202090204" pitchFamily="34" charset="0"/>
+        <a:buFont typeface="Arial" pitchFamily="34" charset="0"/>
         <a:buChar char="–"/>
         <a:defRPr sz="2800" kern="1200">
           <a:solidFill>
@@ -643,7 +650,7 @@
         <a:spcBef>
           <a:spcPct val="20000"/>
         </a:spcBef>
-        <a:buFont typeface="Arial" panose="020B0604020202090204" pitchFamily="34" charset="0"/>
+        <a:buFont typeface="Arial" pitchFamily="34" charset="0"/>
         <a:buChar char="•"/>
         <a:defRPr sz="2400" kern="1200">
           <a:solidFill>
@@ -658,7 +665,7 @@
         <a:spcBef>
           <a:spcPct val="20000"/>
         </a:spcBef>
-        <a:buFont typeface="Arial" panose="020B0604020202090204" pitchFamily="34" charset="0"/>
+        <a:buFont typeface="Arial" pitchFamily="34" charset="0"/>
         <a:buChar char="–"/>
         <a:defRPr sz="2000" kern="1200">
           <a:solidFill>
@@ -673,7 +680,7 @@
         <a:spcBef>
           <a:spcPct val="20000"/>
         </a:spcBef>
-        <a:buFont typeface="Arial" panose="020B0604020202090204" pitchFamily="34" charset="0"/>
+        <a:buFont typeface="Arial" pitchFamily="34" charset="0"/>
         <a:buChar char="»"/>
         <a:defRPr sz="2000" kern="1200">
           <a:solidFill>
@@ -688,7 +695,7 @@
         <a:spcBef>
           <a:spcPct val="20000"/>
         </a:spcBef>
-        <a:buFont typeface="Arial" panose="020B0604020202090204" pitchFamily="34" charset="0"/>
+        <a:buFont typeface="Arial" pitchFamily="34" charset="0"/>
         <a:buChar char="•"/>
         <a:defRPr sz="2000" kern="1200">
           <a:solidFill>
@@ -703,7 +710,7 @@
         <a:spcBef>
           <a:spcPct val="20000"/>
         </a:spcBef>
-        <a:buFont typeface="Arial" panose="020B0604020202090204" pitchFamily="34" charset="0"/>
+        <a:buFont typeface="Arial" pitchFamily="34" charset="0"/>
         <a:buChar char="•"/>
         <a:defRPr sz="2000" kern="1200">
           <a:solidFill>
@@ -718,7 +725,7 @@
         <a:spcBef>
           <a:spcPct val="20000"/>
         </a:spcBef>
-        <a:buFont typeface="Arial" panose="020B0604020202090204" pitchFamily="34" charset="0"/>
+        <a:buFont typeface="Arial" pitchFamily="34" charset="0"/>
         <a:buChar char="•"/>
         <a:defRPr sz="2000" kern="1200">
           <a:solidFill>
@@ -733,7 +740,7 @@
         <a:spcBef>
           <a:spcPct val="20000"/>
         </a:spcBef>
-        <a:buFont typeface="Arial" panose="020B0604020202090204" pitchFamily="34" charset="0"/>
+        <a:buFont typeface="Arial" pitchFamily="34" charset="0"/>
         <a:buChar char="•"/>
         <a:defRPr sz="2000" kern="1200">
           <a:solidFill>
@@ -846,13 +853,12 @@
 
 <file path=ppt/slides/slide1.xml><?xml version="1.0" encoding="utf-8"?>
 <p:sld xmlns:a="http://schemas.openxmlformats.org/drawingml/2006/main" xmlns:r="http://schemas.openxmlformats.org/officeDocument/2006/relationships" xmlns:p="http://schemas.openxmlformats.org/presentationml/2006/main">
-  <p:cSld>
+  <p:cSld name="Slide 1">
     <p:bg>
       <p:bgPr>
         <a:solidFill>
           <a:srgbClr val="FFFFFF"/>
         </a:solidFill>
-        <a:effectLst/>
       </p:bgPr>
     </p:bg>
     <p:spTree>
@@ -884,12 +890,13 @@
             <a:avLst/>
           </a:prstGeom>
           <a:noFill/>
+          <a:ln/>
         </p:spPr>
         <p:txBody>
           <a:bodyPr wrap="square" lIns="0" tIns="0" rIns="0" bIns="0" rtlCol="0" anchor="t"/>
           <a:lstStyle/>
           <a:p>
-            <a:pPr marL="0" indent="0" algn="l">
+            <a:pPr algn="l" indent="0" marL="0">
               <a:lnSpc>
                 <a:spcPct val="100000"/>
               </a:lnSpc>
@@ -900,38 +907,47 @@
                 <a:solidFill>
                   <a:srgbClr val="1A1F2B"/>
                 </a:solidFill>
-                <a:latin typeface="Comic Sans MS Bold" panose="030F0902030302020204" charset="0"/>
-                <a:ea typeface="Arial" panose="020B0604020202090204" pitchFamily="34" charset="-122"/>
-                <a:cs typeface="Comic Sans MS Bold" panose="030F0902030302020204" charset="0"/>
+                <a:latin typeface="Arial" pitchFamily="34" charset="0"/>
+                <a:ea typeface="Arial" pitchFamily="34" charset="-122"/>
+                <a:cs typeface="Arial" pitchFamily="34" charset="-120"/>
               </a:rPr>
               <a:t>(a)   One </a:t>
             </a:r>
-            <a:r>
-              <a:rPr lang="en-US" sz="900" dirty="0">
+            <a:pPr algn="l" indent="0" marL="0">
+              <a:lnSpc>
+                <a:spcPct val="100000"/>
+              </a:lnSpc>
+              <a:buNone/>
+            </a:pPr>
+            <a:r>
+              <a:rPr lang="en-US" sz="900" b="1" dirty="0">
                 <a:solidFill>
                   <a:srgbClr val="1A1F2B"/>
                 </a:solidFill>
-                <a:latin typeface="Comic Sans MS Bold" panose="030F0902030302020204" charset="0"/>
-                <a:ea typeface="Arial" panose="020B0604020202090204" pitchFamily="34" charset="-122"/>
-                <a:cs typeface="Comic Sans MS Bold" panose="030F0902030302020204" charset="0"/>
-              </a:rPr>
-              <a:t>DP-ES iter</a:t>
-            </a:r>
+                <a:latin typeface="Arial" pitchFamily="34" charset="0"/>
+                <a:ea typeface="Arial" pitchFamily="34" charset="-122"/>
+                <a:cs typeface="Arial" pitchFamily="34" charset="-120"/>
+              </a:rPr>
+              <a:t>DP-ES</a:t>
+            </a:r>
+            <a:pPr algn="l" indent="0" marL="0">
+              <a:lnSpc>
+                <a:spcPct val="100000"/>
+              </a:lnSpc>
+              <a:buNone/>
+            </a:pPr>
             <a:r>
               <a:rPr lang="en-US" sz="900" b="1" dirty="0">
                 <a:solidFill>
                   <a:srgbClr val="1A1F2B"/>
                 </a:solidFill>
-                <a:latin typeface="Comic Sans MS Bold" panose="030F0902030302020204" charset="0"/>
-                <a:ea typeface="Arial" panose="020B0604020202090204" pitchFamily="34" charset="-122"/>
-                <a:cs typeface="Comic Sans MS Bold" panose="030F0902030302020204" charset="0"/>
-              </a:rPr>
-              <a:t>ation: privacy-free exploration, private scoring</a:t>
-            </a:r>
-            <a:endParaRPr lang="en-US" sz="900" dirty="0">
-              <a:latin typeface="Comic Sans MS Bold" panose="030F0902030302020204" charset="0"/>
-              <a:cs typeface="Comic Sans MS Bold" panose="030F0902030302020204" charset="0"/>
-            </a:endParaRPr>
+                <a:latin typeface="Arial" pitchFamily="34" charset="0"/>
+                <a:ea typeface="Arial" pitchFamily="34" charset="-122"/>
+                <a:cs typeface="Arial" pitchFamily="34" charset="-120"/>
+              </a:rPr>
+              <a:t> iteration: privacy-free exploration, private scoring</a:t>
+            </a:r>
+            <a:endParaRPr lang="en-US" sz="900" dirty="0"/>
           </a:p>
         </p:txBody>
       </p:sp>
@@ -1041,76 +1057,122 @@
         </p:nvSpPr>
         <p:spPr>
           <a:xfrm>
-            <a:off x="1691640" y="307848"/>
+            <a:off x="1691640" y="315468"/>
             <a:ext cx="2377440" cy="118872"/>
           </a:xfrm>
           <a:prstGeom prst="rect">
             <a:avLst/>
           </a:prstGeom>
           <a:noFill/>
+          <a:ln/>
         </p:spPr>
         <p:txBody>
           <a:bodyPr wrap="square" lIns="0" tIns="0" rIns="0" bIns="0" rtlCol="0" anchor="t"/>
           <a:lstStyle/>
           <a:p>
-            <a:pPr marL="0" indent="0" algn="ctr">
-              <a:lnSpc>
-                <a:spcPct val="100000"/>
-              </a:lnSpc>
-              <a:buNone/>
-            </a:pPr>
-            <a:r>
-              <a:rPr lang="en-US" sz="700" b="1" dirty="0">
+            <a:pPr algn="ctr" indent="0" marL="0">
+              <a:lnSpc>
+                <a:spcPct val="100000"/>
+              </a:lnSpc>
+              <a:buNone/>
+            </a:pPr>
+            <a:r>
+              <a:rPr lang="en-US" sz="680" b="1" dirty="0">
                 <a:solidFill>
                   <a:srgbClr val="1F3D7A"/>
                 </a:solidFill>
-                <a:latin typeface="Comic Sans MS" panose="030F0902030302020204" charset="0"/>
-                <a:ea typeface="Arial" panose="020B0604020202090204" pitchFamily="34" charset="-122"/>
-                <a:cs typeface="Comic Sans MS" panose="030F0902030302020204" charset="0"/>
-              </a:rPr>
-              <a:t>Top-M parents  S</a:t>
-            </a:r>
-            <a:r>
-              <a:rPr lang="en-US" sz="700" b="1" baseline="-40000" dirty="0">
+                <a:latin typeface="Arial" pitchFamily="34" charset="0"/>
+                <a:ea typeface="Arial" pitchFamily="34" charset="-122"/>
+                <a:cs typeface="Arial" pitchFamily="34" charset="-120"/>
+              </a:rPr>
+              <a:t>Top-M parents  </a:t>
+            </a:r>
+            <a:pPr algn="ctr" indent="0" marL="0">
+              <a:lnSpc>
+                <a:spcPct val="100000"/>
+              </a:lnSpc>
+              <a:buNone/>
+            </a:pPr>
+            <a:r>
+              <a:rPr lang="en-US" sz="680" b="1" i="1" dirty="0">
                 <a:solidFill>
                   <a:srgbClr val="1F3D7A"/>
                 </a:solidFill>
-                <a:latin typeface="Comic Sans MS" panose="030F0902030302020204" charset="0"/>
-                <a:ea typeface="Arial" panose="020B0604020202090204" pitchFamily="34" charset="-122"/>
-                <a:cs typeface="Comic Sans MS" panose="030F0902030302020204" charset="0"/>
+                <a:latin typeface="Arial" pitchFamily="34" charset="0"/>
+                <a:ea typeface="Arial" pitchFamily="34" charset="-122"/>
+                <a:cs typeface="Arial" pitchFamily="34" charset="-120"/>
+              </a:rPr>
+              <a:t>S</a:t>
+            </a:r>
+            <a:pPr algn="ctr" indent="0" marL="0">
+              <a:lnSpc>
+                <a:spcPct val="100000"/>
+              </a:lnSpc>
+              <a:buNone/>
+            </a:pPr>
+            <a:r>
+              <a:rPr lang="en-US" sz="680" b="1" baseline="-40000" dirty="0">
+                <a:solidFill>
+                  <a:srgbClr val="1F3D7A"/>
+                </a:solidFill>
+                <a:latin typeface="Arial" pitchFamily="34" charset="0"/>
+                <a:ea typeface="Arial" pitchFamily="34" charset="-122"/>
+                <a:cs typeface="Arial" pitchFamily="34" charset="-120"/>
               </a:rPr>
               <a:t>t</a:t>
             </a:r>
-            <a:r>
-              <a:rPr lang="en-US" sz="700" b="1" dirty="0">
+            <a:pPr algn="ctr" indent="0" marL="0">
+              <a:lnSpc>
+                <a:spcPct val="100000"/>
+              </a:lnSpc>
+              <a:buNone/>
+            </a:pPr>
+            <a:r>
+              <a:rPr lang="en-US" sz="680" b="1" dirty="0">
                 <a:solidFill>
                   <a:srgbClr val="1F3D7A"/>
                 </a:solidFill>
-                <a:latin typeface="Comic Sans MS" panose="030F0902030302020204" charset="0"/>
-                <a:ea typeface="Arial" panose="020B0604020202090204" pitchFamily="34" charset="-122"/>
-                <a:cs typeface="Comic Sans MS" panose="030F0902030302020204" charset="0"/>
-              </a:rPr>
-              <a:t>  →</a:t>
-            </a:r>
-            <a:r>
-              <a:rPr lang="en-US" sz="700" b="1" dirty="0">
+                <a:latin typeface="Arial" pitchFamily="34" charset="0"/>
+                <a:ea typeface="Arial" pitchFamily="34" charset="-122"/>
+                <a:cs typeface="Arial" pitchFamily="34" charset="-120"/>
+              </a:rPr>
+              <a:t>  →  next iteration  (× </a:t>
+            </a:r>
+            <a:pPr algn="ctr" indent="0" marL="0">
+              <a:lnSpc>
+                <a:spcPct val="100000"/>
+              </a:lnSpc>
+              <a:buNone/>
+            </a:pPr>
+            <a:r>
+              <a:rPr lang="en-US" sz="680" b="1" i="1" dirty="0">
                 <a:solidFill>
                   <a:srgbClr val="1F3D7A"/>
                 </a:solidFill>
-                <a:latin typeface="Comic Sans MS" panose="030F0902030302020204" charset="0"/>
-                <a:ea typeface="Arial" panose="020B0604020202090204" pitchFamily="34" charset="-122"/>
-                <a:cs typeface="Comic Sans MS" panose="030F0902030302020204" charset="0"/>
-              </a:rPr>
-              <a:t>  next iteration  (× T )</a:t>
-            </a:r>
-            <a:endParaRPr lang="en-US" sz="700" b="1" dirty="0">
-              <a:solidFill>
-                <a:srgbClr val="1F3D7A"/>
-              </a:solidFill>
-              <a:latin typeface="Comic Sans MS" panose="030F0902030302020204" charset="0"/>
-              <a:ea typeface="Arial" panose="020B0604020202090204" pitchFamily="34" charset="-122"/>
-              <a:cs typeface="Comic Sans MS" panose="030F0902030302020204" charset="0"/>
-            </a:endParaRPr>
+                <a:latin typeface="Arial" pitchFamily="34" charset="0"/>
+                <a:ea typeface="Arial" pitchFamily="34" charset="-122"/>
+                <a:cs typeface="Arial" pitchFamily="34" charset="-120"/>
+              </a:rPr>
+              <a:t>T</a:t>
+            </a:r>
+            <a:pPr algn="ctr" indent="0" marL="0">
+              <a:lnSpc>
+                <a:spcPct val="100000"/>
+              </a:lnSpc>
+              <a:buNone/>
+            </a:pPr>
+            <a:r>
+              <a:rPr lang="en-US" sz="680" b="1" dirty="0">
+                <a:solidFill>
+                  <a:srgbClr val="1F3D7A"/>
+                </a:solidFill>
+                <a:latin typeface="Arial" pitchFamily="34" charset="0"/>
+                <a:ea typeface="Arial" pitchFamily="34" charset="-122"/>
+                <a:cs typeface="Arial" pitchFamily="34" charset="-120"/>
+              </a:rPr>
+              <a:t>)</a:t>
+            </a:r>
+            <a:endParaRPr lang="en-US" sz="680" dirty="0"/>
           </a:p>
         </p:txBody>
       </p:sp>
@@ -1156,36 +1218,30 @@
             <a:avLst/>
           </a:prstGeom>
           <a:noFill/>
+          <a:ln/>
         </p:spPr>
         <p:txBody>
           <a:bodyPr wrap="square" lIns="0" tIns="0" rIns="0" bIns="0" rtlCol="0" anchor="t"/>
           <a:lstStyle/>
           <a:p>
-            <a:pPr marL="0" indent="0" algn="ctr">
-              <a:lnSpc>
-                <a:spcPct val="100000"/>
-              </a:lnSpc>
-              <a:buNone/>
-            </a:pPr>
-            <a:r>
-              <a:rPr lang="en-US" sz="760" b="1" kern="0" spc="35" dirty="0">
+            <a:pPr algn="ctr" indent="0" marL="0">
+              <a:lnSpc>
+                <a:spcPct val="100000"/>
+              </a:lnSpc>
+              <a:buNone/>
+            </a:pPr>
+            <a:r>
+              <a:rPr lang="en-US" sz="760" b="1" spc="35" kern="0" dirty="0">
                 <a:solidFill>
                   <a:srgbClr val="0E7C7B"/>
                 </a:solidFill>
-                <a:latin typeface="Comic Sans MS" panose="030F0902030302020204" charset="0"/>
-                <a:ea typeface="Arial" panose="020B0604020202090204" pitchFamily="34" charset="-122"/>
-                <a:cs typeface="Comic Sans MS" panose="030F0902030302020204" charset="0"/>
+                <a:latin typeface="Arial" pitchFamily="34" charset="0"/>
+                <a:ea typeface="Arial" pitchFamily="34" charset="-122"/>
+                <a:cs typeface="Arial" pitchFamily="34" charset="-120"/>
               </a:rPr>
               <a:t>PRIVACY-FREE</a:t>
             </a:r>
-            <a:endParaRPr lang="en-US" sz="760" b="1" kern="0" spc="35" dirty="0">
-              <a:solidFill>
-                <a:srgbClr val="0E7C7B"/>
-              </a:solidFill>
-              <a:latin typeface="Comic Sans MS" panose="030F0902030302020204" charset="0"/>
-              <a:ea typeface="Arial" panose="020B0604020202090204" pitchFamily="34" charset="-122"/>
-              <a:cs typeface="Comic Sans MS" panose="030F0902030302020204" charset="0"/>
-            </a:endParaRPr>
+            <a:endParaRPr lang="en-US" sz="760" dirty="0"/>
           </a:p>
         </p:txBody>
       </p:sp>
@@ -1231,36 +1287,30 @@
             <a:avLst/>
           </a:prstGeom>
           <a:noFill/>
+          <a:ln/>
         </p:spPr>
         <p:txBody>
           <a:bodyPr wrap="square" lIns="0" tIns="0" rIns="0" bIns="0" rtlCol="0" anchor="t"/>
           <a:lstStyle/>
           <a:p>
-            <a:pPr marL="0" indent="0" algn="ctr">
-              <a:lnSpc>
-                <a:spcPct val="100000"/>
-              </a:lnSpc>
-              <a:buNone/>
-            </a:pPr>
-            <a:r>
-              <a:rPr lang="en-US" sz="760" b="1" kern="0" spc="35" dirty="0">
+            <a:pPr algn="ctr" indent="0" marL="0">
+              <a:lnSpc>
+                <a:spcPct val="100000"/>
+              </a:lnSpc>
+              <a:buNone/>
+            </a:pPr>
+            <a:r>
+              <a:rPr lang="en-US" sz="760" b="1" spc="35" kern="0" dirty="0">
                 <a:solidFill>
                   <a:srgbClr val="1F3D7A"/>
                 </a:solidFill>
-                <a:latin typeface="Comic Sans MS" panose="030F0902030302020204" charset="0"/>
-                <a:ea typeface="Arial" panose="020B0604020202090204" pitchFamily="34" charset="-122"/>
-                <a:cs typeface="Comic Sans MS" panose="030F0902030302020204" charset="0"/>
+                <a:latin typeface="Arial" pitchFamily="34" charset="0"/>
+                <a:ea typeface="Arial" pitchFamily="34" charset="-122"/>
+                <a:cs typeface="Arial" pitchFamily="34" charset="-120"/>
               </a:rPr>
               <a:t>PRIVATE-DATA ACCESS</a:t>
             </a:r>
-            <a:endParaRPr lang="en-US" sz="760" b="1" kern="0" spc="35" dirty="0">
-              <a:solidFill>
-                <a:srgbClr val="1F3D7A"/>
-              </a:solidFill>
-              <a:latin typeface="Comic Sans MS" panose="030F0902030302020204" charset="0"/>
-              <a:ea typeface="Arial" panose="020B0604020202090204" pitchFamily="34" charset="-122"/>
-              <a:cs typeface="Comic Sans MS" panose="030F0902030302020204" charset="0"/>
-            </a:endParaRPr>
+            <a:endParaRPr lang="en-US" sz="760" dirty="0"/>
           </a:p>
         </p:txBody>
       </p:sp>
@@ -1306,36 +1356,30 @@
             <a:avLst/>
           </a:prstGeom>
           <a:noFill/>
+          <a:ln/>
         </p:spPr>
         <p:txBody>
           <a:bodyPr wrap="square" lIns="0" tIns="0" rIns="0" bIns="0" rtlCol="0" anchor="t"/>
           <a:lstStyle/>
           <a:p>
-            <a:pPr marL="0" indent="0" algn="ctr">
-              <a:lnSpc>
-                <a:spcPct val="100000"/>
-              </a:lnSpc>
-              <a:buNone/>
-            </a:pPr>
-            <a:r>
-              <a:rPr lang="en-US" sz="760" b="1" kern="0" spc="35" dirty="0">
+            <a:pPr algn="ctr" indent="0" marL="0">
+              <a:lnSpc>
+                <a:spcPct val="100000"/>
+              </a:lnSpc>
+              <a:buNone/>
+            </a:pPr>
+            <a:r>
+              <a:rPr lang="en-US" sz="760" b="1" spc="35" kern="0" dirty="0">
                 <a:solidFill>
                   <a:srgbClr val="2E7D32"/>
                 </a:solidFill>
-                <a:latin typeface="Comic Sans MS" panose="030F0902030302020204" charset="0"/>
-                <a:ea typeface="Arial" panose="020B0604020202090204" pitchFamily="34" charset="-122"/>
-                <a:cs typeface="Comic Sans MS" panose="030F0902030302020204" charset="0"/>
+                <a:latin typeface="Arial" pitchFamily="34" charset="0"/>
+                <a:ea typeface="Arial" pitchFamily="34" charset="-122"/>
+                <a:cs typeface="Arial" pitchFamily="34" charset="-120"/>
               </a:rPr>
               <a:t>POST-PROCESSING</a:t>
             </a:r>
-            <a:endParaRPr lang="en-US" sz="760" b="1" kern="0" spc="35" dirty="0">
-              <a:solidFill>
-                <a:srgbClr val="2E7D32"/>
-              </a:solidFill>
-              <a:latin typeface="Comic Sans MS" panose="030F0902030302020204" charset="0"/>
-              <a:ea typeface="Arial" panose="020B0604020202090204" pitchFamily="34" charset="-122"/>
-              <a:cs typeface="Comic Sans MS" panose="030F0902030302020204" charset="0"/>
-            </a:endParaRPr>
+            <a:endParaRPr lang="en-US" sz="760" dirty="0"/>
           </a:p>
         </p:txBody>
       </p:sp>
@@ -1383,6 +1427,7 @@
           <a:solidFill>
             <a:srgbClr val="0E7C7B"/>
           </a:solidFill>
+          <a:ln/>
         </p:spPr>
       </p:sp>
       <p:sp>
@@ -1522,12 +1567,13 @@
             <a:avLst/>
           </a:prstGeom>
           <a:noFill/>
+          <a:ln/>
         </p:spPr>
         <p:txBody>
           <a:bodyPr wrap="square" lIns="0" tIns="0" rIns="0" bIns="0" rtlCol="0" anchor="ctr"/>
           <a:lstStyle/>
           <a:p>
-            <a:pPr marL="0" indent="0" algn="ctr">
+            <a:pPr algn="ctr" indent="0" marL="0">
               <a:lnSpc>
                 <a:spcPct val="104000"/>
               </a:lnSpc>
@@ -1538,19 +1584,16 @@
                 <a:solidFill>
                   <a:srgbClr val="0E7C7B"/>
                 </a:solidFill>
-                <a:latin typeface="Comic Sans MS Regular" panose="030F0902030302020204" charset="0"/>
-                <a:ea typeface="Arial" panose="020B0604020202090204" pitchFamily="34" charset="-122"/>
-                <a:cs typeface="Comic Sans MS Regular" panose="030F0902030302020204" charset="0"/>
+                <a:latin typeface="Arial" pitchFamily="34" charset="0"/>
+                <a:ea typeface="Arial" pitchFamily="34" charset="-122"/>
+                <a:cs typeface="Arial" pitchFamily="34" charset="-120"/>
               </a:rPr>
               <a:t>Phase 1</a:t>
             </a:r>
-            <a:endParaRPr lang="en-US" sz="780" dirty="0">
-              <a:latin typeface="Comic Sans MS Regular" panose="030F0902030302020204" charset="0"/>
-              <a:cs typeface="Comic Sans MS Regular" panose="030F0902030302020204" charset="0"/>
-            </a:endParaRPr>
+            <a:endParaRPr lang="en-US" sz="780" dirty="0"/>
           </a:p>
           <a:p>
-            <a:pPr marL="0" indent="0" algn="ctr">
+            <a:pPr algn="ctr" indent="0" marL="0">
               <a:lnSpc>
                 <a:spcPct val="104000"/>
               </a:lnSpc>
@@ -1561,16 +1604,13 @@
                 <a:solidFill>
                   <a:srgbClr val="0E7C7B"/>
                 </a:solidFill>
-                <a:latin typeface="Comic Sans MS Regular" panose="030F0902030302020204" charset="0"/>
-                <a:ea typeface="Arial" panose="020B0604020202090204" pitchFamily="34" charset="-122"/>
-                <a:cs typeface="Comic Sans MS Regular" panose="030F0902030302020204" charset="0"/>
+                <a:latin typeface="Arial" pitchFamily="34" charset="0"/>
+                <a:ea typeface="Arial" pitchFamily="34" charset="-122"/>
+                <a:cs typeface="Arial" pitchFamily="34" charset="-120"/>
               </a:rPr>
               <a:t>LLM mutation</a:t>
             </a:r>
-            <a:endParaRPr lang="en-US" sz="780" dirty="0">
-              <a:latin typeface="Comic Sans MS Regular" panose="030F0902030302020204" charset="0"/>
-              <a:cs typeface="Comic Sans MS Regular" panose="030F0902030302020204" charset="0"/>
-            </a:endParaRPr>
+            <a:endParaRPr lang="en-US" sz="780" dirty="0"/>
           </a:p>
         </p:txBody>
       </p:sp>
@@ -1582,212 +1622,314 @@
         </p:nvSpPr>
         <p:spPr>
           <a:xfrm>
-            <a:off x="256032" y="1273302"/>
+            <a:off x="256032" y="1293876"/>
             <a:ext cx="1493520" cy="118872"/>
           </a:xfrm>
           <a:prstGeom prst="rect">
             <a:avLst/>
           </a:prstGeom>
           <a:noFill/>
+          <a:ln/>
         </p:spPr>
         <p:txBody>
           <a:bodyPr wrap="square" lIns="0" tIns="0" rIns="0" bIns="0" rtlCol="0" anchor="t"/>
           <a:lstStyle/>
           <a:p>
-            <a:pPr marL="0" indent="0" algn="ctr">
-              <a:lnSpc>
-                <a:spcPct val="100000"/>
-              </a:lnSpc>
-              <a:buNone/>
-            </a:pPr>
-            <a:r>
-              <a:rPr lang="en-US" sz="800" dirty="0">
+            <a:pPr algn="ctr" indent="0" marL="0">
+              <a:lnSpc>
+                <a:spcPct val="100000"/>
+              </a:lnSpc>
+              <a:buNone/>
+            </a:pPr>
+            <a:r>
+              <a:rPr lang="en-US" sz="760" i="1" dirty="0">
                 <a:solidFill>
                   <a:srgbClr val="1A1F2B"/>
                 </a:solidFill>
-                <a:latin typeface="Comic Sans MS" panose="030F0902030302020204" charset="0"/>
-                <a:ea typeface="Times New Roman" panose="02020503050405090304" pitchFamily="34" charset="-122"/>
-                <a:cs typeface="Comic Sans MS" panose="030F0902030302020204" charset="0"/>
+                <a:latin typeface="Times New Roman" pitchFamily="34" charset="0"/>
+                <a:ea typeface="Times New Roman" pitchFamily="34" charset="-122"/>
+                <a:cs typeface="Times New Roman" pitchFamily="34" charset="-120"/>
               </a:rPr>
               <a:t>P</a:t>
             </a:r>
-            <a:r>
-              <a:rPr lang="en-US" sz="800" baseline="-40000" dirty="0">
+            <a:pPr algn="ctr" indent="0" marL="0">
+              <a:lnSpc>
+                <a:spcPct val="100000"/>
+              </a:lnSpc>
+              <a:buNone/>
+            </a:pPr>
+            <a:r>
+              <a:rPr lang="en-US" sz="760" baseline="-40000" dirty="0">
                 <a:solidFill>
                   <a:srgbClr val="1A1F2B"/>
                 </a:solidFill>
-                <a:latin typeface="Comic Sans MS" panose="030F0902030302020204" charset="0"/>
-                <a:ea typeface="Times New Roman" panose="02020503050405090304" pitchFamily="34" charset="-122"/>
-                <a:cs typeface="Comic Sans MS" panose="030F0902030302020204" charset="0"/>
+                <a:latin typeface="Times New Roman" pitchFamily="34" charset="0"/>
+                <a:ea typeface="Times New Roman" pitchFamily="34" charset="-122"/>
+                <a:cs typeface="Times New Roman" pitchFamily="34" charset="-120"/>
               </a:rPr>
               <a:t>t</a:t>
             </a:r>
-            <a:r>
-              <a:rPr lang="en-US" sz="800" dirty="0">
+            <a:pPr algn="ctr" indent="0" marL="0">
+              <a:lnSpc>
+                <a:spcPct val="100000"/>
+              </a:lnSpc>
+              <a:buNone/>
+            </a:pPr>
+            <a:r>
+              <a:rPr lang="en-US" sz="760" dirty="0">
                 <a:solidFill>
                   <a:srgbClr val="1A1F2B"/>
                 </a:solidFill>
-                <a:latin typeface="Comic Sans MS" panose="030F0902030302020204" charset="0"/>
-                <a:ea typeface="Times New Roman" panose="02020503050405090304" pitchFamily="34" charset="-122"/>
-                <a:cs typeface="Comic Sans MS" panose="030F0902030302020204" charset="0"/>
-              </a:rPr>
-              <a:t>  ←  Mutate-To-K(S</a:t>
-            </a:r>
-            <a:r>
-              <a:rPr lang="en-US" sz="800" baseline="-40000" dirty="0">
+                <a:latin typeface="Times New Roman" pitchFamily="34" charset="0"/>
+                <a:ea typeface="Times New Roman" pitchFamily="34" charset="-122"/>
+                <a:cs typeface="Times New Roman" pitchFamily="34" charset="-120"/>
+              </a:rPr>
+              <a:t>  ←  Mutate-To-K(</a:t>
+            </a:r>
+            <a:pPr algn="ctr" indent="0" marL="0">
+              <a:lnSpc>
+                <a:spcPct val="100000"/>
+              </a:lnSpc>
+              <a:buNone/>
+            </a:pPr>
+            <a:r>
+              <a:rPr lang="en-US" sz="760" i="1" dirty="0">
                 <a:solidFill>
                   <a:srgbClr val="1A1F2B"/>
                 </a:solidFill>
-                <a:latin typeface="Comic Sans MS" panose="030F0902030302020204" charset="0"/>
-                <a:ea typeface="Times New Roman" panose="02020503050405090304" pitchFamily="34" charset="-122"/>
-                <a:cs typeface="Comic Sans MS" panose="030F0902030302020204" charset="0"/>
+                <a:latin typeface="Times New Roman" pitchFamily="34" charset="0"/>
+                <a:ea typeface="Times New Roman" pitchFamily="34" charset="-122"/>
+                <a:cs typeface="Times New Roman" pitchFamily="34" charset="-120"/>
+              </a:rPr>
+              <a:t>S</a:t>
+            </a:r>
+            <a:pPr algn="ctr" indent="0" marL="0">
+              <a:lnSpc>
+                <a:spcPct val="100000"/>
+              </a:lnSpc>
+              <a:buNone/>
+            </a:pPr>
+            <a:r>
+              <a:rPr lang="en-US" sz="760" baseline="-40000" dirty="0">
+                <a:solidFill>
+                  <a:srgbClr val="1A1F2B"/>
+                </a:solidFill>
+                <a:latin typeface="Times New Roman" pitchFamily="34" charset="0"/>
+                <a:ea typeface="Times New Roman" pitchFamily="34" charset="-122"/>
+                <a:cs typeface="Times New Roman" pitchFamily="34" charset="-120"/>
               </a:rPr>
               <a:t>t−1</a:t>
             </a:r>
-            <a:r>
-              <a:rPr lang="en-US" sz="800" dirty="0">
+            <a:pPr algn="ctr" indent="0" marL="0">
+              <a:lnSpc>
+                <a:spcPct val="100000"/>
+              </a:lnSpc>
+              <a:buNone/>
+            </a:pPr>
+            <a:r>
+              <a:rPr lang="en-US" sz="760" dirty="0">
                 <a:solidFill>
                   <a:srgbClr val="1A1F2B"/>
                 </a:solidFill>
-                <a:latin typeface="Comic Sans MS" panose="030F0902030302020204" charset="0"/>
-                <a:ea typeface="Times New Roman" panose="02020503050405090304" pitchFamily="34" charset="-122"/>
-                <a:cs typeface="Comic Sans MS" panose="030F0902030302020204" charset="0"/>
-              </a:rPr>
-              <a:t>), </a:t>
-            </a:r>
-            <a:endParaRPr lang="en-US" sz="800" dirty="0">
-              <a:solidFill>
-                <a:srgbClr val="1A1F2B"/>
-              </a:solidFill>
-              <a:latin typeface="Comic Sans MS" panose="030F0902030302020204" charset="0"/>
-              <a:ea typeface="Times New Roman" panose="02020503050405090304" pitchFamily="34" charset="-122"/>
-              <a:cs typeface="Comic Sans MS" panose="030F0902030302020204" charset="0"/>
-            </a:endParaRPr>
-          </a:p>
-          <a:p>
-            <a:pPr marL="0" indent="0" algn="ctr">
-              <a:lnSpc>
-                <a:spcPct val="100000"/>
-              </a:lnSpc>
-              <a:buNone/>
-            </a:pPr>
-            <a:r>
-              <a:rPr lang="en-US" sz="800" dirty="0">
-                <a:solidFill>
-                  <a:srgbClr val="1A1F2B"/>
-                </a:solidFill>
-                <a:latin typeface="Comic Sans MS" panose="030F0902030302020204" charset="0"/>
-                <a:ea typeface="Times New Roman" panose="02020503050405090304" pitchFamily="34" charset="-122"/>
-                <a:cs typeface="Comic Sans MS" panose="030F0902030302020204" charset="0"/>
-              </a:rPr>
-              <a:t>  |P</a:t>
-            </a:r>
-            <a:r>
-              <a:rPr lang="en-US" sz="800" baseline="-40000" dirty="0">
-                <a:solidFill>
-                  <a:srgbClr val="1A1F2B"/>
-                </a:solidFill>
-                <a:latin typeface="Comic Sans MS" panose="030F0902030302020204" charset="0"/>
-                <a:ea typeface="Times New Roman" panose="02020503050405090304" pitchFamily="34" charset="-122"/>
-                <a:cs typeface="Comic Sans MS" panose="030F0902030302020204" charset="0"/>
-              </a:rPr>
-              <a:t>t</a:t>
-            </a:r>
-            <a:r>
-              <a:rPr lang="en-US" sz="800" dirty="0">
-                <a:solidFill>
-                  <a:srgbClr val="1A1F2B"/>
-                </a:solidFill>
-                <a:latin typeface="Comic Sans MS" panose="030F0902030302020204" charset="0"/>
-                <a:ea typeface="Times New Roman" panose="02020503050405090304" pitchFamily="34" charset="-122"/>
-                <a:cs typeface="Comic Sans MS" panose="030F0902030302020204" charset="0"/>
-              </a:rPr>
-              <a:t>| = K</a:t>
-            </a:r>
-            <a:endParaRPr lang="en-US" sz="800" dirty="0">
-              <a:solidFill>
-                <a:srgbClr val="1A1F2B"/>
-              </a:solidFill>
-              <a:latin typeface="Comic Sans MS" panose="030F0902030302020204" charset="0"/>
-              <a:ea typeface="Times New Roman" panose="02020503050405090304" pitchFamily="34" charset="-122"/>
-              <a:cs typeface="Comic Sans MS" panose="030F0902030302020204" charset="0"/>
-            </a:endParaRPr>
+                <a:latin typeface="Times New Roman" pitchFamily="34" charset="0"/>
+                <a:ea typeface="Times New Roman" pitchFamily="34" charset="-122"/>
+                <a:cs typeface="Times New Roman" pitchFamily="34" charset="-120"/>
+              </a:rPr>
+              <a:t>),</a:t>
+            </a:r>
+            <a:endParaRPr lang="en-US" sz="760" dirty="0"/>
           </a:p>
         </p:txBody>
       </p:sp>
       <p:sp>
         <p:nvSpPr>
-          <p:cNvPr id="22" name="a.p1.body"/>
+          <p:cNvPr id="22" name="a.p1.formula2"/>
           <p:cNvSpPr txBox="1"/>
           <p:nvPr/>
         </p:nvSpPr>
         <p:spPr>
           <a:xfrm>
-            <a:off x="283464" y="1554480"/>
-            <a:ext cx="1438656" cy="329184"/>
+            <a:off x="256032" y="1412748"/>
+            <a:ext cx="1493520" cy="118872"/>
           </a:xfrm>
           <a:prstGeom prst="rect">
             <a:avLst/>
           </a:prstGeom>
           <a:noFill/>
+          <a:ln/>
         </p:spPr>
         <p:txBody>
           <a:bodyPr wrap="square" lIns="0" tIns="0" rIns="0" bIns="0" rtlCol="0" anchor="t"/>
           <a:lstStyle/>
           <a:p>
-            <a:pPr marL="0" indent="0" algn="l">
-              <a:lnSpc>
-                <a:spcPct val="96000"/>
-              </a:lnSpc>
-              <a:buNone/>
-            </a:pPr>
-            <a:r>
-              <a:rPr lang="en-US" sz="700" dirty="0">
-                <a:solidFill>
-                  <a:srgbClr val="333B48"/>
-                </a:solidFill>
-                <a:latin typeface="Comic Sans MS" panose="030F0902030302020204" charset="0"/>
-                <a:ea typeface="Arial" panose="020B0604020202090204" pitchFamily="34" charset="-122"/>
-                <a:cs typeface="Comic Sans MS" panose="030F0902030302020204" charset="0"/>
-              </a:rPr>
-              <a:t>Builds a fixed K-candidate population from selected parents; never reads the private set </a:t>
-            </a:r>
-            <a:r>
-              <a:rPr lang="en-US" sz="700" dirty="0">
-                <a:solidFill>
-                  <a:srgbClr val="333B48"/>
-                </a:solidFill>
-                <a:latin typeface="Comic Sans MS" panose="030F0902030302020204" charset="0"/>
-                <a:ea typeface="Cambria Math" pitchFamily="34" charset="-122"/>
-                <a:cs typeface="Comic Sans MS" panose="030F0902030302020204" charset="0"/>
-              </a:rPr>
-              <a:t>𝒟</a:t>
-            </a:r>
-            <a:r>
-              <a:rPr lang="en-US" sz="700" dirty="0">
-                <a:solidFill>
-                  <a:srgbClr val="333B48"/>
-                </a:solidFill>
-                <a:latin typeface="Comic Sans MS" panose="030F0902030302020204" charset="0"/>
-                <a:ea typeface="Arial" panose="020B0604020202090204" pitchFamily="34" charset="-122"/>
-                <a:cs typeface="Comic Sans MS" panose="030F0902030302020204" charset="0"/>
-              </a:rPr>
-              <a:t>.</a:t>
-            </a:r>
-            <a:endParaRPr lang="en-US" sz="700" dirty="0">
-              <a:solidFill>
-                <a:srgbClr val="333B48"/>
-              </a:solidFill>
-              <a:latin typeface="Comic Sans MS" panose="030F0902030302020204" charset="0"/>
-              <a:ea typeface="Arial" panose="020B0604020202090204" pitchFamily="34" charset="-122"/>
-              <a:cs typeface="Comic Sans MS" panose="030F0902030302020204" charset="0"/>
-            </a:endParaRPr>
+            <a:pPr algn="ctr" indent="0" marL="0">
+              <a:lnSpc>
+                <a:spcPct val="100000"/>
+              </a:lnSpc>
+              <a:buNone/>
+            </a:pPr>
+            <a:r>
+              <a:rPr lang="en-US" sz="760" dirty="0">
+                <a:solidFill>
+                  <a:srgbClr val="1A1F2B"/>
+                </a:solidFill>
+                <a:latin typeface="Times New Roman" pitchFamily="34" charset="0"/>
+                <a:ea typeface="Times New Roman" pitchFamily="34" charset="-122"/>
+                <a:cs typeface="Times New Roman" pitchFamily="34" charset="-120"/>
+              </a:rPr>
+              <a:t>|</a:t>
+            </a:r>
+            <a:pPr algn="ctr" indent="0" marL="0">
+              <a:lnSpc>
+                <a:spcPct val="100000"/>
+              </a:lnSpc>
+              <a:buNone/>
+            </a:pPr>
+            <a:r>
+              <a:rPr lang="en-US" sz="760" i="1" dirty="0">
+                <a:solidFill>
+                  <a:srgbClr val="1A1F2B"/>
+                </a:solidFill>
+                <a:latin typeface="Times New Roman" pitchFamily="34" charset="0"/>
+                <a:ea typeface="Times New Roman" pitchFamily="34" charset="-122"/>
+                <a:cs typeface="Times New Roman" pitchFamily="34" charset="-120"/>
+              </a:rPr>
+              <a:t>P</a:t>
+            </a:r>
+            <a:pPr algn="ctr" indent="0" marL="0">
+              <a:lnSpc>
+                <a:spcPct val="100000"/>
+              </a:lnSpc>
+              <a:buNone/>
+            </a:pPr>
+            <a:r>
+              <a:rPr lang="en-US" sz="760" baseline="-40000" dirty="0">
+                <a:solidFill>
+                  <a:srgbClr val="1A1F2B"/>
+                </a:solidFill>
+                <a:latin typeface="Times New Roman" pitchFamily="34" charset="0"/>
+                <a:ea typeface="Times New Roman" pitchFamily="34" charset="-122"/>
+                <a:cs typeface="Times New Roman" pitchFamily="34" charset="-120"/>
+              </a:rPr>
+              <a:t>t</a:t>
+            </a:r>
+            <a:pPr algn="ctr" indent="0" marL="0">
+              <a:lnSpc>
+                <a:spcPct val="100000"/>
+              </a:lnSpc>
+              <a:buNone/>
+            </a:pPr>
+            <a:r>
+              <a:rPr lang="en-US" sz="760" dirty="0">
+                <a:solidFill>
+                  <a:srgbClr val="1A1F2B"/>
+                </a:solidFill>
+                <a:latin typeface="Times New Roman" pitchFamily="34" charset="0"/>
+                <a:ea typeface="Times New Roman" pitchFamily="34" charset="-122"/>
+                <a:cs typeface="Times New Roman" pitchFamily="34" charset="-120"/>
+              </a:rPr>
+              <a:t>| = </a:t>
+            </a:r>
+            <a:pPr algn="ctr" indent="0" marL="0">
+              <a:lnSpc>
+                <a:spcPct val="100000"/>
+              </a:lnSpc>
+              <a:buNone/>
+            </a:pPr>
+            <a:r>
+              <a:rPr lang="en-US" sz="760" i="1" dirty="0">
+                <a:solidFill>
+                  <a:srgbClr val="1A1F2B"/>
+                </a:solidFill>
+                <a:latin typeface="Times New Roman" pitchFamily="34" charset="0"/>
+                <a:ea typeface="Times New Roman" pitchFamily="34" charset="-122"/>
+                <a:cs typeface="Times New Roman" pitchFamily="34" charset="-120"/>
+              </a:rPr>
+              <a:t>K</a:t>
+            </a:r>
+            <a:endParaRPr lang="en-US" sz="760" dirty="0"/>
           </a:p>
         </p:txBody>
       </p:sp>
       <p:sp>
         <p:nvSpPr>
-          <p:cNvPr id="23" name="a.p1.costPill"/>
+          <p:cNvPr id="23" name="a.p1.body"/>
+          <p:cNvSpPr txBox="1"/>
+          <p:nvPr/>
+        </p:nvSpPr>
+        <p:spPr>
+          <a:xfrm>
+            <a:off x="283464" y="1554480"/>
+            <a:ext cx="1438656" cy="329184"/>
+          </a:xfrm>
+          <a:prstGeom prst="rect">
+            <a:avLst/>
+          </a:prstGeom>
+          <a:noFill/>
+          <a:ln/>
+        </p:spPr>
+        <p:txBody>
+          <a:bodyPr wrap="square" lIns="0" tIns="0" rIns="0" bIns="0" rtlCol="0" anchor="t"/>
+          <a:lstStyle/>
+          <a:p>
+            <a:pPr algn="l" indent="0" marL="0">
+              <a:lnSpc>
+                <a:spcPct val="96000"/>
+              </a:lnSpc>
+              <a:buNone/>
+            </a:pPr>
+            <a:r>
+              <a:rPr lang="en-US" sz="660" dirty="0">
+                <a:solidFill>
+                  <a:srgbClr val="333B48"/>
+                </a:solidFill>
+                <a:latin typeface="Arial" pitchFamily="34" charset="0"/>
+                <a:ea typeface="Arial" pitchFamily="34" charset="-122"/>
+                <a:cs typeface="Arial" pitchFamily="34" charset="-120"/>
+              </a:rPr>
+              <a:t>Builds a fixed K-candidate population from selected parents; never reads the private set </a:t>
+            </a:r>
+            <a:pPr algn="l" indent="0" marL="0">
+              <a:lnSpc>
+                <a:spcPct val="96000"/>
+              </a:lnSpc>
+              <a:buNone/>
+            </a:pPr>
+            <a:r>
+              <a:rPr lang="en-US" sz="660" dirty="0">
+                <a:solidFill>
+                  <a:srgbClr val="333B48"/>
+                </a:solidFill>
+                <a:latin typeface="Cambria Math" pitchFamily="34" charset="0"/>
+                <a:ea typeface="Cambria Math" pitchFamily="34" charset="-122"/>
+                <a:cs typeface="Cambria Math" pitchFamily="34" charset="-120"/>
+              </a:rPr>
+              <a:t>𝒟</a:t>
+            </a:r>
+            <a:pPr algn="l" indent="0" marL="0">
+              <a:lnSpc>
+                <a:spcPct val="96000"/>
+              </a:lnSpc>
+              <a:buNone/>
+            </a:pPr>
+            <a:r>
+              <a:rPr lang="en-US" sz="660" dirty="0">
+                <a:solidFill>
+                  <a:srgbClr val="333B48"/>
+                </a:solidFill>
+                <a:latin typeface="Arial" pitchFamily="34" charset="0"/>
+                <a:ea typeface="Arial" pitchFamily="34" charset="-122"/>
+                <a:cs typeface="Arial" pitchFamily="34" charset="-120"/>
+              </a:rPr>
+              <a:t>.</a:t>
+            </a:r>
+            <a:endParaRPr lang="en-US" sz="660" dirty="0"/>
+          </a:p>
+        </p:txBody>
+      </p:sp>
+      <p:sp>
+        <p:nvSpPr>
+          <p:cNvPr id="24" name="a.p1.costPill"/>
           <p:cNvSpPr/>
           <p:nvPr/>
         </p:nvSpPr>
@@ -1804,11 +1946,12 @@
           <a:solidFill>
             <a:srgbClr val="0E7C7B"/>
           </a:solidFill>
-        </p:spPr>
-      </p:sp>
-      <p:sp>
-        <p:nvSpPr>
-          <p:cNvPr id="24" name="a.p1.costLabel"/>
+          <a:ln/>
+        </p:spPr>
+      </p:sp>
+      <p:sp>
+        <p:nvSpPr>
+          <p:cNvPr id="25" name="a.p1.costLabel"/>
           <p:cNvSpPr txBox="1"/>
           <p:nvPr/>
         </p:nvSpPr>
@@ -1821,12 +1964,13 @@
             <a:avLst/>
           </a:prstGeom>
           <a:noFill/>
+          <a:ln/>
         </p:spPr>
         <p:txBody>
           <a:bodyPr wrap="square" lIns="0" tIns="0" rIns="0" bIns="0" rtlCol="0" anchor="t"/>
           <a:lstStyle/>
           <a:p>
-            <a:pPr marL="0" indent="0" algn="ctr">
+            <a:pPr algn="ctr" indent="0" marL="0">
               <a:lnSpc>
                 <a:spcPct val="100000"/>
               </a:lnSpc>
@@ -1837,26 +1981,19 @@
                 <a:solidFill>
                   <a:srgbClr val="FFFFFF"/>
                 </a:solidFill>
-                <a:latin typeface="Comic Sans MS Regular" panose="030F0902030302020204" charset="0"/>
-                <a:ea typeface="Arial" panose="020B0604020202090204" pitchFamily="34" charset="-122"/>
-                <a:cs typeface="Comic Sans MS Regular" panose="030F0902030302020204" charset="0"/>
+                <a:latin typeface="Arial" pitchFamily="34" charset="0"/>
+                <a:ea typeface="Arial" pitchFamily="34" charset="-122"/>
+                <a:cs typeface="Arial" pitchFamily="34" charset="-120"/>
               </a:rPr>
               <a:t>0 additional privacy loss</a:t>
             </a:r>
-            <a:endParaRPr lang="en-US" sz="640" b="1" dirty="0">
-              <a:solidFill>
-                <a:srgbClr val="FFFFFF"/>
-              </a:solidFill>
-              <a:latin typeface="Comic Sans MS Regular" panose="030F0902030302020204" charset="0"/>
-              <a:ea typeface="Arial" panose="020B0604020202090204" pitchFamily="34" charset="-122"/>
-              <a:cs typeface="Comic Sans MS Regular" panose="030F0902030302020204" charset="0"/>
-            </a:endParaRPr>
+            <a:endParaRPr lang="en-US" sz="640" dirty="0"/>
           </a:p>
         </p:txBody>
       </p:sp>
       <p:sp>
         <p:nvSpPr>
-          <p:cNvPr id="25" name="a.p2.frame"/>
+          <p:cNvPr id="26" name="a.p2.frame"/>
           <p:cNvSpPr/>
           <p:nvPr/>
         </p:nvSpPr>
@@ -1883,7 +2020,7 @@
       </p:sp>
       <p:sp>
         <p:nvSpPr>
-          <p:cNvPr id="26" name="a.p2.iconDisc"/>
+          <p:cNvPr id="27" name="a.p2.iconDisc"/>
           <p:cNvSpPr/>
           <p:nvPr/>
         </p:nvSpPr>
@@ -1898,11 +2035,12 @@
           <a:solidFill>
             <a:srgbClr val="1F3D7A"/>
           </a:solidFill>
-        </p:spPr>
-      </p:sp>
-      <p:sp>
-        <p:nvSpPr>
-          <p:cNvPr id="27" name="a.p2.icon.curve"/>
+          <a:ln/>
+        </p:spPr>
+      </p:sp>
+      <p:sp>
+        <p:nvSpPr>
+          <p:cNvPr id="28" name="a.p2.icon.curve"/>
           <p:cNvSpPr/>
           <p:nvPr/>
         </p:nvSpPr>
@@ -1945,7 +2083,7 @@
       </p:sp>
       <p:sp>
         <p:nvSpPr>
-          <p:cNvPr id="28" name="a.p2.icon.axis"/>
+          <p:cNvPr id="29" name="a.p2.icon.axis"/>
           <p:cNvSpPr/>
           <p:nvPr/>
         </p:nvSpPr>
@@ -1968,7 +2106,7 @@
       </p:sp>
       <p:sp>
         <p:nvSpPr>
-          <p:cNvPr id="29" name="a.p2.icon.sample"/>
+          <p:cNvPr id="30" name="a.p2.icon.sample"/>
           <p:cNvSpPr/>
           <p:nvPr/>
         </p:nvSpPr>
@@ -1983,11 +2121,12 @@
           <a:solidFill>
             <a:srgbClr val="FFFFFF"/>
           </a:solidFill>
-        </p:spPr>
-      </p:sp>
-      <p:sp>
-        <p:nvSpPr>
-          <p:cNvPr id="30" name="a.p2.title"/>
+          <a:ln/>
+        </p:spPr>
+      </p:sp>
+      <p:sp>
+        <p:nvSpPr>
+          <p:cNvPr id="31" name="a.p2.title"/>
           <p:cNvSpPr txBox="1"/>
           <p:nvPr/>
         </p:nvSpPr>
@@ -2000,12 +2139,13 @@
             <a:avLst/>
           </a:prstGeom>
           <a:noFill/>
+          <a:ln/>
         </p:spPr>
         <p:txBody>
           <a:bodyPr wrap="square" lIns="0" tIns="0" rIns="0" bIns="0" rtlCol="0" anchor="ctr"/>
           <a:lstStyle/>
           <a:p>
-            <a:pPr marL="0" indent="0" algn="ctr">
+            <a:pPr algn="ctr" indent="0" marL="0">
               <a:lnSpc>
                 <a:spcPct val="104000"/>
               </a:lnSpc>
@@ -2016,19 +2156,16 @@
                 <a:solidFill>
                   <a:srgbClr val="1F3D7A"/>
                 </a:solidFill>
-                <a:latin typeface="Comic Sans MS Regular" panose="030F0902030302020204" charset="0"/>
-                <a:ea typeface="Arial" panose="020B0604020202090204" pitchFamily="34" charset="-122"/>
-                <a:cs typeface="Comic Sans MS Regular" panose="030F0902030302020204" charset="0"/>
+                <a:latin typeface="Arial" pitchFamily="34" charset="0"/>
+                <a:ea typeface="Arial" pitchFamily="34" charset="-122"/>
+                <a:cs typeface="Arial" pitchFamily="34" charset="-120"/>
               </a:rPr>
               <a:t>Phase 2</a:t>
             </a:r>
-            <a:endParaRPr lang="en-US" sz="780" dirty="0">
-              <a:latin typeface="Comic Sans MS Regular" panose="030F0902030302020204" charset="0"/>
-              <a:cs typeface="Comic Sans MS Regular" panose="030F0902030302020204" charset="0"/>
-            </a:endParaRPr>
+            <a:endParaRPr lang="en-US" sz="780" dirty="0"/>
           </a:p>
           <a:p>
-            <a:pPr marL="0" indent="0" algn="ctr">
+            <a:pPr algn="ctr" indent="0" marL="0">
               <a:lnSpc>
                 <a:spcPct val="104000"/>
               </a:lnSpc>
@@ -2039,368 +2176,587 @@
                 <a:solidFill>
                   <a:srgbClr val="1F3D7A"/>
                 </a:solidFill>
-                <a:latin typeface="Comic Sans MS Regular" panose="030F0902030302020204" charset="0"/>
-                <a:ea typeface="Arial" panose="020B0604020202090204" pitchFamily="34" charset="-122"/>
-                <a:cs typeface="Comic Sans MS Regular" panose="030F0902030302020204" charset="0"/>
+                <a:latin typeface="Arial" pitchFamily="34" charset="0"/>
+                <a:ea typeface="Arial" pitchFamily="34" charset="-122"/>
+                <a:cs typeface="Arial" pitchFamily="34" charset="-120"/>
               </a:rPr>
               <a:t>DP scoring</a:t>
             </a:r>
-            <a:endParaRPr lang="en-US" sz="780" dirty="0">
-              <a:latin typeface="Comic Sans MS Regular" panose="030F0902030302020204" charset="0"/>
-              <a:cs typeface="Comic Sans MS Regular" panose="030F0902030302020204" charset="0"/>
-            </a:endParaRPr>
+            <a:endParaRPr lang="en-US" sz="780" dirty="0"/>
           </a:p>
         </p:txBody>
       </p:sp>
       <p:sp>
         <p:nvSpPr>
-          <p:cNvPr id="31" name="a.p2.formula1"/>
+          <p:cNvPr id="32" name="a.p2.formula1"/>
           <p:cNvSpPr txBox="1"/>
           <p:nvPr/>
         </p:nvSpPr>
         <p:spPr>
           <a:xfrm>
-            <a:off x="2133600" y="1263396"/>
+            <a:off x="2133600" y="1293876"/>
             <a:ext cx="1493520" cy="118872"/>
           </a:xfrm>
           <a:prstGeom prst="rect">
             <a:avLst/>
           </a:prstGeom>
           <a:noFill/>
+          <a:ln/>
         </p:spPr>
         <p:txBody>
           <a:bodyPr wrap="square" lIns="0" tIns="0" rIns="0" bIns="0" rtlCol="0" anchor="t"/>
           <a:lstStyle/>
           <a:p>
-            <a:pPr marL="0" indent="0" algn="ctr">
-              <a:lnSpc>
-                <a:spcPct val="100000"/>
-              </a:lnSpc>
-              <a:buNone/>
-            </a:pPr>
-            <a:r>
-              <a:rPr lang="en-US" sz="800" dirty="0">
+            <a:pPr algn="ctr" indent="0" marL="0">
+              <a:lnSpc>
+                <a:spcPct val="100000"/>
+              </a:lnSpc>
+              <a:buNone/>
+            </a:pPr>
+            <a:r>
+              <a:rPr lang="en-US" sz="760" i="1" dirty="0">
                 <a:solidFill>
                   <a:srgbClr val="1A1F2B"/>
                 </a:solidFill>
-                <a:latin typeface="Comic Sans MS" panose="030F0902030302020204" charset="0"/>
-                <a:ea typeface="Times New Roman" panose="02020503050405090304" pitchFamily="34" charset="-122"/>
-                <a:cs typeface="Comic Sans MS" panose="030F0902030302020204" charset="0"/>
+                <a:latin typeface="Times New Roman" pitchFamily="34" charset="0"/>
+                <a:ea typeface="Times New Roman" pitchFamily="34" charset="-122"/>
+                <a:cs typeface="Times New Roman" pitchFamily="34" charset="-120"/>
               </a:rPr>
               <a:t>s</a:t>
             </a:r>
-            <a:r>
-              <a:rPr lang="en-US" sz="800" baseline="-40000" dirty="0">
+            <a:pPr algn="ctr" indent="0" marL="0">
+              <a:lnSpc>
+                <a:spcPct val="100000"/>
+              </a:lnSpc>
+              <a:buNone/>
+            </a:pPr>
+            <a:r>
+              <a:rPr lang="en-US" sz="760" baseline="-40000" dirty="0">
                 <a:solidFill>
                   <a:srgbClr val="1A1F2B"/>
                 </a:solidFill>
-                <a:latin typeface="Comic Sans MS" panose="030F0902030302020204" charset="0"/>
-                <a:ea typeface="Times New Roman" panose="02020503050405090304" pitchFamily="34" charset="-122"/>
-                <a:cs typeface="Comic Sans MS" panose="030F0902030302020204" charset="0"/>
+                <a:latin typeface="Times New Roman" pitchFamily="34" charset="0"/>
+                <a:ea typeface="Times New Roman" pitchFamily="34" charset="-122"/>
+                <a:cs typeface="Times New Roman" pitchFamily="34" charset="-120"/>
               </a:rPr>
               <a:t>p</a:t>
             </a:r>
-            <a:r>
-              <a:rPr lang="en-US" sz="800" dirty="0">
+            <a:pPr algn="ctr" indent="0" marL="0">
+              <a:lnSpc>
+                <a:spcPct val="100000"/>
+              </a:lnSpc>
+              <a:buNone/>
+            </a:pPr>
+            <a:r>
+              <a:rPr lang="en-US" sz="760" dirty="0">
                 <a:solidFill>
                   <a:srgbClr val="1A1F2B"/>
                 </a:solidFill>
-                <a:latin typeface="Comic Sans MS" panose="030F0902030302020204" charset="0"/>
-                <a:ea typeface="Times New Roman" panose="02020503050405090304" pitchFamily="34" charset="-122"/>
-                <a:cs typeface="Comic Sans MS" panose="030F0902030302020204" charset="0"/>
-              </a:rPr>
-              <a:t>(B </a:t>
-            </a:r>
-            <a:r>
-              <a:rPr lang="en-US" sz="800" dirty="0">
+                <a:latin typeface="Times New Roman" pitchFamily="34" charset="0"/>
+                <a:ea typeface="Times New Roman" pitchFamily="34" charset="-122"/>
+                <a:cs typeface="Times New Roman" pitchFamily="34" charset="-120"/>
+              </a:rPr>
+              <a:t>(</a:t>
+            </a:r>
+            <a:pPr algn="ctr" indent="0" marL="0">
+              <a:lnSpc>
+                <a:spcPct val="100000"/>
+              </a:lnSpc>
+              <a:buNone/>
+            </a:pPr>
+            <a:r>
+              <a:rPr lang="en-US" sz="760" i="1" dirty="0">
                 <a:solidFill>
                   <a:srgbClr val="1A1F2B"/>
                 </a:solidFill>
-                <a:latin typeface="Comic Sans MS" panose="030F0902030302020204" charset="0"/>
-                <a:ea typeface="Times New Roman" panose="02020503050405090304" pitchFamily="34" charset="-122"/>
-                <a:cs typeface="Comic Sans MS" panose="030F0902030302020204" charset="0"/>
-              </a:rPr>
-              <a:t>) = b</a:t>
-            </a:r>
-            <a:r>
-              <a:rPr lang="en-US" sz="800" baseline="30000" dirty="0">
+                <a:latin typeface="Times New Roman" pitchFamily="34" charset="0"/>
+                <a:ea typeface="Times New Roman" pitchFamily="34" charset="-122"/>
+                <a:cs typeface="Times New Roman" pitchFamily="34" charset="-120"/>
+              </a:rPr>
+              <a:t>B</a:t>
+            </a:r>
+            <a:pPr algn="ctr" indent="0" marL="0">
+              <a:lnSpc>
+                <a:spcPct val="100000"/>
+              </a:lnSpc>
+              <a:buNone/>
+            </a:pPr>
+            <a:r>
+              <a:rPr lang="en-US" sz="760" dirty="0">
                 <a:solidFill>
                   <a:srgbClr val="1A1F2B"/>
                 </a:solidFill>
-                <a:latin typeface="Comic Sans MS" panose="030F0902030302020204" charset="0"/>
-                <a:ea typeface="Times New Roman" panose="02020503050405090304" pitchFamily="34" charset="-122"/>
-                <a:cs typeface="Comic Sans MS" panose="030F0902030302020204" charset="0"/>
+                <a:latin typeface="Times New Roman" pitchFamily="34" charset="0"/>
+                <a:ea typeface="Times New Roman" pitchFamily="34" charset="-122"/>
+                <a:cs typeface="Times New Roman" pitchFamily="34" charset="-120"/>
+              </a:rPr>
+              <a:t>) = </a:t>
+            </a:r>
+            <a:pPr algn="ctr" indent="0" marL="0">
+              <a:lnSpc>
+                <a:spcPct val="100000"/>
+              </a:lnSpc>
+              <a:buNone/>
+            </a:pPr>
+            <a:r>
+              <a:rPr lang="en-US" sz="760" i="1" dirty="0">
+                <a:solidFill>
+                  <a:srgbClr val="1A1F2B"/>
+                </a:solidFill>
+                <a:latin typeface="Times New Roman" pitchFamily="34" charset="0"/>
+                <a:ea typeface="Times New Roman" pitchFamily="34" charset="-122"/>
+                <a:cs typeface="Times New Roman" pitchFamily="34" charset="-120"/>
+              </a:rPr>
+              <a:t>b</a:t>
+            </a:r>
+            <a:pPr algn="ctr" indent="0" marL="0">
+              <a:lnSpc>
+                <a:spcPct val="100000"/>
+              </a:lnSpc>
+              <a:buNone/>
+            </a:pPr>
+            <a:r>
+              <a:rPr lang="en-US" sz="760" baseline="30000" dirty="0">
+                <a:solidFill>
+                  <a:srgbClr val="1A1F2B"/>
+                </a:solidFill>
+                <a:latin typeface="Times New Roman" pitchFamily="34" charset="0"/>
+                <a:ea typeface="Times New Roman" pitchFamily="34" charset="-122"/>
+                <a:cs typeface="Times New Roman" pitchFamily="34" charset="-120"/>
               </a:rPr>
               <a:t>−1</a:t>
             </a:r>
-            <a:r>
-              <a:rPr lang="en-US" sz="800" dirty="0">
+            <a:pPr algn="ctr" indent="0" marL="0">
+              <a:lnSpc>
+                <a:spcPct val="100000"/>
+              </a:lnSpc>
+              <a:buNone/>
+            </a:pPr>
+            <a:r>
+              <a:rPr lang="en-US" sz="760" dirty="0">
                 <a:solidFill>
                   <a:srgbClr val="1A1F2B"/>
                 </a:solidFill>
-                <a:latin typeface="Comic Sans MS" panose="030F0902030302020204" charset="0"/>
-                <a:ea typeface="Times New Roman" panose="02020503050405090304" pitchFamily="34" charset="-122"/>
-                <a:cs typeface="Comic Sans MS" panose="030F0902030302020204" charset="0"/>
+                <a:latin typeface="Times New Roman" pitchFamily="34" charset="0"/>
+                <a:ea typeface="Times New Roman" pitchFamily="34" charset="-122"/>
+                <a:cs typeface="Times New Roman" pitchFamily="34" charset="-120"/>
               </a:rPr>
               <a:t> Σ</a:t>
             </a:r>
-            <a:r>
-              <a:rPr lang="en-US" sz="800" baseline="-40000" dirty="0">
+            <a:pPr algn="ctr" indent="0" marL="0">
+              <a:lnSpc>
+                <a:spcPct val="100000"/>
+              </a:lnSpc>
+              <a:buNone/>
+            </a:pPr>
+            <a:r>
+              <a:rPr lang="en-US" sz="760" baseline="-40000" dirty="0">
                 <a:solidFill>
                   <a:srgbClr val="1A1F2B"/>
                 </a:solidFill>
-                <a:latin typeface="Comic Sans MS" panose="030F0902030302020204" charset="0"/>
-                <a:ea typeface="Times New Roman" panose="02020503050405090304" pitchFamily="34" charset="-122"/>
-                <a:cs typeface="Comic Sans MS" panose="030F0902030302020204" charset="0"/>
+                <a:latin typeface="Times New Roman" pitchFamily="34" charset="0"/>
+                <a:ea typeface="Times New Roman" pitchFamily="34" charset="-122"/>
+                <a:cs typeface="Times New Roman" pitchFamily="34" charset="-120"/>
               </a:rPr>
               <a:t>i∈B</a:t>
             </a:r>
-            <a:r>
-              <a:rPr lang="en-US" sz="800" dirty="0">
+            <a:pPr algn="ctr" indent="0" marL="0">
+              <a:lnSpc>
+                <a:spcPct val="100000"/>
+              </a:lnSpc>
+              <a:buNone/>
+            </a:pPr>
+            <a:r>
+              <a:rPr lang="en-US" sz="760" dirty="0">
                 <a:solidFill>
                   <a:srgbClr val="1A1F2B"/>
                 </a:solidFill>
-                <a:latin typeface="Comic Sans MS" panose="030F0902030302020204" charset="0"/>
-                <a:ea typeface="Times New Roman" panose="02020503050405090304" pitchFamily="34" charset="-122"/>
-                <a:cs typeface="Comic Sans MS" panose="030F0902030302020204" charset="0"/>
-              </a:rPr>
-              <a:t> clip(u</a:t>
-            </a:r>
-            <a:r>
-              <a:rPr lang="en-US" sz="800" baseline="-40000" dirty="0">
+                <a:latin typeface="Times New Roman" pitchFamily="34" charset="0"/>
+                <a:ea typeface="Times New Roman" pitchFamily="34" charset="-122"/>
+                <a:cs typeface="Times New Roman" pitchFamily="34" charset="-120"/>
+              </a:rPr>
+              <a:t> clip(</a:t>
+            </a:r>
+            <a:pPr algn="ctr" indent="0" marL="0">
+              <a:lnSpc>
+                <a:spcPct val="100000"/>
+              </a:lnSpc>
+              <a:buNone/>
+            </a:pPr>
+            <a:r>
+              <a:rPr lang="en-US" sz="760" i="1" dirty="0">
                 <a:solidFill>
                   <a:srgbClr val="1A1F2B"/>
                 </a:solidFill>
-                <a:latin typeface="Comic Sans MS" panose="030F0902030302020204" charset="0"/>
-                <a:ea typeface="Times New Roman" panose="02020503050405090304" pitchFamily="34" charset="-122"/>
-                <a:cs typeface="Comic Sans MS" panose="030F0902030302020204" charset="0"/>
+                <a:latin typeface="Times New Roman" pitchFamily="34" charset="0"/>
+                <a:ea typeface="Times New Roman" pitchFamily="34" charset="-122"/>
+                <a:cs typeface="Times New Roman" pitchFamily="34" charset="-120"/>
+              </a:rPr>
+              <a:t>u</a:t>
+            </a:r>
+            <a:pPr algn="ctr" indent="0" marL="0">
+              <a:lnSpc>
+                <a:spcPct val="100000"/>
+              </a:lnSpc>
+              <a:buNone/>
+            </a:pPr>
+            <a:r>
+              <a:rPr lang="en-US" sz="760" baseline="-40000" dirty="0">
+                <a:solidFill>
+                  <a:srgbClr val="1A1F2B"/>
+                </a:solidFill>
+                <a:latin typeface="Times New Roman" pitchFamily="34" charset="0"/>
+                <a:ea typeface="Times New Roman" pitchFamily="34" charset="-122"/>
+                <a:cs typeface="Times New Roman" pitchFamily="34" charset="-120"/>
               </a:rPr>
               <a:t>i</a:t>
             </a:r>
-            <a:r>
-              <a:rPr lang="en-US" sz="800" dirty="0">
+            <a:pPr algn="ctr" indent="0" marL="0">
+              <a:lnSpc>
+                <a:spcPct val="100000"/>
+              </a:lnSpc>
+              <a:buNone/>
+            </a:pPr>
+            <a:r>
+              <a:rPr lang="en-US" sz="760" dirty="0">
                 <a:solidFill>
                   <a:srgbClr val="1A1F2B"/>
                 </a:solidFill>
-                <a:latin typeface="Comic Sans MS" panose="030F0902030302020204" charset="0"/>
-                <a:ea typeface="Times New Roman" panose="02020503050405090304" pitchFamily="34" charset="-122"/>
-                <a:cs typeface="Comic Sans MS" panose="030F0902030302020204" charset="0"/>
+                <a:latin typeface="Times New Roman" pitchFamily="34" charset="0"/>
+                <a:ea typeface="Times New Roman" pitchFamily="34" charset="-122"/>
+                <a:cs typeface="Times New Roman" pitchFamily="34" charset="-120"/>
               </a:rPr>
               <a:t>)</a:t>
             </a:r>
-            <a:endParaRPr lang="en-US" sz="800" dirty="0">
-              <a:latin typeface="Comic Sans MS" panose="030F0902030302020204" charset="0"/>
-              <a:cs typeface="Comic Sans MS" panose="030F0902030302020204" charset="0"/>
-            </a:endParaRPr>
+            <a:endParaRPr lang="en-US" sz="760" dirty="0"/>
           </a:p>
         </p:txBody>
       </p:sp>
       <p:sp>
         <p:nvSpPr>
-          <p:cNvPr id="32" name="a.p2.formula2"/>
+          <p:cNvPr id="33" name="a.p2.formula2"/>
           <p:cNvSpPr txBox="1"/>
           <p:nvPr/>
         </p:nvSpPr>
         <p:spPr>
           <a:xfrm>
-            <a:off x="2133600" y="1420368"/>
+            <a:off x="2133600" y="1412748"/>
             <a:ext cx="1493520" cy="118872"/>
           </a:xfrm>
           <a:prstGeom prst="rect">
             <a:avLst/>
           </a:prstGeom>
           <a:noFill/>
+          <a:ln/>
         </p:spPr>
         <p:txBody>
           <a:bodyPr wrap="square" lIns="0" tIns="0" rIns="0" bIns="0" rtlCol="0" anchor="t"/>
           <a:lstStyle/>
           <a:p>
-            <a:pPr marL="0" indent="0" algn="ctr">
-              <a:lnSpc>
-                <a:spcPct val="100000"/>
-              </a:lnSpc>
-              <a:buNone/>
-            </a:pPr>
-            <a:r>
-              <a:rPr lang="en-US" sz="800" dirty="0">
+            <a:pPr algn="ctr" indent="0" marL="0">
+              <a:lnSpc>
+                <a:spcPct val="100000"/>
+              </a:lnSpc>
+              <a:buNone/>
+            </a:pPr>
+            <a:r>
+              <a:rPr lang="en-US" sz="760" dirty="0">
                 <a:solidFill>
                   <a:srgbClr val="1A1F2B"/>
                 </a:solidFill>
-                <a:latin typeface="Comic Sans MS" panose="030F0902030302020204" charset="0"/>
-                <a:ea typeface="Times New Roman" panose="02020503050405090304" pitchFamily="34" charset="-122"/>
-                <a:cs typeface="Comic Sans MS" panose="030F0902030302020204" charset="0"/>
-              </a:rPr>
-              <a:t>release  s</a:t>
-            </a:r>
-            <a:r>
-              <a:rPr lang="en-US" sz="800" baseline="-40000" dirty="0">
+                <a:latin typeface="Times New Roman" pitchFamily="34" charset="0"/>
+                <a:ea typeface="Times New Roman" pitchFamily="34" charset="-122"/>
+                <a:cs typeface="Times New Roman" pitchFamily="34" charset="-120"/>
+              </a:rPr>
+              <a:t>release  </a:t>
+            </a:r>
+            <a:pPr algn="ctr" indent="0" marL="0">
+              <a:lnSpc>
+                <a:spcPct val="100000"/>
+              </a:lnSpc>
+              <a:buNone/>
+            </a:pPr>
+            <a:r>
+              <a:rPr lang="en-US" sz="760" i="1" dirty="0">
                 <a:solidFill>
                   <a:srgbClr val="1A1F2B"/>
                 </a:solidFill>
-                <a:latin typeface="Comic Sans MS" panose="030F0902030302020204" charset="0"/>
-                <a:ea typeface="Times New Roman" panose="02020503050405090304" pitchFamily="34" charset="-122"/>
-                <a:cs typeface="Comic Sans MS" panose="030F0902030302020204" charset="0"/>
+                <a:latin typeface="Times New Roman" pitchFamily="34" charset="0"/>
+                <a:ea typeface="Times New Roman" pitchFamily="34" charset="-122"/>
+                <a:cs typeface="Times New Roman" pitchFamily="34" charset="-120"/>
+              </a:rPr>
+              <a:t>s</a:t>
+            </a:r>
+            <a:pPr algn="ctr" indent="0" marL="0">
+              <a:lnSpc>
+                <a:spcPct val="100000"/>
+              </a:lnSpc>
+              <a:buNone/>
+            </a:pPr>
+            <a:r>
+              <a:rPr lang="en-US" sz="760" baseline="-40000" dirty="0">
+                <a:solidFill>
+                  <a:srgbClr val="1A1F2B"/>
+                </a:solidFill>
+                <a:latin typeface="Times New Roman" pitchFamily="34" charset="0"/>
+                <a:ea typeface="Times New Roman" pitchFamily="34" charset="-122"/>
+                <a:cs typeface="Times New Roman" pitchFamily="34" charset="-120"/>
               </a:rPr>
               <a:t>p</a:t>
             </a:r>
-            <a:r>
-              <a:rPr lang="en-US" sz="800" dirty="0">
+            <a:pPr algn="ctr" indent="0" marL="0">
+              <a:lnSpc>
+                <a:spcPct val="100000"/>
+              </a:lnSpc>
+              <a:buNone/>
+            </a:pPr>
+            <a:r>
+              <a:rPr lang="en-US" sz="760" dirty="0">
                 <a:solidFill>
                   <a:srgbClr val="1A1F2B"/>
                 </a:solidFill>
-                <a:latin typeface="Comic Sans MS" panose="030F0902030302020204" charset="0"/>
-                <a:ea typeface="Times New Roman" panose="02020503050405090304" pitchFamily="34" charset="-122"/>
-                <a:cs typeface="Comic Sans MS" panose="030F0902030302020204" charset="0"/>
+                <a:latin typeface="Times New Roman" pitchFamily="34" charset="0"/>
+                <a:ea typeface="Times New Roman" pitchFamily="34" charset="-122"/>
+                <a:cs typeface="Times New Roman" pitchFamily="34" charset="-120"/>
               </a:rPr>
               <a:t> + </a:t>
             </a:r>
-            <a:r>
-              <a:rPr lang="en-US" sz="800" dirty="0">
+            <a:pPr algn="ctr" indent="0" marL="0">
+              <a:lnSpc>
+                <a:spcPct val="100000"/>
+              </a:lnSpc>
+              <a:buNone/>
+            </a:pPr>
+            <a:r>
+              <a:rPr lang="en-US" sz="760" dirty="0">
                 <a:solidFill>
                   <a:srgbClr val="1A1F2B"/>
                 </a:solidFill>
-                <a:latin typeface="Comic Sans MS" panose="030F0902030302020204" charset="0"/>
+                <a:latin typeface="Cambria Math" pitchFamily="34" charset="0"/>
                 <a:ea typeface="Cambria Math" pitchFamily="34" charset="-122"/>
-                <a:cs typeface="Comic Sans MS" panose="030F0902030302020204" charset="0"/>
+                <a:cs typeface="Cambria Math" pitchFamily="34" charset="-120"/>
               </a:rPr>
               <a:t>𝒩</a:t>
             </a:r>
-            <a:r>
-              <a:rPr lang="en-US" sz="800" dirty="0">
+            <a:pPr algn="ctr" indent="0" marL="0">
+              <a:lnSpc>
+                <a:spcPct val="100000"/>
+              </a:lnSpc>
+              <a:buNone/>
+            </a:pPr>
+            <a:r>
+              <a:rPr lang="en-US" sz="760" dirty="0">
                 <a:solidFill>
                   <a:srgbClr val="1A1F2B"/>
                 </a:solidFill>
-                <a:latin typeface="Comic Sans MS" panose="030F0902030302020204" charset="0"/>
-                <a:ea typeface="Times New Roman" panose="02020503050405090304" pitchFamily="34" charset="-122"/>
-                <a:cs typeface="Comic Sans MS" panose="030F0902030302020204" charset="0"/>
-              </a:rPr>
-              <a:t>(0, (z C</a:t>
-            </a:r>
-            <a:r>
-              <a:rPr lang="en-US" sz="800" baseline="-40000" dirty="0">
+                <a:latin typeface="Times New Roman" pitchFamily="34" charset="0"/>
+                <a:ea typeface="Times New Roman" pitchFamily="34" charset="-122"/>
+                <a:cs typeface="Times New Roman" pitchFamily="34" charset="-120"/>
+              </a:rPr>
+              <a:t>(0, (</a:t>
+            </a:r>
+            <a:pPr algn="ctr" indent="0" marL="0">
+              <a:lnSpc>
+                <a:spcPct val="100000"/>
+              </a:lnSpc>
+              <a:buNone/>
+            </a:pPr>
+            <a:r>
+              <a:rPr lang="en-US" sz="760" i="1" dirty="0">
                 <a:solidFill>
                   <a:srgbClr val="1A1F2B"/>
                 </a:solidFill>
-                <a:latin typeface="Comic Sans MS" panose="030F0902030302020204" charset="0"/>
-                <a:ea typeface="Times New Roman" panose="02020503050405090304" pitchFamily="34" charset="-122"/>
-                <a:cs typeface="Comic Sans MS" panose="030F0902030302020204" charset="0"/>
+                <a:latin typeface="Times New Roman" pitchFamily="34" charset="0"/>
+                <a:ea typeface="Times New Roman" pitchFamily="34" charset="-122"/>
+                <a:cs typeface="Times New Roman" pitchFamily="34" charset="-120"/>
+              </a:rPr>
+              <a:t>z</a:t>
+            </a:r>
+            <a:pPr algn="ctr" indent="0" marL="0">
+              <a:lnSpc>
+                <a:spcPct val="100000"/>
+              </a:lnSpc>
+              <a:buNone/>
+            </a:pPr>
+            <a:r>
+              <a:rPr lang="en-US" sz="760" dirty="0">
+                <a:solidFill>
+                  <a:srgbClr val="1A1F2B"/>
+                </a:solidFill>
+                <a:latin typeface="Times New Roman" pitchFamily="34" charset="0"/>
+                <a:ea typeface="Times New Roman" pitchFamily="34" charset="-122"/>
+                <a:cs typeface="Times New Roman" pitchFamily="34" charset="-120"/>
+              </a:rPr>
+              <a:t> </a:t>
+            </a:r>
+            <a:pPr algn="ctr" indent="0" marL="0">
+              <a:lnSpc>
+                <a:spcPct val="100000"/>
+              </a:lnSpc>
+              <a:buNone/>
+            </a:pPr>
+            <a:r>
+              <a:rPr lang="en-US" sz="760" i="1" dirty="0">
+                <a:solidFill>
+                  <a:srgbClr val="1A1F2B"/>
+                </a:solidFill>
+                <a:latin typeface="Times New Roman" pitchFamily="34" charset="0"/>
+                <a:ea typeface="Times New Roman" pitchFamily="34" charset="-122"/>
+                <a:cs typeface="Times New Roman" pitchFamily="34" charset="-120"/>
+              </a:rPr>
+              <a:t>C</a:t>
+            </a:r>
+            <a:pPr algn="ctr" indent="0" marL="0">
+              <a:lnSpc>
+                <a:spcPct val="100000"/>
+              </a:lnSpc>
+              <a:buNone/>
+            </a:pPr>
+            <a:r>
+              <a:rPr lang="en-US" sz="760" baseline="-40000" dirty="0">
+                <a:solidFill>
+                  <a:srgbClr val="1A1F2B"/>
+                </a:solidFill>
+                <a:latin typeface="Times New Roman" pitchFamily="34" charset="0"/>
+                <a:ea typeface="Times New Roman" pitchFamily="34" charset="-122"/>
+                <a:cs typeface="Times New Roman" pitchFamily="34" charset="-120"/>
               </a:rPr>
               <a:t>clip</a:t>
             </a:r>
-            <a:r>
-              <a:rPr lang="en-US" sz="800" dirty="0">
+            <a:pPr algn="ctr" indent="0" marL="0">
+              <a:lnSpc>
+                <a:spcPct val="100000"/>
+              </a:lnSpc>
+              <a:buNone/>
+            </a:pPr>
+            <a:r>
+              <a:rPr lang="en-US" sz="760" dirty="0">
                 <a:solidFill>
                   <a:srgbClr val="1A1F2B"/>
                 </a:solidFill>
-                <a:latin typeface="Comic Sans MS" panose="030F0902030302020204" charset="0"/>
-                <a:ea typeface="Times New Roman" panose="02020503050405090304" pitchFamily="34" charset="-122"/>
-                <a:cs typeface="Comic Sans MS" panose="030F0902030302020204" charset="0"/>
+                <a:latin typeface="Times New Roman" pitchFamily="34" charset="0"/>
+                <a:ea typeface="Times New Roman" pitchFamily="34" charset="-122"/>
+                <a:cs typeface="Times New Roman" pitchFamily="34" charset="-120"/>
               </a:rPr>
               <a:t>/</a:t>
             </a:r>
-            <a:r>
-              <a:rPr lang="en-US" sz="800" dirty="0">
+            <a:pPr algn="ctr" indent="0" marL="0">
+              <a:lnSpc>
+                <a:spcPct val="100000"/>
+              </a:lnSpc>
+              <a:buNone/>
+            </a:pPr>
+            <a:r>
+              <a:rPr lang="en-US" sz="760" i="1" dirty="0">
                 <a:solidFill>
                   <a:srgbClr val="1A1F2B"/>
                 </a:solidFill>
-                <a:latin typeface="Comic Sans MS" panose="030F0902030302020204" charset="0"/>
-                <a:ea typeface="Times New Roman" panose="02020503050405090304" pitchFamily="34" charset="-122"/>
-                <a:cs typeface="Comic Sans MS" panose="030F0902030302020204" charset="0"/>
-              </a:rPr>
-              <a:t>b)²)</a:t>
-            </a:r>
-            <a:endParaRPr lang="en-US" sz="800" dirty="0">
-              <a:solidFill>
-                <a:srgbClr val="1A1F2B"/>
-              </a:solidFill>
-              <a:latin typeface="Comic Sans MS" panose="030F0902030302020204" charset="0"/>
-              <a:ea typeface="Times New Roman" panose="02020503050405090304" pitchFamily="34" charset="-122"/>
-              <a:cs typeface="Comic Sans MS" panose="030F0902030302020204" charset="0"/>
-            </a:endParaRPr>
+                <a:latin typeface="Times New Roman" pitchFamily="34" charset="0"/>
+                <a:ea typeface="Times New Roman" pitchFamily="34" charset="-122"/>
+                <a:cs typeface="Times New Roman" pitchFamily="34" charset="-120"/>
+              </a:rPr>
+              <a:t>b</a:t>
+            </a:r>
+            <a:pPr algn="ctr" indent="0" marL="0">
+              <a:lnSpc>
+                <a:spcPct val="100000"/>
+              </a:lnSpc>
+              <a:buNone/>
+            </a:pPr>
+            <a:r>
+              <a:rPr lang="en-US" sz="760" dirty="0">
+                <a:solidFill>
+                  <a:srgbClr val="1A1F2B"/>
+                </a:solidFill>
+                <a:latin typeface="Times New Roman" pitchFamily="34" charset="0"/>
+                <a:ea typeface="Times New Roman" pitchFamily="34" charset="-122"/>
+                <a:cs typeface="Times New Roman" pitchFamily="34" charset="-120"/>
+              </a:rPr>
+              <a:t>)²)</a:t>
+            </a:r>
+            <a:endParaRPr lang="en-US" sz="760" dirty="0"/>
           </a:p>
         </p:txBody>
       </p:sp>
       <p:sp>
         <p:nvSpPr>
-          <p:cNvPr id="33" name="a.p2.body"/>
+          <p:cNvPr id="34" name="a.p2.body"/>
           <p:cNvSpPr txBox="1"/>
           <p:nvPr/>
         </p:nvSpPr>
         <p:spPr>
           <a:xfrm>
-            <a:off x="2252345" y="1579880"/>
-            <a:ext cx="1367790" cy="328930"/>
+            <a:off x="2161032" y="1554480"/>
+            <a:ext cx="1438656" cy="329184"/>
           </a:xfrm>
           <a:prstGeom prst="rect">
             <a:avLst/>
           </a:prstGeom>
           <a:noFill/>
+          <a:ln/>
         </p:spPr>
         <p:txBody>
-          <a:bodyPr wrap="square" lIns="0" tIns="0" rIns="0" bIns="0" rtlCol="0" anchor="t">
-            <a:noAutofit/>
-          </a:bodyPr>
+          <a:bodyPr wrap="square" lIns="0" tIns="0" rIns="0" bIns="0" rtlCol="0" anchor="t"/>
           <a:lstStyle/>
           <a:p>
-            <a:pPr lvl="0" algn="l">
+            <a:pPr algn="l" indent="0" marL="0">
               <a:lnSpc>
                 <a:spcPct val="96000"/>
               </a:lnSpc>
-              <a:buClrTx/>
-              <a:buSzTx/>
-              <a:buFontTx/>
-            </a:pPr>
-            <a:r>
-              <a:rPr lang="en-US" sz="700" dirty="0">
+              <a:buNone/>
+            </a:pPr>
+            <a:r>
+              <a:rPr lang="en-US" sz="660" dirty="0">
                 <a:solidFill>
                   <a:srgbClr val="333B48"/>
                 </a:solidFill>
-                <a:latin typeface="Comic Sans MS" panose="030F0902030302020204" charset="0"/>
-                <a:ea typeface="Arial" panose="020B0604020202090204" pitchFamily="34" charset="-122"/>
-                <a:cs typeface="Comic Sans MS" panose="030F0902030302020204" charset="0"/>
-                <a:sym typeface="+mn-ea"/>
+                <a:latin typeface="Arial" pitchFamily="34" charset="0"/>
+                <a:ea typeface="Arial" pitchFamily="34" charset="-122"/>
+                <a:cs typeface="Arial" pitchFamily="34" charset="-120"/>
               </a:rPr>
               <a:t>Each candidate releases one clipped, sampled-Gaussian score from </a:t>
             </a:r>
-            <a:r>
-              <a:rPr lang="en-US" sz="700" dirty="0">
+            <a:pPr algn="l" indent="0" marL="0">
+              <a:lnSpc>
+                <a:spcPct val="96000"/>
+              </a:lnSpc>
+              <a:buNone/>
+            </a:pPr>
+            <a:r>
+              <a:rPr lang="en-US" sz="660" dirty="0">
                 <a:solidFill>
                   <a:srgbClr val="333B48"/>
                 </a:solidFill>
-                <a:latin typeface="Comic Sans MS" panose="030F0902030302020204" charset="0"/>
-                <a:ea typeface="Arial" panose="020B0604020202090204" pitchFamily="34" charset="-122"/>
-                <a:cs typeface="Comic Sans MS" panose="030F0902030302020204" charset="0"/>
-                <a:sym typeface="+mn-ea"/>
+                <a:latin typeface="Cambria Math" pitchFamily="34" charset="0"/>
+                <a:ea typeface="Cambria Math" pitchFamily="34" charset="-122"/>
+                <a:cs typeface="Cambria Math" pitchFamily="34" charset="-120"/>
               </a:rPr>
               <a:t>𝒟</a:t>
             </a:r>
-            <a:r>
-              <a:rPr lang="en-US" sz="700" dirty="0">
+            <a:pPr algn="l" indent="0" marL="0">
+              <a:lnSpc>
+                <a:spcPct val="96000"/>
+              </a:lnSpc>
+              <a:buNone/>
+            </a:pPr>
+            <a:r>
+              <a:rPr lang="en-US" sz="660" dirty="0">
                 <a:solidFill>
                   <a:srgbClr val="333B48"/>
                 </a:solidFill>
-                <a:latin typeface="Comic Sans MS" panose="030F0902030302020204" charset="0"/>
-                <a:ea typeface="Arial" panose="020B0604020202090204" pitchFamily="34" charset="-122"/>
-                <a:cs typeface="Comic Sans MS" panose="030F0902030302020204" charset="0"/>
-                <a:sym typeface="+mn-ea"/>
+                <a:latin typeface="Arial" pitchFamily="34" charset="0"/>
+                <a:ea typeface="Arial" pitchFamily="34" charset="-122"/>
+                <a:cs typeface="Arial" pitchFamily="34" charset="-120"/>
               </a:rPr>
               <a:t>.</a:t>
             </a:r>
-            <a:endParaRPr lang="en-US" sz="700" dirty="0">
-              <a:solidFill>
-                <a:srgbClr val="333B48"/>
-              </a:solidFill>
-              <a:latin typeface="Comic Sans MS" panose="030F0902030302020204" charset="0"/>
-              <a:ea typeface="Arial" panose="020B0604020202090204" pitchFamily="34" charset="-122"/>
-              <a:cs typeface="Comic Sans MS" panose="030F0902030302020204" charset="0"/>
-              <a:sym typeface="+mn-ea"/>
-            </a:endParaRPr>
+            <a:endParaRPr lang="en-US" sz="660" dirty="0"/>
           </a:p>
         </p:txBody>
       </p:sp>
       <p:sp>
         <p:nvSpPr>
-          <p:cNvPr id="34" name="a.p2.costPill"/>
+          <p:cNvPr id="35" name="a.p2.costPill"/>
           <p:cNvSpPr/>
           <p:nvPr/>
         </p:nvSpPr>
@@ -2417,11 +2773,12 @@
           <a:solidFill>
             <a:srgbClr val="1F3D7A"/>
           </a:solidFill>
-        </p:spPr>
-      </p:sp>
-      <p:sp>
-        <p:nvSpPr>
-          <p:cNvPr id="35" name="a.p2.costLabel"/>
+          <a:ln/>
+        </p:spPr>
+      </p:sp>
+      <p:sp>
+        <p:nvSpPr>
+          <p:cNvPr id="36" name="a.p2.costLabel"/>
           <p:cNvSpPr txBox="1"/>
           <p:nvPr/>
         </p:nvSpPr>
@@ -2434,12 +2791,13 @@
             <a:avLst/>
           </a:prstGeom>
           <a:noFill/>
+          <a:ln/>
         </p:spPr>
         <p:txBody>
           <a:bodyPr wrap="square" lIns="0" tIns="0" rIns="0" bIns="0" rtlCol="0" anchor="t"/>
           <a:lstStyle/>
           <a:p>
-            <a:pPr marL="0" indent="0" algn="ctr">
+            <a:pPr algn="ctr" indent="0" marL="0">
               <a:lnSpc>
                 <a:spcPct val="100000"/>
               </a:lnSpc>
@@ -2450,44 +2808,53 @@
                 <a:solidFill>
                   <a:srgbClr val="FFFFFF"/>
                 </a:solidFill>
-                <a:latin typeface="Comic Sans MS Regular" panose="030F0902030302020204" charset="0"/>
-                <a:ea typeface="Arial" panose="020B0604020202090204" pitchFamily="34" charset="-122"/>
-                <a:cs typeface="Comic Sans MS Regular" panose="030F0902030302020204" charset="0"/>
-              </a:rPr>
-              <a:t>≤</a:t>
-            </a:r>
+                <a:latin typeface="Arial" pitchFamily="34" charset="0"/>
+                <a:ea typeface="Arial" pitchFamily="34" charset="-122"/>
+                <a:cs typeface="Arial" pitchFamily="34" charset="-120"/>
+              </a:rPr>
+              <a:t>≤ </a:t>
+            </a:r>
+            <a:pPr algn="ctr" indent="0" marL="0">
+              <a:lnSpc>
+                <a:spcPct val="100000"/>
+              </a:lnSpc>
+              <a:buNone/>
+            </a:pPr>
             <a:r>
               <a:rPr lang="en-US" sz="640" b="1" i="1" dirty="0">
                 <a:solidFill>
                   <a:srgbClr val="FFFFFF"/>
                 </a:solidFill>
-                <a:latin typeface="Comic Sans MS Regular" panose="030F0902030302020204" charset="0"/>
-                <a:ea typeface="Arial" panose="020B0604020202090204" pitchFamily="34" charset="-122"/>
-                <a:cs typeface="Comic Sans MS Regular" panose="030F0902030302020204" charset="0"/>
+                <a:latin typeface="Arial" pitchFamily="34" charset="0"/>
+                <a:ea typeface="Arial" pitchFamily="34" charset="-122"/>
+                <a:cs typeface="Arial" pitchFamily="34" charset="-120"/>
               </a:rPr>
               <a:t>TK</a:t>
             </a:r>
+            <a:pPr algn="ctr" indent="0" marL="0">
+              <a:lnSpc>
+                <a:spcPct val="100000"/>
+              </a:lnSpc>
+              <a:buNone/>
+            </a:pPr>
             <a:r>
               <a:rPr lang="en-US" sz="640" b="1" dirty="0">
                 <a:solidFill>
                   <a:srgbClr val="FFFFFF"/>
                 </a:solidFill>
-                <a:latin typeface="Comic Sans MS Regular" panose="030F0902030302020204" charset="0"/>
-                <a:ea typeface="Arial" panose="020B0604020202090204" pitchFamily="34" charset="-122"/>
-                <a:cs typeface="Comic Sans MS Regular" panose="030F0902030302020204" charset="0"/>
+                <a:latin typeface="Arial" pitchFamily="34" charset="0"/>
+                <a:ea typeface="Arial" pitchFamily="34" charset="-122"/>
+                <a:cs typeface="Arial" pitchFamily="34" charset="-120"/>
               </a:rPr>
               <a:t> score releases total</a:t>
             </a:r>
-            <a:endParaRPr lang="en-US" sz="640" dirty="0">
-              <a:latin typeface="Comic Sans MS Regular" panose="030F0902030302020204" charset="0"/>
-              <a:cs typeface="Comic Sans MS Regular" panose="030F0902030302020204" charset="0"/>
-            </a:endParaRPr>
+            <a:endParaRPr lang="en-US" sz="640" dirty="0"/>
           </a:p>
         </p:txBody>
       </p:sp>
       <p:sp>
         <p:nvSpPr>
-          <p:cNvPr id="36" name="a.p3.frame"/>
+          <p:cNvPr id="37" name="a.p3.frame"/>
           <p:cNvSpPr/>
           <p:nvPr/>
         </p:nvSpPr>
@@ -2514,7 +2881,7 @@
       </p:sp>
       <p:sp>
         <p:nvSpPr>
-          <p:cNvPr id="37" name="a.p3.iconDisc"/>
+          <p:cNvPr id="38" name="a.p3.iconDisc"/>
           <p:cNvSpPr/>
           <p:nvPr/>
         </p:nvSpPr>
@@ -2529,11 +2896,12 @@
           <a:solidFill>
             <a:srgbClr val="2E7D32"/>
           </a:solidFill>
-        </p:spPr>
-      </p:sp>
-      <p:sp>
-        <p:nvSpPr>
-          <p:cNvPr id="38" name="a.p3.icon"/>
+          <a:ln/>
+        </p:spPr>
+      </p:sp>
+      <p:sp>
+        <p:nvSpPr>
+          <p:cNvPr id="39" name="a.p3.icon"/>
           <p:cNvSpPr/>
           <p:nvPr/>
         </p:nvSpPr>
@@ -2575,11 +2943,12 @@
           <a:solidFill>
             <a:srgbClr val="FFFFFF"/>
           </a:solidFill>
-        </p:spPr>
-      </p:sp>
-      <p:sp>
-        <p:nvSpPr>
-          <p:cNvPr id="39" name="a.p3.title"/>
+          <a:ln/>
+        </p:spPr>
+      </p:sp>
+      <p:sp>
+        <p:nvSpPr>
+          <p:cNvPr id="40" name="a.p3.title"/>
           <p:cNvSpPr txBox="1"/>
           <p:nvPr/>
         </p:nvSpPr>
@@ -2592,12 +2961,13 @@
             <a:avLst/>
           </a:prstGeom>
           <a:noFill/>
+          <a:ln/>
         </p:spPr>
         <p:txBody>
           <a:bodyPr wrap="square" lIns="0" tIns="0" rIns="0" bIns="0" rtlCol="0" anchor="ctr"/>
           <a:lstStyle/>
           <a:p>
-            <a:pPr marL="0" indent="0" algn="ctr">
+            <a:pPr algn="ctr" indent="0" marL="0">
               <a:lnSpc>
                 <a:spcPct val="104000"/>
               </a:lnSpc>
@@ -2608,19 +2978,16 @@
                 <a:solidFill>
                   <a:srgbClr val="2E7D32"/>
                 </a:solidFill>
-                <a:latin typeface="Comic Sans MS Regular" panose="030F0902030302020204" charset="0"/>
-                <a:ea typeface="Arial" panose="020B0604020202090204" pitchFamily="34" charset="-122"/>
-                <a:cs typeface="Comic Sans MS Regular" panose="030F0902030302020204" charset="0"/>
+                <a:latin typeface="Arial" pitchFamily="34" charset="0"/>
+                <a:ea typeface="Arial" pitchFamily="34" charset="-122"/>
+                <a:cs typeface="Arial" pitchFamily="34" charset="-120"/>
               </a:rPr>
               <a:t>Phase 3</a:t>
             </a:r>
-            <a:endParaRPr lang="en-US" sz="780" dirty="0">
-              <a:latin typeface="Comic Sans MS Regular" panose="030F0902030302020204" charset="0"/>
-              <a:cs typeface="Comic Sans MS Regular" panose="030F0902030302020204" charset="0"/>
-            </a:endParaRPr>
+            <a:endParaRPr lang="en-US" sz="780" dirty="0"/>
           </a:p>
           <a:p>
-            <a:pPr marL="0" indent="0" algn="ctr">
+            <a:pPr algn="ctr" indent="0" marL="0">
               <a:lnSpc>
                 <a:spcPct val="104000"/>
               </a:lnSpc>
@@ -2631,172 +2998,145 @@
                 <a:solidFill>
                   <a:srgbClr val="2E7D32"/>
                 </a:solidFill>
-                <a:latin typeface="Comic Sans MS Regular" panose="030F0902030302020204" charset="0"/>
-                <a:ea typeface="Arial" panose="020B0604020202090204" pitchFamily="34" charset="-122"/>
-                <a:cs typeface="Comic Sans MS Regular" panose="030F0902030302020204" charset="0"/>
+                <a:latin typeface="Arial" pitchFamily="34" charset="0"/>
+                <a:ea typeface="Arial" pitchFamily="34" charset="-122"/>
+                <a:cs typeface="Arial" pitchFamily="34" charset="-120"/>
               </a:rPr>
               <a:t>Post-process &amp; select</a:t>
             </a:r>
-            <a:endParaRPr lang="en-US" sz="780" dirty="0">
-              <a:latin typeface="Comic Sans MS Regular" panose="030F0902030302020204" charset="0"/>
-              <a:cs typeface="Comic Sans MS Regular" panose="030F0902030302020204" charset="0"/>
-            </a:endParaRPr>
+            <a:endParaRPr lang="en-US" sz="780" dirty="0"/>
           </a:p>
         </p:txBody>
       </p:sp>
       <p:sp>
         <p:nvSpPr>
-          <p:cNvPr id="40" name="a.p3.formula1"/>
+          <p:cNvPr id="41" name="a.p3.formula1"/>
           <p:cNvSpPr txBox="1"/>
           <p:nvPr/>
         </p:nvSpPr>
         <p:spPr>
           <a:xfrm>
-            <a:off x="3883025" y="1290320"/>
-            <a:ext cx="1755775" cy="118745"/>
+            <a:off x="4011168" y="1293876"/>
+            <a:ext cx="1493520" cy="118872"/>
           </a:xfrm>
           <a:prstGeom prst="rect">
             <a:avLst/>
           </a:prstGeom>
           <a:noFill/>
+          <a:ln/>
         </p:spPr>
         <p:txBody>
           <a:bodyPr wrap="square" lIns="0" tIns="0" rIns="0" bIns="0" rtlCol="0" anchor="t"/>
           <a:lstStyle/>
           <a:p>
-            <a:pPr marL="0" indent="0" algn="ctr">
-              <a:lnSpc>
-                <a:spcPct val="100000"/>
-              </a:lnSpc>
-              <a:buNone/>
-            </a:pPr>
-            <a:r>
-              <a:rPr lang="en-US" sz="780" dirty="0">
+            <a:pPr algn="ctr" indent="0" marL="0">
+              <a:lnSpc>
+                <a:spcPct val="100000"/>
+              </a:lnSpc>
+              <a:buNone/>
+            </a:pPr>
+            <a:r>
+              <a:rPr lang="en-US" sz="720" dirty="0">
                 <a:solidFill>
                   <a:srgbClr val="1A1F2B"/>
                 </a:solidFill>
-                <a:latin typeface="Comic Sans MS" panose="030F0902030302020204" charset="0"/>
-                <a:ea typeface="Times New Roman" panose="02020503050405090304" pitchFamily="34" charset="-122"/>
-                <a:cs typeface="Comic Sans MS" panose="030F0902030302020204" charset="0"/>
+                <a:latin typeface="Times New Roman" pitchFamily="34" charset="0"/>
+                <a:ea typeface="Times New Roman" pitchFamily="34" charset="-122"/>
+                <a:cs typeface="Times New Roman" pitchFamily="34" charset="-120"/>
               </a:rPr>
               <a:t>Gumbel-smoothed or deterministic</a:t>
             </a:r>
-            <a:endParaRPr lang="en-US" sz="780" dirty="0">
-              <a:solidFill>
-                <a:srgbClr val="1A1F2B"/>
-              </a:solidFill>
-              <a:latin typeface="Comic Sans MS" panose="030F0902030302020204" charset="0"/>
-              <a:ea typeface="Times New Roman" panose="02020503050405090304" pitchFamily="34" charset="-122"/>
-              <a:cs typeface="Comic Sans MS" panose="030F0902030302020204" charset="0"/>
-            </a:endParaRPr>
+            <a:endParaRPr lang="en-US" sz="720" dirty="0"/>
           </a:p>
         </p:txBody>
       </p:sp>
       <p:sp>
         <p:nvSpPr>
-          <p:cNvPr id="41" name="a.p3.formula2"/>
+          <p:cNvPr id="42" name="a.p3.formula2"/>
           <p:cNvSpPr txBox="1"/>
           <p:nvPr/>
         </p:nvSpPr>
         <p:spPr>
           <a:xfrm>
-            <a:off x="4011168" y="1454658"/>
+            <a:off x="4011168" y="1412748"/>
             <a:ext cx="1493520" cy="118872"/>
           </a:xfrm>
           <a:prstGeom prst="rect">
             <a:avLst/>
           </a:prstGeom>
           <a:noFill/>
+          <a:ln/>
         </p:spPr>
         <p:txBody>
           <a:bodyPr wrap="square" lIns="0" tIns="0" rIns="0" bIns="0" rtlCol="0" anchor="t"/>
           <a:lstStyle/>
           <a:p>
-            <a:pPr marL="0" indent="0" algn="ctr">
-              <a:lnSpc>
-                <a:spcPct val="100000"/>
-              </a:lnSpc>
-              <a:buNone/>
-            </a:pPr>
-            <a:r>
-              <a:rPr lang="en-US" sz="800" dirty="0">
+            <a:pPr algn="ctr" indent="0" marL="0">
+              <a:lnSpc>
+                <a:spcPct val="100000"/>
+              </a:lnSpc>
+              <a:buNone/>
+            </a:pPr>
+            <a:r>
+              <a:rPr lang="en-US" sz="720" dirty="0">
                 <a:solidFill>
                   <a:srgbClr val="1A1F2B"/>
                 </a:solidFill>
-                <a:latin typeface="Comic Sans MS" panose="030F0902030302020204" charset="0"/>
-                <a:ea typeface="Times New Roman" panose="02020503050405090304" pitchFamily="34" charset="-122"/>
-                <a:cs typeface="Comic Sans MS" panose="030F0902030302020204" charset="0"/>
+                <a:latin typeface="Times New Roman" pitchFamily="34" charset="0"/>
+                <a:ea typeface="Times New Roman" pitchFamily="34" charset="-122"/>
+                <a:cs typeface="Times New Roman" pitchFamily="34" charset="-120"/>
               </a:rPr>
               <a:t>Top-M(privatized scores)</a:t>
             </a:r>
-            <a:endParaRPr lang="en-US" sz="800" dirty="0">
-              <a:solidFill>
-                <a:srgbClr val="1A1F2B"/>
-              </a:solidFill>
-              <a:latin typeface="Comic Sans MS" panose="030F0902030302020204" charset="0"/>
-              <a:ea typeface="Times New Roman" panose="02020503050405090304" pitchFamily="34" charset="-122"/>
-              <a:cs typeface="Comic Sans MS" panose="030F0902030302020204" charset="0"/>
-            </a:endParaRPr>
+            <a:endParaRPr lang="en-US" sz="720" dirty="0"/>
           </a:p>
         </p:txBody>
       </p:sp>
       <p:sp>
         <p:nvSpPr>
-          <p:cNvPr id="42" name="a.p3.body"/>
+          <p:cNvPr id="43" name="a.p3.body"/>
           <p:cNvSpPr txBox="1"/>
           <p:nvPr/>
         </p:nvSpPr>
         <p:spPr>
           <a:xfrm>
-            <a:off x="4102100" y="1629410"/>
+            <a:off x="4038600" y="1554480"/>
             <a:ext cx="1438656" cy="329184"/>
           </a:xfrm>
           <a:prstGeom prst="rect">
             <a:avLst/>
           </a:prstGeom>
           <a:noFill/>
+          <a:ln/>
         </p:spPr>
         <p:txBody>
-          <a:bodyPr wrap="square" lIns="0" tIns="0" rIns="0" bIns="0" rtlCol="0" anchor="t">
-            <a:noAutofit/>
-          </a:bodyPr>
+          <a:bodyPr wrap="square" lIns="0" tIns="0" rIns="0" bIns="0" rtlCol="0" anchor="t"/>
           <a:lstStyle/>
           <a:p>
-            <a:pPr lvl="0" algn="l">
+            <a:pPr algn="l" indent="0" marL="0">
               <a:lnSpc>
                 <a:spcPct val="96000"/>
               </a:lnSpc>
-              <a:buClrTx/>
-              <a:buSzTx/>
-              <a:buFontTx/>
-            </a:pPr>
-            <a:r>
-              <a:rPr lang="en-US" sz="700" dirty="0">
+              <a:buNone/>
+            </a:pPr>
+            <a:r>
+              <a:rPr lang="en-US" sz="660" dirty="0">
                 <a:solidFill>
                   <a:srgbClr val="333B48"/>
                 </a:solidFill>
-                <a:latin typeface="Comic Sans MS" panose="030F0902030302020204" charset="0"/>
-                <a:ea typeface="Arial" panose="020B0604020202090204" pitchFamily="34" charset="-122"/>
-                <a:cs typeface="Comic Sans MS" panose="030F0902030302020204" charset="0"/>
-                <a:sym typeface="+mn-ea"/>
+                <a:latin typeface="Arial" pitchFamily="34" charset="0"/>
+                <a:ea typeface="Arial" pitchFamily="34" charset="-122"/>
+                <a:cs typeface="Arial" pitchFamily="34" charset="-120"/>
               </a:rPr>
               <a:t>Top-M uses only released scores; both options are post-processing.</a:t>
             </a:r>
-            <a:endParaRPr lang="en-US" sz="700" dirty="0">
-              <a:solidFill>
-                <a:srgbClr val="333B48"/>
-              </a:solidFill>
-              <a:latin typeface="Comic Sans MS" panose="030F0902030302020204" charset="0"/>
-              <a:ea typeface="Arial" panose="020B0604020202090204" pitchFamily="34" charset="-122"/>
-              <a:cs typeface="Comic Sans MS" panose="030F0902030302020204" charset="0"/>
-              <a:sym typeface="+mn-ea"/>
-            </a:endParaRPr>
+            <a:endParaRPr lang="en-US" sz="660" dirty="0"/>
           </a:p>
         </p:txBody>
       </p:sp>
       <p:sp>
         <p:nvSpPr>
-          <p:cNvPr id="43" name="a.p3.costPill"/>
+          <p:cNvPr id="44" name="a.p3.costPill"/>
           <p:cNvSpPr/>
           <p:nvPr/>
         </p:nvSpPr>
@@ -2813,11 +3153,12 @@
           <a:solidFill>
             <a:srgbClr val="2E7D32"/>
           </a:solidFill>
-        </p:spPr>
-      </p:sp>
-      <p:sp>
-        <p:nvSpPr>
-          <p:cNvPr id="44" name="a.p3.costLabel"/>
+          <a:ln/>
+        </p:spPr>
+      </p:sp>
+      <p:sp>
+        <p:nvSpPr>
+          <p:cNvPr id="45" name="a.p3.costLabel"/>
           <p:cNvSpPr txBox="1"/>
           <p:nvPr/>
         </p:nvSpPr>
@@ -2830,12 +3171,13 @@
             <a:avLst/>
           </a:prstGeom>
           <a:noFill/>
+          <a:ln/>
         </p:spPr>
         <p:txBody>
           <a:bodyPr wrap="square" lIns="0" tIns="0" rIns="0" bIns="0" rtlCol="0" anchor="t"/>
           <a:lstStyle/>
           <a:p>
-            <a:pPr marL="0" indent="0" algn="ctr">
+            <a:pPr algn="ctr" indent="0" marL="0">
               <a:lnSpc>
                 <a:spcPct val="100000"/>
               </a:lnSpc>
@@ -2846,26 +3188,19 @@
                 <a:solidFill>
                   <a:srgbClr val="FFFFFF"/>
                 </a:solidFill>
-                <a:latin typeface="Comic Sans MS Regular" panose="030F0902030302020204" charset="0"/>
-                <a:ea typeface="Arial" panose="020B0604020202090204" pitchFamily="34" charset="-122"/>
-                <a:cs typeface="Comic Sans MS Regular" panose="030F0902030302020204" charset="0"/>
+                <a:latin typeface="Arial" pitchFamily="34" charset="0"/>
+                <a:ea typeface="Arial" pitchFamily="34" charset="-122"/>
+                <a:cs typeface="Arial" pitchFamily="34" charset="-120"/>
               </a:rPr>
               <a:t>0 additional privacy loss</a:t>
             </a:r>
-            <a:endParaRPr lang="en-US" sz="640" b="1" dirty="0">
-              <a:solidFill>
-                <a:srgbClr val="FFFFFF"/>
-              </a:solidFill>
-              <a:latin typeface="Comic Sans MS Regular" panose="030F0902030302020204" charset="0"/>
-              <a:ea typeface="Arial" panose="020B0604020202090204" pitchFamily="34" charset="-122"/>
-              <a:cs typeface="Comic Sans MS Regular" panose="030F0902030302020204" charset="0"/>
-            </a:endParaRPr>
+            <a:endParaRPr lang="en-US" sz="640" dirty="0"/>
           </a:p>
         </p:txBody>
       </p:sp>
       <p:sp>
         <p:nvSpPr>
-          <p:cNvPr id="45" name="a.flow.p1p2"/>
+          <p:cNvPr id="46" name="a.flow.p1p2"/>
           <p:cNvSpPr/>
           <p:nvPr/>
         </p:nvSpPr>
@@ -2889,7 +3224,7 @@
       </p:sp>
       <p:sp>
         <p:nvSpPr>
-          <p:cNvPr id="46" name="a.flow.p2p3"/>
+          <p:cNvPr id="47" name="a.flow.p2p3"/>
           <p:cNvSpPr/>
           <p:nvPr/>
         </p:nvSpPr>
@@ -2913,7 +3248,7 @@
       </p:sp>
       <p:sp>
         <p:nvSpPr>
-          <p:cNvPr id="47" name="a.z1.noAccess.ring"/>
+          <p:cNvPr id="48" name="a.z1.noAccess.ring"/>
           <p:cNvSpPr/>
           <p:nvPr/>
         </p:nvSpPr>
@@ -2938,7 +3273,7 @@
       </p:sp>
       <p:sp>
         <p:nvSpPr>
-          <p:cNvPr id="48" name="a.z1.noAccess.slash"/>
+          <p:cNvPr id="49" name="a.z1.noAccess.slash"/>
           <p:cNvSpPr/>
           <p:nvPr/>
         </p:nvSpPr>
@@ -2961,7 +3296,7 @@
       </p:sp>
       <p:sp>
         <p:nvSpPr>
-          <p:cNvPr id="49" name="a.z1.note"/>
+          <p:cNvPr id="50" name="a.z1.note"/>
           <p:cNvSpPr txBox="1"/>
           <p:nvPr/>
         </p:nvSpPr>
@@ -2974,72 +3309,73 @@
             <a:avLst/>
           </a:prstGeom>
           <a:noFill/>
+          <a:ln/>
         </p:spPr>
         <p:txBody>
           <a:bodyPr wrap="square" lIns="0" tIns="0" rIns="0" bIns="0" rtlCol="0" anchor="ctr"/>
           <a:lstStyle/>
           <a:p>
-            <a:pPr marL="0" indent="0" algn="l">
+            <a:pPr algn="l" indent="0" marL="0">
               <a:lnSpc>
                 <a:spcPct val="102000"/>
               </a:lnSpc>
               <a:buNone/>
             </a:pPr>
             <a:r>
-              <a:rPr lang="en-US" sz="800" b="1" dirty="0">
+              <a:rPr lang="en-US" sz="680" b="1" dirty="0">
                 <a:solidFill>
                   <a:srgbClr val="0E7C7B"/>
                 </a:solidFill>
-                <a:latin typeface="Comic Sans MS Regular" panose="030F0902030302020204" charset="0"/>
-                <a:ea typeface="Arial" panose="020B0604020202090204" pitchFamily="34" charset="-122"/>
-                <a:cs typeface="Comic Sans MS Regular" panose="030F0902030302020204" charset="0"/>
+                <a:latin typeface="Arial" pitchFamily="34" charset="0"/>
+                <a:ea typeface="Arial" pitchFamily="34" charset="-122"/>
+                <a:cs typeface="Arial" pitchFamily="34" charset="-120"/>
               </a:rPr>
               <a:t>Mutation never</a:t>
             </a:r>
-            <a:endParaRPr lang="en-US" sz="800" dirty="0">
-              <a:latin typeface="Comic Sans MS Regular" panose="030F0902030302020204" charset="0"/>
-              <a:cs typeface="Comic Sans MS Regular" panose="030F0902030302020204" charset="0"/>
-            </a:endParaRPr>
+            <a:endParaRPr lang="en-US" sz="680" dirty="0"/>
           </a:p>
           <a:p>
-            <a:pPr marL="0" indent="0" algn="l">
+            <a:pPr algn="l" indent="0" marL="0">
               <a:lnSpc>
                 <a:spcPct val="102000"/>
               </a:lnSpc>
               <a:buNone/>
             </a:pPr>
             <a:r>
-              <a:rPr lang="en-US" sz="800" b="1" dirty="0">
+              <a:rPr lang="en-US" sz="680" b="1" dirty="0">
                 <a:solidFill>
                   <a:srgbClr val="0E7C7B"/>
                 </a:solidFill>
-                <a:latin typeface="Comic Sans MS Regular" panose="030F0902030302020204" charset="0"/>
-                <a:ea typeface="Arial" panose="020B0604020202090204" pitchFamily="34" charset="-122"/>
-                <a:cs typeface="Comic Sans MS Regular" panose="030F0902030302020204" charset="0"/>
+                <a:latin typeface="Arial" pitchFamily="34" charset="0"/>
+                <a:ea typeface="Arial" pitchFamily="34" charset="-122"/>
+                <a:cs typeface="Arial" pitchFamily="34" charset="-120"/>
               </a:rPr>
               <a:t>reads </a:t>
             </a:r>
-            <a:r>
-              <a:rPr lang="en-US" sz="800" b="1" dirty="0">
+            <a:pPr algn="l" indent="0" marL="0">
+              <a:lnSpc>
+                <a:spcPct val="102000"/>
+              </a:lnSpc>
+              <a:buNone/>
+            </a:pPr>
+            <a:r>
+              <a:rPr lang="en-US" sz="680" b="1" dirty="0">
                 <a:solidFill>
                   <a:srgbClr val="0E7C7B"/>
                 </a:solidFill>
-                <a:latin typeface="Comic Sans MS Regular" panose="030F0902030302020204" charset="0"/>
+                <a:latin typeface="Cambria Math" pitchFamily="34" charset="0"/>
                 <a:ea typeface="Cambria Math" pitchFamily="34" charset="-122"/>
-                <a:cs typeface="Comic Sans MS Regular" panose="030F0902030302020204" charset="0"/>
+                <a:cs typeface="Cambria Math" pitchFamily="34" charset="-120"/>
               </a:rPr>
               <a:t>𝒟</a:t>
             </a:r>
-            <a:endParaRPr lang="en-US" sz="800" dirty="0">
-              <a:latin typeface="Comic Sans MS Regular" panose="030F0902030302020204" charset="0"/>
-              <a:cs typeface="Comic Sans MS Regular" panose="030F0902030302020204" charset="0"/>
-            </a:endParaRPr>
+            <a:endParaRPr lang="en-US" sz="680" dirty="0"/>
           </a:p>
         </p:txBody>
       </p:sp>
       <p:sp>
         <p:nvSpPr>
-          <p:cNvPr id="50" name="a.z2.dataset"/>
+          <p:cNvPr id="51" name="a.z2.dataset"/>
           <p:cNvSpPr/>
           <p:nvPr/>
         </p:nvSpPr>
@@ -3064,7 +3400,7 @@
       </p:sp>
       <p:sp>
         <p:nvSpPr>
-          <p:cNvPr id="51" name="a.z2.note"/>
+          <p:cNvPr id="52" name="a.z2.note"/>
           <p:cNvSpPr txBox="1"/>
           <p:nvPr/>
         </p:nvSpPr>
@@ -3077,116 +3413,141 @@
             <a:avLst/>
           </a:prstGeom>
           <a:noFill/>
+          <a:ln/>
         </p:spPr>
         <p:txBody>
           <a:bodyPr wrap="square" lIns="0" tIns="0" rIns="0" bIns="0" rtlCol="0" anchor="ctr"/>
           <a:lstStyle/>
           <a:p>
-            <a:pPr marL="0" indent="0" algn="l">
+            <a:pPr algn="l" indent="0" marL="0">
               <a:lnSpc>
                 <a:spcPct val="102000"/>
               </a:lnSpc>
               <a:buNone/>
             </a:pPr>
             <a:r>
-              <a:rPr lang="en-US" sz="800" dirty="0">
+              <a:rPr lang="en-US" sz="680" dirty="0">
                 <a:solidFill>
                   <a:srgbClr val="1F3D7A"/>
                 </a:solidFill>
-                <a:latin typeface="Comic Sans MS Regular" panose="030F0902030302020204" charset="0"/>
+                <a:latin typeface="Cambria Math" pitchFamily="34" charset="0"/>
                 <a:ea typeface="Cambria Math" pitchFamily="34" charset="-122"/>
-                <a:cs typeface="Comic Sans MS Regular" panose="030F0902030302020204" charset="0"/>
+                <a:cs typeface="Cambria Math" pitchFamily="34" charset="-120"/>
               </a:rPr>
               <a:t>𝒟</a:t>
             </a:r>
-            <a:r>
-              <a:rPr lang="en-US" sz="800" dirty="0">
+            <a:pPr algn="l" indent="0" marL="0">
+              <a:lnSpc>
+                <a:spcPct val="102000"/>
+              </a:lnSpc>
+              <a:buNone/>
+            </a:pPr>
+            <a:r>
+              <a:rPr lang="en-US" sz="680" dirty="0">
                 <a:solidFill>
                   <a:srgbClr val="1F3D7A"/>
                 </a:solidFill>
-                <a:latin typeface="Comic Sans MS Regular" panose="030F0902030302020204" charset="0"/>
-                <a:ea typeface="Arial" panose="020B0604020202090204" pitchFamily="34" charset="-122"/>
-                <a:cs typeface="Comic Sans MS Regular" panose="030F0902030302020204" charset="0"/>
+                <a:latin typeface="Arial" pitchFamily="34" charset="0"/>
+                <a:ea typeface="Arial" pitchFamily="34" charset="-122"/>
+                <a:cs typeface="Arial" pitchFamily="34" charset="-120"/>
               </a:rPr>
               <a:t>: </a:t>
             </a:r>
-            <a:r>
-              <a:rPr lang="en-US" sz="800" b="1" dirty="0">
+            <a:pPr algn="l" indent="0" marL="0">
+              <a:lnSpc>
+                <a:spcPct val="102000"/>
+              </a:lnSpc>
+              <a:buNone/>
+            </a:pPr>
+            <a:r>
+              <a:rPr lang="en-US" sz="680" b="1" dirty="0">
                 <a:solidFill>
                   <a:srgbClr val="1F3D7A"/>
                 </a:solidFill>
-                <a:latin typeface="Comic Sans MS Regular" panose="030F0902030302020204" charset="0"/>
-                <a:ea typeface="Arial" panose="020B0604020202090204" pitchFamily="34" charset="-122"/>
-                <a:cs typeface="Comic Sans MS Regular" panose="030F0902030302020204" charset="0"/>
+                <a:latin typeface="Arial" pitchFamily="34" charset="0"/>
+                <a:ea typeface="Arial" pitchFamily="34" charset="-122"/>
+                <a:cs typeface="Arial" pitchFamily="34" charset="-120"/>
               </a:rPr>
               <a:t>private</a:t>
             </a:r>
-            <a:r>
-              <a:rPr lang="en-US" sz="800" dirty="0">
+            <a:pPr algn="l" indent="0" marL="0">
+              <a:lnSpc>
+                <a:spcPct val="102000"/>
+              </a:lnSpc>
+              <a:buNone/>
+            </a:pPr>
+            <a:r>
+              <a:rPr lang="en-US" sz="680" dirty="0">
                 <a:solidFill>
                   <a:srgbClr val="1F3D7A"/>
                 </a:solidFill>
-                <a:latin typeface="Comic Sans MS Regular" panose="030F0902030302020204" charset="0"/>
-                <a:ea typeface="Arial" panose="020B0604020202090204" pitchFamily="34" charset="-122"/>
-                <a:cs typeface="Comic Sans MS Regular" panose="030F0902030302020204" charset="0"/>
+                <a:latin typeface="Arial" pitchFamily="34" charset="0"/>
+                <a:ea typeface="Arial" pitchFamily="34" charset="-122"/>
+                <a:cs typeface="Arial" pitchFamily="34" charset="-120"/>
               </a:rPr>
               <a:t> optimization</a:t>
             </a:r>
-            <a:endParaRPr lang="en-US" sz="800" dirty="0">
-              <a:latin typeface="Comic Sans MS Regular" panose="030F0902030302020204" charset="0"/>
-              <a:cs typeface="Comic Sans MS Regular" panose="030F0902030302020204" charset="0"/>
-            </a:endParaRPr>
+            <a:endParaRPr lang="en-US" sz="680" dirty="0"/>
           </a:p>
           <a:p>
-            <a:pPr marL="0" indent="0" algn="l">
+            <a:pPr algn="l" indent="0" marL="0">
               <a:lnSpc>
                 <a:spcPct val="102000"/>
               </a:lnSpc>
               <a:buNone/>
             </a:pPr>
             <a:r>
-              <a:rPr lang="en-US" sz="800" dirty="0">
+              <a:rPr lang="en-US" sz="680" dirty="0">
                 <a:solidFill>
                   <a:srgbClr val="1F3D7A"/>
                 </a:solidFill>
-                <a:latin typeface="Comic Sans MS Regular" panose="030F0902030302020204" charset="0"/>
-                <a:ea typeface="Arial" panose="020B0604020202090204" pitchFamily="34" charset="-122"/>
-                <a:cs typeface="Comic Sans MS Regular" panose="030F0902030302020204" charset="0"/>
+                <a:latin typeface="Arial" pitchFamily="34" charset="0"/>
+                <a:ea typeface="Arial" pitchFamily="34" charset="-122"/>
+                <a:cs typeface="Arial" pitchFamily="34" charset="-120"/>
               </a:rPr>
               <a:t>set (</a:t>
             </a:r>
-            <a:r>
-              <a:rPr lang="en-US" sz="800" i="1" dirty="0">
+            <a:pPr algn="l" indent="0" marL="0">
+              <a:lnSpc>
+                <a:spcPct val="102000"/>
+              </a:lnSpc>
+              <a:buNone/>
+            </a:pPr>
+            <a:r>
+              <a:rPr lang="en-US" sz="680" i="1" dirty="0">
                 <a:solidFill>
                   <a:srgbClr val="1F3D7A"/>
                 </a:solidFill>
-                <a:latin typeface="Comic Sans MS Regular" panose="030F0902030302020204" charset="0"/>
-                <a:ea typeface="Arial" panose="020B0604020202090204" pitchFamily="34" charset="-122"/>
-                <a:cs typeface="Comic Sans MS Regular" panose="030F0902030302020204" charset="0"/>
+                <a:latin typeface="Arial" pitchFamily="34" charset="0"/>
+                <a:ea typeface="Arial" pitchFamily="34" charset="-122"/>
+                <a:cs typeface="Arial" pitchFamily="34" charset="-120"/>
               </a:rPr>
               <a:t>n</a:t>
             </a:r>
-            <a:r>
-              <a:rPr lang="en-US" sz="800" dirty="0">
+            <a:pPr algn="l" indent="0" marL="0">
+              <a:lnSpc>
+                <a:spcPct val="102000"/>
+              </a:lnSpc>
+              <a:buNone/>
+            </a:pPr>
+            <a:r>
+              <a:rPr lang="en-US" sz="680" dirty="0">
                 <a:solidFill>
                   <a:srgbClr val="1F3D7A"/>
                 </a:solidFill>
-                <a:latin typeface="Comic Sans MS Regular" panose="030F0902030302020204" charset="0"/>
-                <a:ea typeface="Arial" panose="020B0604020202090204" pitchFamily="34" charset="-122"/>
-                <a:cs typeface="Comic Sans MS Regular" panose="030F0902030302020204" charset="0"/>
+                <a:latin typeface="Arial" pitchFamily="34" charset="0"/>
+                <a:ea typeface="Arial" pitchFamily="34" charset="-122"/>
+                <a:cs typeface="Arial" pitchFamily="34" charset="-120"/>
               </a:rPr>
               <a:t> records)</a:t>
             </a:r>
-            <a:endParaRPr lang="en-US" sz="800" dirty="0">
-              <a:latin typeface="Comic Sans MS Regular" panose="030F0902030302020204" charset="0"/>
-              <a:cs typeface="Comic Sans MS Regular" panose="030F0902030302020204" charset="0"/>
-            </a:endParaRPr>
+            <a:endParaRPr lang="en-US" sz="680" dirty="0"/>
           </a:p>
         </p:txBody>
       </p:sp>
       <p:sp>
         <p:nvSpPr>
-          <p:cNvPr id="52" name="a.z2.feed"/>
+          <p:cNvPr id="53" name="a.z2.feed"/>
           <p:cNvSpPr/>
           <p:nvPr/>
         </p:nvSpPr>
@@ -3210,7 +3571,7 @@
       </p:sp>
       <p:sp>
         <p:nvSpPr>
-          <p:cNvPr id="53" name="a.z3.noAccess.ring"/>
+          <p:cNvPr id="54" name="a.z3.noAccess.ring"/>
           <p:cNvSpPr/>
           <p:nvPr/>
         </p:nvSpPr>
@@ -3235,7 +3596,7 @@
       </p:sp>
       <p:sp>
         <p:nvSpPr>
-          <p:cNvPr id="54" name="a.z3.noAccess.slash"/>
+          <p:cNvPr id="55" name="a.z3.noAccess.slash"/>
           <p:cNvSpPr/>
           <p:nvPr/>
         </p:nvSpPr>
@@ -3258,7 +3619,7 @@
       </p:sp>
       <p:sp>
         <p:nvSpPr>
-          <p:cNvPr id="55" name="a.z3.note"/>
+          <p:cNvPr id="56" name="a.z3.note"/>
           <p:cNvSpPr txBox="1"/>
           <p:nvPr/>
         </p:nvSpPr>
@@ -3271,61 +3632,56 @@
             <a:avLst/>
           </a:prstGeom>
           <a:noFill/>
+          <a:ln/>
         </p:spPr>
         <p:txBody>
           <a:bodyPr wrap="square" lIns="0" tIns="0" rIns="0" bIns="0" rtlCol="0" anchor="ctr"/>
           <a:lstStyle/>
           <a:p>
-            <a:pPr marL="0" indent="0" algn="l">
+            <a:pPr algn="l" indent="0" marL="0">
               <a:lnSpc>
                 <a:spcPct val="102000"/>
               </a:lnSpc>
               <a:buNone/>
             </a:pPr>
             <a:r>
-              <a:rPr lang="en-US" sz="800" b="1" dirty="0">
+              <a:rPr lang="en-US" sz="680" b="1" dirty="0">
                 <a:solidFill>
                   <a:srgbClr val="2E7D32"/>
                 </a:solidFill>
-                <a:latin typeface="Comic Sans MS Regular" panose="030F0902030302020204" charset="0"/>
-                <a:ea typeface="Arial" panose="020B0604020202090204" pitchFamily="34" charset="-122"/>
-                <a:cs typeface="Comic Sans MS Regular" panose="030F0902030302020204" charset="0"/>
+                <a:latin typeface="Arial" pitchFamily="34" charset="0"/>
+                <a:ea typeface="Arial" pitchFamily="34" charset="-122"/>
+                <a:cs typeface="Arial" pitchFamily="34" charset="-120"/>
               </a:rPr>
               <a:t>Selection reads only</a:t>
             </a:r>
-            <a:endParaRPr lang="en-US" sz="800" dirty="0">
-              <a:latin typeface="Comic Sans MS Regular" panose="030F0902030302020204" charset="0"/>
-              <a:cs typeface="Comic Sans MS Regular" panose="030F0902030302020204" charset="0"/>
-            </a:endParaRPr>
+            <a:endParaRPr lang="en-US" sz="680" dirty="0"/>
           </a:p>
           <a:p>
-            <a:pPr marL="0" indent="0" algn="l">
+            <a:pPr algn="l" indent="0" marL="0">
               <a:lnSpc>
                 <a:spcPct val="102000"/>
               </a:lnSpc>
               <a:buNone/>
             </a:pPr>
             <a:r>
-              <a:rPr lang="en-US" sz="800" b="1" dirty="0">
+              <a:rPr lang="en-US" sz="680" b="1" dirty="0">
                 <a:solidFill>
                   <a:srgbClr val="2E7D32"/>
                 </a:solidFill>
-                <a:latin typeface="Comic Sans MS Regular" panose="030F0902030302020204" charset="0"/>
-                <a:ea typeface="Arial" panose="020B0604020202090204" pitchFamily="34" charset="-122"/>
-                <a:cs typeface="Comic Sans MS Regular" panose="030F0902030302020204" charset="0"/>
+                <a:latin typeface="Arial" pitchFamily="34" charset="0"/>
+                <a:ea typeface="Arial" pitchFamily="34" charset="-122"/>
+                <a:cs typeface="Arial" pitchFamily="34" charset="-120"/>
               </a:rPr>
               <a:t>privatized scores</a:t>
             </a:r>
-            <a:endParaRPr lang="en-US" sz="800" dirty="0">
-              <a:latin typeface="Comic Sans MS Regular" panose="030F0902030302020204" charset="0"/>
-              <a:cs typeface="Comic Sans MS Regular" panose="030F0902030302020204" charset="0"/>
-            </a:endParaRPr>
+            <a:endParaRPr lang="en-US" sz="680" dirty="0"/>
           </a:p>
         </p:txBody>
       </p:sp>
       <p:sp>
         <p:nvSpPr>
-          <p:cNvPr id="56" name="a.acct.frame"/>
+          <p:cNvPr id="57" name="a.acct.frame"/>
           <p:cNvSpPr/>
           <p:nvPr/>
         </p:nvSpPr>
@@ -3352,7 +3708,7 @@
       </p:sp>
       <p:sp>
         <p:nvSpPr>
-          <p:cNvPr id="57" name="a.acct.line1"/>
+          <p:cNvPr id="58" name="a.acct.line1"/>
           <p:cNvSpPr txBox="1"/>
           <p:nvPr/>
         </p:nvSpPr>
@@ -3365,53 +3721,87 @@
             <a:avLst/>
           </a:prstGeom>
           <a:noFill/>
+          <a:ln/>
         </p:spPr>
         <p:txBody>
           <a:bodyPr wrap="square" lIns="0" tIns="0" rIns="0" bIns="0" rtlCol="0" anchor="t"/>
           <a:lstStyle/>
           <a:p>
-            <a:pPr marL="0" indent="0" algn="ctr">
-              <a:lnSpc>
-                <a:spcPct val="100000"/>
-              </a:lnSpc>
-              <a:buNone/>
-            </a:pPr>
-            <a:r>
-              <a:rPr lang="en-US" sz="800" b="1" dirty="0">
+            <a:pPr algn="ctr" indent="0" marL="0">
+              <a:lnSpc>
+                <a:spcPct val="100000"/>
+              </a:lnSpc>
+              <a:buNone/>
+            </a:pPr>
+            <a:r>
+              <a:rPr lang="en-US" sz="720" b="1" dirty="0">
                 <a:solidFill>
                   <a:srgbClr val="1F3D7A"/>
                 </a:solidFill>
-                <a:latin typeface="Comic Sans MS" panose="030F0902030302020204" charset="0"/>
-                <a:ea typeface="Arial" panose="020B0604020202090204" pitchFamily="34" charset="-122"/>
-                <a:cs typeface="Comic Sans MS" panose="030F0902030302020204" charset="0"/>
+                <a:latin typeface="Arial" pitchFamily="34" charset="0"/>
+                <a:ea typeface="Arial" pitchFamily="34" charset="-122"/>
+                <a:cs typeface="Arial" pitchFamily="34" charset="-120"/>
               </a:rPr>
               <a:t>Privacy accounting:</a:t>
             </a:r>
-            <a:r>
-              <a:rPr lang="en-US" sz="800" dirty="0">
+            <a:pPr algn="ctr" indent="0" marL="0">
+              <a:lnSpc>
+                <a:spcPct val="100000"/>
+              </a:lnSpc>
+              <a:buNone/>
+            </a:pPr>
+            <a:r>
+              <a:rPr lang="en-US" sz="720" dirty="0">
                 <a:solidFill>
                   <a:srgbClr val="1F3D7A"/>
                 </a:solidFill>
-                <a:latin typeface="Comic Sans MS" panose="030F0902030302020204" charset="0"/>
-                <a:ea typeface="Arial" panose="020B0604020202090204" pitchFamily="34" charset="-122"/>
-                <a:cs typeface="Comic Sans MS" panose="030F0902030302020204" charset="0"/>
-              </a:rPr>
-              <a:t>  at most TK sampled-Gaussian score releases compose in one</a:t>
-            </a:r>
-            <a:endParaRPr lang="en-US" sz="800" dirty="0">
-              <a:solidFill>
-                <a:srgbClr val="1F3D7A"/>
-              </a:solidFill>
-              <a:latin typeface="Comic Sans MS" panose="030F0902030302020204" charset="0"/>
-              <a:ea typeface="Arial" panose="020B0604020202090204" pitchFamily="34" charset="-122"/>
-              <a:cs typeface="Comic Sans MS" panose="030F0902030302020204" charset="0"/>
-            </a:endParaRPr>
+                <a:latin typeface="Arial" pitchFamily="34" charset="0"/>
+                <a:ea typeface="Arial" pitchFamily="34" charset="-122"/>
+                <a:cs typeface="Arial" pitchFamily="34" charset="-120"/>
+              </a:rPr>
+              <a:t>  at most </a:t>
+            </a:r>
+            <a:pPr algn="ctr" indent="0" marL="0">
+              <a:lnSpc>
+                <a:spcPct val="100000"/>
+              </a:lnSpc>
+              <a:buNone/>
+            </a:pPr>
+            <a:r>
+              <a:rPr lang="en-US" sz="720" i="1" dirty="0">
+                <a:solidFill>
+                  <a:srgbClr val="1F3D7A"/>
+                </a:solidFill>
+                <a:latin typeface="Arial" pitchFamily="34" charset="0"/>
+                <a:ea typeface="Arial" pitchFamily="34" charset="-122"/>
+                <a:cs typeface="Arial" pitchFamily="34" charset="-120"/>
+              </a:rPr>
+              <a:t>TK</a:t>
+            </a:r>
+            <a:pPr algn="ctr" indent="0" marL="0">
+              <a:lnSpc>
+                <a:spcPct val="100000"/>
+              </a:lnSpc>
+              <a:buNone/>
+            </a:pPr>
+            <a:r>
+              <a:rPr lang="en-US" sz="720" dirty="0">
+                <a:solidFill>
+                  <a:srgbClr val="1F3D7A"/>
+                </a:solidFill>
+                <a:latin typeface="Arial" pitchFamily="34" charset="0"/>
+                <a:ea typeface="Arial" pitchFamily="34" charset="-122"/>
+                <a:cs typeface="Arial" pitchFamily="34" charset="-120"/>
+              </a:rPr>
+              <a:t> sampled-Gaussian score releases compose in one</a:t>
+            </a:r>
+            <a:endParaRPr lang="en-US" sz="720" dirty="0"/>
           </a:p>
         </p:txBody>
       </p:sp>
       <p:sp>
         <p:nvSpPr>
-          <p:cNvPr id="58" name="a.acct.line2"/>
+          <p:cNvPr id="59" name="a.acct.line2"/>
           <p:cNvSpPr txBox="1"/>
           <p:nvPr/>
         </p:nvSpPr>
@@ -3424,42 +3814,36 @@
             <a:avLst/>
           </a:prstGeom>
           <a:noFill/>
+          <a:ln/>
         </p:spPr>
         <p:txBody>
           <a:bodyPr wrap="square" lIns="0" tIns="0" rIns="0" bIns="0" rtlCol="0" anchor="t"/>
           <a:lstStyle/>
           <a:p>
-            <a:pPr marL="0" indent="0" algn="ctr">
-              <a:lnSpc>
-                <a:spcPct val="100000"/>
-              </a:lnSpc>
-              <a:buNone/>
-            </a:pPr>
-            <a:r>
-              <a:rPr lang="en-US" sz="800" dirty="0">
+            <a:pPr algn="ctr" indent="0" marL="0">
+              <a:lnSpc>
+                <a:spcPct val="100000"/>
+              </a:lnSpc>
+              <a:buNone/>
+            </a:pPr>
+            <a:r>
+              <a:rPr lang="en-US" sz="720" dirty="0">
                 <a:solidFill>
                   <a:srgbClr val="1F3D7A"/>
                 </a:solidFill>
-                <a:latin typeface="Comic Sans MS" panose="030F0902030302020204" charset="0"/>
-                <a:ea typeface="Arial" panose="020B0604020202090204" pitchFamily="34" charset="-122"/>
-                <a:cs typeface="Comic Sans MS" panose="030F0902030302020204" charset="0"/>
+                <a:latin typeface="Arial" pitchFamily="34" charset="0"/>
+                <a:ea typeface="Arial" pitchFamily="34" charset="-122"/>
+                <a:cs typeface="Arial" pitchFamily="34" charset="-120"/>
               </a:rPr>
               <a:t>RDP accountant  ⟹  overall (ε, δ)-DP.   Mutation and selection add no privacy loss.</a:t>
             </a:r>
-            <a:endParaRPr lang="en-US" sz="800" dirty="0">
-              <a:solidFill>
-                <a:srgbClr val="1F3D7A"/>
-              </a:solidFill>
-              <a:latin typeface="Comic Sans MS" panose="030F0902030302020204" charset="0"/>
-              <a:ea typeface="Arial" panose="020B0604020202090204" pitchFamily="34" charset="-122"/>
-              <a:cs typeface="Comic Sans MS" panose="030F0902030302020204" charset="0"/>
-            </a:endParaRPr>
+            <a:endParaRPr lang="en-US" sz="720" dirty="0"/>
           </a:p>
         </p:txBody>
       </p:sp>
       <p:sp>
         <p:nvSpPr>
-          <p:cNvPr id="59" name="b.title"/>
+          <p:cNvPr id="60" name="b.title"/>
           <p:cNvSpPr txBox="1"/>
           <p:nvPr/>
         </p:nvSpPr>
@@ -3472,12 +3856,13 @@
             <a:avLst/>
           </a:prstGeom>
           <a:noFill/>
+          <a:ln/>
         </p:spPr>
         <p:txBody>
           <a:bodyPr wrap="square" lIns="0" tIns="0" rIns="0" bIns="0" rtlCol="0" anchor="t"/>
           <a:lstStyle/>
           <a:p>
-            <a:pPr marL="0" indent="0" algn="l">
+            <a:pPr algn="l" indent="0" marL="0">
               <a:lnSpc>
                 <a:spcPct val="100000"/>
               </a:lnSpc>
@@ -3488,70 +3873,97 @@
                 <a:solidFill>
                   <a:srgbClr val="1A1F2B"/>
                 </a:solidFill>
-                <a:latin typeface="Comic Sans MS" panose="030F0902030302020204" charset="0"/>
-                <a:ea typeface="Arial" panose="020B0604020202090204" pitchFamily="34" charset="-122"/>
-                <a:cs typeface="Comic Sans MS" panose="030F0902030302020204" charset="0"/>
+                <a:latin typeface="Arial" pitchFamily="34" charset="0"/>
+                <a:ea typeface="Arial" pitchFamily="34" charset="-122"/>
+                <a:cs typeface="Arial" pitchFamily="34" charset="-120"/>
               </a:rPr>
               <a:t>(b)   </a:t>
             </a:r>
+            <a:pPr algn="l" indent="0" marL="0">
+              <a:lnSpc>
+                <a:spcPct val="100000"/>
+              </a:lnSpc>
+              <a:buNone/>
+            </a:pPr>
             <a:r>
               <a:rPr lang="en-US" sz="900" b="1" dirty="0">
                 <a:solidFill>
                   <a:srgbClr val="0E7C7B"/>
                 </a:solidFill>
-                <a:latin typeface="Comic Sans MS" panose="030F0902030302020204" charset="0"/>
-                <a:ea typeface="Arial" panose="020B0604020202090204" pitchFamily="34" charset="-122"/>
-                <a:cs typeface="Comic Sans MS" panose="030F0902030302020204" charset="0"/>
+                <a:latin typeface="Arial" pitchFamily="34" charset="0"/>
+                <a:ea typeface="Arial" pitchFamily="34" charset="-122"/>
+                <a:cs typeface="Arial" pitchFamily="34" charset="-120"/>
               </a:rPr>
               <a:t>DP-ES</a:t>
             </a:r>
+            <a:pPr algn="l" indent="0" marL="0">
+              <a:lnSpc>
+                <a:spcPct val="100000"/>
+              </a:lnSpc>
+              <a:buNone/>
+            </a:pPr>
             <a:r>
               <a:rPr lang="en-US" sz="900" b="1" dirty="0">
                 <a:solidFill>
                   <a:srgbClr val="1A1F2B"/>
                 </a:solidFill>
-                <a:latin typeface="Comic Sans MS" panose="030F0902030302020204" charset="0"/>
-                <a:ea typeface="Arial" panose="020B0604020202090204" pitchFamily="34" charset="-122"/>
-                <a:cs typeface="Comic Sans MS" panose="030F0902030302020204" charset="0"/>
+                <a:latin typeface="Arial" pitchFamily="34" charset="0"/>
+                <a:ea typeface="Arial" pitchFamily="34" charset="-122"/>
+                <a:cs typeface="Arial" pitchFamily="34" charset="-120"/>
               </a:rPr>
               <a:t> vs. </a:t>
             </a:r>
+            <a:pPr algn="l" indent="0" marL="0">
+              <a:lnSpc>
+                <a:spcPct val="100000"/>
+              </a:lnSpc>
+              <a:buNone/>
+            </a:pPr>
             <a:r>
               <a:rPr lang="en-US" sz="900" b="1" dirty="0">
                 <a:solidFill>
                   <a:srgbClr val="B23124"/>
                 </a:solidFill>
-                <a:latin typeface="Comic Sans MS" panose="030F0902030302020204" charset="0"/>
-                <a:ea typeface="Arial" panose="020B0604020202090204" pitchFamily="34" charset="-122"/>
-                <a:cs typeface="Comic Sans MS" panose="030F0902030302020204" charset="0"/>
+                <a:latin typeface="Arial" pitchFamily="34" charset="0"/>
+                <a:ea typeface="Arial" pitchFamily="34" charset="-122"/>
+                <a:cs typeface="Arial" pitchFamily="34" charset="-120"/>
               </a:rPr>
               <a:t>DP-OPT</a:t>
             </a:r>
+            <a:pPr algn="l" indent="0" marL="0">
+              <a:lnSpc>
+                <a:spcPct val="100000"/>
+              </a:lnSpc>
+              <a:buNone/>
+            </a:pPr>
             <a:r>
               <a:rPr lang="en-US" sz="900" b="1" dirty="0">
                 <a:solidFill>
                   <a:srgbClr val="1A1F2B"/>
                 </a:solidFill>
-                <a:latin typeface="Comic Sans MS" panose="030F0902030302020204" charset="0"/>
-                <a:ea typeface="Arial" panose="020B0604020202090204" pitchFamily="34" charset="-122"/>
-                <a:cs typeface="Comic Sans MS" panose="030F0902030302020204" charset="0"/>
+                <a:latin typeface="Arial" pitchFamily="34" charset="0"/>
+                <a:ea typeface="Arial" pitchFamily="34" charset="-122"/>
+                <a:cs typeface="Arial" pitchFamily="34" charset="-120"/>
               </a:rPr>
               <a:t>: mechanism and observed stability</a:t>
             </a:r>
-            <a:endParaRPr lang="en-US" sz="900" b="1" dirty="0">
-              <a:latin typeface="Comic Sans MS" panose="030F0902030302020204" charset="0"/>
-              <a:cs typeface="Comic Sans MS" panose="030F0902030302020204" charset="0"/>
-            </a:endParaRPr>
+            <a:endParaRPr lang="en-US" sz="900" dirty="0"/>
           </a:p>
         </p:txBody>
       </p:sp>
       <p:graphicFrame>
         <p:nvGraphicFramePr>
-          <p:cNvPr id="60" name="b.table"/>
+          <p:cNvPr id="2" name="b.table"/>
           <p:cNvGraphicFramePr>
             <a:graphicFrameLocks noGrp="1"/>
           </p:cNvGraphicFramePr>
-          <p:nvPr/>
+          <p:nvPr>
+            <p:extLst>
+              <p:ext uri="{D42A27DB-BD31-4B8C-83A1-F6EECF244321}">
+                <p14:modId xmlns:p14="http://schemas.microsoft.com/office/powerpoint/2010/main" val="1579011935"/>
+              </p:ext>
+            </p:extLst>
+          </p:nvPr>
         </p:nvGraphicFramePr>
         <p:xfrm>
           <a:off x="109728" y="3474720"/>
@@ -3572,7 +3984,7 @@
                     <a:bodyPr/>
                     <a:lstStyle/>
                     <a:p>
-                      <a:pPr marL="0" indent="0" algn="ctr">
+                      <a:pPr algn="ctr" indent="0" marL="0">
                         <a:buNone/>
                       </a:pPr>
                       <a:r>
@@ -3580,20 +3992,13 @@
                           <a:solidFill>
                             <a:srgbClr val="1A1F2B"/>
                           </a:solidFill>
-                          <a:latin typeface="Comic Sans MS" panose="030F0902030302020204" charset="0"/>
-                          <a:ea typeface="Arial" panose="020B0604020202090204" pitchFamily="34" charset="-122"/>
-                          <a:cs typeface="Comic Sans MS" panose="030F0902030302020204" charset="0"/>
+                          <a:latin typeface="Arial" pitchFamily="34" charset="0"/>
+                          <a:ea typeface="Arial" pitchFamily="34" charset="-122"/>
+                          <a:cs typeface="Arial" pitchFamily="34" charset="-120"/>
                         </a:rPr>
                         <a:t>Aspect</a:t>
                       </a:r>
-                      <a:endParaRPr lang="en-US" sz="740" b="1" dirty="0">
-                        <a:solidFill>
-                          <a:srgbClr val="1A1F2B"/>
-                        </a:solidFill>
-                        <a:latin typeface="Comic Sans MS" panose="030F0902030302020204" charset="0"/>
-                        <a:ea typeface="Arial" panose="020B0604020202090204" pitchFamily="34" charset="-122"/>
-                        <a:cs typeface="Comic Sans MS" panose="030F0902030302020204" charset="0"/>
-                      </a:endParaRPr>
+                      <a:endParaRPr lang="en-US" sz="1200" dirty="0"/>
                     </a:p>
                   </a:txBody>
                   <a:tcPr marL="38100" marR="38100" marT="12700" marB="12700" anchor="ctr">
@@ -3628,7 +4033,7 @@
                     <a:bodyPr/>
                     <a:lstStyle/>
                     <a:p>
-                      <a:pPr marL="0" indent="0" algn="ctr">
+                      <a:pPr algn="ctr" indent="0" marL="0">
                         <a:buNone/>
                       </a:pPr>
                       <a:r>
@@ -3636,20 +4041,13 @@
                           <a:solidFill>
                             <a:srgbClr val="0E7C7B"/>
                           </a:solidFill>
-                          <a:latin typeface="Comic Sans MS" panose="030F0902030302020204" charset="0"/>
-                          <a:ea typeface="Arial" panose="020B0604020202090204" pitchFamily="34" charset="-122"/>
-                          <a:cs typeface="Comic Sans MS" panose="030F0902030302020204" charset="0"/>
+                          <a:latin typeface="Arial" pitchFamily="34" charset="0"/>
+                          <a:ea typeface="Arial" pitchFamily="34" charset="-122"/>
+                          <a:cs typeface="Arial" pitchFamily="34" charset="-120"/>
                         </a:rPr>
                         <a:t>DP-ES (ours)</a:t>
                       </a:r>
-                      <a:endParaRPr lang="en-US" sz="740" b="1" dirty="0">
-                        <a:solidFill>
-                          <a:srgbClr val="0E7C7B"/>
-                        </a:solidFill>
-                        <a:latin typeface="Comic Sans MS" panose="030F0902030302020204" charset="0"/>
-                        <a:ea typeface="Arial" panose="020B0604020202090204" pitchFamily="34" charset="-122"/>
-                        <a:cs typeface="Comic Sans MS" panose="030F0902030302020204" charset="0"/>
-                      </a:endParaRPr>
+                      <a:endParaRPr lang="en-US" sz="1200" dirty="0"/>
                     </a:p>
                   </a:txBody>
                   <a:tcPr marL="38100" marR="38100" marT="12700" marB="12700" anchor="ctr">
@@ -3684,7 +4082,7 @@
                     <a:bodyPr/>
                     <a:lstStyle/>
                     <a:p>
-                      <a:pPr marL="0" indent="0" algn="ctr">
+                      <a:pPr algn="ctr" indent="0" marL="0">
                         <a:buNone/>
                       </a:pPr>
                       <a:r>
@@ -3692,20 +4090,13 @@
                           <a:solidFill>
                             <a:srgbClr val="B23124"/>
                           </a:solidFill>
-                          <a:latin typeface="Comic Sans MS" panose="030F0902030302020204" charset="0"/>
-                          <a:ea typeface="Arial" panose="020B0604020202090204" pitchFamily="34" charset="-122"/>
-                          <a:cs typeface="Comic Sans MS" panose="030F0902030302020204" charset="0"/>
+                          <a:latin typeface="Arial" pitchFamily="34" charset="0"/>
+                          <a:ea typeface="Arial" pitchFamily="34" charset="-122"/>
+                          <a:cs typeface="Arial" pitchFamily="34" charset="-120"/>
                         </a:rPr>
                         <a:t>DP-OPT</a:t>
                       </a:r>
-                      <a:endParaRPr lang="en-US" sz="740" b="1" dirty="0">
-                        <a:solidFill>
-                          <a:srgbClr val="B23124"/>
-                        </a:solidFill>
-                        <a:latin typeface="Comic Sans MS" panose="030F0902030302020204" charset="0"/>
-                        <a:ea typeface="Arial" panose="020B0604020202090204" pitchFamily="34" charset="-122"/>
-                        <a:cs typeface="Comic Sans MS" panose="030F0902030302020204" charset="0"/>
-                      </a:endParaRPr>
+                      <a:endParaRPr lang="en-US" sz="1200" dirty="0"/>
                     </a:p>
                   </a:txBody>
                   <a:tcPr marL="38100" marR="38100" marT="12700" marB="12700" anchor="ctr">
@@ -3742,7 +4133,7 @@
                     <a:bodyPr/>
                     <a:lstStyle/>
                     <a:p>
-                      <a:pPr marL="0" indent="0" algn="ctr">
+                      <a:pPr algn="ctr" indent="0" marL="0">
                         <a:buNone/>
                       </a:pPr>
                       <a:r>
@@ -3750,20 +4141,13 @@
                           <a:solidFill>
                             <a:srgbClr val="1A1F2B"/>
                           </a:solidFill>
-                          <a:latin typeface="Comic Sans MS" panose="030F0902030302020204" charset="0"/>
-                          <a:ea typeface="Arial" panose="020B0604020202090204" pitchFamily="34" charset="-122"/>
-                          <a:cs typeface="Comic Sans MS" panose="030F0902030302020204" charset="0"/>
+                          <a:latin typeface="Arial" pitchFamily="34" charset="0"/>
+                          <a:ea typeface="Arial" pitchFamily="34" charset="-122"/>
+                          <a:cs typeface="Arial" pitchFamily="34" charset="-120"/>
                         </a:rPr>
                         <a:t>Search unit</a:t>
                       </a:r>
-                      <a:endParaRPr lang="en-US" sz="700" b="1" dirty="0">
-                        <a:solidFill>
-                          <a:srgbClr val="1A1F2B"/>
-                        </a:solidFill>
-                        <a:latin typeface="Comic Sans MS" panose="030F0902030302020204" charset="0"/>
-                        <a:ea typeface="Arial" panose="020B0604020202090204" pitchFamily="34" charset="-122"/>
-                        <a:cs typeface="Comic Sans MS" panose="030F0902030302020204" charset="0"/>
-                      </a:endParaRPr>
+                      <a:endParaRPr lang="en-US" sz="1200" dirty="0"/>
                     </a:p>
                   </a:txBody>
                   <a:tcPr marL="38100" marR="38100" marT="12700" marB="12700" anchor="ctr">
@@ -3792,28 +4176,21 @@
                     <a:bodyPr/>
                     <a:lstStyle/>
                     <a:p>
-                      <a:pPr marL="0" indent="0" algn="ctr">
+                      <a:pPr algn="ctr" indent="0" marL="0">
                         <a:buNone/>
                       </a:pPr>
                       <a:r>
-                        <a:rPr lang="en-US" sz="700" dirty="0">
+                        <a:rPr lang="en-US" sz="680" dirty="0">
                           <a:solidFill>
                             <a:srgbClr val="1A1F2B"/>
                           </a:solidFill>
-                          <a:latin typeface="Palatino Regular" charset="0"/>
-                          <a:ea typeface="Arial" panose="020B0604020202090204" pitchFamily="34" charset="-122"/>
-                          <a:cs typeface="Palatino Regular" charset="0"/>
+                          <a:latin typeface="Arial" pitchFamily="34" charset="0"/>
+                          <a:ea typeface="Arial" pitchFamily="34" charset="-122"/>
+                          <a:cs typeface="Arial" pitchFamily="34" charset="-120"/>
                         </a:rPr>
                         <a:t>Population of complete prompts</a:t>
                       </a:r>
-                      <a:endParaRPr lang="en-US" sz="700" dirty="0">
-                        <a:solidFill>
-                          <a:srgbClr val="1A1F2B"/>
-                        </a:solidFill>
-                        <a:latin typeface="Palatino Regular" charset="0"/>
-                        <a:ea typeface="Arial" panose="020B0604020202090204" pitchFamily="34" charset="-122"/>
-                        <a:cs typeface="Palatino Regular" charset="0"/>
-                      </a:endParaRPr>
+                      <a:endParaRPr lang="en-US" sz="1200" dirty="0"/>
                     </a:p>
                   </a:txBody>
                   <a:tcPr marL="38100" marR="38100" marT="12700" marB="12700" anchor="ctr">
@@ -3842,31 +4219,21 @@
                     <a:bodyPr/>
                     <a:lstStyle/>
                     <a:p>
-                      <a:pPr marL="0" algn="ctr">
-                        <a:buClrTx/>
-                        <a:buSzTx/>
-                        <a:buFontTx/>
+                      <a:pPr algn="ctr" indent="0" marL="0">
                         <a:buNone/>
                       </a:pPr>
                       <a:r>
-                        <a:rPr lang="en-US" sz="700" dirty="0">
+                        <a:rPr lang="en-US" sz="680" dirty="0">
                           <a:solidFill>
                             <a:srgbClr val="1A1F2B"/>
                           </a:solidFill>
-                          <a:latin typeface="Palatino Regular" charset="0"/>
-                          <a:ea typeface="Arial" panose="020B0604020202090204" pitchFamily="34" charset="-122"/>
-                          <a:cs typeface="Palatino Regular" charset="0"/>
+                          <a:latin typeface="Arial" pitchFamily="34" charset="0"/>
+                          <a:ea typeface="Arial" pitchFamily="34" charset="-122"/>
+                          <a:cs typeface="Arial" pitchFamily="34" charset="-120"/>
                         </a:rPr>
                         <a:t>Greedy token-by-token construction</a:t>
                       </a:r>
-                      <a:endParaRPr lang="en-US" sz="700" dirty="0">
-                        <a:solidFill>
-                          <a:srgbClr val="1A1F2B"/>
-                        </a:solidFill>
-                        <a:latin typeface="Palatino Regular" charset="0"/>
-                        <a:ea typeface="Arial" panose="020B0604020202090204" pitchFamily="34" charset="-122"/>
-                        <a:cs typeface="Palatino Regular" charset="0"/>
-                      </a:endParaRPr>
+                      <a:endParaRPr lang="en-US" sz="1200" dirty="0"/>
                     </a:p>
                   </a:txBody>
                   <a:tcPr marL="38100" marR="38100" marT="12700" marB="12700" anchor="ctr">
@@ -3897,7 +4264,7 @@
                     <a:bodyPr/>
                     <a:lstStyle/>
                     <a:p>
-                      <a:pPr marL="0" indent="0" algn="ctr">
+                      <a:pPr algn="ctr" indent="0" marL="0">
                         <a:buNone/>
                       </a:pPr>
                       <a:r>
@@ -3905,20 +4272,13 @@
                           <a:solidFill>
                             <a:srgbClr val="1A1F2B"/>
                           </a:solidFill>
-                          <a:latin typeface="Comic Sans MS" panose="030F0902030302020204" charset="0"/>
-                          <a:ea typeface="Arial" panose="020B0604020202090204" pitchFamily="34" charset="-122"/>
-                          <a:cs typeface="Comic Sans MS" panose="030F0902030302020204" charset="0"/>
+                          <a:latin typeface="Arial" pitchFamily="34" charset="0"/>
+                          <a:ea typeface="Arial" pitchFamily="34" charset="-122"/>
+                          <a:cs typeface="Arial" pitchFamily="34" charset="-120"/>
                         </a:rPr>
                         <a:t>Private-data access</a:t>
                       </a:r>
-                      <a:endParaRPr lang="en-US" sz="700" b="1" dirty="0">
-                        <a:solidFill>
-                          <a:srgbClr val="1A1F2B"/>
-                        </a:solidFill>
-                        <a:latin typeface="Comic Sans MS" panose="030F0902030302020204" charset="0"/>
-                        <a:ea typeface="Arial" panose="020B0604020202090204" pitchFamily="34" charset="-122"/>
-                        <a:cs typeface="Comic Sans MS" panose="030F0902030302020204" charset="0"/>
-                      </a:endParaRPr>
+                      <a:endParaRPr lang="en-US" sz="1200" dirty="0"/>
                     </a:p>
                   </a:txBody>
                   <a:tcPr marL="38100" marR="38100" marT="12700" marB="12700" anchor="ctr">
@@ -3947,31 +4307,21 @@
                     <a:bodyPr/>
                     <a:lstStyle/>
                     <a:p>
-                      <a:pPr marL="0" algn="ctr">
-                        <a:buClrTx/>
-                        <a:buSzTx/>
-                        <a:buFontTx/>
+                      <a:pPr algn="ctr" indent="0" marL="0">
                         <a:buNone/>
                       </a:pPr>
                       <a:r>
-                        <a:rPr lang="en-US" sz="700" dirty="0">
+                        <a:rPr lang="en-US" sz="680" dirty="0">
                           <a:solidFill>
                             <a:srgbClr val="1A1F2B"/>
                           </a:solidFill>
-                          <a:latin typeface="Palatino Regular" charset="0"/>
-                          <a:ea typeface="Arial" panose="020B0604020202090204" pitchFamily="34" charset="-122"/>
-                          <a:cs typeface="Palatino Regular" charset="0"/>
+                          <a:latin typeface="Arial" pitchFamily="34" charset="0"/>
+                          <a:ea typeface="Arial" pitchFamily="34" charset="-122"/>
+                          <a:cs typeface="Arial" pitchFamily="34" charset="-120"/>
                         </a:rPr>
                         <a:t>Sampled utility scoring only</a:t>
                       </a:r>
-                      <a:endParaRPr lang="en-US" sz="700" dirty="0">
-                        <a:solidFill>
-                          <a:srgbClr val="1A1F2B"/>
-                        </a:solidFill>
-                        <a:latin typeface="Palatino Regular" charset="0"/>
-                        <a:ea typeface="Arial" panose="020B0604020202090204" pitchFamily="34" charset="-122"/>
-                        <a:cs typeface="Palatino Regular" charset="0"/>
-                      </a:endParaRPr>
+                      <a:endParaRPr lang="en-US" sz="1200" dirty="0"/>
                     </a:p>
                   </a:txBody>
                   <a:tcPr marL="38100" marR="38100" marT="12700" marB="12700" anchor="ctr">
@@ -4000,31 +4350,21 @@
                     <a:bodyPr/>
                     <a:lstStyle/>
                     <a:p>
-                      <a:pPr marL="0" algn="ctr">
-                        <a:buClrTx/>
-                        <a:buSzTx/>
-                        <a:buFontTx/>
+                      <a:pPr algn="ctr" indent="0" marL="0">
                         <a:buNone/>
                       </a:pPr>
                       <a:r>
-                        <a:rPr lang="en-US" sz="700" dirty="0">
+                        <a:rPr lang="en-US" sz="680" dirty="0">
                           <a:solidFill>
                             <a:srgbClr val="1A1F2B"/>
                           </a:solidFill>
-                          <a:latin typeface="Palatino Regular" charset="0"/>
-                          <a:ea typeface="Arial" panose="020B0604020202090204" pitchFamily="34" charset="-122"/>
-                          <a:cs typeface="Palatino Regular" charset="0"/>
+                          <a:latin typeface="Arial" pitchFamily="34" charset="0"/>
+                          <a:ea typeface="Arial" pitchFamily="34" charset="-122"/>
+                          <a:cs typeface="Arial" pitchFamily="34" charset="-120"/>
                         </a:rPr>
                         <a:t>Private histogram queries during construction</a:t>
                       </a:r>
-                      <a:endParaRPr lang="en-US" sz="700" dirty="0">
-                        <a:solidFill>
-                          <a:srgbClr val="1A1F2B"/>
-                        </a:solidFill>
-                        <a:latin typeface="Palatino Regular" charset="0"/>
-                        <a:ea typeface="Arial" panose="020B0604020202090204" pitchFamily="34" charset="-122"/>
-                        <a:cs typeface="Palatino Regular" charset="0"/>
-                      </a:endParaRPr>
+                      <a:endParaRPr lang="en-US" sz="1200" dirty="0"/>
                     </a:p>
                   </a:txBody>
                   <a:tcPr marL="38100" marR="38100" marT="12700" marB="12700" anchor="ctr">
@@ -4055,7 +4395,7 @@
                     <a:bodyPr/>
                     <a:lstStyle/>
                     <a:p>
-                      <a:pPr marL="0" indent="0" algn="ctr">
+                      <a:pPr algn="ctr" indent="0" marL="0">
                         <a:buNone/>
                       </a:pPr>
                       <a:r>
@@ -4063,20 +4403,13 @@
                           <a:solidFill>
                             <a:srgbClr val="1A1F2B"/>
                           </a:solidFill>
-                          <a:latin typeface="Comic Sans MS" panose="030F0902030302020204" charset="0"/>
-                          <a:ea typeface="Arial" panose="020B0604020202090204" pitchFamily="34" charset="-122"/>
-                          <a:cs typeface="Comic Sans MS" panose="030F0902030302020204" charset="0"/>
+                          <a:latin typeface="Arial" pitchFamily="34" charset="0"/>
+                          <a:ea typeface="Arial" pitchFamily="34" charset="-122"/>
+                          <a:cs typeface="Arial" pitchFamily="34" charset="-120"/>
                         </a:rPr>
                         <a:t>Selection / recovery</a:t>
                       </a:r>
-                      <a:endParaRPr lang="en-US" sz="700" b="1" dirty="0">
-                        <a:solidFill>
-                          <a:srgbClr val="1A1F2B"/>
-                        </a:solidFill>
-                        <a:latin typeface="Comic Sans MS" panose="030F0902030302020204" charset="0"/>
-                        <a:ea typeface="Arial" panose="020B0604020202090204" pitchFamily="34" charset="-122"/>
-                        <a:cs typeface="Comic Sans MS" panose="030F0902030302020204" charset="0"/>
-                      </a:endParaRPr>
+                      <a:endParaRPr lang="en-US" sz="1200" dirty="0"/>
                     </a:p>
                   </a:txBody>
                   <a:tcPr marL="38100" marR="38100" marT="12700" marB="12700" anchor="ctr">
@@ -4105,31 +4438,21 @@
                     <a:bodyPr/>
                     <a:lstStyle/>
                     <a:p>
-                      <a:pPr marL="0" algn="ctr">
-                        <a:buClrTx/>
-                        <a:buSzTx/>
-                        <a:buFontTx/>
+                      <a:pPr algn="ctr" indent="0" marL="0">
                         <a:buNone/>
                       </a:pPr>
                       <a:r>
-                        <a:rPr lang="en-US" sz="700" dirty="0">
+                        <a:rPr lang="en-US" sz="680" dirty="0">
                           <a:solidFill>
                             <a:srgbClr val="1A1F2B"/>
                           </a:solidFill>
-                          <a:latin typeface="Palatino Regular" charset="0"/>
-                          <a:ea typeface="Arial" panose="020B0604020202090204" pitchFamily="34" charset="-122"/>
-                          <a:cs typeface="Palatino Regular" charset="0"/>
+                          <a:latin typeface="Arial" pitchFamily="34" charset="0"/>
+                          <a:ea typeface="Arial" pitchFamily="34" charset="-122"/>
+                          <a:cs typeface="Arial" pitchFamily="34" charset="-120"/>
                         </a:rPr>
                         <a:t>Top-M on privatized scores; alternatives persist</a:t>
                       </a:r>
-                      <a:endParaRPr lang="en-US" sz="700" dirty="0">
-                        <a:solidFill>
-                          <a:srgbClr val="1A1F2B"/>
-                        </a:solidFill>
-                        <a:latin typeface="Palatino Regular" charset="0"/>
-                        <a:ea typeface="Arial" panose="020B0604020202090204" pitchFamily="34" charset="-122"/>
-                        <a:cs typeface="Palatino Regular" charset="0"/>
-                      </a:endParaRPr>
+                      <a:endParaRPr lang="en-US" sz="1200" dirty="0"/>
                     </a:p>
                   </a:txBody>
                   <a:tcPr marL="38100" marR="38100" marT="12700" marB="12700" anchor="ctr">
@@ -4158,31 +4481,21 @@
                     <a:bodyPr/>
                     <a:lstStyle/>
                     <a:p>
-                      <a:pPr marL="0" algn="ctr">
-                        <a:buClrTx/>
-                        <a:buSzTx/>
-                        <a:buFontTx/>
+                      <a:pPr algn="ctr" indent="0" marL="0">
                         <a:buNone/>
                       </a:pPr>
                       <a:r>
-                        <a:rPr lang="en-US" sz="700" dirty="0">
+                        <a:rPr lang="en-US" sz="680" dirty="0">
                           <a:solidFill>
                             <a:srgbClr val="1A1F2B"/>
                           </a:solidFill>
-                          <a:latin typeface="Palatino Regular" charset="0"/>
-                          <a:ea typeface="Arial" panose="020B0604020202090204" pitchFamily="34" charset="-122"/>
-                          <a:cs typeface="Palatino Regular" charset="0"/>
+                          <a:latin typeface="Arial" pitchFamily="34" charset="0"/>
+                          <a:ea typeface="Arial" pitchFamily="34" charset="-122"/>
+                          <a:cs typeface="Arial" pitchFamily="34" charset="-120"/>
                         </a:rPr>
                         <a:t>Private token releases; no token-level backtracking</a:t>
                       </a:r>
-                      <a:endParaRPr lang="en-US" sz="700" dirty="0">
-                        <a:solidFill>
-                          <a:srgbClr val="1A1F2B"/>
-                        </a:solidFill>
-                        <a:latin typeface="Palatino Regular" charset="0"/>
-                        <a:ea typeface="Arial" panose="020B0604020202090204" pitchFamily="34" charset="-122"/>
-                        <a:cs typeface="Palatino Regular" charset="0"/>
-                      </a:endParaRPr>
+                      <a:endParaRPr lang="en-US" sz="1200" dirty="0"/>
                     </a:p>
                   </a:txBody>
                   <a:tcPr marL="38100" marR="38100" marT="12700" marB="12700" anchor="ctr">
@@ -4213,7 +4526,7 @@
                     <a:bodyPr/>
                     <a:lstStyle/>
                     <a:p>
-                      <a:pPr marL="0" indent="0" algn="ctr">
+                      <a:pPr algn="ctr" indent="0" marL="0">
                         <a:buNone/>
                       </a:pPr>
                       <a:r>
@@ -4221,20 +4534,13 @@
                           <a:solidFill>
                             <a:srgbClr val="1A1F2B"/>
                           </a:solidFill>
-                          <a:latin typeface="Comic Sans MS" panose="030F0902030302020204" charset="0"/>
-                          <a:ea typeface="Arial" panose="020B0604020202090204" pitchFamily="34" charset="-122"/>
-                          <a:cs typeface="Comic Sans MS" panose="030F0902030302020204" charset="0"/>
+                          <a:latin typeface="Arial" pitchFamily="34" charset="0"/>
+                          <a:ea typeface="Arial" pitchFamily="34" charset="-122"/>
+                          <a:cs typeface="Arial" pitchFamily="34" charset="-120"/>
                         </a:rPr>
                         <a:t>GSM8K (30 runs)</a:t>
                       </a:r>
-                      <a:endParaRPr lang="en-US" sz="700" b="1" dirty="0">
-                        <a:solidFill>
-                          <a:srgbClr val="1A1F2B"/>
-                        </a:solidFill>
-                        <a:latin typeface="Comic Sans MS" panose="030F0902030302020204" charset="0"/>
-                        <a:ea typeface="Arial" panose="020B0604020202090204" pitchFamily="34" charset="-122"/>
-                        <a:cs typeface="Comic Sans MS" panose="030F0902030302020204" charset="0"/>
-                      </a:endParaRPr>
+                      <a:endParaRPr lang="en-US" sz="1200" dirty="0"/>
                     </a:p>
                   </a:txBody>
                   <a:tcPr marL="38100" marR="38100" marT="12700" marB="12700" anchor="ctr">
@@ -4263,7 +4569,7 @@
                     <a:bodyPr/>
                     <a:lstStyle/>
                     <a:p>
-                      <a:pPr marL="0" indent="0" algn="ctr">
+                      <a:pPr algn="ctr" indent="0" marL="0">
                         <a:buNone/>
                       </a:pPr>
                       <a:r>
@@ -4271,20 +4577,13 @@
                           <a:solidFill>
                             <a:srgbClr val="0E7C7B"/>
                           </a:solidFill>
-                          <a:latin typeface="Palatino Regular" charset="0"/>
-                          <a:ea typeface="Arial" panose="020B0604020202090204" pitchFamily="34" charset="-122"/>
-                          <a:cs typeface="Palatino Regular" charset="0"/>
+                          <a:latin typeface="Arial" pitchFamily="34" charset="0"/>
+                          <a:ea typeface="Arial" pitchFamily="34" charset="-122"/>
+                          <a:cs typeface="Arial" pitchFamily="34" charset="-120"/>
                         </a:rPr>
                         <a:t>88.1 ± 3.2%</a:t>
                       </a:r>
-                      <a:endParaRPr lang="en-US" sz="800" b="1" dirty="0">
-                        <a:solidFill>
-                          <a:srgbClr val="0E7C7B"/>
-                        </a:solidFill>
-                        <a:latin typeface="Palatino Regular" charset="0"/>
-                        <a:ea typeface="Arial" panose="020B0604020202090204" pitchFamily="34" charset="-122"/>
-                        <a:cs typeface="Palatino Regular" charset="0"/>
-                      </a:endParaRPr>
+                      <a:endParaRPr lang="en-US" sz="1200" dirty="0"/>
                     </a:p>
                   </a:txBody>
                   <a:tcPr marL="38100" marR="38100" marT="12700" marB="12700" anchor="ctr">
@@ -4316,7 +4615,7 @@
                     <a:bodyPr/>
                     <a:lstStyle/>
                     <a:p>
-                      <a:pPr marL="0" indent="0" algn="ctr">
+                      <a:pPr algn="ctr" indent="0" marL="0">
                         <a:buNone/>
                       </a:pPr>
                       <a:r>
@@ -4324,20 +4623,13 @@
                           <a:solidFill>
                             <a:srgbClr val="B23124"/>
                           </a:solidFill>
-                          <a:latin typeface="Palatino Regular" charset="0"/>
-                          <a:ea typeface="Arial" panose="020B0604020202090204" pitchFamily="34" charset="-122"/>
-                          <a:cs typeface="Palatino Regular" charset="0"/>
+                          <a:latin typeface="Arial" pitchFamily="34" charset="0"/>
+                          <a:ea typeface="Arial" pitchFamily="34" charset="-122"/>
+                          <a:cs typeface="Arial" pitchFamily="34" charset="-120"/>
                         </a:rPr>
                         <a:t>49.5 ± 28.5%</a:t>
                       </a:r>
-                      <a:endParaRPr lang="en-US" sz="800" b="1" dirty="0">
-                        <a:solidFill>
-                          <a:srgbClr val="B23124"/>
-                        </a:solidFill>
-                        <a:latin typeface="Palatino Regular" charset="0"/>
-                        <a:ea typeface="Arial" panose="020B0604020202090204" pitchFamily="34" charset="-122"/>
-                        <a:cs typeface="Palatino Regular" charset="0"/>
-                      </a:endParaRPr>
+                      <a:endParaRPr lang="en-US" sz="1200" dirty="0"/>
                     </a:p>
                   </a:txBody>
                   <a:tcPr marL="38100" marR="38100" marT="12700" marB="12700" anchor="ctr">
@@ -4420,7 +4712,7 @@
     </a:clrScheme>
     <a:fontScheme name="Office">
       <a:majorFont>
-        <a:latin typeface="Calibri Light"/>
+        <a:latin typeface="Calibri Light" panose="020F0302020204030204"/>
         <a:ea typeface=""/>
         <a:cs typeface=""/>
         <a:font script="Jpan" typeface="游ゴシック Light"/>
@@ -4453,9 +4745,26 @@
         <a:font script="Viet" typeface="Times New Roman"/>
         <a:font script="Uigh" typeface="Microsoft Uighur"/>
         <a:font script="Geor" typeface="Sylfaen"/>
+        <a:font script="Armn" typeface="Arial"/>
+        <a:font script="Bugi" typeface="Leelawadee UI"/>
+        <a:font script="Bopo" typeface="Microsoft JhengHei"/>
+        <a:font script="Java" typeface="Javanese Text"/>
+        <a:font script="Lisu" typeface="Segoe UI"/>
+        <a:font script="Mymr" typeface="Myanmar Text"/>
+        <a:font script="Nkoo" typeface="Ebrima"/>
+        <a:font script="Olck" typeface="Nirmala UI"/>
+        <a:font script="Osma" typeface="Ebrima"/>
+        <a:font script="Phag" typeface="Phagspa"/>
+        <a:font script="Syrn" typeface="Estrangelo Edessa"/>
+        <a:font script="Syrj" typeface="Estrangelo Edessa"/>
+        <a:font script="Syre" typeface="Estrangelo Edessa"/>
+        <a:font script="Sora" typeface="Nirmala UI"/>
+        <a:font script="Tale" typeface="Microsoft Tai Le"/>
+        <a:font script="Talu" typeface="Microsoft New Tai Lue"/>
+        <a:font script="Tfng" typeface="Ebrima"/>
       </a:majorFont>
       <a:minorFont>
-        <a:latin typeface="Calibri"/>
+        <a:latin typeface="Calibri" panose="020F0502020204030204"/>
         <a:ea typeface=""/>
         <a:cs typeface=""/>
         <a:font script="Jpan" typeface="游ゴシック"/>
@@ -4488,6 +4797,23 @@
         <a:font script="Viet" typeface="Arial"/>
         <a:font script="Uigh" typeface="Microsoft Uighur"/>
         <a:font script="Geor" typeface="Sylfaen"/>
+        <a:font script="Armn" typeface="Arial"/>
+        <a:font script="Bugi" typeface="Leelawadee UI"/>
+        <a:font script="Bopo" typeface="Microsoft JhengHei"/>
+        <a:font script="Java" typeface="Javanese Text"/>
+        <a:font script="Lisu" typeface="Segoe UI"/>
+        <a:font script="Mymr" typeface="Myanmar Text"/>
+        <a:font script="Nkoo" typeface="Ebrima"/>
+        <a:font script="Olck" typeface="Nirmala UI"/>
+        <a:font script="Osma" typeface="Ebrima"/>
+        <a:font script="Phag" typeface="Phagspa"/>
+        <a:font script="Syrn" typeface="Estrangelo Edessa"/>
+        <a:font script="Syrj" typeface="Estrangelo Edessa"/>
+        <a:font script="Syre" typeface="Estrangelo Edessa"/>
+        <a:font script="Sora" typeface="Nirmala UI"/>
+        <a:font script="Tale" typeface="Microsoft Tai Le"/>
+        <a:font script="Talu" typeface="Microsoft New Tai Lue"/>
+        <a:font script="Tfng" typeface="Ebrima"/>
       </a:minorFont>
     </a:fontScheme>
     <a:fmtScheme name="Office">
@@ -4628,265 +4954,8 @@
       </a:bgFillStyleLst>
     </a:fmtScheme>
   </a:themeElements>
-  <a:extLst>
-    <a:ext uri="{05A4C25C-085E-4340-85A3-A5531E510DB2}">
-      <thm15:themeFamily xmlns:thm15="http://schemas.microsoft.com/office/thememl/2012/main" name="Office Theme" id="{62F939B6-93AF-4DB8-9C6B-D6C7DFDC589F}" vid="{4A3C46E8-61CC-4603-A589-7422A47A8E4A}"/>
-    </a:ext>
-  </a:extLst>
-</a:theme>
-</file>
-
-<file path=ppt/theme/theme2.xml><?xml version="1.0" encoding="utf-8"?>
-<a:theme xmlns:a="http://schemas.openxmlformats.org/drawingml/2006/main" name="Office Theme">
-  <a:themeElements>
-    <a:clrScheme name="Office">
-      <a:dk1>
-        <a:sysClr val="windowText" lastClr="000000"/>
-      </a:dk1>
-      <a:lt1>
-        <a:sysClr val="window" lastClr="FFFFFF"/>
-      </a:lt1>
-      <a:dk2>
-        <a:srgbClr val="44546A"/>
-      </a:dk2>
-      <a:lt2>
-        <a:srgbClr val="E7E6E6"/>
-      </a:lt2>
-      <a:accent1>
-        <a:srgbClr val="4472C4"/>
-      </a:accent1>
-      <a:accent2>
-        <a:srgbClr val="ED7D31"/>
-      </a:accent2>
-      <a:accent3>
-        <a:srgbClr val="A5A5A5"/>
-      </a:accent3>
-      <a:accent4>
-        <a:srgbClr val="FFC000"/>
-      </a:accent4>
-      <a:accent5>
-        <a:srgbClr val="5B9BD5"/>
-      </a:accent5>
-      <a:accent6>
-        <a:srgbClr val="70AD47"/>
-      </a:accent6>
-      <a:hlink>
-        <a:srgbClr val="0563C1"/>
-      </a:hlink>
-      <a:folHlink>
-        <a:srgbClr val="954F72"/>
-      </a:folHlink>
-    </a:clrScheme>
-    <a:fontScheme name="Office">
-      <a:majorFont>
-        <a:latin typeface="Calibri Light"/>
-        <a:ea typeface=""/>
-        <a:cs typeface=""/>
-        <a:font script="Jpan" typeface="游ゴシック Light"/>
-        <a:font script="Hang" typeface="맑은 고딕"/>
-        <a:font script="Hans" typeface="等线 Light"/>
-        <a:font script="Hant" typeface="新細明體"/>
-        <a:font script="Arab" typeface="Times New Roman"/>
-        <a:font script="Hebr" typeface="Times New Roman"/>
-        <a:font script="Thai" typeface="Angsana New"/>
-        <a:font script="Ethi" typeface="Nyala"/>
-        <a:font script="Beng" typeface="Vrinda"/>
-        <a:font script="Gujr" typeface="Shruti"/>
-        <a:font script="Khmr" typeface="MoolBoran"/>
-        <a:font script="Knda" typeface="Tunga"/>
-        <a:font script="Guru" typeface="Raavi"/>
-        <a:font script="Cans" typeface="Euphemia"/>
-        <a:font script="Cher" typeface="Plantagenet Cherokee"/>
-        <a:font script="Yiii" typeface="Microsoft Yi Baiti"/>
-        <a:font script="Tibt" typeface="Microsoft Himalaya"/>
-        <a:font script="Thaa" typeface="MV Boli"/>
-        <a:font script="Deva" typeface="Mangal"/>
-        <a:font script="Telu" typeface="Gautami"/>
-        <a:font script="Taml" typeface="Latha"/>
-        <a:font script="Syrc" typeface="Estrangelo Edessa"/>
-        <a:font script="Orya" typeface="Kalinga"/>
-        <a:font script="Mlym" typeface="Kartika"/>
-        <a:font script="Laoo" typeface="DokChampa"/>
-        <a:font script="Sinh" typeface="Iskoola Pota"/>
-        <a:font script="Mong" typeface="Mongolian Baiti"/>
-        <a:font script="Viet" typeface="Times New Roman"/>
-        <a:font script="Uigh" typeface="Microsoft Uighur"/>
-        <a:font script="Geor" typeface="Sylfaen"/>
-      </a:majorFont>
-      <a:minorFont>
-        <a:latin typeface="Calibri"/>
-        <a:ea typeface=""/>
-        <a:cs typeface=""/>
-        <a:font script="Jpan" typeface="游ゴシック"/>
-        <a:font script="Hang" typeface="맑은 고딕"/>
-        <a:font script="Hans" typeface="等线"/>
-        <a:font script="Hant" typeface="新細明體"/>
-        <a:font script="Arab" typeface="Arial"/>
-        <a:font script="Hebr" typeface="Arial"/>
-        <a:font script="Thai" typeface="Cordia New"/>
-        <a:font script="Ethi" typeface="Nyala"/>
-        <a:font script="Beng" typeface="Vrinda"/>
-        <a:font script="Gujr" typeface="Shruti"/>
-        <a:font script="Khmr" typeface="DaunPenh"/>
-        <a:font script="Knda" typeface="Tunga"/>
-        <a:font script="Guru" typeface="Raavi"/>
-        <a:font script="Cans" typeface="Euphemia"/>
-        <a:font script="Cher" typeface="Plantagenet Cherokee"/>
-        <a:font script="Yiii" typeface="Microsoft Yi Baiti"/>
-        <a:font script="Tibt" typeface="Microsoft Himalaya"/>
-        <a:font script="Thaa" typeface="MV Boli"/>
-        <a:font script="Deva" typeface="Mangal"/>
-        <a:font script="Telu" typeface="Gautami"/>
-        <a:font script="Taml" typeface="Latha"/>
-        <a:font script="Syrc" typeface="Estrangelo Edessa"/>
-        <a:font script="Orya" typeface="Kalinga"/>
-        <a:font script="Mlym" typeface="Kartika"/>
-        <a:font script="Laoo" typeface="DokChampa"/>
-        <a:font script="Sinh" typeface="Iskoola Pota"/>
-        <a:font script="Mong" typeface="Mongolian Baiti"/>
-        <a:font script="Viet" typeface="Arial"/>
-        <a:font script="Uigh" typeface="Microsoft Uighur"/>
-        <a:font script="Geor" typeface="Sylfaen"/>
-      </a:minorFont>
-    </a:fontScheme>
-    <a:fmtScheme name="Office">
-      <a:fillStyleLst>
-        <a:solidFill>
-          <a:schemeClr val="phClr"/>
-        </a:solidFill>
-        <a:gradFill rotWithShape="1">
-          <a:gsLst>
-            <a:gs pos="0">
-              <a:schemeClr val="phClr">
-                <a:lumMod val="110000"/>
-                <a:satMod val="105000"/>
-                <a:tint val="67000"/>
-              </a:schemeClr>
-            </a:gs>
-            <a:gs pos="50000">
-              <a:schemeClr val="phClr">
-                <a:lumMod val="105000"/>
-                <a:satMod val="103000"/>
-                <a:tint val="73000"/>
-              </a:schemeClr>
-            </a:gs>
-            <a:gs pos="100000">
-              <a:schemeClr val="phClr">
-                <a:lumMod val="105000"/>
-                <a:satMod val="109000"/>
-                <a:tint val="81000"/>
-              </a:schemeClr>
-            </a:gs>
-          </a:gsLst>
-          <a:lin ang="5400000" scaled="0"/>
-        </a:gradFill>
-        <a:gradFill rotWithShape="1">
-          <a:gsLst>
-            <a:gs pos="0">
-              <a:schemeClr val="phClr">
-                <a:satMod val="103000"/>
-                <a:lumMod val="102000"/>
-                <a:tint val="94000"/>
-              </a:schemeClr>
-            </a:gs>
-            <a:gs pos="50000">
-              <a:schemeClr val="phClr">
-                <a:satMod val="110000"/>
-                <a:lumMod val="100000"/>
-                <a:shade val="100000"/>
-              </a:schemeClr>
-            </a:gs>
-            <a:gs pos="100000">
-              <a:schemeClr val="phClr">
-                <a:lumMod val="99000"/>
-                <a:satMod val="120000"/>
-                <a:shade val="78000"/>
-              </a:schemeClr>
-            </a:gs>
-          </a:gsLst>
-          <a:lin ang="5400000" scaled="0"/>
-        </a:gradFill>
-      </a:fillStyleLst>
-      <a:lnStyleLst>
-        <a:ln w="6350" cap="flat" cmpd="sng" algn="ctr">
-          <a:solidFill>
-            <a:schemeClr val="phClr"/>
-          </a:solidFill>
-          <a:prstDash val="solid"/>
-          <a:miter lim="800000"/>
-        </a:ln>
-        <a:ln w="12700" cap="flat" cmpd="sng" algn="ctr">
-          <a:solidFill>
-            <a:schemeClr val="phClr"/>
-          </a:solidFill>
-          <a:prstDash val="solid"/>
-          <a:miter lim="800000"/>
-        </a:ln>
-        <a:ln w="19050" cap="flat" cmpd="sng" algn="ctr">
-          <a:solidFill>
-            <a:schemeClr val="phClr"/>
-          </a:solidFill>
-          <a:prstDash val="solid"/>
-          <a:miter lim="800000"/>
-        </a:ln>
-      </a:lnStyleLst>
-      <a:effectStyleLst>
-        <a:effectStyle>
-          <a:effectLst/>
-        </a:effectStyle>
-        <a:effectStyle>
-          <a:effectLst/>
-        </a:effectStyle>
-        <a:effectStyle>
-          <a:effectLst>
-            <a:outerShdw blurRad="57150" dist="19050" dir="5400000" algn="ctr" rotWithShape="0">
-              <a:srgbClr val="000000">
-                <a:alpha val="63000"/>
-              </a:srgbClr>
-            </a:outerShdw>
-          </a:effectLst>
-        </a:effectStyle>
-      </a:effectStyleLst>
-      <a:bgFillStyleLst>
-        <a:solidFill>
-          <a:schemeClr val="phClr"/>
-        </a:solidFill>
-        <a:solidFill>
-          <a:schemeClr val="phClr">
-            <a:tint val="95000"/>
-            <a:satMod val="170000"/>
-          </a:schemeClr>
-        </a:solidFill>
-        <a:gradFill rotWithShape="1">
-          <a:gsLst>
-            <a:gs pos="0">
-              <a:schemeClr val="phClr">
-                <a:tint val="93000"/>
-                <a:satMod val="150000"/>
-                <a:shade val="98000"/>
-                <a:lumMod val="102000"/>
-              </a:schemeClr>
-            </a:gs>
-            <a:gs pos="50000">
-              <a:schemeClr val="phClr">
-                <a:tint val="98000"/>
-                <a:satMod val="130000"/>
-                <a:shade val="90000"/>
-                <a:lumMod val="103000"/>
-              </a:schemeClr>
-            </a:gs>
-            <a:gs pos="100000">
-              <a:schemeClr val="phClr">
-                <a:shade val="63000"/>
-                <a:satMod val="120000"/>
-              </a:schemeClr>
-            </a:gs>
-          </a:gsLst>
-          <a:lin ang="5400000" scaled="0"/>
-        </a:gradFill>
-      </a:bgFillStyleLst>
-    </a:fmtScheme>
-  </a:themeElements>
+  <a:objectDefaults/>
+  <a:extraClrSchemeLst/>
   <a:extLst>
     <a:ext uri="{05A4C25C-085E-4340-85A3-A5531E510DB2}">
       <thm15:themeFamily xmlns:thm15="http://schemas.microsoft.com/office/thememl/2012/main" name="Office Theme" id="{62F939B6-93AF-4DB8-9C6B-D6C7DFDC589F}" vid="{4A3C46E8-61CC-4603-A589-7422A47A8E4A}"/>

</xml_diff>